<commit_message>
Correct Fall 2026 GTA roster in syllabus and Lecture 01
</commit_message>
<xml_diff>
--- a/site/docs/MIE402_Lecture01_Report_Writing_Fall2026_v1.pptx
+++ b/site/docs/MIE402_Lecture01_Report_Writing_Fall2026_v1.pptx
@@ -2,43 +2,43 @@
 <file path=ppt/presentation.xml><?xml version="1.0" encoding="utf-8"?>
 <p:presentation xmlns:p="http://schemas.openxmlformats.org/presentationml/2006/main">
   <p:sldMasterIdLst>
-    <p:sldMasterId xmlns:r="http://schemas.openxmlformats.org/officeDocument/2006/relationships" id="2147483648" r:id="R3ea6978fb64c4fba"/>
+    <p:sldMasterId xmlns:r="http://schemas.openxmlformats.org/officeDocument/2006/relationships" id="2147483648" r:id="R84eadb1f28fb4f83"/>
   </p:sldMasterIdLst>
   <p:notesMasterIdLst>
-    <p:notesMasterId xmlns:r="http://schemas.openxmlformats.org/officeDocument/2006/relationships" r:id="Rd1f2308a97a547dd"/>
+    <p:notesMasterId xmlns:r="http://schemas.openxmlformats.org/officeDocument/2006/relationships" r:id="Rbb5a737ac96e4e2e"/>
   </p:notesMasterIdLst>
   <p:sldIdLst>
-    <p:sldId xmlns:r="http://schemas.openxmlformats.org/officeDocument/2006/relationships" id="256" r:id="Rfb04a774188b4f51"/>
-    <p:sldId xmlns:r="http://schemas.openxmlformats.org/officeDocument/2006/relationships" id="257" r:id="R0532f0d055a6469b"/>
-    <p:sldId xmlns:r="http://schemas.openxmlformats.org/officeDocument/2006/relationships" id="258" r:id="R61629b500e4c4a49"/>
-    <p:sldId xmlns:r="http://schemas.openxmlformats.org/officeDocument/2006/relationships" id="259" r:id="R82d0356db6a1472c"/>
-    <p:sldId xmlns:r="http://schemas.openxmlformats.org/officeDocument/2006/relationships" id="260" r:id="R7d77557bdb724b65"/>
-    <p:sldId xmlns:r="http://schemas.openxmlformats.org/officeDocument/2006/relationships" id="261" r:id="R6b6dd33519b54f86"/>
-    <p:sldId xmlns:r="http://schemas.openxmlformats.org/officeDocument/2006/relationships" id="262" r:id="Re9444d54fb2f4527"/>
-    <p:sldId xmlns:r="http://schemas.openxmlformats.org/officeDocument/2006/relationships" id="263" r:id="R7898c18414754240"/>
-    <p:sldId xmlns:r="http://schemas.openxmlformats.org/officeDocument/2006/relationships" id="264" r:id="R40551a5a3e344876"/>
-    <p:sldId xmlns:r="http://schemas.openxmlformats.org/officeDocument/2006/relationships" id="265" r:id="Reabe269b924b4a59"/>
-    <p:sldId xmlns:r="http://schemas.openxmlformats.org/officeDocument/2006/relationships" id="266" r:id="R8ba66865935c444d"/>
-    <p:sldId xmlns:r="http://schemas.openxmlformats.org/officeDocument/2006/relationships" id="267" r:id="Re8eca86033d4446d"/>
-    <p:sldId xmlns:r="http://schemas.openxmlformats.org/officeDocument/2006/relationships" id="268" r:id="R72c854d3a7244470"/>
-    <p:sldId xmlns:r="http://schemas.openxmlformats.org/officeDocument/2006/relationships" id="269" r:id="R0f8a225371dc413f"/>
-    <p:sldId xmlns:r="http://schemas.openxmlformats.org/officeDocument/2006/relationships" id="270" r:id="R8228d224cdee4731"/>
-    <p:sldId xmlns:r="http://schemas.openxmlformats.org/officeDocument/2006/relationships" id="271" r:id="R964c27af9a804f07"/>
-    <p:sldId xmlns:r="http://schemas.openxmlformats.org/officeDocument/2006/relationships" id="272" r:id="R9a4a5667c63b43d2"/>
-    <p:sldId xmlns:r="http://schemas.openxmlformats.org/officeDocument/2006/relationships" id="273" r:id="Rf5f2fd7541864344"/>
-    <p:sldId xmlns:r="http://schemas.openxmlformats.org/officeDocument/2006/relationships" id="274" r:id="R25cebc2812094a0a"/>
-    <p:sldId xmlns:r="http://schemas.openxmlformats.org/officeDocument/2006/relationships" id="275" r:id="R1e64aae1b95e46fe"/>
-    <p:sldId xmlns:r="http://schemas.openxmlformats.org/officeDocument/2006/relationships" id="276" r:id="R31fcdfb196914c7d"/>
-    <p:sldId xmlns:r="http://schemas.openxmlformats.org/officeDocument/2006/relationships" id="277" r:id="R5ffa5ef777ad4d45"/>
-    <p:sldId xmlns:r="http://schemas.openxmlformats.org/officeDocument/2006/relationships" id="278" r:id="R0ed3a5e2dade410d"/>
-    <p:sldId xmlns:r="http://schemas.openxmlformats.org/officeDocument/2006/relationships" id="279" r:id="Rda1991d6d94a4768"/>
-    <p:sldId xmlns:r="http://schemas.openxmlformats.org/officeDocument/2006/relationships" id="280" r:id="R189b8ec3858343d5"/>
-    <p:sldId xmlns:r="http://schemas.openxmlformats.org/officeDocument/2006/relationships" id="281" r:id="Re64ee00bc11b458e"/>
-    <p:sldId xmlns:r="http://schemas.openxmlformats.org/officeDocument/2006/relationships" id="282" r:id="R37ba6f3a6bea49c5"/>
-    <p:sldId xmlns:r="http://schemas.openxmlformats.org/officeDocument/2006/relationships" id="283" r:id="Rd0e2fab91ff24151"/>
-    <p:sldId xmlns:r="http://schemas.openxmlformats.org/officeDocument/2006/relationships" id="284" r:id="Rab5efab2691d4371"/>
-    <p:sldId xmlns:r="http://schemas.openxmlformats.org/officeDocument/2006/relationships" id="285" r:id="R07b11985cb6a4883"/>
-    <p:sldId xmlns:r="http://schemas.openxmlformats.org/officeDocument/2006/relationships" id="286" r:id="R35eefa0eb7f845f1"/>
+    <p:sldId xmlns:r="http://schemas.openxmlformats.org/officeDocument/2006/relationships" id="256" r:id="Rc24eb59950c44ee0"/>
+    <p:sldId xmlns:r="http://schemas.openxmlformats.org/officeDocument/2006/relationships" id="257" r:id="R2d45e1aa99d44cd3"/>
+    <p:sldId xmlns:r="http://schemas.openxmlformats.org/officeDocument/2006/relationships" id="258" r:id="Ra602d9409b0540ac"/>
+    <p:sldId xmlns:r="http://schemas.openxmlformats.org/officeDocument/2006/relationships" id="259" r:id="R584dae359adf4e6d"/>
+    <p:sldId xmlns:r="http://schemas.openxmlformats.org/officeDocument/2006/relationships" id="260" r:id="R5584d0b387364a25"/>
+    <p:sldId xmlns:r="http://schemas.openxmlformats.org/officeDocument/2006/relationships" id="261" r:id="R0005c2f09afd4d02"/>
+    <p:sldId xmlns:r="http://schemas.openxmlformats.org/officeDocument/2006/relationships" id="262" r:id="Rcbb3b518b73a4b1f"/>
+    <p:sldId xmlns:r="http://schemas.openxmlformats.org/officeDocument/2006/relationships" id="263" r:id="R8c2f4c57c4aa42f2"/>
+    <p:sldId xmlns:r="http://schemas.openxmlformats.org/officeDocument/2006/relationships" id="264" r:id="R3406378ac5e04ded"/>
+    <p:sldId xmlns:r="http://schemas.openxmlformats.org/officeDocument/2006/relationships" id="265" r:id="R0d0fbcf3f8b247ca"/>
+    <p:sldId xmlns:r="http://schemas.openxmlformats.org/officeDocument/2006/relationships" id="266" r:id="R4aac9c09e5084085"/>
+    <p:sldId xmlns:r="http://schemas.openxmlformats.org/officeDocument/2006/relationships" id="267" r:id="Rf1679ce93c00476b"/>
+    <p:sldId xmlns:r="http://schemas.openxmlformats.org/officeDocument/2006/relationships" id="268" r:id="R2d48222bee424bc4"/>
+    <p:sldId xmlns:r="http://schemas.openxmlformats.org/officeDocument/2006/relationships" id="269" r:id="R55ef97810cbd47ff"/>
+    <p:sldId xmlns:r="http://schemas.openxmlformats.org/officeDocument/2006/relationships" id="270" r:id="R5b04dac1fedd45d1"/>
+    <p:sldId xmlns:r="http://schemas.openxmlformats.org/officeDocument/2006/relationships" id="271" r:id="R0ba4dd63a8e0424f"/>
+    <p:sldId xmlns:r="http://schemas.openxmlformats.org/officeDocument/2006/relationships" id="272" r:id="Rf80513c7dd9f4b41"/>
+    <p:sldId xmlns:r="http://schemas.openxmlformats.org/officeDocument/2006/relationships" id="273" r:id="R2b0e803465894db2"/>
+    <p:sldId xmlns:r="http://schemas.openxmlformats.org/officeDocument/2006/relationships" id="274" r:id="Re2334d2cb9df4e26"/>
+    <p:sldId xmlns:r="http://schemas.openxmlformats.org/officeDocument/2006/relationships" id="275" r:id="Rdef1ef7e0456422c"/>
+    <p:sldId xmlns:r="http://schemas.openxmlformats.org/officeDocument/2006/relationships" id="276" r:id="Rdedd7b6c6a9541e1"/>
+    <p:sldId xmlns:r="http://schemas.openxmlformats.org/officeDocument/2006/relationships" id="277" r:id="R847d273b30094202"/>
+    <p:sldId xmlns:r="http://schemas.openxmlformats.org/officeDocument/2006/relationships" id="278" r:id="Ra9767f1e497c4e52"/>
+    <p:sldId xmlns:r="http://schemas.openxmlformats.org/officeDocument/2006/relationships" id="279" r:id="Re02342af6b1a4a54"/>
+    <p:sldId xmlns:r="http://schemas.openxmlformats.org/officeDocument/2006/relationships" id="280" r:id="R897e8dfeda064186"/>
+    <p:sldId xmlns:r="http://schemas.openxmlformats.org/officeDocument/2006/relationships" id="281" r:id="Ra60abe02309f49c7"/>
+    <p:sldId xmlns:r="http://schemas.openxmlformats.org/officeDocument/2006/relationships" id="282" r:id="R8ecbb2ba50a6440a"/>
+    <p:sldId xmlns:r="http://schemas.openxmlformats.org/officeDocument/2006/relationships" id="283" r:id="R8a82106dd1584e6a"/>
+    <p:sldId xmlns:r="http://schemas.openxmlformats.org/officeDocument/2006/relationships" id="284" r:id="R4251e48241c84bcc"/>
+    <p:sldId xmlns:r="http://schemas.openxmlformats.org/officeDocument/2006/relationships" id="285" r:id="R716da1e59de94c20"/>
+    <p:sldId xmlns:r="http://schemas.openxmlformats.org/officeDocument/2006/relationships" id="286" r:id="R3a4d66a95baa438c"/>
   </p:sldIdLst>
   <p:sldSz cx="12192000" cy="6858000"/>
   <p:notesSz cx="6858000" cy="9144000"/>
@@ -2857,7 +2857,7 @@
           </a:p>
           <a:p xmlns:a="http://schemas.openxmlformats.org/drawingml/2006/main">
             <a:r>
-              <a:t>Introduce all three GTAs, including Ryan Cameron, whose name was missing from the earlier slide. Ask students to check their own section and GTA in Canvas. September 9 is a one-time Wednesday orientation. Regular theory meetings are on Mondays. There is no regular Wednesday theory meeting. Explain the difference between the 50-minute theory meeting and the scheduled laboratory section. General questions belong in lecture, individual questions in office hours, and email is appropriate when those options are not practical.</a:t>
+              <a:t>Introduce the two GTAs, Yuyuan Zhang and Nazila Emamdoost. Ask students to check their own section and GTA in Canvas. September 9 is a one-time Wednesday orientation. Regular theory meetings are on Mondays. There is no regular Wednesday theory meeting. Explain the difference between the 50-minute theory meeting and the scheduled laboratory section. General questions belong in lecture, individual questions in office hours, and email is appropriate when those options are not practical.</a:t>
             </a:r>
           </a:p>
           <a:p xmlns:a="http://schemas.openxmlformats.org/drawingml/2006/main">
@@ -3415,7 +3415,7 @@
   </p:cSld>
   <p:clrMap bg1="lt1" tx1="dk1" bg2="lt2" tx2="dk2" accent1="accent1" accent2="accent2" accent3="accent3" accent4="accent4" accent5="accent5" accent6="accent6" hlink="hlink" folHlink="folHlink"/>
   <p:sldLayoutIdLst>
-    <p:sldLayoutId xmlns:r="http://schemas.openxmlformats.org/officeDocument/2006/relationships" id="2147483649" r:id="Rc919addb26254cdb"/>
+    <p:sldLayoutId xmlns:r="http://schemas.openxmlformats.org/officeDocument/2006/relationships" id="2147483649" r:id="Rfd598a04274c42b4"/>
   </p:sldLayoutIdLst>
   <p:txStyles>
     <p:titleStyle>
@@ -6015,7 +6015,7 @@
           <p:cNvPr id="11" name="course">
             <a:extLst xmlns:a="http://schemas.openxmlformats.org/drawingml/2006/main">
               <a:ext uri="{FF2B5EF4-FFF2-40B4-BE49-F238E27FC236}">
-                <a16:creationId xmlns:a16="http://schemas.microsoft.com/office/drawing/2014/main" id="{268D333B-91FC-4CDC-9400-727035DCBCD0}"/>
+                <a16:creationId xmlns:a16="http://schemas.microsoft.com/office/drawing/2014/main" id="{00044A58-CD51-47A7-927B-846CAA370E34}"/>
               </a:ext>
             </a:extLst>
           </p:cNvPr>
@@ -6072,7 +6072,7 @@
           <p:cNvPr id="2" name="title">
             <a:extLst xmlns:a="http://schemas.openxmlformats.org/drawingml/2006/main">
               <a:ext uri="{FF2B5EF4-FFF2-40B4-BE49-F238E27FC236}">
-                <a16:creationId xmlns:a16="http://schemas.microsoft.com/office/drawing/2014/main" id="{B0503DCC-00DB-4C59-9901-2F0DF5E4FCEA}"/>
+                <a16:creationId xmlns:a16="http://schemas.microsoft.com/office/drawing/2014/main" id="{F95E1EA2-6B4C-4401-8BCC-9598BD0E14AF}"/>
               </a:ext>
             </a:extLst>
           </p:cNvPr>
@@ -6129,7 +6129,7 @@
           <p:cNvPr id="3" name="body">
             <a:extLst xmlns:a="http://schemas.openxmlformats.org/drawingml/2006/main">
               <a:ext uri="{FF2B5EF4-FFF2-40B4-BE49-F238E27FC236}">
-                <a16:creationId xmlns:a16="http://schemas.microsoft.com/office/drawing/2014/main" id="{4C12BD4A-539F-4383-B1CB-59A5B1FE89C8}"/>
+                <a16:creationId xmlns:a16="http://schemas.microsoft.com/office/drawing/2014/main" id="{FF15A17A-59D6-40FC-81F5-289B7AABE51B}"/>
               </a:ext>
             </a:extLst>
           </p:cNvPr>
@@ -6186,7 +6186,7 @@
           <p:cNvPr id="4" name="body">
             <a:extLst xmlns:a="http://schemas.openxmlformats.org/drawingml/2006/main">
               <a:ext uri="{FF2B5EF4-FFF2-40B4-BE49-F238E27FC236}">
-                <a16:creationId xmlns:a16="http://schemas.microsoft.com/office/drawing/2014/main" id="{ABC6E8E5-B13E-44FB-8B8B-FA39337BFEA8}"/>
+                <a16:creationId xmlns:a16="http://schemas.microsoft.com/office/drawing/2014/main" id="{4A9947C8-E9EF-47AC-A903-76354FF9E931}"/>
               </a:ext>
             </a:extLst>
           </p:cNvPr>
@@ -6243,7 +6243,7 @@
           <p:cNvPr id="5" name="body">
             <a:extLst xmlns:a="http://schemas.openxmlformats.org/drawingml/2006/main">
               <a:ext uri="{FF2B5EF4-FFF2-40B4-BE49-F238E27FC236}">
-                <a16:creationId xmlns:a16="http://schemas.microsoft.com/office/drawing/2014/main" id="{AEFDD630-F879-4E2D-ACDB-BFB34AEF8AF9}"/>
+                <a16:creationId xmlns:a16="http://schemas.microsoft.com/office/drawing/2014/main" id="{83B6A5AB-113E-4A04-993D-375DC3C532E7}"/>
               </a:ext>
             </a:extLst>
           </p:cNvPr>
@@ -6300,7 +6300,7 @@
           <p:cNvPr id="6" name="body">
             <a:extLst xmlns:a="http://schemas.openxmlformats.org/drawingml/2006/main">
               <a:ext uri="{FF2B5EF4-FFF2-40B4-BE49-F238E27FC236}">
-                <a16:creationId xmlns:a16="http://schemas.microsoft.com/office/drawing/2014/main" id="{A07EFA40-16F0-4904-A1E7-924897403EC4}"/>
+                <a16:creationId xmlns:a16="http://schemas.microsoft.com/office/drawing/2014/main" id="{DA631368-8596-472A-B854-1C9779230F07}"/>
               </a:ext>
             </a:extLst>
           </p:cNvPr>
@@ -6357,7 +6357,7 @@
           <p:cNvPr id="7" name="body">
             <a:extLst xmlns:a="http://schemas.openxmlformats.org/drawingml/2006/main">
               <a:ext uri="{FF2B5EF4-FFF2-40B4-BE49-F238E27FC236}">
-                <a16:creationId xmlns:a16="http://schemas.microsoft.com/office/drawing/2014/main" id="{70970948-811C-4513-85B7-E400485F57C1}"/>
+                <a16:creationId xmlns:a16="http://schemas.microsoft.com/office/drawing/2014/main" id="{38094D53-1AFD-4558-A5E9-93B3880A9C1B}"/>
               </a:ext>
             </a:extLst>
           </p:cNvPr>
@@ -6414,7 +6414,7 @@
           <p:cNvPr id="8" name="body">
             <a:extLst xmlns:a="http://schemas.openxmlformats.org/drawingml/2006/main">
               <a:ext uri="{FF2B5EF4-FFF2-40B4-BE49-F238E27FC236}">
-                <a16:creationId xmlns:a16="http://schemas.microsoft.com/office/drawing/2014/main" id="{C891E136-8D75-4B58-9B3D-FA443B3AA71B}"/>
+                <a16:creationId xmlns:a16="http://schemas.microsoft.com/office/drawing/2014/main" id="{B63CB462-DBE5-402F-9986-7C990B7CA825}"/>
               </a:ext>
             </a:extLst>
           </p:cNvPr>
@@ -6471,7 +6471,7 @@
           <p:cNvPr id="9" name="footnote">
             <a:extLst xmlns:a="http://schemas.openxmlformats.org/drawingml/2006/main">
               <a:ext uri="{FF2B5EF4-FFF2-40B4-BE49-F238E27FC236}">
-                <a16:creationId xmlns:a16="http://schemas.microsoft.com/office/drawing/2014/main" id="{B49B63C1-6A67-4026-AC7B-066154A31623}"/>
+                <a16:creationId xmlns:a16="http://schemas.microsoft.com/office/drawing/2014/main" id="{178021EB-FF37-4E2A-8420-2448A037161E}"/>
               </a:ext>
             </a:extLst>
           </p:cNvPr>
@@ -6528,7 +6528,7 @@
           <p:cNvPr id="10" name="page">
             <a:extLst xmlns:a="http://schemas.openxmlformats.org/drawingml/2006/main">
               <a:ext uri="{FF2B5EF4-FFF2-40B4-BE49-F238E27FC236}">
-                <a16:creationId xmlns:a16="http://schemas.microsoft.com/office/drawing/2014/main" id="{B0FCEC60-2302-4F3F-9E9E-F65801A864B9}"/>
+                <a16:creationId xmlns:a16="http://schemas.microsoft.com/office/drawing/2014/main" id="{24D76FF0-B4FA-4799-8DC2-D2685099399F}"/>
               </a:ext>
             </a:extLst>
           </p:cNvPr>
@@ -6583,7 +6583,7 @@
     </p:spTree>
     <p:extLst>
       <p:ext uri="{BB962C8B-B14F-4D97-AF65-F5344CB8AC3E}">
-        <p14:creationId xmlns:p14="http://schemas.microsoft.com/office/powerpoint/2010/main" val="1748997798"/>
+        <p14:creationId xmlns:p14="http://schemas.microsoft.com/office/powerpoint/2010/main" val="1474794615"/>
       </p:ext>
     </p:extLst>
   </p:cSld>
@@ -6614,7 +6614,7 @@
           <p:cNvPr id="12" name="course">
             <a:extLst xmlns:a="http://schemas.openxmlformats.org/drawingml/2006/main">
               <a:ext uri="{FF2B5EF4-FFF2-40B4-BE49-F238E27FC236}">
-                <a16:creationId xmlns:a16="http://schemas.microsoft.com/office/drawing/2014/main" id="{F445C6D1-FAFB-4DEF-887D-0897FE7BD0A0}"/>
+                <a16:creationId xmlns:a16="http://schemas.microsoft.com/office/drawing/2014/main" id="{6BDA7AEE-BF4F-4966-BB9E-C6069DE91979}"/>
               </a:ext>
             </a:extLst>
           </p:cNvPr>
@@ -6671,7 +6671,7 @@
           <p:cNvPr id="2" name="title">
             <a:extLst xmlns:a="http://schemas.openxmlformats.org/drawingml/2006/main">
               <a:ext uri="{FF2B5EF4-FFF2-40B4-BE49-F238E27FC236}">
-                <a16:creationId xmlns:a16="http://schemas.microsoft.com/office/drawing/2014/main" id="{FED62FF4-38AF-491E-978F-94787E523A70}"/>
+                <a16:creationId xmlns:a16="http://schemas.microsoft.com/office/drawing/2014/main" id="{10D7D722-153B-4908-B968-E509CFF0D6AF}"/>
               </a:ext>
             </a:extLst>
           </p:cNvPr>
@@ -6728,7 +6728,7 @@
           <p:cNvPr id="3" name="body">
             <a:extLst xmlns:a="http://schemas.openxmlformats.org/drawingml/2006/main">
               <a:ext uri="{FF2B5EF4-FFF2-40B4-BE49-F238E27FC236}">
-                <a16:creationId xmlns:a16="http://schemas.microsoft.com/office/drawing/2014/main" id="{8E9C25B0-78BC-4AAB-8CC3-E4FDF8793FB9}"/>
+                <a16:creationId xmlns:a16="http://schemas.microsoft.com/office/drawing/2014/main" id="{9BF153E3-793B-43D2-A24C-20062CE3BD9B}"/>
               </a:ext>
             </a:extLst>
           </p:cNvPr>
@@ -6785,7 +6785,7 @@
           <p:cNvPr id="4" name="body">
             <a:extLst xmlns:a="http://schemas.openxmlformats.org/drawingml/2006/main">
               <a:ext uri="{FF2B5EF4-FFF2-40B4-BE49-F238E27FC236}">
-                <a16:creationId xmlns:a16="http://schemas.microsoft.com/office/drawing/2014/main" id="{0AA3D10F-D939-4FF4-8BAD-6299C9CEC3BB}"/>
+                <a16:creationId xmlns:a16="http://schemas.microsoft.com/office/drawing/2014/main" id="{543BF15C-3667-4FD5-BC62-087E36B256E0}"/>
               </a:ext>
             </a:extLst>
           </p:cNvPr>
@@ -6842,7 +6842,7 @@
           <p:cNvPr id="5" name="body">
             <a:extLst xmlns:a="http://schemas.openxmlformats.org/drawingml/2006/main">
               <a:ext uri="{FF2B5EF4-FFF2-40B4-BE49-F238E27FC236}">
-                <a16:creationId xmlns:a16="http://schemas.microsoft.com/office/drawing/2014/main" id="{8061E2C0-F264-48D3-BE0A-7F523CD4901A}"/>
+                <a16:creationId xmlns:a16="http://schemas.microsoft.com/office/drawing/2014/main" id="{A25B9CFC-060C-4BC3-85FE-645998705482}"/>
               </a:ext>
             </a:extLst>
           </p:cNvPr>
@@ -6899,7 +6899,7 @@
           <p:cNvPr id="6" name="body">
             <a:extLst xmlns:a="http://schemas.openxmlformats.org/drawingml/2006/main">
               <a:ext uri="{FF2B5EF4-FFF2-40B4-BE49-F238E27FC236}">
-                <a16:creationId xmlns:a16="http://schemas.microsoft.com/office/drawing/2014/main" id="{A6FDE15B-FCB4-4E0C-901E-161D9F712CC0}"/>
+                <a16:creationId xmlns:a16="http://schemas.microsoft.com/office/drawing/2014/main" id="{663556F3-07E5-4BB5-A903-70CC6259D312}"/>
               </a:ext>
             </a:extLst>
           </p:cNvPr>
@@ -6956,7 +6956,7 @@
           <p:cNvPr id="7" name="body">
             <a:extLst xmlns:a="http://schemas.openxmlformats.org/drawingml/2006/main">
               <a:ext uri="{FF2B5EF4-FFF2-40B4-BE49-F238E27FC236}">
-                <a16:creationId xmlns:a16="http://schemas.microsoft.com/office/drawing/2014/main" id="{1C287629-00AC-4475-9373-8F135036BB01}"/>
+                <a16:creationId xmlns:a16="http://schemas.microsoft.com/office/drawing/2014/main" id="{565FA018-1B15-412E-9A8B-FED546CF61E5}"/>
               </a:ext>
             </a:extLst>
           </p:cNvPr>
@@ -7013,7 +7013,7 @@
           <p:cNvPr id="8" name="body">
             <a:extLst xmlns:a="http://schemas.openxmlformats.org/drawingml/2006/main">
               <a:ext uri="{FF2B5EF4-FFF2-40B4-BE49-F238E27FC236}">
-                <a16:creationId xmlns:a16="http://schemas.microsoft.com/office/drawing/2014/main" id="{BA622EFD-4C76-48B5-8A9E-38EF33287E9F}"/>
+                <a16:creationId xmlns:a16="http://schemas.microsoft.com/office/drawing/2014/main" id="{8B448933-B6DE-4236-AE2F-9C79CAACF0FC}"/>
               </a:ext>
             </a:extLst>
           </p:cNvPr>
@@ -7070,7 +7070,7 @@
           <p:cNvPr id="9" name="equation">
             <a:extLst xmlns:a="http://schemas.openxmlformats.org/drawingml/2006/main">
               <a:ext uri="{FF2B5EF4-FFF2-40B4-BE49-F238E27FC236}">
-                <a16:creationId xmlns:a16="http://schemas.microsoft.com/office/drawing/2014/main" id="{2D2AFC03-9224-496F-8E3B-8FA020296FD5}"/>
+                <a16:creationId xmlns:a16="http://schemas.microsoft.com/office/drawing/2014/main" id="{DB2991A2-8E42-41EF-9E83-30C046FF1274}"/>
               </a:ext>
             </a:extLst>
           </p:cNvPr>
@@ -7127,7 +7127,7 @@
           <p:cNvPr id="10" name="footnote">
             <a:extLst xmlns:a="http://schemas.openxmlformats.org/drawingml/2006/main">
               <a:ext uri="{FF2B5EF4-FFF2-40B4-BE49-F238E27FC236}">
-                <a16:creationId xmlns:a16="http://schemas.microsoft.com/office/drawing/2014/main" id="{A1D49516-806C-4CF5-B389-A9B85C4EB92F}"/>
+                <a16:creationId xmlns:a16="http://schemas.microsoft.com/office/drawing/2014/main" id="{5CA0BBDC-B898-4949-8FB5-583F7ADEFAEF}"/>
               </a:ext>
             </a:extLst>
           </p:cNvPr>
@@ -7184,7 +7184,7 @@
           <p:cNvPr id="11" name="page">
             <a:extLst xmlns:a="http://schemas.openxmlformats.org/drawingml/2006/main">
               <a:ext uri="{FF2B5EF4-FFF2-40B4-BE49-F238E27FC236}">
-                <a16:creationId xmlns:a16="http://schemas.microsoft.com/office/drawing/2014/main" id="{FFD6072A-1162-49EA-B42E-EEC37DDE9CBC}"/>
+                <a16:creationId xmlns:a16="http://schemas.microsoft.com/office/drawing/2014/main" id="{95768914-A788-4985-87BA-A1F167DF660C}"/>
               </a:ext>
             </a:extLst>
           </p:cNvPr>
@@ -7239,7 +7239,7 @@
     </p:spTree>
     <p:extLst>
       <p:ext uri="{BB962C8B-B14F-4D97-AF65-F5344CB8AC3E}">
-        <p14:creationId xmlns:p14="http://schemas.microsoft.com/office/powerpoint/2010/main" val="1492470242"/>
+        <p14:creationId xmlns:p14="http://schemas.microsoft.com/office/powerpoint/2010/main" val="980667071"/>
       </p:ext>
     </p:extLst>
   </p:cSld>
@@ -7270,7 +7270,7 @@
           <p:cNvPr id="12" name="course">
             <a:extLst xmlns:a="http://schemas.openxmlformats.org/drawingml/2006/main">
               <a:ext uri="{FF2B5EF4-FFF2-40B4-BE49-F238E27FC236}">
-                <a16:creationId xmlns:a16="http://schemas.microsoft.com/office/drawing/2014/main" id="{AC634767-616A-4EEF-B50D-D70B6BD6B4DC}"/>
+                <a16:creationId xmlns:a16="http://schemas.microsoft.com/office/drawing/2014/main" id="{DE6F55F2-4D58-4FB5-9F00-AFDE81E152AA}"/>
               </a:ext>
             </a:extLst>
           </p:cNvPr>
@@ -7327,7 +7327,7 @@
           <p:cNvPr id="2" name="title">
             <a:extLst xmlns:a="http://schemas.openxmlformats.org/drawingml/2006/main">
               <a:ext uri="{FF2B5EF4-FFF2-40B4-BE49-F238E27FC236}">
-                <a16:creationId xmlns:a16="http://schemas.microsoft.com/office/drawing/2014/main" id="{FC3964EA-FD9C-4B27-8A56-E49B6D8D0C5C}"/>
+                <a16:creationId xmlns:a16="http://schemas.microsoft.com/office/drawing/2014/main" id="{CF3B351A-BA80-447B-9CFB-45667D9EB56D}"/>
               </a:ext>
             </a:extLst>
           </p:cNvPr>
@@ -7384,7 +7384,7 @@
           <p:cNvPr id="3" name="body">
             <a:extLst xmlns:a="http://schemas.openxmlformats.org/drawingml/2006/main">
               <a:ext uri="{FF2B5EF4-FFF2-40B4-BE49-F238E27FC236}">
-                <a16:creationId xmlns:a16="http://schemas.microsoft.com/office/drawing/2014/main" id="{8AE42123-72C0-472F-A53F-27DC6EDDA504}"/>
+                <a16:creationId xmlns:a16="http://schemas.microsoft.com/office/drawing/2014/main" id="{AB88E571-6C6E-4BF1-95BA-C68D6249798D}"/>
               </a:ext>
             </a:extLst>
           </p:cNvPr>
@@ -7441,7 +7441,7 @@
           <p:cNvPr id="4" name="body">
             <a:extLst xmlns:a="http://schemas.openxmlformats.org/drawingml/2006/main">
               <a:ext uri="{FF2B5EF4-FFF2-40B4-BE49-F238E27FC236}">
-                <a16:creationId xmlns:a16="http://schemas.microsoft.com/office/drawing/2014/main" id="{0FA22A0B-F210-4BBF-BEF2-57FCBC38F745}"/>
+                <a16:creationId xmlns:a16="http://schemas.microsoft.com/office/drawing/2014/main" id="{A2E44955-6832-4698-A014-9859849FB83B}"/>
               </a:ext>
             </a:extLst>
           </p:cNvPr>
@@ -7498,7 +7498,7 @@
           <p:cNvPr id="5" name="body">
             <a:extLst xmlns:a="http://schemas.openxmlformats.org/drawingml/2006/main">
               <a:ext uri="{FF2B5EF4-FFF2-40B4-BE49-F238E27FC236}">
-                <a16:creationId xmlns:a16="http://schemas.microsoft.com/office/drawing/2014/main" id="{322AE7FF-40F4-4470-802B-D15FE88CAE29}"/>
+                <a16:creationId xmlns:a16="http://schemas.microsoft.com/office/drawing/2014/main" id="{DB0BFC76-20D8-4713-855B-3004946B526C}"/>
               </a:ext>
             </a:extLst>
           </p:cNvPr>
@@ -7555,7 +7555,7 @@
           <p:cNvPr id="6" name="body">
             <a:extLst xmlns:a="http://schemas.openxmlformats.org/drawingml/2006/main">
               <a:ext uri="{FF2B5EF4-FFF2-40B4-BE49-F238E27FC236}">
-                <a16:creationId xmlns:a16="http://schemas.microsoft.com/office/drawing/2014/main" id="{78DA6F9A-0A7F-4E1F-826C-E666065778E5}"/>
+                <a16:creationId xmlns:a16="http://schemas.microsoft.com/office/drawing/2014/main" id="{4939B6D3-A825-45E4-95B5-771B345F9431}"/>
               </a:ext>
             </a:extLst>
           </p:cNvPr>
@@ -7612,7 +7612,7 @@
           <p:cNvPr id="7" name="body">
             <a:extLst xmlns:a="http://schemas.openxmlformats.org/drawingml/2006/main">
               <a:ext uri="{FF2B5EF4-FFF2-40B4-BE49-F238E27FC236}">
-                <a16:creationId xmlns:a16="http://schemas.microsoft.com/office/drawing/2014/main" id="{CEE9F073-28D7-43B4-B192-854419E9EA25}"/>
+                <a16:creationId xmlns:a16="http://schemas.microsoft.com/office/drawing/2014/main" id="{96440966-89FB-41C9-B2E6-D10202357A56}"/>
               </a:ext>
             </a:extLst>
           </p:cNvPr>
@@ -7669,7 +7669,7 @@
           <p:cNvPr id="8" name="body">
             <a:extLst xmlns:a="http://schemas.openxmlformats.org/drawingml/2006/main">
               <a:ext uri="{FF2B5EF4-FFF2-40B4-BE49-F238E27FC236}">
-                <a16:creationId xmlns:a16="http://schemas.microsoft.com/office/drawing/2014/main" id="{E6996CC4-B2B6-47A3-88E6-03597E41A25D}"/>
+                <a16:creationId xmlns:a16="http://schemas.microsoft.com/office/drawing/2014/main" id="{F01CFEED-A748-41EF-A57C-AAD9B5EBF2C9}"/>
               </a:ext>
             </a:extLst>
           </p:cNvPr>
@@ -7726,7 +7726,7 @@
           <p:cNvPr id="9" name="equation">
             <a:extLst xmlns:a="http://schemas.openxmlformats.org/drawingml/2006/main">
               <a:ext uri="{FF2B5EF4-FFF2-40B4-BE49-F238E27FC236}">
-                <a16:creationId xmlns:a16="http://schemas.microsoft.com/office/drawing/2014/main" id="{7B706310-C2D1-4FC1-9C99-0B0543CDAA7C}"/>
+                <a16:creationId xmlns:a16="http://schemas.microsoft.com/office/drawing/2014/main" id="{F155AFB4-E2D4-4C78-B710-3A1985B775A3}"/>
               </a:ext>
             </a:extLst>
           </p:cNvPr>
@@ -7783,7 +7783,7 @@
           <p:cNvPr id="10" name="footnote">
             <a:extLst xmlns:a="http://schemas.openxmlformats.org/drawingml/2006/main">
               <a:ext uri="{FF2B5EF4-FFF2-40B4-BE49-F238E27FC236}">
-                <a16:creationId xmlns:a16="http://schemas.microsoft.com/office/drawing/2014/main" id="{BBCFF91F-8943-46C2-8D59-3075F3E598F6}"/>
+                <a16:creationId xmlns:a16="http://schemas.microsoft.com/office/drawing/2014/main" id="{9D39C1C5-2238-4BE9-B0CA-3B92F20CA8F3}"/>
               </a:ext>
             </a:extLst>
           </p:cNvPr>
@@ -7840,7 +7840,7 @@
           <p:cNvPr id="11" name="page">
             <a:extLst xmlns:a="http://schemas.openxmlformats.org/drawingml/2006/main">
               <a:ext uri="{FF2B5EF4-FFF2-40B4-BE49-F238E27FC236}">
-                <a16:creationId xmlns:a16="http://schemas.microsoft.com/office/drawing/2014/main" id="{29E26319-6293-4CD2-9C66-4B3D7B8D477C}"/>
+                <a16:creationId xmlns:a16="http://schemas.microsoft.com/office/drawing/2014/main" id="{98D72619-9B68-464F-84D9-AB28BECCC168}"/>
               </a:ext>
             </a:extLst>
           </p:cNvPr>
@@ -7895,7 +7895,7 @@
     </p:spTree>
     <p:extLst>
       <p:ext uri="{BB962C8B-B14F-4D97-AF65-F5344CB8AC3E}">
-        <p14:creationId xmlns:p14="http://schemas.microsoft.com/office/powerpoint/2010/main" val="1926827395"/>
+        <p14:creationId xmlns:p14="http://schemas.microsoft.com/office/powerpoint/2010/main" val="702513032"/>
       </p:ext>
     </p:extLst>
   </p:cSld>
@@ -7926,7 +7926,7 @@
           <p:cNvPr id="12" name="course">
             <a:extLst xmlns:a="http://schemas.openxmlformats.org/drawingml/2006/main">
               <a:ext uri="{FF2B5EF4-FFF2-40B4-BE49-F238E27FC236}">
-                <a16:creationId xmlns:a16="http://schemas.microsoft.com/office/drawing/2014/main" id="{4EAD0A99-5345-4A62-BBBA-2802469303BE}"/>
+                <a16:creationId xmlns:a16="http://schemas.microsoft.com/office/drawing/2014/main" id="{B7EEA936-68ED-4F13-B233-D1DABD52A839}"/>
               </a:ext>
             </a:extLst>
           </p:cNvPr>
@@ -7983,7 +7983,7 @@
           <p:cNvPr id="2" name="title">
             <a:extLst xmlns:a="http://schemas.openxmlformats.org/drawingml/2006/main">
               <a:ext uri="{FF2B5EF4-FFF2-40B4-BE49-F238E27FC236}">
-                <a16:creationId xmlns:a16="http://schemas.microsoft.com/office/drawing/2014/main" id="{3C10501B-FCA6-4595-A418-09528490B6D5}"/>
+                <a16:creationId xmlns:a16="http://schemas.microsoft.com/office/drawing/2014/main" id="{2EA4A7EA-FCF1-4967-B490-4B7D15C7D143}"/>
               </a:ext>
             </a:extLst>
           </p:cNvPr>
@@ -8040,7 +8040,7 @@
           <p:cNvPr id="3" name="body">
             <a:extLst xmlns:a="http://schemas.openxmlformats.org/drawingml/2006/main">
               <a:ext uri="{FF2B5EF4-FFF2-40B4-BE49-F238E27FC236}">
-                <a16:creationId xmlns:a16="http://schemas.microsoft.com/office/drawing/2014/main" id="{54CC4319-CFB7-4895-AF11-EE65CEFA167D}"/>
+                <a16:creationId xmlns:a16="http://schemas.microsoft.com/office/drawing/2014/main" id="{4E0BD7B1-FE99-420D-AD5A-B30BE96CBFA1}"/>
               </a:ext>
             </a:extLst>
           </p:cNvPr>
@@ -8097,7 +8097,7 @@
           <p:cNvPr id="4" name="body">
             <a:extLst xmlns:a="http://schemas.openxmlformats.org/drawingml/2006/main">
               <a:ext uri="{FF2B5EF4-FFF2-40B4-BE49-F238E27FC236}">
-                <a16:creationId xmlns:a16="http://schemas.microsoft.com/office/drawing/2014/main" id="{636CAFCD-C405-40F9-87F1-84F909C11DED}"/>
+                <a16:creationId xmlns:a16="http://schemas.microsoft.com/office/drawing/2014/main" id="{5CB5F66D-85CF-454E-80B2-89DBD38737D8}"/>
               </a:ext>
             </a:extLst>
           </p:cNvPr>
@@ -8154,7 +8154,7 @@
           <p:cNvPr id="5" name="body">
             <a:extLst xmlns:a="http://schemas.openxmlformats.org/drawingml/2006/main">
               <a:ext uri="{FF2B5EF4-FFF2-40B4-BE49-F238E27FC236}">
-                <a16:creationId xmlns:a16="http://schemas.microsoft.com/office/drawing/2014/main" id="{A2E45B3E-73D0-4B27-8B2A-B50EC542A4D7}"/>
+                <a16:creationId xmlns:a16="http://schemas.microsoft.com/office/drawing/2014/main" id="{60C15628-806B-4C99-A7A9-E29A088DD5A0}"/>
               </a:ext>
             </a:extLst>
           </p:cNvPr>
@@ -8211,7 +8211,7 @@
           <p:cNvPr id="6" name="body">
             <a:extLst xmlns:a="http://schemas.openxmlformats.org/drawingml/2006/main">
               <a:ext uri="{FF2B5EF4-FFF2-40B4-BE49-F238E27FC236}">
-                <a16:creationId xmlns:a16="http://schemas.microsoft.com/office/drawing/2014/main" id="{7B9AE537-40E0-4C08-98A4-CCEC7199B524}"/>
+                <a16:creationId xmlns:a16="http://schemas.microsoft.com/office/drawing/2014/main" id="{66C454E8-6825-488E-93DF-047E892360D6}"/>
               </a:ext>
             </a:extLst>
           </p:cNvPr>
@@ -8268,7 +8268,7 @@
           <p:cNvPr id="7" name="body">
             <a:extLst xmlns:a="http://schemas.openxmlformats.org/drawingml/2006/main">
               <a:ext uri="{FF2B5EF4-FFF2-40B4-BE49-F238E27FC236}">
-                <a16:creationId xmlns:a16="http://schemas.microsoft.com/office/drawing/2014/main" id="{E0B641A1-858A-4D63-B0CC-8ACC23DB057F}"/>
+                <a16:creationId xmlns:a16="http://schemas.microsoft.com/office/drawing/2014/main" id="{76ADBC4B-DEFA-4E36-84E7-BE3E0A95FBE2}"/>
               </a:ext>
             </a:extLst>
           </p:cNvPr>
@@ -8325,7 +8325,7 @@
           <p:cNvPr id="8" name="body">
             <a:extLst xmlns:a="http://schemas.openxmlformats.org/drawingml/2006/main">
               <a:ext uri="{FF2B5EF4-FFF2-40B4-BE49-F238E27FC236}">
-                <a16:creationId xmlns:a16="http://schemas.microsoft.com/office/drawing/2014/main" id="{B22DDEFC-CAE3-4F06-B436-66E0C3C17066}"/>
+                <a16:creationId xmlns:a16="http://schemas.microsoft.com/office/drawing/2014/main" id="{8E0A9585-68E4-4828-ADF2-61E72A33900B}"/>
               </a:ext>
             </a:extLst>
           </p:cNvPr>
@@ -8382,7 +8382,7 @@
           <p:cNvPr id="9" name="equation">
             <a:extLst xmlns:a="http://schemas.openxmlformats.org/drawingml/2006/main">
               <a:ext uri="{FF2B5EF4-FFF2-40B4-BE49-F238E27FC236}">
-                <a16:creationId xmlns:a16="http://schemas.microsoft.com/office/drawing/2014/main" id="{7F63DE0A-6C52-45D6-B646-978382303161}"/>
+                <a16:creationId xmlns:a16="http://schemas.microsoft.com/office/drawing/2014/main" id="{E9971163-9595-424A-9BCF-D28A6E47F998}"/>
               </a:ext>
             </a:extLst>
           </p:cNvPr>
@@ -8439,7 +8439,7 @@
           <p:cNvPr id="10" name="footnote">
             <a:extLst xmlns:a="http://schemas.openxmlformats.org/drawingml/2006/main">
               <a:ext uri="{FF2B5EF4-FFF2-40B4-BE49-F238E27FC236}">
-                <a16:creationId xmlns:a16="http://schemas.microsoft.com/office/drawing/2014/main" id="{071B743D-8886-4974-8A31-0B49DEDB005C}"/>
+                <a16:creationId xmlns:a16="http://schemas.microsoft.com/office/drawing/2014/main" id="{39503B1F-E065-4ED4-8C5D-E8123D4CCB9A}"/>
               </a:ext>
             </a:extLst>
           </p:cNvPr>
@@ -8496,7 +8496,7 @@
           <p:cNvPr id="11" name="page">
             <a:extLst xmlns:a="http://schemas.openxmlformats.org/drawingml/2006/main">
               <a:ext uri="{FF2B5EF4-FFF2-40B4-BE49-F238E27FC236}">
-                <a16:creationId xmlns:a16="http://schemas.microsoft.com/office/drawing/2014/main" id="{4DB6BE75-8E11-486B-8F2E-069EDC746345}"/>
+                <a16:creationId xmlns:a16="http://schemas.microsoft.com/office/drawing/2014/main" id="{2493DFC1-898A-4EB3-9885-46CD04DCC47D}"/>
               </a:ext>
             </a:extLst>
           </p:cNvPr>
@@ -8551,7 +8551,7 @@
     </p:spTree>
     <p:extLst>
       <p:ext uri="{BB962C8B-B14F-4D97-AF65-F5344CB8AC3E}">
-        <p14:creationId xmlns:p14="http://schemas.microsoft.com/office/powerpoint/2010/main" val="1815403659"/>
+        <p14:creationId xmlns:p14="http://schemas.microsoft.com/office/powerpoint/2010/main" val="1870949367"/>
       </p:ext>
     </p:extLst>
   </p:cSld>
@@ -9282,7 +9282,7 @@
           <p:cNvPr id="6" name="course">
             <a:extLst xmlns:a="http://schemas.openxmlformats.org/drawingml/2006/main">
               <a:ext uri="{FF2B5EF4-FFF2-40B4-BE49-F238E27FC236}">
-                <a16:creationId xmlns:a16="http://schemas.microsoft.com/office/drawing/2014/main" id="{C6192054-1BA0-4EFB-879B-F8BFEFDAB03C}"/>
+                <a16:creationId xmlns:a16="http://schemas.microsoft.com/office/drawing/2014/main" id="{80A955ED-8416-4406-BF29-7F84C1AB12CA}"/>
               </a:ext>
             </a:extLst>
           </p:cNvPr>
@@ -9339,7 +9339,7 @@
           <p:cNvPr id="2" name="title">
             <a:extLst xmlns:a="http://schemas.openxmlformats.org/drawingml/2006/main">
               <a:ext uri="{FF2B5EF4-FFF2-40B4-BE49-F238E27FC236}">
-                <a16:creationId xmlns:a16="http://schemas.microsoft.com/office/drawing/2014/main" id="{847D46B3-87D8-4190-BE42-8A21F06E8A48}"/>
+                <a16:creationId xmlns:a16="http://schemas.microsoft.com/office/drawing/2014/main" id="{74A3C0E6-3B1A-4F4E-B36C-86DCBD91E6F2}"/>
               </a:ext>
             </a:extLst>
           </p:cNvPr>
@@ -10011,7 +10011,7 @@
           <p:cNvPr id="4" name="footnote">
             <a:extLst xmlns:a="http://schemas.openxmlformats.org/drawingml/2006/main">
               <a:ext uri="{FF2B5EF4-FFF2-40B4-BE49-F238E27FC236}">
-                <a16:creationId xmlns:a16="http://schemas.microsoft.com/office/drawing/2014/main" id="{1D8BAF0C-C1A3-4E0B-BBDD-3C1940817343}"/>
+                <a16:creationId xmlns:a16="http://schemas.microsoft.com/office/drawing/2014/main" id="{37305A25-E322-4ABA-91AA-B4F228A389A7}"/>
               </a:ext>
             </a:extLst>
           </p:cNvPr>
@@ -10068,7 +10068,7 @@
           <p:cNvPr id="5" name="page">
             <a:extLst xmlns:a="http://schemas.openxmlformats.org/drawingml/2006/main">
               <a:ext uri="{FF2B5EF4-FFF2-40B4-BE49-F238E27FC236}">
-                <a16:creationId xmlns:a16="http://schemas.microsoft.com/office/drawing/2014/main" id="{BBFBA63D-9294-477F-9622-D233937F486D}"/>
+                <a16:creationId xmlns:a16="http://schemas.microsoft.com/office/drawing/2014/main" id="{7C2643E0-2DA6-4BD3-BB30-48C25D82E4BA}"/>
               </a:ext>
             </a:extLst>
           </p:cNvPr>
@@ -10123,7 +10123,7 @@
     </p:spTree>
     <p:extLst>
       <p:ext uri="{BB962C8B-B14F-4D97-AF65-F5344CB8AC3E}">
-        <p14:creationId xmlns:p14="http://schemas.microsoft.com/office/powerpoint/2010/main" val="1931213787"/>
+        <p14:creationId xmlns:p14="http://schemas.microsoft.com/office/powerpoint/2010/main" val="1095551757"/>
       </p:ext>
     </p:extLst>
   </p:cSld>
@@ -10154,7 +10154,7 @@
           <p:cNvPr id="11" name="course">
             <a:extLst xmlns:a="http://schemas.openxmlformats.org/drawingml/2006/main">
               <a:ext uri="{FF2B5EF4-FFF2-40B4-BE49-F238E27FC236}">
-                <a16:creationId xmlns:a16="http://schemas.microsoft.com/office/drawing/2014/main" id="{1504556C-5D56-4685-81B9-981071B29D42}"/>
+                <a16:creationId xmlns:a16="http://schemas.microsoft.com/office/drawing/2014/main" id="{06746896-5E47-4666-B991-BFDA7C9997CC}"/>
               </a:ext>
             </a:extLst>
           </p:cNvPr>
@@ -10211,7 +10211,7 @@
           <p:cNvPr id="2" name="title">
             <a:extLst xmlns:a="http://schemas.openxmlformats.org/drawingml/2006/main">
               <a:ext uri="{FF2B5EF4-FFF2-40B4-BE49-F238E27FC236}">
-                <a16:creationId xmlns:a16="http://schemas.microsoft.com/office/drawing/2014/main" id="{C8A0F04D-F4AC-4076-ACFE-ED3E759DDF08}"/>
+                <a16:creationId xmlns:a16="http://schemas.microsoft.com/office/drawing/2014/main" id="{48F16CFD-0475-4E6F-B48D-AD7E7104FA5C}"/>
               </a:ext>
             </a:extLst>
           </p:cNvPr>
@@ -10268,7 +10268,7 @@
           <p:cNvPr id="3" name="body">
             <a:extLst xmlns:a="http://schemas.openxmlformats.org/drawingml/2006/main">
               <a:ext uri="{FF2B5EF4-FFF2-40B4-BE49-F238E27FC236}">
-                <a16:creationId xmlns:a16="http://schemas.microsoft.com/office/drawing/2014/main" id="{92027277-F1EF-48AE-AACE-A67092A6B106}"/>
+                <a16:creationId xmlns:a16="http://schemas.microsoft.com/office/drawing/2014/main" id="{4B642081-BCEA-4AB4-8D85-00EE6030C8AE}"/>
               </a:ext>
             </a:extLst>
           </p:cNvPr>
@@ -10325,7 +10325,7 @@
           <p:cNvPr id="4" name="body">
             <a:extLst xmlns:a="http://schemas.openxmlformats.org/drawingml/2006/main">
               <a:ext uri="{FF2B5EF4-FFF2-40B4-BE49-F238E27FC236}">
-                <a16:creationId xmlns:a16="http://schemas.microsoft.com/office/drawing/2014/main" id="{82ECC828-5DAD-472D-8248-9E1CF4CC128A}"/>
+                <a16:creationId xmlns:a16="http://schemas.microsoft.com/office/drawing/2014/main" id="{03BB7F13-2038-42CB-A2BE-78EA7C9D09B3}"/>
               </a:ext>
             </a:extLst>
           </p:cNvPr>
@@ -10382,7 +10382,7 @@
           <p:cNvPr id="5" name="body">
             <a:extLst xmlns:a="http://schemas.openxmlformats.org/drawingml/2006/main">
               <a:ext uri="{FF2B5EF4-FFF2-40B4-BE49-F238E27FC236}">
-                <a16:creationId xmlns:a16="http://schemas.microsoft.com/office/drawing/2014/main" id="{C2E8411A-94AF-4315-A4D2-F6A2621FEF1B}"/>
+                <a16:creationId xmlns:a16="http://schemas.microsoft.com/office/drawing/2014/main" id="{4056F6B3-C459-403A-8CC8-D714F31F14F2}"/>
               </a:ext>
             </a:extLst>
           </p:cNvPr>
@@ -10439,7 +10439,7 @@
           <p:cNvPr id="6" name="body">
             <a:extLst xmlns:a="http://schemas.openxmlformats.org/drawingml/2006/main">
               <a:ext uri="{FF2B5EF4-FFF2-40B4-BE49-F238E27FC236}">
-                <a16:creationId xmlns:a16="http://schemas.microsoft.com/office/drawing/2014/main" id="{095E5DC0-5F75-4880-92F2-9454668A07A2}"/>
+                <a16:creationId xmlns:a16="http://schemas.microsoft.com/office/drawing/2014/main" id="{2AB68C11-A5CB-431F-AED6-E1E2382225CC}"/>
               </a:ext>
             </a:extLst>
           </p:cNvPr>
@@ -10496,7 +10496,7 @@
           <p:cNvPr id="7" name="body">
             <a:extLst xmlns:a="http://schemas.openxmlformats.org/drawingml/2006/main">
               <a:ext uri="{FF2B5EF4-FFF2-40B4-BE49-F238E27FC236}">
-                <a16:creationId xmlns:a16="http://schemas.microsoft.com/office/drawing/2014/main" id="{8038B6EC-5E98-4A7E-83B0-7861D9A98F9F}"/>
+                <a16:creationId xmlns:a16="http://schemas.microsoft.com/office/drawing/2014/main" id="{A4896DC6-A265-49B2-B2AC-1998729622EA}"/>
               </a:ext>
             </a:extLst>
           </p:cNvPr>
@@ -10553,7 +10553,7 @@
           <p:cNvPr id="8" name="body">
             <a:extLst xmlns:a="http://schemas.openxmlformats.org/drawingml/2006/main">
               <a:ext uri="{FF2B5EF4-FFF2-40B4-BE49-F238E27FC236}">
-                <a16:creationId xmlns:a16="http://schemas.microsoft.com/office/drawing/2014/main" id="{F7B85265-C6BB-44DA-8E01-572BC30CAFEC}"/>
+                <a16:creationId xmlns:a16="http://schemas.microsoft.com/office/drawing/2014/main" id="{44AE66B2-39C1-4204-B8A3-D8A514B60AFC}"/>
               </a:ext>
             </a:extLst>
           </p:cNvPr>
@@ -10610,7 +10610,7 @@
           <p:cNvPr id="9" name="footnote">
             <a:extLst xmlns:a="http://schemas.openxmlformats.org/drawingml/2006/main">
               <a:ext uri="{FF2B5EF4-FFF2-40B4-BE49-F238E27FC236}">
-                <a16:creationId xmlns:a16="http://schemas.microsoft.com/office/drawing/2014/main" id="{1004D67C-59D8-420A-A78A-1396D76B1D4B}"/>
+                <a16:creationId xmlns:a16="http://schemas.microsoft.com/office/drawing/2014/main" id="{AC414F71-ED72-4E23-8F30-AD8758CD1E30}"/>
               </a:ext>
             </a:extLst>
           </p:cNvPr>
@@ -10667,7 +10667,7 @@
           <p:cNvPr id="10" name="page">
             <a:extLst xmlns:a="http://schemas.openxmlformats.org/drawingml/2006/main">
               <a:ext uri="{FF2B5EF4-FFF2-40B4-BE49-F238E27FC236}">
-                <a16:creationId xmlns:a16="http://schemas.microsoft.com/office/drawing/2014/main" id="{1BA12F4F-22F2-4426-9A5E-E23126241947}"/>
+                <a16:creationId xmlns:a16="http://schemas.microsoft.com/office/drawing/2014/main" id="{4A3EA71B-5086-40E1-8661-BD83AA105473}"/>
               </a:ext>
             </a:extLst>
           </p:cNvPr>
@@ -10722,7 +10722,7 @@
     </p:spTree>
     <p:extLst>
       <p:ext uri="{BB962C8B-B14F-4D97-AF65-F5344CB8AC3E}">
-        <p14:creationId xmlns:p14="http://schemas.microsoft.com/office/powerpoint/2010/main" val="1925327066"/>
+        <p14:creationId xmlns:p14="http://schemas.microsoft.com/office/powerpoint/2010/main" val="63661402"/>
       </p:ext>
     </p:extLst>
   </p:cSld>
@@ -10753,7 +10753,7 @@
           <p:cNvPr id="11" name="course">
             <a:extLst xmlns:a="http://schemas.openxmlformats.org/drawingml/2006/main">
               <a:ext uri="{FF2B5EF4-FFF2-40B4-BE49-F238E27FC236}">
-                <a16:creationId xmlns:a16="http://schemas.microsoft.com/office/drawing/2014/main" id="{4624631E-B8B2-42B0-82EC-FEDB0F9160F8}"/>
+                <a16:creationId xmlns:a16="http://schemas.microsoft.com/office/drawing/2014/main" id="{5B922324-0222-4CA2-BBBC-5B234AE742D9}"/>
               </a:ext>
             </a:extLst>
           </p:cNvPr>
@@ -10810,7 +10810,7 @@
           <p:cNvPr id="2" name="title">
             <a:extLst xmlns:a="http://schemas.openxmlformats.org/drawingml/2006/main">
               <a:ext uri="{FF2B5EF4-FFF2-40B4-BE49-F238E27FC236}">
-                <a16:creationId xmlns:a16="http://schemas.microsoft.com/office/drawing/2014/main" id="{9BEACCFF-6965-4870-B673-4CA500AF0E20}"/>
+                <a16:creationId xmlns:a16="http://schemas.microsoft.com/office/drawing/2014/main" id="{83F19C27-2036-40A9-8E11-B1EC948803C5}"/>
               </a:ext>
             </a:extLst>
           </p:cNvPr>
@@ -10867,7 +10867,7 @@
           <p:cNvPr id="3" name="body">
             <a:extLst xmlns:a="http://schemas.openxmlformats.org/drawingml/2006/main">
               <a:ext uri="{FF2B5EF4-FFF2-40B4-BE49-F238E27FC236}">
-                <a16:creationId xmlns:a16="http://schemas.microsoft.com/office/drawing/2014/main" id="{2B07CA68-BF96-4879-B47F-7C19D2A9F449}"/>
+                <a16:creationId xmlns:a16="http://schemas.microsoft.com/office/drawing/2014/main" id="{B9E4C854-0BC1-4891-85F9-E31E6AB30E95}"/>
               </a:ext>
             </a:extLst>
           </p:cNvPr>
@@ -10924,7 +10924,7 @@
           <p:cNvPr id="4" name="body">
             <a:extLst xmlns:a="http://schemas.openxmlformats.org/drawingml/2006/main">
               <a:ext uri="{FF2B5EF4-FFF2-40B4-BE49-F238E27FC236}">
-                <a16:creationId xmlns:a16="http://schemas.microsoft.com/office/drawing/2014/main" id="{250620CD-3131-43B9-BA73-05252128D70F}"/>
+                <a16:creationId xmlns:a16="http://schemas.microsoft.com/office/drawing/2014/main" id="{70C34988-B754-4D4F-B924-58E48F0C90B9}"/>
               </a:ext>
             </a:extLst>
           </p:cNvPr>
@@ -10981,7 +10981,7 @@
           <p:cNvPr id="5" name="body">
             <a:extLst xmlns:a="http://schemas.openxmlformats.org/drawingml/2006/main">
               <a:ext uri="{FF2B5EF4-FFF2-40B4-BE49-F238E27FC236}">
-                <a16:creationId xmlns:a16="http://schemas.microsoft.com/office/drawing/2014/main" id="{C18FD98E-ACF3-4280-BA6E-DE3765D34780}"/>
+                <a16:creationId xmlns:a16="http://schemas.microsoft.com/office/drawing/2014/main" id="{CC16BF18-8309-4AB9-A77A-05D5FF182D00}"/>
               </a:ext>
             </a:extLst>
           </p:cNvPr>
@@ -11038,7 +11038,7 @@
           <p:cNvPr id="6" name="body">
             <a:extLst xmlns:a="http://schemas.openxmlformats.org/drawingml/2006/main">
               <a:ext uri="{FF2B5EF4-FFF2-40B4-BE49-F238E27FC236}">
-                <a16:creationId xmlns:a16="http://schemas.microsoft.com/office/drawing/2014/main" id="{C87644E3-3EDA-4812-B2D9-14C2346E173A}"/>
+                <a16:creationId xmlns:a16="http://schemas.microsoft.com/office/drawing/2014/main" id="{57AFBA50-8646-4CC9-8C96-5D411E29D19F}"/>
               </a:ext>
             </a:extLst>
           </p:cNvPr>
@@ -11095,7 +11095,7 @@
           <p:cNvPr id="7" name="body">
             <a:extLst xmlns:a="http://schemas.openxmlformats.org/drawingml/2006/main">
               <a:ext uri="{FF2B5EF4-FFF2-40B4-BE49-F238E27FC236}">
-                <a16:creationId xmlns:a16="http://schemas.microsoft.com/office/drawing/2014/main" id="{D78A05CB-46B9-4E80-986D-B743E6F188E9}"/>
+                <a16:creationId xmlns:a16="http://schemas.microsoft.com/office/drawing/2014/main" id="{64B9EB4C-C389-498A-AE8E-450B5EF1A204}"/>
               </a:ext>
             </a:extLst>
           </p:cNvPr>
@@ -11152,7 +11152,7 @@
           <p:cNvPr id="8" name="body">
             <a:extLst xmlns:a="http://schemas.openxmlformats.org/drawingml/2006/main">
               <a:ext uri="{FF2B5EF4-FFF2-40B4-BE49-F238E27FC236}">
-                <a16:creationId xmlns:a16="http://schemas.microsoft.com/office/drawing/2014/main" id="{3153D85B-3EEB-493D-A1FA-ED582DCD6359}"/>
+                <a16:creationId xmlns:a16="http://schemas.microsoft.com/office/drawing/2014/main" id="{EEF693C5-1F79-4203-8191-C47235FC25DF}"/>
               </a:ext>
             </a:extLst>
           </p:cNvPr>
@@ -11209,7 +11209,7 @@
           <p:cNvPr id="9" name="footnote">
             <a:extLst xmlns:a="http://schemas.openxmlformats.org/drawingml/2006/main">
               <a:ext uri="{FF2B5EF4-FFF2-40B4-BE49-F238E27FC236}">
-                <a16:creationId xmlns:a16="http://schemas.microsoft.com/office/drawing/2014/main" id="{D66D2984-80B6-4586-A60C-20CE9E1AA413}"/>
+                <a16:creationId xmlns:a16="http://schemas.microsoft.com/office/drawing/2014/main" id="{48BEAA49-FE74-4F98-BD1F-F4AEAE026ACC}"/>
               </a:ext>
             </a:extLst>
           </p:cNvPr>
@@ -11266,7 +11266,7 @@
           <p:cNvPr id="10" name="page">
             <a:extLst xmlns:a="http://schemas.openxmlformats.org/drawingml/2006/main">
               <a:ext uri="{FF2B5EF4-FFF2-40B4-BE49-F238E27FC236}">
-                <a16:creationId xmlns:a16="http://schemas.microsoft.com/office/drawing/2014/main" id="{AAE9E135-E335-43DB-B38E-72075FA62214}"/>
+                <a16:creationId xmlns:a16="http://schemas.microsoft.com/office/drawing/2014/main" id="{48FE5ED1-D22B-4B2A-BB6A-0149AACC5DA8}"/>
               </a:ext>
             </a:extLst>
           </p:cNvPr>
@@ -11321,7 +11321,7 @@
     </p:spTree>
     <p:extLst>
       <p:ext uri="{BB962C8B-B14F-4D97-AF65-F5344CB8AC3E}">
-        <p14:creationId xmlns:p14="http://schemas.microsoft.com/office/powerpoint/2010/main" val="621956937"/>
+        <p14:creationId xmlns:p14="http://schemas.microsoft.com/office/powerpoint/2010/main" val="930703595"/>
       </p:ext>
     </p:extLst>
   </p:cSld>
@@ -11352,7 +11352,7 @@
           <p:cNvPr id="11" name="course">
             <a:extLst xmlns:a="http://schemas.openxmlformats.org/drawingml/2006/main">
               <a:ext uri="{FF2B5EF4-FFF2-40B4-BE49-F238E27FC236}">
-                <a16:creationId xmlns:a16="http://schemas.microsoft.com/office/drawing/2014/main" id="{E0B4D54F-FCBA-4838-98D1-7F6128ABEB62}"/>
+                <a16:creationId xmlns:a16="http://schemas.microsoft.com/office/drawing/2014/main" id="{769A67D4-789C-4BAA-898A-119940B76398}"/>
               </a:ext>
             </a:extLst>
           </p:cNvPr>
@@ -11409,7 +11409,7 @@
           <p:cNvPr id="2" name="title">
             <a:extLst xmlns:a="http://schemas.openxmlformats.org/drawingml/2006/main">
               <a:ext uri="{FF2B5EF4-FFF2-40B4-BE49-F238E27FC236}">
-                <a16:creationId xmlns:a16="http://schemas.microsoft.com/office/drawing/2014/main" id="{3EBA9A3D-7BCE-446C-82AB-CC024E5BBC11}"/>
+                <a16:creationId xmlns:a16="http://schemas.microsoft.com/office/drawing/2014/main" id="{A85CD9F7-B351-45E4-AE27-CB2E79586093}"/>
               </a:ext>
             </a:extLst>
           </p:cNvPr>
@@ -11466,7 +11466,7 @@
           <p:cNvPr id="3" name="body">
             <a:extLst xmlns:a="http://schemas.openxmlformats.org/drawingml/2006/main">
               <a:ext uri="{FF2B5EF4-FFF2-40B4-BE49-F238E27FC236}">
-                <a16:creationId xmlns:a16="http://schemas.microsoft.com/office/drawing/2014/main" id="{21A2EBB6-D5E9-4E6F-A453-60E8610BF7B8}"/>
+                <a16:creationId xmlns:a16="http://schemas.microsoft.com/office/drawing/2014/main" id="{6F6AB507-C7EF-40BD-A575-8983850375F3}"/>
               </a:ext>
             </a:extLst>
           </p:cNvPr>
@@ -11523,7 +11523,7 @@
           <p:cNvPr id="4" name="body">
             <a:extLst xmlns:a="http://schemas.openxmlformats.org/drawingml/2006/main">
               <a:ext uri="{FF2B5EF4-FFF2-40B4-BE49-F238E27FC236}">
-                <a16:creationId xmlns:a16="http://schemas.microsoft.com/office/drawing/2014/main" id="{A5D98C37-1B46-455A-97D3-7B614E869D31}"/>
+                <a16:creationId xmlns:a16="http://schemas.microsoft.com/office/drawing/2014/main" id="{C551174B-7169-4E33-AFB5-2063D810F07C}"/>
               </a:ext>
             </a:extLst>
           </p:cNvPr>
@@ -11580,7 +11580,7 @@
           <p:cNvPr id="5" name="body">
             <a:extLst xmlns:a="http://schemas.openxmlformats.org/drawingml/2006/main">
               <a:ext uri="{FF2B5EF4-FFF2-40B4-BE49-F238E27FC236}">
-                <a16:creationId xmlns:a16="http://schemas.microsoft.com/office/drawing/2014/main" id="{E2383752-AD6C-4BB1-B12E-B03104EF38C7}"/>
+                <a16:creationId xmlns:a16="http://schemas.microsoft.com/office/drawing/2014/main" id="{9720DE92-0082-4185-BC06-2471961275A4}"/>
               </a:ext>
             </a:extLst>
           </p:cNvPr>
@@ -11637,7 +11637,7 @@
           <p:cNvPr id="6" name="body">
             <a:extLst xmlns:a="http://schemas.openxmlformats.org/drawingml/2006/main">
               <a:ext uri="{FF2B5EF4-FFF2-40B4-BE49-F238E27FC236}">
-                <a16:creationId xmlns:a16="http://schemas.microsoft.com/office/drawing/2014/main" id="{CEE0C4DF-0257-4CA2-8532-1BC4DAD2DD29}"/>
+                <a16:creationId xmlns:a16="http://schemas.microsoft.com/office/drawing/2014/main" id="{12C63E68-6716-4AA9-AAEB-7FAB634D4D1F}"/>
               </a:ext>
             </a:extLst>
           </p:cNvPr>
@@ -11694,7 +11694,7 @@
           <p:cNvPr id="7" name="body">
             <a:extLst xmlns:a="http://schemas.openxmlformats.org/drawingml/2006/main">
               <a:ext uri="{FF2B5EF4-FFF2-40B4-BE49-F238E27FC236}">
-                <a16:creationId xmlns:a16="http://schemas.microsoft.com/office/drawing/2014/main" id="{FE95E114-792A-4509-9E3C-1248D1BEBC18}"/>
+                <a16:creationId xmlns:a16="http://schemas.microsoft.com/office/drawing/2014/main" id="{72351866-76ED-45AE-B7D1-ED53E4618406}"/>
               </a:ext>
             </a:extLst>
           </p:cNvPr>
@@ -11751,7 +11751,7 @@
           <p:cNvPr id="8" name="body">
             <a:extLst xmlns:a="http://schemas.openxmlformats.org/drawingml/2006/main">
               <a:ext uri="{FF2B5EF4-FFF2-40B4-BE49-F238E27FC236}">
-                <a16:creationId xmlns:a16="http://schemas.microsoft.com/office/drawing/2014/main" id="{EAA2EADB-BF21-4EC1-91D7-D027629EAAC8}"/>
+                <a16:creationId xmlns:a16="http://schemas.microsoft.com/office/drawing/2014/main" id="{B01BEC06-D256-4A15-A10A-D7D0A5B7F5DE}"/>
               </a:ext>
             </a:extLst>
           </p:cNvPr>
@@ -11808,7 +11808,7 @@
           <p:cNvPr id="9" name="footnote">
             <a:extLst xmlns:a="http://schemas.openxmlformats.org/drawingml/2006/main">
               <a:ext uri="{FF2B5EF4-FFF2-40B4-BE49-F238E27FC236}">
-                <a16:creationId xmlns:a16="http://schemas.microsoft.com/office/drawing/2014/main" id="{D2B855C1-0262-452E-B9B4-89641F80E12D}"/>
+                <a16:creationId xmlns:a16="http://schemas.microsoft.com/office/drawing/2014/main" id="{86C01F23-BA6F-42E5-8D7B-0326C98C2669}"/>
               </a:ext>
             </a:extLst>
           </p:cNvPr>
@@ -11865,7 +11865,7 @@
           <p:cNvPr id="10" name="page">
             <a:extLst xmlns:a="http://schemas.openxmlformats.org/drawingml/2006/main">
               <a:ext uri="{FF2B5EF4-FFF2-40B4-BE49-F238E27FC236}">
-                <a16:creationId xmlns:a16="http://schemas.microsoft.com/office/drawing/2014/main" id="{9C8FB154-2D3D-435B-8C6A-87E47C85550A}"/>
+                <a16:creationId xmlns:a16="http://schemas.microsoft.com/office/drawing/2014/main" id="{E0F2CEED-1704-4101-A2AE-39DA385876AD}"/>
               </a:ext>
             </a:extLst>
           </p:cNvPr>
@@ -11920,7 +11920,7 @@
     </p:spTree>
     <p:extLst>
       <p:ext uri="{BB962C8B-B14F-4D97-AF65-F5344CB8AC3E}">
-        <p14:creationId xmlns:p14="http://schemas.microsoft.com/office/powerpoint/2010/main" val="544892399"/>
+        <p14:creationId xmlns:p14="http://schemas.microsoft.com/office/powerpoint/2010/main" val="2133497494"/>
       </p:ext>
     </p:extLst>
   </p:cSld>
@@ -13641,7 +13641,7 @@
           <p:cNvPr id="6" name="course">
             <a:extLst xmlns:a="http://schemas.openxmlformats.org/drawingml/2006/main">
               <a:ext uri="{FF2B5EF4-FFF2-40B4-BE49-F238E27FC236}">
-                <a16:creationId xmlns:a16="http://schemas.microsoft.com/office/drawing/2014/main" id="{F5743900-DD16-4BDE-AE4B-ADE1B9328C45}"/>
+                <a16:creationId xmlns:a16="http://schemas.microsoft.com/office/drawing/2014/main" id="{928AA55C-DDA0-4139-88B7-6F95E763DE4A}"/>
               </a:ext>
             </a:extLst>
           </p:cNvPr>
@@ -13698,7 +13698,7 @@
           <p:cNvPr id="2" name="title">
             <a:extLst xmlns:a="http://schemas.openxmlformats.org/drawingml/2006/main">
               <a:ext uri="{FF2B5EF4-FFF2-40B4-BE49-F238E27FC236}">
-                <a16:creationId xmlns:a16="http://schemas.microsoft.com/office/drawing/2014/main" id="{10647508-1CF3-4393-B1D0-58D49CF2B122}"/>
+                <a16:creationId xmlns:a16="http://schemas.microsoft.com/office/drawing/2014/main" id="{A59720AB-CD24-4C8D-AEA7-92F8D51EFC04}"/>
               </a:ext>
             </a:extLst>
           </p:cNvPr>
@@ -13762,7 +13762,7 @@
         </p:xfrm>
         <a:graphic xmlns:a="http://schemas.openxmlformats.org/drawingml/2006/main">
           <a:graphicData uri="http://schemas.openxmlformats.org/drawingml/2006/chart">
-            <c:chart xmlns:r="http://schemas.openxmlformats.org/officeDocument/2006/relationships" xmlns:c="http://schemas.openxmlformats.org/drawingml/2006/chart" r:id="Rd7b6ffee66fb4fcb"/>
+            <c:chart xmlns:r="http://schemas.openxmlformats.org/officeDocument/2006/relationships" xmlns:c="http://schemas.openxmlformats.org/drawingml/2006/chart" r:id="Rd44ab79741a7453d"/>
           </a:graphicData>
         </a:graphic>
       </p:graphicFrame>
@@ -13771,7 +13771,7 @@
           <p:cNvPr id="4" name="footnote">
             <a:extLst xmlns:a="http://schemas.openxmlformats.org/drawingml/2006/main">
               <a:ext uri="{FF2B5EF4-FFF2-40B4-BE49-F238E27FC236}">
-                <a16:creationId xmlns:a16="http://schemas.microsoft.com/office/drawing/2014/main" id="{168982A3-DDDA-4E25-8DCC-E7A688E5FCD2}"/>
+                <a16:creationId xmlns:a16="http://schemas.microsoft.com/office/drawing/2014/main" id="{81200E07-CE69-4EFF-936D-9221A35F4A3C}"/>
               </a:ext>
             </a:extLst>
           </p:cNvPr>
@@ -13828,7 +13828,7 @@
           <p:cNvPr id="5" name="page">
             <a:extLst xmlns:a="http://schemas.openxmlformats.org/drawingml/2006/main">
               <a:ext uri="{FF2B5EF4-FFF2-40B4-BE49-F238E27FC236}">
-                <a16:creationId xmlns:a16="http://schemas.microsoft.com/office/drawing/2014/main" id="{0CDC4DAB-72A7-40BA-8010-DBB8CC0BE1E2}"/>
+                <a16:creationId xmlns:a16="http://schemas.microsoft.com/office/drawing/2014/main" id="{D04119ED-736F-43CC-BF77-57E87D7B7715}"/>
               </a:ext>
             </a:extLst>
           </p:cNvPr>
@@ -13883,7 +13883,7 @@
     </p:spTree>
     <p:extLst>
       <p:ext uri="{BB962C8B-B14F-4D97-AF65-F5344CB8AC3E}">
-        <p14:creationId xmlns:p14="http://schemas.microsoft.com/office/powerpoint/2010/main" val="487044912"/>
+        <p14:creationId xmlns:p14="http://schemas.microsoft.com/office/powerpoint/2010/main" val="507763883"/>
       </p:ext>
     </p:extLst>
   </p:cSld>
@@ -13914,7 +13914,7 @@
           <p:cNvPr id="12" name="course">
             <a:extLst xmlns:a="http://schemas.openxmlformats.org/drawingml/2006/main">
               <a:ext uri="{FF2B5EF4-FFF2-40B4-BE49-F238E27FC236}">
-                <a16:creationId xmlns:a16="http://schemas.microsoft.com/office/drawing/2014/main" id="{6EC65682-A0E0-4C34-A58D-709CFB333DD8}"/>
+                <a16:creationId xmlns:a16="http://schemas.microsoft.com/office/drawing/2014/main" id="{8161CDFC-C716-4030-AA54-9FD8F0A463A1}"/>
               </a:ext>
             </a:extLst>
           </p:cNvPr>
@@ -13971,7 +13971,7 @@
           <p:cNvPr id="2" name="title">
             <a:extLst xmlns:a="http://schemas.openxmlformats.org/drawingml/2006/main">
               <a:ext uri="{FF2B5EF4-FFF2-40B4-BE49-F238E27FC236}">
-                <a16:creationId xmlns:a16="http://schemas.microsoft.com/office/drawing/2014/main" id="{FB9B1A77-0EF0-4D9A-9F25-3F364EBE54FD}"/>
+                <a16:creationId xmlns:a16="http://schemas.microsoft.com/office/drawing/2014/main" id="{DAB3CDFA-0738-425D-828C-E743A3568020}"/>
               </a:ext>
             </a:extLst>
           </p:cNvPr>
@@ -14028,7 +14028,7 @@
           <p:cNvPr id="3" name="body">
             <a:extLst xmlns:a="http://schemas.openxmlformats.org/drawingml/2006/main">
               <a:ext uri="{FF2B5EF4-FFF2-40B4-BE49-F238E27FC236}">
-                <a16:creationId xmlns:a16="http://schemas.microsoft.com/office/drawing/2014/main" id="{5030DCA5-0E9C-4361-B60D-619E8D050834}"/>
+                <a16:creationId xmlns:a16="http://schemas.microsoft.com/office/drawing/2014/main" id="{BD754908-6B7C-4A2C-9BA4-B6F16CB90A94}"/>
               </a:ext>
             </a:extLst>
           </p:cNvPr>
@@ -14085,7 +14085,7 @@
           <p:cNvPr id="4" name="body">
             <a:extLst xmlns:a="http://schemas.openxmlformats.org/drawingml/2006/main">
               <a:ext uri="{FF2B5EF4-FFF2-40B4-BE49-F238E27FC236}">
-                <a16:creationId xmlns:a16="http://schemas.microsoft.com/office/drawing/2014/main" id="{A70ACF6D-BB59-48F0-A2F9-3E943638BDBC}"/>
+                <a16:creationId xmlns:a16="http://schemas.microsoft.com/office/drawing/2014/main" id="{8057F0A9-332C-49B6-92BC-69B2805554F8}"/>
               </a:ext>
             </a:extLst>
           </p:cNvPr>
@@ -14142,7 +14142,7 @@
           <p:cNvPr id="5" name="body">
             <a:extLst xmlns:a="http://schemas.openxmlformats.org/drawingml/2006/main">
               <a:ext uri="{FF2B5EF4-FFF2-40B4-BE49-F238E27FC236}">
-                <a16:creationId xmlns:a16="http://schemas.microsoft.com/office/drawing/2014/main" id="{1646185C-2CAD-4A0A-A8BC-7178FAAA301E}"/>
+                <a16:creationId xmlns:a16="http://schemas.microsoft.com/office/drawing/2014/main" id="{CAF0CB36-70C4-4D3A-B3CC-C56486164987}"/>
               </a:ext>
             </a:extLst>
           </p:cNvPr>
@@ -14199,7 +14199,7 @@
           <p:cNvPr id="6" name="body">
             <a:extLst xmlns:a="http://schemas.openxmlformats.org/drawingml/2006/main">
               <a:ext uri="{FF2B5EF4-FFF2-40B4-BE49-F238E27FC236}">
-                <a16:creationId xmlns:a16="http://schemas.microsoft.com/office/drawing/2014/main" id="{EDAFD10D-9022-4756-8CAE-DC7541263098}"/>
+                <a16:creationId xmlns:a16="http://schemas.microsoft.com/office/drawing/2014/main" id="{2DA43C52-2FCB-437F-9668-16551DE8447A}"/>
               </a:ext>
             </a:extLst>
           </p:cNvPr>
@@ -14256,7 +14256,7 @@
           <p:cNvPr id="7" name="body">
             <a:extLst xmlns:a="http://schemas.openxmlformats.org/drawingml/2006/main">
               <a:ext uri="{FF2B5EF4-FFF2-40B4-BE49-F238E27FC236}">
-                <a16:creationId xmlns:a16="http://schemas.microsoft.com/office/drawing/2014/main" id="{A4C7EDD2-EB39-40AE-BEC4-2B0E705EE49D}"/>
+                <a16:creationId xmlns:a16="http://schemas.microsoft.com/office/drawing/2014/main" id="{82732CA7-46E0-4131-AB42-5725A9383B71}"/>
               </a:ext>
             </a:extLst>
           </p:cNvPr>
@@ -14313,7 +14313,7 @@
           <p:cNvPr id="8" name="body">
             <a:extLst xmlns:a="http://schemas.openxmlformats.org/drawingml/2006/main">
               <a:ext uri="{FF2B5EF4-FFF2-40B4-BE49-F238E27FC236}">
-                <a16:creationId xmlns:a16="http://schemas.microsoft.com/office/drawing/2014/main" id="{1D9A5070-94E0-4ADE-B63C-9C504AD46A31}"/>
+                <a16:creationId xmlns:a16="http://schemas.microsoft.com/office/drawing/2014/main" id="{925587AF-B1C1-4049-8757-48DE351B5F51}"/>
               </a:ext>
             </a:extLst>
           </p:cNvPr>
@@ -14370,7 +14370,7 @@
           <p:cNvPr id="9" name="equation">
             <a:extLst xmlns:a="http://schemas.openxmlformats.org/drawingml/2006/main">
               <a:ext uri="{FF2B5EF4-FFF2-40B4-BE49-F238E27FC236}">
-                <a16:creationId xmlns:a16="http://schemas.microsoft.com/office/drawing/2014/main" id="{7BDCC1DF-9130-4376-8203-8D731CD4AB07}"/>
+                <a16:creationId xmlns:a16="http://schemas.microsoft.com/office/drawing/2014/main" id="{BB0D843C-60DB-498A-8222-352A571725A4}"/>
               </a:ext>
             </a:extLst>
           </p:cNvPr>
@@ -14427,7 +14427,7 @@
           <p:cNvPr id="10" name="footnote">
             <a:extLst xmlns:a="http://schemas.openxmlformats.org/drawingml/2006/main">
               <a:ext uri="{FF2B5EF4-FFF2-40B4-BE49-F238E27FC236}">
-                <a16:creationId xmlns:a16="http://schemas.microsoft.com/office/drawing/2014/main" id="{618DBC81-AE0F-46C7-9AF1-2A65F1E550DF}"/>
+                <a16:creationId xmlns:a16="http://schemas.microsoft.com/office/drawing/2014/main" id="{7816E62E-FE8E-4EF8-821A-25194CF9EFBE}"/>
               </a:ext>
             </a:extLst>
           </p:cNvPr>
@@ -14484,7 +14484,7 @@
           <p:cNvPr id="11" name="page">
             <a:extLst xmlns:a="http://schemas.openxmlformats.org/drawingml/2006/main">
               <a:ext uri="{FF2B5EF4-FFF2-40B4-BE49-F238E27FC236}">
-                <a16:creationId xmlns:a16="http://schemas.microsoft.com/office/drawing/2014/main" id="{61035652-CA62-47B0-92FA-68704A99508D}"/>
+                <a16:creationId xmlns:a16="http://schemas.microsoft.com/office/drawing/2014/main" id="{27BA20E1-4D3E-4B3D-ACFF-2F2FC54C79AE}"/>
               </a:ext>
             </a:extLst>
           </p:cNvPr>
@@ -14539,7 +14539,7 @@
     </p:spTree>
     <p:extLst>
       <p:ext uri="{BB962C8B-B14F-4D97-AF65-F5344CB8AC3E}">
-        <p14:creationId xmlns:p14="http://schemas.microsoft.com/office/powerpoint/2010/main" val="1673958844"/>
+        <p14:creationId xmlns:p14="http://schemas.microsoft.com/office/powerpoint/2010/main" val="575169669"/>
       </p:ext>
     </p:extLst>
   </p:cSld>
@@ -14570,7 +14570,7 @@
           <p:cNvPr id="12" name="course">
             <a:extLst xmlns:a="http://schemas.openxmlformats.org/drawingml/2006/main">
               <a:ext uri="{FF2B5EF4-FFF2-40B4-BE49-F238E27FC236}">
-                <a16:creationId xmlns:a16="http://schemas.microsoft.com/office/drawing/2014/main" id="{ED09C6D8-B643-41A6-85C3-35A4A53DFC7E}"/>
+                <a16:creationId xmlns:a16="http://schemas.microsoft.com/office/drawing/2014/main" id="{8BA42F86-4D3A-4816-ADA9-F907F28FD974}"/>
               </a:ext>
             </a:extLst>
           </p:cNvPr>
@@ -14627,7 +14627,7 @@
           <p:cNvPr id="2" name="title">
             <a:extLst xmlns:a="http://schemas.openxmlformats.org/drawingml/2006/main">
               <a:ext uri="{FF2B5EF4-FFF2-40B4-BE49-F238E27FC236}">
-                <a16:creationId xmlns:a16="http://schemas.microsoft.com/office/drawing/2014/main" id="{AF7D627D-27CF-43A4-970C-088754E48CD5}"/>
+                <a16:creationId xmlns:a16="http://schemas.microsoft.com/office/drawing/2014/main" id="{53A1F7B3-4CB7-4BFF-B0A5-48DA94E118B1}"/>
               </a:ext>
             </a:extLst>
           </p:cNvPr>
@@ -14684,7 +14684,7 @@
           <p:cNvPr id="3" name="body">
             <a:extLst xmlns:a="http://schemas.openxmlformats.org/drawingml/2006/main">
               <a:ext uri="{FF2B5EF4-FFF2-40B4-BE49-F238E27FC236}">
-                <a16:creationId xmlns:a16="http://schemas.microsoft.com/office/drawing/2014/main" id="{5CA114C1-E12E-4D50-9A7B-E2DCF6D67BAE}"/>
+                <a16:creationId xmlns:a16="http://schemas.microsoft.com/office/drawing/2014/main" id="{B0026F2F-E8A8-49A5-9520-F04CE0CB8431}"/>
               </a:ext>
             </a:extLst>
           </p:cNvPr>
@@ -14741,7 +14741,7 @@
           <p:cNvPr id="4" name="body">
             <a:extLst xmlns:a="http://schemas.openxmlformats.org/drawingml/2006/main">
               <a:ext uri="{FF2B5EF4-FFF2-40B4-BE49-F238E27FC236}">
-                <a16:creationId xmlns:a16="http://schemas.microsoft.com/office/drawing/2014/main" id="{3775C266-A5B6-4706-9AD1-61E32621AFA6}"/>
+                <a16:creationId xmlns:a16="http://schemas.microsoft.com/office/drawing/2014/main" id="{4DA5D039-7695-46E6-9C77-7C7AF704BF60}"/>
               </a:ext>
             </a:extLst>
           </p:cNvPr>
@@ -14798,7 +14798,7 @@
           <p:cNvPr id="5" name="body">
             <a:extLst xmlns:a="http://schemas.openxmlformats.org/drawingml/2006/main">
               <a:ext uri="{FF2B5EF4-FFF2-40B4-BE49-F238E27FC236}">
-                <a16:creationId xmlns:a16="http://schemas.microsoft.com/office/drawing/2014/main" id="{557CD676-3286-421F-9499-8AD7D34FB7DE}"/>
+                <a16:creationId xmlns:a16="http://schemas.microsoft.com/office/drawing/2014/main" id="{6AB0C00D-B041-4405-9857-DC8BBD36F2C6}"/>
               </a:ext>
             </a:extLst>
           </p:cNvPr>
@@ -14855,7 +14855,7 @@
           <p:cNvPr id="6" name="body">
             <a:extLst xmlns:a="http://schemas.openxmlformats.org/drawingml/2006/main">
               <a:ext uri="{FF2B5EF4-FFF2-40B4-BE49-F238E27FC236}">
-                <a16:creationId xmlns:a16="http://schemas.microsoft.com/office/drawing/2014/main" id="{717AF9C5-0D8A-484E-9E96-1FD3A3901A1B}"/>
+                <a16:creationId xmlns:a16="http://schemas.microsoft.com/office/drawing/2014/main" id="{3643D2D6-BAC5-458E-AA70-9BE57BC8EFF2}"/>
               </a:ext>
             </a:extLst>
           </p:cNvPr>
@@ -14912,7 +14912,7 @@
           <p:cNvPr id="7" name="body">
             <a:extLst xmlns:a="http://schemas.openxmlformats.org/drawingml/2006/main">
               <a:ext uri="{FF2B5EF4-FFF2-40B4-BE49-F238E27FC236}">
-                <a16:creationId xmlns:a16="http://schemas.microsoft.com/office/drawing/2014/main" id="{A689D6F8-0137-4DFF-AA7E-169A390AA15F}"/>
+                <a16:creationId xmlns:a16="http://schemas.microsoft.com/office/drawing/2014/main" id="{7DFAD015-86EF-4C35-8CFA-0B60DE7742B8}"/>
               </a:ext>
             </a:extLst>
           </p:cNvPr>
@@ -14969,7 +14969,7 @@
           <p:cNvPr id="8" name="body">
             <a:extLst xmlns:a="http://schemas.openxmlformats.org/drawingml/2006/main">
               <a:ext uri="{FF2B5EF4-FFF2-40B4-BE49-F238E27FC236}">
-                <a16:creationId xmlns:a16="http://schemas.microsoft.com/office/drawing/2014/main" id="{5675FEDA-33FA-4660-9235-2821E274F1CC}"/>
+                <a16:creationId xmlns:a16="http://schemas.microsoft.com/office/drawing/2014/main" id="{2CDCA17F-516A-4579-A554-1E53F3FAC535}"/>
               </a:ext>
             </a:extLst>
           </p:cNvPr>
@@ -15026,7 +15026,7 @@
           <p:cNvPr id="9" name="equation">
             <a:extLst xmlns:a="http://schemas.openxmlformats.org/drawingml/2006/main">
               <a:ext uri="{FF2B5EF4-FFF2-40B4-BE49-F238E27FC236}">
-                <a16:creationId xmlns:a16="http://schemas.microsoft.com/office/drawing/2014/main" id="{3A85C9B6-423C-4034-A019-0E9EA09CD9C6}"/>
+                <a16:creationId xmlns:a16="http://schemas.microsoft.com/office/drawing/2014/main" id="{B9E5EEAD-855B-46E6-AD0A-6316FE87C6AD}"/>
               </a:ext>
             </a:extLst>
           </p:cNvPr>
@@ -15083,7 +15083,7 @@
           <p:cNvPr id="10" name="footnote">
             <a:extLst xmlns:a="http://schemas.openxmlformats.org/drawingml/2006/main">
               <a:ext uri="{FF2B5EF4-FFF2-40B4-BE49-F238E27FC236}">
-                <a16:creationId xmlns:a16="http://schemas.microsoft.com/office/drawing/2014/main" id="{F470047A-06F5-4151-8678-2AB66C1C6DF4}"/>
+                <a16:creationId xmlns:a16="http://schemas.microsoft.com/office/drawing/2014/main" id="{7F9FAA2E-2184-42B1-9144-53D1A2FD34DC}"/>
               </a:ext>
             </a:extLst>
           </p:cNvPr>
@@ -15140,7 +15140,7 @@
           <p:cNvPr id="11" name="page">
             <a:extLst xmlns:a="http://schemas.openxmlformats.org/drawingml/2006/main">
               <a:ext uri="{FF2B5EF4-FFF2-40B4-BE49-F238E27FC236}">
-                <a16:creationId xmlns:a16="http://schemas.microsoft.com/office/drawing/2014/main" id="{E86CF023-EBC1-43AE-8038-0877C572AC6B}"/>
+                <a16:creationId xmlns:a16="http://schemas.microsoft.com/office/drawing/2014/main" id="{13C65843-E0C5-4604-AA6D-A317248C7BCC}"/>
               </a:ext>
             </a:extLst>
           </p:cNvPr>
@@ -15195,7 +15195,7 @@
     </p:spTree>
     <p:extLst>
       <p:ext uri="{BB962C8B-B14F-4D97-AF65-F5344CB8AC3E}">
-        <p14:creationId xmlns:p14="http://schemas.microsoft.com/office/powerpoint/2010/main" val="495006918"/>
+        <p14:creationId xmlns:p14="http://schemas.microsoft.com/office/powerpoint/2010/main" val="2009308054"/>
       </p:ext>
     </p:extLst>
   </p:cSld>
@@ -15226,7 +15226,7 @@
           <p:cNvPr id="11" name="course">
             <a:extLst xmlns:a="http://schemas.openxmlformats.org/drawingml/2006/main">
               <a:ext uri="{FF2B5EF4-FFF2-40B4-BE49-F238E27FC236}">
-                <a16:creationId xmlns:a16="http://schemas.microsoft.com/office/drawing/2014/main" id="{5A14E3C4-3B49-44F6-BD0C-26FE9DDA543F}"/>
+                <a16:creationId xmlns:a16="http://schemas.microsoft.com/office/drawing/2014/main" id="{BC701787-CC0D-4EAC-887D-47BDFB40B086}"/>
               </a:ext>
             </a:extLst>
           </p:cNvPr>
@@ -15283,7 +15283,7 @@
           <p:cNvPr id="2" name="title">
             <a:extLst xmlns:a="http://schemas.openxmlformats.org/drawingml/2006/main">
               <a:ext uri="{FF2B5EF4-FFF2-40B4-BE49-F238E27FC236}">
-                <a16:creationId xmlns:a16="http://schemas.microsoft.com/office/drawing/2014/main" id="{F54C40FE-030D-42DE-AF79-E24F7150E4C6}"/>
+                <a16:creationId xmlns:a16="http://schemas.microsoft.com/office/drawing/2014/main" id="{3111ECCA-1301-4C34-9016-E9428B3E3B38}"/>
               </a:ext>
             </a:extLst>
           </p:cNvPr>
@@ -15340,7 +15340,7 @@
           <p:cNvPr id="3" name="body">
             <a:extLst xmlns:a="http://schemas.openxmlformats.org/drawingml/2006/main">
               <a:ext uri="{FF2B5EF4-FFF2-40B4-BE49-F238E27FC236}">
-                <a16:creationId xmlns:a16="http://schemas.microsoft.com/office/drawing/2014/main" id="{29998E6B-B2A0-4AAD-BD18-9DE23BFFD78F}"/>
+                <a16:creationId xmlns:a16="http://schemas.microsoft.com/office/drawing/2014/main" id="{C0EC493B-815B-4273-B74C-F63ED7FF38E4}"/>
               </a:ext>
             </a:extLst>
           </p:cNvPr>
@@ -15397,7 +15397,7 @@
           <p:cNvPr id="4" name="body">
             <a:extLst xmlns:a="http://schemas.openxmlformats.org/drawingml/2006/main">
               <a:ext uri="{FF2B5EF4-FFF2-40B4-BE49-F238E27FC236}">
-                <a16:creationId xmlns:a16="http://schemas.microsoft.com/office/drawing/2014/main" id="{E017A372-40D6-4DC3-990D-CF4EB5DA57E2}"/>
+                <a16:creationId xmlns:a16="http://schemas.microsoft.com/office/drawing/2014/main" id="{2C6CE307-D160-4A8D-8F0E-7E8FF218D79B}"/>
               </a:ext>
             </a:extLst>
           </p:cNvPr>
@@ -15454,7 +15454,7 @@
           <p:cNvPr id="5" name="body">
             <a:extLst xmlns:a="http://schemas.openxmlformats.org/drawingml/2006/main">
               <a:ext uri="{FF2B5EF4-FFF2-40B4-BE49-F238E27FC236}">
-                <a16:creationId xmlns:a16="http://schemas.microsoft.com/office/drawing/2014/main" id="{666335AD-09F3-49DC-ACB4-2D9C78E0A44B}"/>
+                <a16:creationId xmlns:a16="http://schemas.microsoft.com/office/drawing/2014/main" id="{17F87952-E582-4343-9A6A-8B7241BF84B1}"/>
               </a:ext>
             </a:extLst>
           </p:cNvPr>
@@ -15511,7 +15511,7 @@
           <p:cNvPr id="6" name="body">
             <a:extLst xmlns:a="http://schemas.openxmlformats.org/drawingml/2006/main">
               <a:ext uri="{FF2B5EF4-FFF2-40B4-BE49-F238E27FC236}">
-                <a16:creationId xmlns:a16="http://schemas.microsoft.com/office/drawing/2014/main" id="{331A612E-557F-4F93-987E-D65574EE5134}"/>
+                <a16:creationId xmlns:a16="http://schemas.microsoft.com/office/drawing/2014/main" id="{FABCF74C-9A94-4F4B-93A3-F91819F7F1C6}"/>
               </a:ext>
             </a:extLst>
           </p:cNvPr>
@@ -15568,7 +15568,7 @@
           <p:cNvPr id="7" name="body">
             <a:extLst xmlns:a="http://schemas.openxmlformats.org/drawingml/2006/main">
               <a:ext uri="{FF2B5EF4-FFF2-40B4-BE49-F238E27FC236}">
-                <a16:creationId xmlns:a16="http://schemas.microsoft.com/office/drawing/2014/main" id="{0E071F3C-0F44-40DC-A01F-9874B2A2AE58}"/>
+                <a16:creationId xmlns:a16="http://schemas.microsoft.com/office/drawing/2014/main" id="{8E0DEF2E-D79E-4534-A316-5A7F408CF1F9}"/>
               </a:ext>
             </a:extLst>
           </p:cNvPr>
@@ -15625,7 +15625,7 @@
           <p:cNvPr id="8" name="body">
             <a:extLst xmlns:a="http://schemas.openxmlformats.org/drawingml/2006/main">
               <a:ext uri="{FF2B5EF4-FFF2-40B4-BE49-F238E27FC236}">
-                <a16:creationId xmlns:a16="http://schemas.microsoft.com/office/drawing/2014/main" id="{9920C7D7-54B2-46FE-9575-AE0C92F03591}"/>
+                <a16:creationId xmlns:a16="http://schemas.microsoft.com/office/drawing/2014/main" id="{B345F1C1-6659-49DE-B23E-8E51353C071F}"/>
               </a:ext>
             </a:extLst>
           </p:cNvPr>
@@ -15682,7 +15682,7 @@
           <p:cNvPr id="9" name="footnote">
             <a:extLst xmlns:a="http://schemas.openxmlformats.org/drawingml/2006/main">
               <a:ext uri="{FF2B5EF4-FFF2-40B4-BE49-F238E27FC236}">
-                <a16:creationId xmlns:a16="http://schemas.microsoft.com/office/drawing/2014/main" id="{10F4BB36-78C6-421E-B66E-157C157FE581}"/>
+                <a16:creationId xmlns:a16="http://schemas.microsoft.com/office/drawing/2014/main" id="{C4FC35C3-6B68-44B1-ACF2-47DD8ECE52FF}"/>
               </a:ext>
             </a:extLst>
           </p:cNvPr>
@@ -15739,7 +15739,7 @@
           <p:cNvPr id="10" name="page">
             <a:extLst xmlns:a="http://schemas.openxmlformats.org/drawingml/2006/main">
               <a:ext uri="{FF2B5EF4-FFF2-40B4-BE49-F238E27FC236}">
-                <a16:creationId xmlns:a16="http://schemas.microsoft.com/office/drawing/2014/main" id="{EBE68535-E233-4D01-B76D-C3E6F4AF4CF7}"/>
+                <a16:creationId xmlns:a16="http://schemas.microsoft.com/office/drawing/2014/main" id="{94590A8C-A9B1-4617-8879-47BF87555253}"/>
               </a:ext>
             </a:extLst>
           </p:cNvPr>
@@ -15794,7 +15794,7 @@
     </p:spTree>
     <p:extLst>
       <p:ext uri="{BB962C8B-B14F-4D97-AF65-F5344CB8AC3E}">
-        <p14:creationId xmlns:p14="http://schemas.microsoft.com/office/powerpoint/2010/main" val="45449209"/>
+        <p14:creationId xmlns:p14="http://schemas.microsoft.com/office/powerpoint/2010/main" val="1853405047"/>
       </p:ext>
     </p:extLst>
   </p:cSld>
@@ -15825,7 +15825,7 @@
           <p:cNvPr id="10" name="course">
             <a:extLst xmlns:a="http://schemas.openxmlformats.org/drawingml/2006/main">
               <a:ext uri="{FF2B5EF4-FFF2-40B4-BE49-F238E27FC236}">
-                <a16:creationId xmlns:a16="http://schemas.microsoft.com/office/drawing/2014/main" id="{B3B67377-A770-45B9-8A5C-E8D10FFA1C9B}"/>
+                <a16:creationId xmlns:a16="http://schemas.microsoft.com/office/drawing/2014/main" id="{AA8E719D-7AC6-41CF-B638-1BDF841054CD}"/>
               </a:ext>
             </a:extLst>
           </p:cNvPr>
@@ -15882,7 +15882,7 @@
           <p:cNvPr id="2" name="title">
             <a:extLst xmlns:a="http://schemas.openxmlformats.org/drawingml/2006/main">
               <a:ext uri="{FF2B5EF4-FFF2-40B4-BE49-F238E27FC236}">
-                <a16:creationId xmlns:a16="http://schemas.microsoft.com/office/drawing/2014/main" id="{9E701E02-EA1B-4A96-A1DA-40ADF4F6078B}"/>
+                <a16:creationId xmlns:a16="http://schemas.microsoft.com/office/drawing/2014/main" id="{AB0D41A8-5807-47DC-BCAF-D3DEF18CEC24}"/>
               </a:ext>
             </a:extLst>
           </p:cNvPr>
@@ -15939,7 +15939,7 @@
           <p:cNvPr id="3" name="body">
             <a:extLst xmlns:a="http://schemas.openxmlformats.org/drawingml/2006/main">
               <a:ext uri="{FF2B5EF4-FFF2-40B4-BE49-F238E27FC236}">
-                <a16:creationId xmlns:a16="http://schemas.microsoft.com/office/drawing/2014/main" id="{297891D0-E51A-42BD-BF27-BFFF4BDD2589}"/>
+                <a16:creationId xmlns:a16="http://schemas.microsoft.com/office/drawing/2014/main" id="{66EBF546-B89C-402D-AE24-48EC891C3E1A}"/>
               </a:ext>
             </a:extLst>
           </p:cNvPr>
@@ -15996,7 +15996,7 @@
           <p:cNvPr id="4" name="body">
             <a:extLst xmlns:a="http://schemas.openxmlformats.org/drawingml/2006/main">
               <a:ext uri="{FF2B5EF4-FFF2-40B4-BE49-F238E27FC236}">
-                <a16:creationId xmlns:a16="http://schemas.microsoft.com/office/drawing/2014/main" id="{B63098A4-17CF-4E86-84DC-E5A3AACECACD}"/>
+                <a16:creationId xmlns:a16="http://schemas.microsoft.com/office/drawing/2014/main" id="{6613CB27-2C1B-4A0F-959C-2691CB02C83E}"/>
               </a:ext>
             </a:extLst>
           </p:cNvPr>
@@ -16053,7 +16053,7 @@
           <p:cNvPr id="5" name="body">
             <a:extLst xmlns:a="http://schemas.openxmlformats.org/drawingml/2006/main">
               <a:ext uri="{FF2B5EF4-FFF2-40B4-BE49-F238E27FC236}">
-                <a16:creationId xmlns:a16="http://schemas.microsoft.com/office/drawing/2014/main" id="{600C7383-655F-46CA-8D86-9CE1A01698C8}"/>
+                <a16:creationId xmlns:a16="http://schemas.microsoft.com/office/drawing/2014/main" id="{EAA2AF10-E54F-4045-9553-04C86AD68817}"/>
               </a:ext>
             </a:extLst>
           </p:cNvPr>
@@ -16110,7 +16110,7 @@
           <p:cNvPr id="6" name="body">
             <a:extLst xmlns:a="http://schemas.openxmlformats.org/drawingml/2006/main">
               <a:ext uri="{FF2B5EF4-FFF2-40B4-BE49-F238E27FC236}">
-                <a16:creationId xmlns:a16="http://schemas.microsoft.com/office/drawing/2014/main" id="{9D061D5C-5B3A-4F1B-8954-A488285C6B35}"/>
+                <a16:creationId xmlns:a16="http://schemas.microsoft.com/office/drawing/2014/main" id="{5FE8EF9D-EEBE-4E2B-B1E8-A1B04B6B850A}"/>
               </a:ext>
             </a:extLst>
           </p:cNvPr>
@@ -16167,7 +16167,7 @@
           <p:cNvPr id="7" name="body">
             <a:extLst xmlns:a="http://schemas.openxmlformats.org/drawingml/2006/main">
               <a:ext uri="{FF2B5EF4-FFF2-40B4-BE49-F238E27FC236}">
-                <a16:creationId xmlns:a16="http://schemas.microsoft.com/office/drawing/2014/main" id="{4C5EA95F-EAA4-43E2-9F49-3A4B0F3EEB8F}"/>
+                <a16:creationId xmlns:a16="http://schemas.microsoft.com/office/drawing/2014/main" id="{396206A4-45EB-4596-B450-27F206308BD8}"/>
               </a:ext>
             </a:extLst>
           </p:cNvPr>
@@ -16224,7 +16224,7 @@
           <p:cNvPr id="8" name="body">
             <a:extLst xmlns:a="http://schemas.openxmlformats.org/drawingml/2006/main">
               <a:ext uri="{FF2B5EF4-FFF2-40B4-BE49-F238E27FC236}">
-                <a16:creationId xmlns:a16="http://schemas.microsoft.com/office/drawing/2014/main" id="{20D620DA-D8D7-4391-92A6-72FBF5DA63A8}"/>
+                <a16:creationId xmlns:a16="http://schemas.microsoft.com/office/drawing/2014/main" id="{DB64AB36-F235-4538-8D47-A170ED45DB7A}"/>
               </a:ext>
             </a:extLst>
           </p:cNvPr>
@@ -16281,7 +16281,7 @@
           <p:cNvPr id="9" name="page">
             <a:extLst xmlns:a="http://schemas.openxmlformats.org/drawingml/2006/main">
               <a:ext uri="{FF2B5EF4-FFF2-40B4-BE49-F238E27FC236}">
-                <a16:creationId xmlns:a16="http://schemas.microsoft.com/office/drawing/2014/main" id="{8FB7F59B-3B3E-433A-86C1-D31AAE71CBED}"/>
+                <a16:creationId xmlns:a16="http://schemas.microsoft.com/office/drawing/2014/main" id="{73AA4A37-E722-4C6F-B94C-971A278CEF89}"/>
               </a:ext>
             </a:extLst>
           </p:cNvPr>
@@ -16336,7 +16336,7 @@
     </p:spTree>
     <p:extLst>
       <p:ext uri="{BB962C8B-B14F-4D97-AF65-F5344CB8AC3E}">
-        <p14:creationId xmlns:p14="http://schemas.microsoft.com/office/powerpoint/2010/main" val="1173990069"/>
+        <p14:creationId xmlns:p14="http://schemas.microsoft.com/office/powerpoint/2010/main" val="900194391"/>
       </p:ext>
     </p:extLst>
   </p:cSld>
@@ -16367,7 +16367,7 @@
           <p:cNvPr id="11" name="course">
             <a:extLst xmlns:a="http://schemas.openxmlformats.org/drawingml/2006/main">
               <a:ext uri="{FF2B5EF4-FFF2-40B4-BE49-F238E27FC236}">
-                <a16:creationId xmlns:a16="http://schemas.microsoft.com/office/drawing/2014/main" id="{55E45BAB-D38A-478B-B318-20103C05D1D4}"/>
+                <a16:creationId xmlns:a16="http://schemas.microsoft.com/office/drawing/2014/main" id="{5D892F7B-5918-4FB0-B01A-10E211FC4330}"/>
               </a:ext>
             </a:extLst>
           </p:cNvPr>
@@ -16424,7 +16424,7 @@
           <p:cNvPr id="2" name="title">
             <a:extLst xmlns:a="http://schemas.openxmlformats.org/drawingml/2006/main">
               <a:ext uri="{FF2B5EF4-FFF2-40B4-BE49-F238E27FC236}">
-                <a16:creationId xmlns:a16="http://schemas.microsoft.com/office/drawing/2014/main" id="{5DC2B07D-4213-4060-B082-9D8D5D2A7193}"/>
+                <a16:creationId xmlns:a16="http://schemas.microsoft.com/office/drawing/2014/main" id="{4F4C846A-E74D-441F-B8A9-226ECE2094FC}"/>
               </a:ext>
             </a:extLst>
           </p:cNvPr>
@@ -16481,7 +16481,7 @@
           <p:cNvPr id="3" name="body">
             <a:extLst xmlns:a="http://schemas.openxmlformats.org/drawingml/2006/main">
               <a:ext uri="{FF2B5EF4-FFF2-40B4-BE49-F238E27FC236}">
-                <a16:creationId xmlns:a16="http://schemas.microsoft.com/office/drawing/2014/main" id="{B8F8B75E-3DFA-4418-9999-3749C1E2EF96}"/>
+                <a16:creationId xmlns:a16="http://schemas.microsoft.com/office/drawing/2014/main" id="{CF368F3F-BAE7-4459-9F76-4DEE68C50A58}"/>
               </a:ext>
             </a:extLst>
           </p:cNvPr>
@@ -16538,7 +16538,7 @@
           <p:cNvPr id="4" name="body">
             <a:extLst xmlns:a="http://schemas.openxmlformats.org/drawingml/2006/main">
               <a:ext uri="{FF2B5EF4-FFF2-40B4-BE49-F238E27FC236}">
-                <a16:creationId xmlns:a16="http://schemas.microsoft.com/office/drawing/2014/main" id="{036482A2-B11B-49C1-A59D-41CBEAFBC033}"/>
+                <a16:creationId xmlns:a16="http://schemas.microsoft.com/office/drawing/2014/main" id="{2C5132DB-F17D-404E-8655-CD53BDD51CA1}"/>
               </a:ext>
             </a:extLst>
           </p:cNvPr>
@@ -16595,7 +16595,7 @@
           <p:cNvPr id="5" name="body">
             <a:extLst xmlns:a="http://schemas.openxmlformats.org/drawingml/2006/main">
               <a:ext uri="{FF2B5EF4-FFF2-40B4-BE49-F238E27FC236}">
-                <a16:creationId xmlns:a16="http://schemas.microsoft.com/office/drawing/2014/main" id="{993050B5-5ACC-40DB-9E8C-F9E4D5EDF992}"/>
+                <a16:creationId xmlns:a16="http://schemas.microsoft.com/office/drawing/2014/main" id="{169D80F6-95A2-4115-B352-D817974032D5}"/>
               </a:ext>
             </a:extLst>
           </p:cNvPr>
@@ -16652,7 +16652,7 @@
           <p:cNvPr id="6" name="body">
             <a:extLst xmlns:a="http://schemas.openxmlformats.org/drawingml/2006/main">
               <a:ext uri="{FF2B5EF4-FFF2-40B4-BE49-F238E27FC236}">
-                <a16:creationId xmlns:a16="http://schemas.microsoft.com/office/drawing/2014/main" id="{76AC9294-612B-4F89-9011-B61F880FD5E5}"/>
+                <a16:creationId xmlns:a16="http://schemas.microsoft.com/office/drawing/2014/main" id="{448667F7-A2C6-4B75-AC5A-FF15CC0C5498}"/>
               </a:ext>
             </a:extLst>
           </p:cNvPr>
@@ -16709,7 +16709,7 @@
           <p:cNvPr id="7" name="body">
             <a:extLst xmlns:a="http://schemas.openxmlformats.org/drawingml/2006/main">
               <a:ext uri="{FF2B5EF4-FFF2-40B4-BE49-F238E27FC236}">
-                <a16:creationId xmlns:a16="http://schemas.microsoft.com/office/drawing/2014/main" id="{6645218C-693D-4A5A-8592-76677CC9314A}"/>
+                <a16:creationId xmlns:a16="http://schemas.microsoft.com/office/drawing/2014/main" id="{B4708B7E-AC3B-4787-8743-4FD641F77177}"/>
               </a:ext>
             </a:extLst>
           </p:cNvPr>
@@ -16766,7 +16766,7 @@
           <p:cNvPr id="8" name="body">
             <a:extLst xmlns:a="http://schemas.openxmlformats.org/drawingml/2006/main">
               <a:ext uri="{FF2B5EF4-FFF2-40B4-BE49-F238E27FC236}">
-                <a16:creationId xmlns:a16="http://schemas.microsoft.com/office/drawing/2014/main" id="{E05C708F-4CBF-4B24-AC1F-70DC766277FF}"/>
+                <a16:creationId xmlns:a16="http://schemas.microsoft.com/office/drawing/2014/main" id="{3D6C4009-58DA-4FA5-8EF9-69DD18E4BC49}"/>
               </a:ext>
             </a:extLst>
           </p:cNvPr>
@@ -16823,7 +16823,7 @@
           <p:cNvPr id="9" name="footnote">
             <a:extLst xmlns:a="http://schemas.openxmlformats.org/drawingml/2006/main">
               <a:ext uri="{FF2B5EF4-FFF2-40B4-BE49-F238E27FC236}">
-                <a16:creationId xmlns:a16="http://schemas.microsoft.com/office/drawing/2014/main" id="{554EBAC6-3A64-4E6B-957D-0D835FE6AD98}"/>
+                <a16:creationId xmlns:a16="http://schemas.microsoft.com/office/drawing/2014/main" id="{6443BD48-0949-46E8-A0FE-AA61987C191E}"/>
               </a:ext>
             </a:extLst>
           </p:cNvPr>
@@ -16880,7 +16880,7 @@
           <p:cNvPr id="10" name="page">
             <a:extLst xmlns:a="http://schemas.openxmlformats.org/drawingml/2006/main">
               <a:ext uri="{FF2B5EF4-FFF2-40B4-BE49-F238E27FC236}">
-                <a16:creationId xmlns:a16="http://schemas.microsoft.com/office/drawing/2014/main" id="{73A17232-E8B7-4246-9AF2-571967DEA912}"/>
+                <a16:creationId xmlns:a16="http://schemas.microsoft.com/office/drawing/2014/main" id="{5B16E0C4-661C-4A0F-ADDF-0D0D6F1AD033}"/>
               </a:ext>
             </a:extLst>
           </p:cNvPr>
@@ -16935,7 +16935,7 @@
     </p:spTree>
     <p:extLst>
       <p:ext uri="{BB962C8B-B14F-4D97-AF65-F5344CB8AC3E}">
-        <p14:creationId xmlns:p14="http://schemas.microsoft.com/office/powerpoint/2010/main" val="1983745563"/>
+        <p14:creationId xmlns:p14="http://schemas.microsoft.com/office/powerpoint/2010/main" val="475711544"/>
       </p:ext>
     </p:extLst>
   </p:cSld>
@@ -16966,7 +16966,7 @@
           <p:cNvPr id="6" name="course">
             <a:extLst xmlns:a="http://schemas.openxmlformats.org/drawingml/2006/main">
               <a:ext uri="{FF2B5EF4-FFF2-40B4-BE49-F238E27FC236}">
-                <a16:creationId xmlns:a16="http://schemas.microsoft.com/office/drawing/2014/main" id="{EA9D8600-3BFD-4900-A490-966FD90FB15D}"/>
+                <a16:creationId xmlns:a16="http://schemas.microsoft.com/office/drawing/2014/main" id="{423BC952-D9A9-4F04-8F80-493D618AD7D6}"/>
               </a:ext>
             </a:extLst>
           </p:cNvPr>
@@ -17023,7 +17023,7 @@
           <p:cNvPr id="2" name="title">
             <a:extLst xmlns:a="http://schemas.openxmlformats.org/drawingml/2006/main">
               <a:ext uri="{FF2B5EF4-FFF2-40B4-BE49-F238E27FC236}">
-                <a16:creationId xmlns:a16="http://schemas.microsoft.com/office/drawing/2014/main" id="{DF135743-C40F-4A6F-9939-E591D87AB090}"/>
+                <a16:creationId xmlns:a16="http://schemas.microsoft.com/office/drawing/2014/main" id="{2A2DDBFB-D6B1-40E7-BD29-4497DC8019CC}"/>
               </a:ext>
             </a:extLst>
           </p:cNvPr>
@@ -17402,7 +17402,7 @@
           <p:cNvPr id="4" name="footnote">
             <a:extLst xmlns:a="http://schemas.openxmlformats.org/drawingml/2006/main">
               <a:ext uri="{FF2B5EF4-FFF2-40B4-BE49-F238E27FC236}">
-                <a16:creationId xmlns:a16="http://schemas.microsoft.com/office/drawing/2014/main" id="{489A1CA7-0E6E-46DB-AE74-9D89263557FD}"/>
+                <a16:creationId xmlns:a16="http://schemas.microsoft.com/office/drawing/2014/main" id="{9E386E99-AB64-4662-A4CD-D7345F39F786}"/>
               </a:ext>
             </a:extLst>
           </p:cNvPr>
@@ -17459,7 +17459,7 @@
           <p:cNvPr id="5" name="page">
             <a:extLst xmlns:a="http://schemas.openxmlformats.org/drawingml/2006/main">
               <a:ext uri="{FF2B5EF4-FFF2-40B4-BE49-F238E27FC236}">
-                <a16:creationId xmlns:a16="http://schemas.microsoft.com/office/drawing/2014/main" id="{8B7D978B-A078-4307-8727-5FCA6BD22932}"/>
+                <a16:creationId xmlns:a16="http://schemas.microsoft.com/office/drawing/2014/main" id="{51D408FC-2E33-4980-8618-6EBCFAC84AA9}"/>
               </a:ext>
             </a:extLst>
           </p:cNvPr>
@@ -17514,7 +17514,7 @@
     </p:spTree>
     <p:extLst>
       <p:ext uri="{BB962C8B-B14F-4D97-AF65-F5344CB8AC3E}">
-        <p14:creationId xmlns:p14="http://schemas.microsoft.com/office/powerpoint/2010/main" val="1243961819"/>
+        <p14:creationId xmlns:p14="http://schemas.microsoft.com/office/powerpoint/2010/main" val="1569864292"/>
       </p:ext>
     </p:extLst>
   </p:cSld>
@@ -18383,7 +18383,7 @@
           <p:cNvPr id="11" name="course">
             <a:extLst xmlns:a="http://schemas.openxmlformats.org/drawingml/2006/main">
               <a:ext uri="{FF2B5EF4-FFF2-40B4-BE49-F238E27FC236}">
-                <a16:creationId xmlns:a16="http://schemas.microsoft.com/office/drawing/2014/main" id="{3B84682B-6A6E-4CDF-8AA6-CB42FE27643D}"/>
+                <a16:creationId xmlns:a16="http://schemas.microsoft.com/office/drawing/2014/main" id="{D50FC024-0EA1-4A4B-98EA-E30281F9C782}"/>
               </a:ext>
             </a:extLst>
           </p:cNvPr>
@@ -18440,7 +18440,7 @@
           <p:cNvPr id="2" name="title">
             <a:extLst xmlns:a="http://schemas.openxmlformats.org/drawingml/2006/main">
               <a:ext uri="{FF2B5EF4-FFF2-40B4-BE49-F238E27FC236}">
-                <a16:creationId xmlns:a16="http://schemas.microsoft.com/office/drawing/2014/main" id="{A07952F8-B824-4B4A-B270-70686786483E}"/>
+                <a16:creationId xmlns:a16="http://schemas.microsoft.com/office/drawing/2014/main" id="{62CBEED0-1FCE-4164-A534-5B841BB1E29C}"/>
               </a:ext>
             </a:extLst>
           </p:cNvPr>
@@ -18497,7 +18497,7 @@
           <p:cNvPr id="3" name="body">
             <a:extLst xmlns:a="http://schemas.openxmlformats.org/drawingml/2006/main">
               <a:ext uri="{FF2B5EF4-FFF2-40B4-BE49-F238E27FC236}">
-                <a16:creationId xmlns:a16="http://schemas.microsoft.com/office/drawing/2014/main" id="{5E60AE2F-7ADB-49B4-B16F-21706CB6B41C}"/>
+                <a16:creationId xmlns:a16="http://schemas.microsoft.com/office/drawing/2014/main" id="{D5E0B1E1-D653-4130-854C-DF64D84B4A38}"/>
               </a:ext>
             </a:extLst>
           </p:cNvPr>
@@ -18554,7 +18554,7 @@
           <p:cNvPr id="4" name="body">
             <a:extLst xmlns:a="http://schemas.openxmlformats.org/drawingml/2006/main">
               <a:ext uri="{FF2B5EF4-FFF2-40B4-BE49-F238E27FC236}">
-                <a16:creationId xmlns:a16="http://schemas.microsoft.com/office/drawing/2014/main" id="{EF84E69C-62B0-4B2D-AC0C-AA6CC70C145A}"/>
+                <a16:creationId xmlns:a16="http://schemas.microsoft.com/office/drawing/2014/main" id="{F46653E9-EB29-46C2-8D22-FF172D7B0FB5}"/>
               </a:ext>
             </a:extLst>
           </p:cNvPr>
@@ -18611,7 +18611,7 @@
           <p:cNvPr id="5" name="body">
             <a:extLst xmlns:a="http://schemas.openxmlformats.org/drawingml/2006/main">
               <a:ext uri="{FF2B5EF4-FFF2-40B4-BE49-F238E27FC236}">
-                <a16:creationId xmlns:a16="http://schemas.microsoft.com/office/drawing/2014/main" id="{65419DBC-9203-4BC6-B628-F314014551AC}"/>
+                <a16:creationId xmlns:a16="http://schemas.microsoft.com/office/drawing/2014/main" id="{911E06E7-6521-4B1E-ADA5-60233400CF43}"/>
               </a:ext>
             </a:extLst>
           </p:cNvPr>
@@ -18668,7 +18668,7 @@
           <p:cNvPr id="6" name="body">
             <a:extLst xmlns:a="http://schemas.openxmlformats.org/drawingml/2006/main">
               <a:ext uri="{FF2B5EF4-FFF2-40B4-BE49-F238E27FC236}">
-                <a16:creationId xmlns:a16="http://schemas.microsoft.com/office/drawing/2014/main" id="{DF8416AB-D6DE-46D5-9E63-186CFE73E59A}"/>
+                <a16:creationId xmlns:a16="http://schemas.microsoft.com/office/drawing/2014/main" id="{7D89BD11-BF87-493E-9893-B1FCE671517B}"/>
               </a:ext>
             </a:extLst>
           </p:cNvPr>
@@ -18725,7 +18725,7 @@
           <p:cNvPr id="7" name="body">
             <a:extLst xmlns:a="http://schemas.openxmlformats.org/drawingml/2006/main">
               <a:ext uri="{FF2B5EF4-FFF2-40B4-BE49-F238E27FC236}">
-                <a16:creationId xmlns:a16="http://schemas.microsoft.com/office/drawing/2014/main" id="{3663C7E0-07BC-4D44-BD06-75E0E7449AC6}"/>
+                <a16:creationId xmlns:a16="http://schemas.microsoft.com/office/drawing/2014/main" id="{E6B13EC8-850E-4358-804B-8BDE48977D15}"/>
               </a:ext>
             </a:extLst>
           </p:cNvPr>
@@ -18782,7 +18782,7 @@
           <p:cNvPr id="8" name="body">
             <a:extLst xmlns:a="http://schemas.openxmlformats.org/drawingml/2006/main">
               <a:ext uri="{FF2B5EF4-FFF2-40B4-BE49-F238E27FC236}">
-                <a16:creationId xmlns:a16="http://schemas.microsoft.com/office/drawing/2014/main" id="{2E501F26-45FB-47E1-9324-9C708743591D}"/>
+                <a16:creationId xmlns:a16="http://schemas.microsoft.com/office/drawing/2014/main" id="{3AF7DE9E-E55B-40E7-9F9D-121D4732DFC2}"/>
               </a:ext>
             </a:extLst>
           </p:cNvPr>
@@ -18839,7 +18839,7 @@
           <p:cNvPr id="9" name="footnote">
             <a:extLst xmlns:a="http://schemas.openxmlformats.org/drawingml/2006/main">
               <a:ext uri="{FF2B5EF4-FFF2-40B4-BE49-F238E27FC236}">
-                <a16:creationId xmlns:a16="http://schemas.microsoft.com/office/drawing/2014/main" id="{68E305D2-A2B2-4C42-A6EB-9BC6788A89B6}"/>
+                <a16:creationId xmlns:a16="http://schemas.microsoft.com/office/drawing/2014/main" id="{D29E698A-E8B2-421B-B506-3478DFC82BE1}"/>
               </a:ext>
             </a:extLst>
           </p:cNvPr>
@@ -18896,7 +18896,7 @@
           <p:cNvPr id="10" name="page">
             <a:extLst xmlns:a="http://schemas.openxmlformats.org/drawingml/2006/main">
               <a:ext uri="{FF2B5EF4-FFF2-40B4-BE49-F238E27FC236}">
-                <a16:creationId xmlns:a16="http://schemas.microsoft.com/office/drawing/2014/main" id="{FA85C0D1-70F3-4CB9-81B4-CDC528B4C8DB}"/>
+                <a16:creationId xmlns:a16="http://schemas.microsoft.com/office/drawing/2014/main" id="{76EBA183-7DF5-4CA7-AEB9-3C3267BF4357}"/>
               </a:ext>
             </a:extLst>
           </p:cNvPr>
@@ -18951,7 +18951,7 @@
     </p:spTree>
     <p:extLst>
       <p:ext uri="{BB962C8B-B14F-4D97-AF65-F5344CB8AC3E}">
-        <p14:creationId xmlns:p14="http://schemas.microsoft.com/office/powerpoint/2010/main" val="1361521625"/>
+        <p14:creationId xmlns:p14="http://schemas.microsoft.com/office/powerpoint/2010/main" val="1661518404"/>
       </p:ext>
     </p:extLst>
   </p:cSld>
@@ -18982,7 +18982,7 @@
           <p:cNvPr id="11" name="course">
             <a:extLst xmlns:a="http://schemas.openxmlformats.org/drawingml/2006/main">
               <a:ext uri="{FF2B5EF4-FFF2-40B4-BE49-F238E27FC236}">
-                <a16:creationId xmlns:a16="http://schemas.microsoft.com/office/drawing/2014/main" id="{61847A57-F37D-4037-9033-802580A02D8C}"/>
+                <a16:creationId xmlns:a16="http://schemas.microsoft.com/office/drawing/2014/main" id="{98B9945F-7E39-4700-9E11-1D5277FA747A}"/>
               </a:ext>
             </a:extLst>
           </p:cNvPr>
@@ -19039,7 +19039,7 @@
           <p:cNvPr id="2" name="title">
             <a:extLst xmlns:a="http://schemas.openxmlformats.org/drawingml/2006/main">
               <a:ext uri="{FF2B5EF4-FFF2-40B4-BE49-F238E27FC236}">
-                <a16:creationId xmlns:a16="http://schemas.microsoft.com/office/drawing/2014/main" id="{8E87E479-9B4E-4824-AB4E-FD0412B37762}"/>
+                <a16:creationId xmlns:a16="http://schemas.microsoft.com/office/drawing/2014/main" id="{7BC3C653-1DBD-491E-AC76-26EE449D7DC5}"/>
               </a:ext>
             </a:extLst>
           </p:cNvPr>
@@ -19096,7 +19096,7 @@
           <p:cNvPr id="3" name="body">
             <a:extLst xmlns:a="http://schemas.openxmlformats.org/drawingml/2006/main">
               <a:ext uri="{FF2B5EF4-FFF2-40B4-BE49-F238E27FC236}">
-                <a16:creationId xmlns:a16="http://schemas.microsoft.com/office/drawing/2014/main" id="{3C784731-7F60-4B60-90E1-7F55E3350292}"/>
+                <a16:creationId xmlns:a16="http://schemas.microsoft.com/office/drawing/2014/main" id="{3A3EE6EA-BB26-465B-BB92-9CBE75D5668E}"/>
               </a:ext>
             </a:extLst>
           </p:cNvPr>
@@ -19153,7 +19153,7 @@
           <p:cNvPr id="4" name="body">
             <a:extLst xmlns:a="http://schemas.openxmlformats.org/drawingml/2006/main">
               <a:ext uri="{FF2B5EF4-FFF2-40B4-BE49-F238E27FC236}">
-                <a16:creationId xmlns:a16="http://schemas.microsoft.com/office/drawing/2014/main" id="{21767FAD-1F07-4466-8D64-89344F0EDEBF}"/>
+                <a16:creationId xmlns:a16="http://schemas.microsoft.com/office/drawing/2014/main" id="{58A53649-A33E-4D21-895A-B58A9AC29857}"/>
               </a:ext>
             </a:extLst>
           </p:cNvPr>
@@ -19210,7 +19210,7 @@
           <p:cNvPr id="5" name="body">
             <a:extLst xmlns:a="http://schemas.openxmlformats.org/drawingml/2006/main">
               <a:ext uri="{FF2B5EF4-FFF2-40B4-BE49-F238E27FC236}">
-                <a16:creationId xmlns:a16="http://schemas.microsoft.com/office/drawing/2014/main" id="{B3DA5E1E-B36D-405F-99E0-0606CB9CFB7F}"/>
+                <a16:creationId xmlns:a16="http://schemas.microsoft.com/office/drawing/2014/main" id="{117CAE12-CB0B-409A-BC33-B909606BEFED}"/>
               </a:ext>
             </a:extLst>
           </p:cNvPr>
@@ -19267,7 +19267,7 @@
           <p:cNvPr id="6" name="body">
             <a:extLst xmlns:a="http://schemas.openxmlformats.org/drawingml/2006/main">
               <a:ext uri="{FF2B5EF4-FFF2-40B4-BE49-F238E27FC236}">
-                <a16:creationId xmlns:a16="http://schemas.microsoft.com/office/drawing/2014/main" id="{DDA6D3F6-D22E-4564-9515-BC1B6B83EFFC}"/>
+                <a16:creationId xmlns:a16="http://schemas.microsoft.com/office/drawing/2014/main" id="{BDD2DEA9-322D-4F41-B732-F341C3EAE62A}"/>
               </a:ext>
             </a:extLst>
           </p:cNvPr>
@@ -19324,7 +19324,7 @@
           <p:cNvPr id="7" name="body">
             <a:extLst xmlns:a="http://schemas.openxmlformats.org/drawingml/2006/main">
               <a:ext uri="{FF2B5EF4-FFF2-40B4-BE49-F238E27FC236}">
-                <a16:creationId xmlns:a16="http://schemas.microsoft.com/office/drawing/2014/main" id="{A107F3B7-5349-45A1-93E6-DD60A0C789C8}"/>
+                <a16:creationId xmlns:a16="http://schemas.microsoft.com/office/drawing/2014/main" id="{46F4ABEE-A249-4EA8-BCB8-ADBB064C7C3F}"/>
               </a:ext>
             </a:extLst>
           </p:cNvPr>
@@ -19381,7 +19381,7 @@
           <p:cNvPr id="8" name="body">
             <a:extLst xmlns:a="http://schemas.openxmlformats.org/drawingml/2006/main">
               <a:ext uri="{FF2B5EF4-FFF2-40B4-BE49-F238E27FC236}">
-                <a16:creationId xmlns:a16="http://schemas.microsoft.com/office/drawing/2014/main" id="{4F6DC977-2E29-4555-930B-55BDBA8B3E96}"/>
+                <a16:creationId xmlns:a16="http://schemas.microsoft.com/office/drawing/2014/main" id="{C4F16E81-6B67-4578-A489-FC6E4B12978B}"/>
               </a:ext>
             </a:extLst>
           </p:cNvPr>
@@ -19438,7 +19438,7 @@
           <p:cNvPr id="9" name="footnote">
             <a:extLst xmlns:a="http://schemas.openxmlformats.org/drawingml/2006/main">
               <a:ext uri="{FF2B5EF4-FFF2-40B4-BE49-F238E27FC236}">
-                <a16:creationId xmlns:a16="http://schemas.microsoft.com/office/drawing/2014/main" id="{6F1CDCCE-C641-4DE4-9826-4BB1D6EDB209}"/>
+                <a16:creationId xmlns:a16="http://schemas.microsoft.com/office/drawing/2014/main" id="{1FC423C9-83CC-41A1-A03C-DEA509C41ECD}"/>
               </a:ext>
             </a:extLst>
           </p:cNvPr>
@@ -19495,7 +19495,7 @@
           <p:cNvPr id="10" name="page">
             <a:extLst xmlns:a="http://schemas.openxmlformats.org/drawingml/2006/main">
               <a:ext uri="{FF2B5EF4-FFF2-40B4-BE49-F238E27FC236}">
-                <a16:creationId xmlns:a16="http://schemas.microsoft.com/office/drawing/2014/main" id="{0592F7BF-82F7-4C01-ADAB-CCF3EDC49BFB}"/>
+                <a16:creationId xmlns:a16="http://schemas.microsoft.com/office/drawing/2014/main" id="{76190287-C027-4993-A5E9-7F81D3792C70}"/>
               </a:ext>
             </a:extLst>
           </p:cNvPr>
@@ -19550,7 +19550,7 @@
     </p:spTree>
     <p:extLst>
       <p:ext uri="{BB962C8B-B14F-4D97-AF65-F5344CB8AC3E}">
-        <p14:creationId xmlns:p14="http://schemas.microsoft.com/office/powerpoint/2010/main" val="292493076"/>
+        <p14:creationId xmlns:p14="http://schemas.microsoft.com/office/powerpoint/2010/main" val="834011421"/>
       </p:ext>
     </p:extLst>
   </p:cSld>
@@ -22467,24 +22467,6 @@
                   <a:srgbClr val="111111"/>
                 </a:solidFill>
               </a:rPr>
-              <a:t>Ryan Cameron</a:t>
-            </a:r>
-          </a:p>
-          <a:p xmlns:a="http://schemas.openxmlformats.org/drawingml/2006/main">
-            <a:pPr algn="l">
-              <a:buNone/>
-              <a:defRPr sz="1875" b="0">
-                <a:solidFill>
-                  <a:srgbClr val="111111"/>
-                </a:solidFill>
-              </a:defRPr>
-            </a:pPr>
-            <a:r>
-              <a:rPr sz="1875" b="0">
-                <a:solidFill>
-                  <a:srgbClr val="111111"/>
-                </a:solidFill>
-              </a:rPr>
               <a:t>Nazila Emamdoost</a:t>
             </a:r>
           </a:p>
@@ -23199,7 +23181,7 @@
         </p:xfrm>
         <a:graphic xmlns:a="http://schemas.openxmlformats.org/drawingml/2006/main">
           <a:graphicData uri="http://schemas.openxmlformats.org/drawingml/2006/chart">
-            <c:chart xmlns:r="http://schemas.openxmlformats.org/officeDocument/2006/relationships" xmlns:c="http://schemas.openxmlformats.org/drawingml/2006/chart" r:id="Rce4d70ead765436f"/>
+            <c:chart xmlns:r="http://schemas.openxmlformats.org/officeDocument/2006/relationships" xmlns:c="http://schemas.openxmlformats.org/drawingml/2006/chart" r:id="R5b20d49ecc3b47d7"/>
           </a:graphicData>
         </a:graphic>
       </p:graphicFrame>
@@ -25228,7 +25210,7 @@
           <p:cNvPr id="12" name="course">
             <a:extLst xmlns:a="http://schemas.openxmlformats.org/drawingml/2006/main">
               <a:ext uri="{FF2B5EF4-FFF2-40B4-BE49-F238E27FC236}">
-                <a16:creationId xmlns:a16="http://schemas.microsoft.com/office/drawing/2014/main" id="{754F65B5-6AEF-4428-BF02-D462A5B05BBD}"/>
+                <a16:creationId xmlns:a16="http://schemas.microsoft.com/office/drawing/2014/main" id="{644075A0-A121-47C0-B59B-6FE7CE555F63}"/>
               </a:ext>
             </a:extLst>
           </p:cNvPr>
@@ -25285,7 +25267,7 @@
           <p:cNvPr id="2" name="title">
             <a:extLst xmlns:a="http://schemas.openxmlformats.org/drawingml/2006/main">
               <a:ext uri="{FF2B5EF4-FFF2-40B4-BE49-F238E27FC236}">
-                <a16:creationId xmlns:a16="http://schemas.microsoft.com/office/drawing/2014/main" id="{321A2097-B27C-4FBA-8A46-3E2C81EBBBAF}"/>
+                <a16:creationId xmlns:a16="http://schemas.microsoft.com/office/drawing/2014/main" id="{06F683C6-9F5C-4A40-889B-186FB927BA66}"/>
               </a:ext>
             </a:extLst>
           </p:cNvPr>
@@ -25342,7 +25324,7 @@
           <p:cNvPr id="3" name="body">
             <a:extLst xmlns:a="http://schemas.openxmlformats.org/drawingml/2006/main">
               <a:ext uri="{FF2B5EF4-FFF2-40B4-BE49-F238E27FC236}">
-                <a16:creationId xmlns:a16="http://schemas.microsoft.com/office/drawing/2014/main" id="{199E520A-4A48-4B30-9E90-297085A1D846}"/>
+                <a16:creationId xmlns:a16="http://schemas.microsoft.com/office/drawing/2014/main" id="{CA703D9D-9A44-4F4E-A32B-A8E80147A69C}"/>
               </a:ext>
             </a:extLst>
           </p:cNvPr>
@@ -25399,7 +25381,7 @@
           <p:cNvPr id="4" name="body">
             <a:extLst xmlns:a="http://schemas.openxmlformats.org/drawingml/2006/main">
               <a:ext uri="{FF2B5EF4-FFF2-40B4-BE49-F238E27FC236}">
-                <a16:creationId xmlns:a16="http://schemas.microsoft.com/office/drawing/2014/main" id="{C217029F-365F-4438-B06F-D7C32F108A28}"/>
+                <a16:creationId xmlns:a16="http://schemas.microsoft.com/office/drawing/2014/main" id="{2A6D6B89-83AE-48ED-A356-80373E69781A}"/>
               </a:ext>
             </a:extLst>
           </p:cNvPr>
@@ -25456,7 +25438,7 @@
           <p:cNvPr id="5" name="body">
             <a:extLst xmlns:a="http://schemas.openxmlformats.org/drawingml/2006/main">
               <a:ext uri="{FF2B5EF4-FFF2-40B4-BE49-F238E27FC236}">
-                <a16:creationId xmlns:a16="http://schemas.microsoft.com/office/drawing/2014/main" id="{C4DACCC9-AF52-4AA5-B8D9-932539B29B70}"/>
+                <a16:creationId xmlns:a16="http://schemas.microsoft.com/office/drawing/2014/main" id="{23269B9A-57BC-48CA-9659-B5DA3092F03A}"/>
               </a:ext>
             </a:extLst>
           </p:cNvPr>
@@ -25513,7 +25495,7 @@
           <p:cNvPr id="6" name="body">
             <a:extLst xmlns:a="http://schemas.openxmlformats.org/drawingml/2006/main">
               <a:ext uri="{FF2B5EF4-FFF2-40B4-BE49-F238E27FC236}">
-                <a16:creationId xmlns:a16="http://schemas.microsoft.com/office/drawing/2014/main" id="{BB9720E4-1A70-439D-8946-96A10C612BDE}"/>
+                <a16:creationId xmlns:a16="http://schemas.microsoft.com/office/drawing/2014/main" id="{325A329A-C525-485E-B657-E60EB34F384A}"/>
               </a:ext>
             </a:extLst>
           </p:cNvPr>
@@ -25570,7 +25552,7 @@
           <p:cNvPr id="7" name="body">
             <a:extLst xmlns:a="http://schemas.openxmlformats.org/drawingml/2006/main">
               <a:ext uri="{FF2B5EF4-FFF2-40B4-BE49-F238E27FC236}">
-                <a16:creationId xmlns:a16="http://schemas.microsoft.com/office/drawing/2014/main" id="{49F01E8A-64A9-4FF9-B62A-E52A59AF371E}"/>
+                <a16:creationId xmlns:a16="http://schemas.microsoft.com/office/drawing/2014/main" id="{5B3D8BC8-D37F-4750-8327-1137604A0A47}"/>
               </a:ext>
             </a:extLst>
           </p:cNvPr>
@@ -25627,7 +25609,7 @@
           <p:cNvPr id="8" name="body">
             <a:extLst xmlns:a="http://schemas.openxmlformats.org/drawingml/2006/main">
               <a:ext uri="{FF2B5EF4-FFF2-40B4-BE49-F238E27FC236}">
-                <a16:creationId xmlns:a16="http://schemas.microsoft.com/office/drawing/2014/main" id="{E6C0BCCC-169E-45CE-AD58-52ED5BBC2E58}"/>
+                <a16:creationId xmlns:a16="http://schemas.microsoft.com/office/drawing/2014/main" id="{EAF7E2B9-CB69-46D1-AC4A-77E4AE9CB47A}"/>
               </a:ext>
             </a:extLst>
           </p:cNvPr>
@@ -25684,7 +25666,7 @@
           <p:cNvPr id="9" name="equation">
             <a:extLst xmlns:a="http://schemas.openxmlformats.org/drawingml/2006/main">
               <a:ext uri="{FF2B5EF4-FFF2-40B4-BE49-F238E27FC236}">
-                <a16:creationId xmlns:a16="http://schemas.microsoft.com/office/drawing/2014/main" id="{878FA39B-4ACB-488C-98BF-0ED032C8B4B2}"/>
+                <a16:creationId xmlns:a16="http://schemas.microsoft.com/office/drawing/2014/main" id="{2B898752-80CA-463A-8C9D-B3097EE3AEC2}"/>
               </a:ext>
             </a:extLst>
           </p:cNvPr>
@@ -25741,7 +25723,7 @@
           <p:cNvPr id="10" name="footnote">
             <a:extLst xmlns:a="http://schemas.openxmlformats.org/drawingml/2006/main">
               <a:ext uri="{FF2B5EF4-FFF2-40B4-BE49-F238E27FC236}">
-                <a16:creationId xmlns:a16="http://schemas.microsoft.com/office/drawing/2014/main" id="{95E83488-94FE-492E-AADE-D7490B836123}"/>
+                <a16:creationId xmlns:a16="http://schemas.microsoft.com/office/drawing/2014/main" id="{BE36D5BC-1CF0-47EE-9283-89E45E4A55DB}"/>
               </a:ext>
             </a:extLst>
           </p:cNvPr>
@@ -25798,7 +25780,7 @@
           <p:cNvPr id="11" name="page">
             <a:extLst xmlns:a="http://schemas.openxmlformats.org/drawingml/2006/main">
               <a:ext uri="{FF2B5EF4-FFF2-40B4-BE49-F238E27FC236}">
-                <a16:creationId xmlns:a16="http://schemas.microsoft.com/office/drawing/2014/main" id="{30391F59-B94F-4A49-8BE9-CEDB69D20694}"/>
+                <a16:creationId xmlns:a16="http://schemas.microsoft.com/office/drawing/2014/main" id="{0E80DC56-D88D-4B35-8674-C86B275A5D62}"/>
               </a:ext>
             </a:extLst>
           </p:cNvPr>
@@ -25853,7 +25835,7 @@
     </p:spTree>
     <p:extLst>
       <p:ext uri="{BB962C8B-B14F-4D97-AF65-F5344CB8AC3E}">
-        <p14:creationId xmlns:p14="http://schemas.microsoft.com/office/powerpoint/2010/main" val="2063052499"/>
+        <p14:creationId xmlns:p14="http://schemas.microsoft.com/office/powerpoint/2010/main" val="1715495833"/>
       </p:ext>
     </p:extLst>
   </p:cSld>
@@ -25884,7 +25866,7 @@
           <p:cNvPr id="12" name="course">
             <a:extLst xmlns:a="http://schemas.openxmlformats.org/drawingml/2006/main">
               <a:ext uri="{FF2B5EF4-FFF2-40B4-BE49-F238E27FC236}">
-                <a16:creationId xmlns:a16="http://schemas.microsoft.com/office/drawing/2014/main" id="{94607168-8B2E-412F-BEF0-BC88129B2472}"/>
+                <a16:creationId xmlns:a16="http://schemas.microsoft.com/office/drawing/2014/main" id="{70EA9162-D344-4AAB-8115-422AC8D04F87}"/>
               </a:ext>
             </a:extLst>
           </p:cNvPr>
@@ -25941,7 +25923,7 @@
           <p:cNvPr id="2" name="title">
             <a:extLst xmlns:a="http://schemas.openxmlformats.org/drawingml/2006/main">
               <a:ext uri="{FF2B5EF4-FFF2-40B4-BE49-F238E27FC236}">
-                <a16:creationId xmlns:a16="http://schemas.microsoft.com/office/drawing/2014/main" id="{F9FC2120-3F08-499D-8C13-BF069312622F}"/>
+                <a16:creationId xmlns:a16="http://schemas.microsoft.com/office/drawing/2014/main" id="{431DF7C7-56D6-4B9E-A0DF-F4FA2F0EF44D}"/>
               </a:ext>
             </a:extLst>
           </p:cNvPr>
@@ -25998,7 +25980,7 @@
           <p:cNvPr id="3" name="body">
             <a:extLst xmlns:a="http://schemas.openxmlformats.org/drawingml/2006/main">
               <a:ext uri="{FF2B5EF4-FFF2-40B4-BE49-F238E27FC236}">
-                <a16:creationId xmlns:a16="http://schemas.microsoft.com/office/drawing/2014/main" id="{D8BF8516-5E27-4FE2-B88B-55264D9996AD}"/>
+                <a16:creationId xmlns:a16="http://schemas.microsoft.com/office/drawing/2014/main" id="{23AA244F-2C5B-4390-8A6F-6A89ED4E6C5B}"/>
               </a:ext>
             </a:extLst>
           </p:cNvPr>
@@ -26055,7 +26037,7 @@
           <p:cNvPr id="4" name="body">
             <a:extLst xmlns:a="http://schemas.openxmlformats.org/drawingml/2006/main">
               <a:ext uri="{FF2B5EF4-FFF2-40B4-BE49-F238E27FC236}">
-                <a16:creationId xmlns:a16="http://schemas.microsoft.com/office/drawing/2014/main" id="{1BB528D3-0B92-4E31-B40C-9B670539B6D2}"/>
+                <a16:creationId xmlns:a16="http://schemas.microsoft.com/office/drawing/2014/main" id="{7DCC54F8-1BD8-42FE-B643-C36F0A9A6B02}"/>
               </a:ext>
             </a:extLst>
           </p:cNvPr>
@@ -26112,7 +26094,7 @@
           <p:cNvPr id="5" name="body">
             <a:extLst xmlns:a="http://schemas.openxmlformats.org/drawingml/2006/main">
               <a:ext uri="{FF2B5EF4-FFF2-40B4-BE49-F238E27FC236}">
-                <a16:creationId xmlns:a16="http://schemas.microsoft.com/office/drawing/2014/main" id="{DC0E01AA-F2F4-4441-8FB3-857D97D6A600}"/>
+                <a16:creationId xmlns:a16="http://schemas.microsoft.com/office/drawing/2014/main" id="{430B9C3A-3753-4089-B42C-2CE53B25FCFE}"/>
               </a:ext>
             </a:extLst>
           </p:cNvPr>
@@ -26169,7 +26151,7 @@
           <p:cNvPr id="6" name="body">
             <a:extLst xmlns:a="http://schemas.openxmlformats.org/drawingml/2006/main">
               <a:ext uri="{FF2B5EF4-FFF2-40B4-BE49-F238E27FC236}">
-                <a16:creationId xmlns:a16="http://schemas.microsoft.com/office/drawing/2014/main" id="{237F58AE-9AD8-4CEF-B4D7-FF523C75042B}"/>
+                <a16:creationId xmlns:a16="http://schemas.microsoft.com/office/drawing/2014/main" id="{3120E00C-AD74-4B2C-9377-6852D7DB57D2}"/>
               </a:ext>
             </a:extLst>
           </p:cNvPr>
@@ -26226,7 +26208,7 @@
           <p:cNvPr id="7" name="body">
             <a:extLst xmlns:a="http://schemas.openxmlformats.org/drawingml/2006/main">
               <a:ext uri="{FF2B5EF4-FFF2-40B4-BE49-F238E27FC236}">
-                <a16:creationId xmlns:a16="http://schemas.microsoft.com/office/drawing/2014/main" id="{A57C5E8D-D6D1-467A-817F-4909AACACF8D}"/>
+                <a16:creationId xmlns:a16="http://schemas.microsoft.com/office/drawing/2014/main" id="{F1DF01C3-9477-4CE2-999F-2531590283B0}"/>
               </a:ext>
             </a:extLst>
           </p:cNvPr>
@@ -26283,7 +26265,7 @@
           <p:cNvPr id="8" name="body">
             <a:extLst xmlns:a="http://schemas.openxmlformats.org/drawingml/2006/main">
               <a:ext uri="{FF2B5EF4-FFF2-40B4-BE49-F238E27FC236}">
-                <a16:creationId xmlns:a16="http://schemas.microsoft.com/office/drawing/2014/main" id="{A23F6DBD-5DC1-459B-858D-1938D46AD8D2}"/>
+                <a16:creationId xmlns:a16="http://schemas.microsoft.com/office/drawing/2014/main" id="{90B82DBF-D6C9-4709-B039-CD944D1C2880}"/>
               </a:ext>
             </a:extLst>
           </p:cNvPr>
@@ -26340,7 +26322,7 @@
           <p:cNvPr id="9" name="equation">
             <a:extLst xmlns:a="http://schemas.openxmlformats.org/drawingml/2006/main">
               <a:ext uri="{FF2B5EF4-FFF2-40B4-BE49-F238E27FC236}">
-                <a16:creationId xmlns:a16="http://schemas.microsoft.com/office/drawing/2014/main" id="{F27646CA-FA2F-4778-AFDA-839F657B0213}"/>
+                <a16:creationId xmlns:a16="http://schemas.microsoft.com/office/drawing/2014/main" id="{358BB9E5-7D71-4EC7-8D7E-8B42F661A143}"/>
               </a:ext>
             </a:extLst>
           </p:cNvPr>
@@ -26397,7 +26379,7 @@
           <p:cNvPr id="10" name="footnote">
             <a:extLst xmlns:a="http://schemas.openxmlformats.org/drawingml/2006/main">
               <a:ext uri="{FF2B5EF4-FFF2-40B4-BE49-F238E27FC236}">
-                <a16:creationId xmlns:a16="http://schemas.microsoft.com/office/drawing/2014/main" id="{CD35D848-CA2D-4412-A88C-B5D4FD15488C}"/>
+                <a16:creationId xmlns:a16="http://schemas.microsoft.com/office/drawing/2014/main" id="{73A54F28-7210-4E89-82EE-5598033EABDD}"/>
               </a:ext>
             </a:extLst>
           </p:cNvPr>
@@ -26454,7 +26436,7 @@
           <p:cNvPr id="11" name="page">
             <a:extLst xmlns:a="http://schemas.openxmlformats.org/drawingml/2006/main">
               <a:ext uri="{FF2B5EF4-FFF2-40B4-BE49-F238E27FC236}">
-                <a16:creationId xmlns:a16="http://schemas.microsoft.com/office/drawing/2014/main" id="{F76E334E-4645-41DF-B247-9CE442C4F1B6}"/>
+                <a16:creationId xmlns:a16="http://schemas.microsoft.com/office/drawing/2014/main" id="{2ED32C72-DFFB-49FE-8682-80958773A14B}"/>
               </a:ext>
             </a:extLst>
           </p:cNvPr>
@@ -26509,7 +26491,7 @@
     </p:spTree>
     <p:extLst>
       <p:ext uri="{BB962C8B-B14F-4D97-AF65-F5344CB8AC3E}">
-        <p14:creationId xmlns:p14="http://schemas.microsoft.com/office/powerpoint/2010/main" val="1097774696"/>
+        <p14:creationId xmlns:p14="http://schemas.microsoft.com/office/powerpoint/2010/main" val="228907474"/>
       </p:ext>
     </p:extLst>
   </p:cSld>

</xml_diff>

<commit_message>
Expand six experiment introductions in Lecture 01
</commit_message>
<xml_diff>
--- a/site/docs/MIE402_Lecture01_Report_Writing_Fall2026_v1.pptx
+++ b/site/docs/MIE402_Lecture01_Report_Writing_Fall2026_v1.pptx
@@ -2,43 +2,43 @@
 <file path=ppt/presentation.xml><?xml version="1.0" encoding="utf-8"?>
 <p:presentation xmlns:p="http://schemas.openxmlformats.org/presentationml/2006/main">
   <p:sldMasterIdLst>
-    <p:sldMasterId xmlns:r="http://schemas.openxmlformats.org/officeDocument/2006/relationships" id="2147483648" r:id="R84eadb1f28fb4f83"/>
+    <p:sldMasterId xmlns:r="http://schemas.openxmlformats.org/officeDocument/2006/relationships" id="2147483648" r:id="Rbcf33a22744d467e"/>
   </p:sldMasterIdLst>
   <p:notesMasterIdLst>
-    <p:notesMasterId xmlns:r="http://schemas.openxmlformats.org/officeDocument/2006/relationships" r:id="Rbb5a737ac96e4e2e"/>
+    <p:notesMasterId xmlns:r="http://schemas.openxmlformats.org/officeDocument/2006/relationships" r:id="Rca26043123f947fd"/>
   </p:notesMasterIdLst>
   <p:sldIdLst>
-    <p:sldId xmlns:r="http://schemas.openxmlformats.org/officeDocument/2006/relationships" id="256" r:id="Rc24eb59950c44ee0"/>
-    <p:sldId xmlns:r="http://schemas.openxmlformats.org/officeDocument/2006/relationships" id="257" r:id="R2d45e1aa99d44cd3"/>
-    <p:sldId xmlns:r="http://schemas.openxmlformats.org/officeDocument/2006/relationships" id="258" r:id="Ra602d9409b0540ac"/>
-    <p:sldId xmlns:r="http://schemas.openxmlformats.org/officeDocument/2006/relationships" id="259" r:id="R584dae359adf4e6d"/>
-    <p:sldId xmlns:r="http://schemas.openxmlformats.org/officeDocument/2006/relationships" id="260" r:id="R5584d0b387364a25"/>
-    <p:sldId xmlns:r="http://schemas.openxmlformats.org/officeDocument/2006/relationships" id="261" r:id="R0005c2f09afd4d02"/>
-    <p:sldId xmlns:r="http://schemas.openxmlformats.org/officeDocument/2006/relationships" id="262" r:id="Rcbb3b518b73a4b1f"/>
-    <p:sldId xmlns:r="http://schemas.openxmlformats.org/officeDocument/2006/relationships" id="263" r:id="R8c2f4c57c4aa42f2"/>
-    <p:sldId xmlns:r="http://schemas.openxmlformats.org/officeDocument/2006/relationships" id="264" r:id="R3406378ac5e04ded"/>
-    <p:sldId xmlns:r="http://schemas.openxmlformats.org/officeDocument/2006/relationships" id="265" r:id="R0d0fbcf3f8b247ca"/>
-    <p:sldId xmlns:r="http://schemas.openxmlformats.org/officeDocument/2006/relationships" id="266" r:id="R4aac9c09e5084085"/>
-    <p:sldId xmlns:r="http://schemas.openxmlformats.org/officeDocument/2006/relationships" id="267" r:id="Rf1679ce93c00476b"/>
-    <p:sldId xmlns:r="http://schemas.openxmlformats.org/officeDocument/2006/relationships" id="268" r:id="R2d48222bee424bc4"/>
-    <p:sldId xmlns:r="http://schemas.openxmlformats.org/officeDocument/2006/relationships" id="269" r:id="R55ef97810cbd47ff"/>
-    <p:sldId xmlns:r="http://schemas.openxmlformats.org/officeDocument/2006/relationships" id="270" r:id="R5b04dac1fedd45d1"/>
-    <p:sldId xmlns:r="http://schemas.openxmlformats.org/officeDocument/2006/relationships" id="271" r:id="R0ba4dd63a8e0424f"/>
-    <p:sldId xmlns:r="http://schemas.openxmlformats.org/officeDocument/2006/relationships" id="272" r:id="Rf80513c7dd9f4b41"/>
-    <p:sldId xmlns:r="http://schemas.openxmlformats.org/officeDocument/2006/relationships" id="273" r:id="R2b0e803465894db2"/>
-    <p:sldId xmlns:r="http://schemas.openxmlformats.org/officeDocument/2006/relationships" id="274" r:id="Re2334d2cb9df4e26"/>
-    <p:sldId xmlns:r="http://schemas.openxmlformats.org/officeDocument/2006/relationships" id="275" r:id="Rdef1ef7e0456422c"/>
-    <p:sldId xmlns:r="http://schemas.openxmlformats.org/officeDocument/2006/relationships" id="276" r:id="Rdedd7b6c6a9541e1"/>
-    <p:sldId xmlns:r="http://schemas.openxmlformats.org/officeDocument/2006/relationships" id="277" r:id="R847d273b30094202"/>
-    <p:sldId xmlns:r="http://schemas.openxmlformats.org/officeDocument/2006/relationships" id="278" r:id="Ra9767f1e497c4e52"/>
-    <p:sldId xmlns:r="http://schemas.openxmlformats.org/officeDocument/2006/relationships" id="279" r:id="Re02342af6b1a4a54"/>
-    <p:sldId xmlns:r="http://schemas.openxmlformats.org/officeDocument/2006/relationships" id="280" r:id="R897e8dfeda064186"/>
-    <p:sldId xmlns:r="http://schemas.openxmlformats.org/officeDocument/2006/relationships" id="281" r:id="Ra60abe02309f49c7"/>
-    <p:sldId xmlns:r="http://schemas.openxmlformats.org/officeDocument/2006/relationships" id="282" r:id="R8ecbb2ba50a6440a"/>
-    <p:sldId xmlns:r="http://schemas.openxmlformats.org/officeDocument/2006/relationships" id="283" r:id="R8a82106dd1584e6a"/>
-    <p:sldId xmlns:r="http://schemas.openxmlformats.org/officeDocument/2006/relationships" id="284" r:id="R4251e48241c84bcc"/>
-    <p:sldId xmlns:r="http://schemas.openxmlformats.org/officeDocument/2006/relationships" id="285" r:id="R716da1e59de94c20"/>
-    <p:sldId xmlns:r="http://schemas.openxmlformats.org/officeDocument/2006/relationships" id="286" r:id="R3a4d66a95baa438c"/>
+    <p:sldId xmlns:r="http://schemas.openxmlformats.org/officeDocument/2006/relationships" id="256" r:id="Rc4c142acdbd74147"/>
+    <p:sldId xmlns:r="http://schemas.openxmlformats.org/officeDocument/2006/relationships" id="257" r:id="R8e7d719d62d44c79"/>
+    <p:sldId xmlns:r="http://schemas.openxmlformats.org/officeDocument/2006/relationships" id="258" r:id="R6bf03beb94674cc1"/>
+    <p:sldId xmlns:r="http://schemas.openxmlformats.org/officeDocument/2006/relationships" id="259" r:id="Rf9aeb262d167473c"/>
+    <p:sldId xmlns:r="http://schemas.openxmlformats.org/officeDocument/2006/relationships" id="260" r:id="Rac4dbb6e6a6e4c61"/>
+    <p:sldId xmlns:r="http://schemas.openxmlformats.org/officeDocument/2006/relationships" id="261" r:id="Rced9bf1254c04364"/>
+    <p:sldId xmlns:r="http://schemas.openxmlformats.org/officeDocument/2006/relationships" id="262" r:id="R6bb04cc030cd4573"/>
+    <p:sldId xmlns:r="http://schemas.openxmlformats.org/officeDocument/2006/relationships" id="263" r:id="R61b583a851c94d85"/>
+    <p:sldId xmlns:r="http://schemas.openxmlformats.org/officeDocument/2006/relationships" id="264" r:id="Rca66a93c80104475"/>
+    <p:sldId xmlns:r="http://schemas.openxmlformats.org/officeDocument/2006/relationships" id="265" r:id="Rc4f0ca17b83f43cc"/>
+    <p:sldId xmlns:r="http://schemas.openxmlformats.org/officeDocument/2006/relationships" id="266" r:id="R2b269e384a7b439e"/>
+    <p:sldId xmlns:r="http://schemas.openxmlformats.org/officeDocument/2006/relationships" id="267" r:id="R68f60188ca634b95"/>
+    <p:sldId xmlns:r="http://schemas.openxmlformats.org/officeDocument/2006/relationships" id="268" r:id="Rfed55e57081347ea"/>
+    <p:sldId xmlns:r="http://schemas.openxmlformats.org/officeDocument/2006/relationships" id="269" r:id="R32205d45a44446bc"/>
+    <p:sldId xmlns:r="http://schemas.openxmlformats.org/officeDocument/2006/relationships" id="270" r:id="R6ce9cffe402248c5"/>
+    <p:sldId xmlns:r="http://schemas.openxmlformats.org/officeDocument/2006/relationships" id="271" r:id="R7ff18e075ae64cba"/>
+    <p:sldId xmlns:r="http://schemas.openxmlformats.org/officeDocument/2006/relationships" id="272" r:id="Rb0e3cc6423a84237"/>
+    <p:sldId xmlns:r="http://schemas.openxmlformats.org/officeDocument/2006/relationships" id="273" r:id="R24466631b7ca45cd"/>
+    <p:sldId xmlns:r="http://schemas.openxmlformats.org/officeDocument/2006/relationships" id="274" r:id="R92bf14b82ecc4593"/>
+    <p:sldId xmlns:r="http://schemas.openxmlformats.org/officeDocument/2006/relationships" id="275" r:id="R22c8f18afc504092"/>
+    <p:sldId xmlns:r="http://schemas.openxmlformats.org/officeDocument/2006/relationships" id="276" r:id="Recd74c8aea954390"/>
+    <p:sldId xmlns:r="http://schemas.openxmlformats.org/officeDocument/2006/relationships" id="277" r:id="R317e4c1b238c49ca"/>
+    <p:sldId xmlns:r="http://schemas.openxmlformats.org/officeDocument/2006/relationships" id="278" r:id="R5ea48bea1b364347"/>
+    <p:sldId xmlns:r="http://schemas.openxmlformats.org/officeDocument/2006/relationships" id="279" r:id="R0e757865f3d745dd"/>
+    <p:sldId xmlns:r="http://schemas.openxmlformats.org/officeDocument/2006/relationships" id="280" r:id="R06c0f976879846e8"/>
+    <p:sldId xmlns:r="http://schemas.openxmlformats.org/officeDocument/2006/relationships" id="281" r:id="R76b1404690f64263"/>
+    <p:sldId xmlns:r="http://schemas.openxmlformats.org/officeDocument/2006/relationships" id="282" r:id="R582aba0db5564954"/>
+    <p:sldId xmlns:r="http://schemas.openxmlformats.org/officeDocument/2006/relationships" id="283" r:id="R0e5211d6e64f415b"/>
+    <p:sldId xmlns:r="http://schemas.openxmlformats.org/officeDocument/2006/relationships" id="284" r:id="R688aae3d21284738"/>
+    <p:sldId xmlns:r="http://schemas.openxmlformats.org/officeDocument/2006/relationships" id="285" r:id="R2101d9f5912c469d"/>
+    <p:sldId xmlns:r="http://schemas.openxmlformats.org/officeDocument/2006/relationships" id="286" r:id="Rce2e18aee4d74494"/>
   </p:sldIdLst>
   <p:sldSz cx="12192000" cy="6858000"/>
   <p:notesSz cx="6858000" cy="9144000"/>
@@ -567,7 +567,7 @@
           <a:lstStyle xmlns:a="http://schemas.openxmlformats.org/drawingml/2006/main"/>
           <a:p xmlns:a="http://schemas.openxmlformats.org/drawingml/2006/main">
             <a:r>
-              <a:t>TIME: 12–14 minutes (2 minutes)</a:t>
+              <a:t>TIME: 13–15.5 minutes (2.5 minutes)</a:t>
             </a:r>
           </a:p>
           <a:p xmlns:a="http://schemas.openxmlformats.org/drawingml/2006/main">
@@ -577,7 +577,7 @@
           </a:p>
           <a:p xmlns:a="http://schemas.openxmlformats.org/drawingml/2006/main">
             <a:r>
-              <a:t>A second angle introduces coupling: the motion of one link influences the other. At small amplitudes, students can look for coupled oscillatory behavior and multiple characteristic frequencies. At larger amplitudes, nonlinear behavior makes a single sinusoidal description inadequate and trajectories can become sensitive to initial conditions. Avoid promising that every trial is chaotic. Ask whether a late mismatch between measured and simulated trajectories automatically means a numerical solver is wrong. Possible causes include a small initial-angle mismatch, uncertain mass properties, unmodeled friction, and image-tracking error. The report should show both angles with clear definitions and time alignment.</a:t>
+              <a:t>A second moving link introduces coupling: the motion of one link influences the other. The procedure begins with a small-angle case and asks for at least three large-angle initial conditions. Students must record both initial angles accurately because small differences can grow during a nonlinear response. At small amplitudes, look for coupled oscillatory behavior and more than one characteristic frequency. At larger amplitudes, a single sinusoid is inadequate and trajectories can become sensitive to initial conditions. Ask whether a late mismatch automatically means the numerical solver is wrong. Other causes include initial-angle mismatch, uncertain mass properties, friction, out-of-plane motion, and image-tracking error. The report should define both angles and use the same time origin for experiment and simulation.</a:t>
             </a:r>
           </a:p>
           <a:p xmlns:a="http://schemas.openxmlformats.org/drawingml/2006/main">
@@ -662,7 +662,7 @@
           <a:lstStyle xmlns:a="http://schemas.openxmlformats.org/drawingml/2006/main"/>
           <a:p xmlns:a="http://schemas.openxmlformats.org/drawingml/2006/main">
             <a:r>
-              <a:t>TIME: 14–16 minutes (2 minutes)</a:t>
+              <a:t>TIME: 15.5–18 minutes (2.5 minutes)</a:t>
             </a:r>
           </a:p>
           <a:p xmlns:a="http://schemas.openxmlformats.org/drawingml/2006/main">
@@ -672,7 +672,7 @@
           </a:p>
           <a:p xmlns:a="http://schemas.openxmlformats.org/drawingml/2006/main">
             <a:r>
-              <a:t>Use the terms carefully. A free response starts from an initial condition without continued excitation. The oscillation period primarily reflects mass and stiffness, while the envelope decay reflects damping. Ask students to predict what happens when mass increases while stiffness stays fixed: the natural frequency decreases. Keep the effective system stiffness consistent with the spring arrangement. For an underdamped response, the peak spacing gives the damped frequency. A logarithmic decrement can estimate damping when the viscous model and clean peak data are appropriate. Students should explain how they selected peaks, removed equilibrium offsets, and compared multiple configurations.</a:t>
+              <a:t>A free response begins with an initial displacement and no continued excitation. Students first measure component masses and spring stiffness, then record the cart decay with the Vernier system at the assigned rate, no higher than 25 Hz in the supplied procedure. The procedure suggests a base case and separate changes to mass, damping, and stiffness, for a minimum of seven useful cases. The oscillation period mainly reflects mass and effective stiffness, while the envelope decay reflects damping. For an underdamped record, peak spacing gives the damped frequency and logarithmic decrement can estimate damping when clean peaks and a viscous model are appropriate. Students must zero the position, record the initial displacement, verify the exported CSV, and state how they selected peaks and removed the equilibrium offset.</a:t>
             </a:r>
           </a:p>
           <a:p xmlns:a="http://schemas.openxmlformats.org/drawingml/2006/main">
@@ -757,7 +757,7 @@
           <a:lstStyle xmlns:a="http://schemas.openxmlformats.org/drawingml/2006/main"/>
           <a:p xmlns:a="http://schemas.openxmlformats.org/drawingml/2006/main">
             <a:r>
-              <a:t>TIME: 16–18 minutes (2 minutes)</a:t>
+              <a:t>TIME: 18–20.5 minutes (2.5 minutes)</a:t>
             </a:r>
           </a:p>
           <a:p xmlns:a="http://schemas.openxmlformats.org/drawingml/2006/main">
@@ -767,7 +767,7 @@
           </a:p>
           <a:p xmlns:a="http://schemas.openxmlformats.org/drawingml/2006/main">
             <a:r>
-              <a:t>Explain the difference between free decay and sustained forcing. Near resonance, a lightly damped system can respond strongly. Ask why a measurement immediately after changing excitation frequency might be misleading: transient motion remains. The supplied apparatus includes motion of a spring attachment, so students must identify whether they measure force or base displacement and choose the matching input-output model. Record input amplitude at every frequency rather than assuming it remains constant. For the combined report, use the Lab 4 estimates as an independent check on the Lab 5 response wherever the configuration is the same. Document changes to springs, mass, or damping before comparing parameters.</a:t>
+              <a:t>The experiment has two parts. First, students apply three different impulse forces and compare time histories and spectra. Second, the motor supplies harmonic input. The supplied procedure calls for magnetic damping, a measured input amplitude, at least several frequencies below and above resonance, and one to two minutes for the cart to approach steady motion after a frequency change. Avoid prolonged operation at resonance. Students use the tachometer for driving frequency and must convert RPM to rad/s. The Bode magnitude point is output amplitude divided by input amplitude, so the input must be measured at every frequency. For the combined report, compare the experimental curve with transfer-function or state-space prediction and use Lab 4 estimates only when the mass, springs, and damping configuration match.</a:t>
             </a:r>
           </a:p>
           <a:p xmlns:a="http://schemas.openxmlformats.org/drawingml/2006/main">
@@ -852,7 +852,7 @@
           <a:lstStyle xmlns:a="http://schemas.openxmlformats.org/drawingml/2006/main"/>
           <a:p xmlns:a="http://schemas.openxmlformats.org/drawingml/2006/main">
             <a:r>
-              <a:t>TIME: 18–20 minutes (2 minutes)</a:t>
+              <a:t>TIME: 20.5–23 minutes (2.5 minutes)</a:t>
             </a:r>
           </a:p>
           <a:p xmlns:a="http://schemas.openxmlformats.org/drawingml/2006/main">
@@ -862,7 +862,7 @@
           </a:p>
           <a:p xmlns:a="http://schemas.openxmlformats.org/drawingml/2006/main">
             <a:r>
-              <a:t>The black and reflective vane surfaces interact differently with radiation. Temperature differences and rarefied-gas transport generate the observed torque. Ordinary photon-pressure reasoning does not explain the typical Crookes radiometer rotation. Keep the first lecture focused on the measurable output: cumulative angle and an average slope over a stated interval. Differentiating noisy frame-by-frame angles can produce misleading speed spikes. Use the same elapsed-time window when comparing cases and record whether later runs start warm. The available module discusses thermal slowdown and an optional first-order rotational model. Do not demand a precise Knudsen number from an unknown internal gas pressure. Follow the released procedure and instructor guidance for lamp placement and glass handling.</a:t>
+              <a:t>The LED heats black and reflective vane surfaces differently. Temperature gradients and rarefied-gas transport near the vane edges generate the observed torque. Ordinary photon pressure is far too small to explain the typical Crookes radiometer rotation. The required workflow uses one clear video over a fixed 60 to 90 second window, with the camera, light, radiometer, and background stationary. The matte black board should sit behind the bulb without touching it or receiving the strongest beam. Students inspect the tracking annulus, unwrap cumulative angle, and fit a robust slope. Frame-by-frame differentiation creates misleading speed spikes. Compare identical time windows, record whether later trials start warm, and use interval RPM to discuss thermal slowdown. Lux measures visible illuminance rather than absorbed thermal power. Keep the glass away from the table edge and avoid glare or excessive heating.</a:t>
             </a:r>
           </a:p>
           <a:p xmlns:a="http://schemas.openxmlformats.org/drawingml/2006/main">
@@ -947,7 +947,7 @@
           <a:lstStyle xmlns:a="http://schemas.openxmlformats.org/drawingml/2006/main"/>
           <a:p xmlns:a="http://schemas.openxmlformats.org/drawingml/2006/main">
             <a:r>
-              <a:t>TIME: 20–22 minutes (2 minutes)</a:t>
+              <a:t>TIME: 23–24.5 minutes (1.5 minutes)</a:t>
             </a:r>
           </a:p>
           <a:p xmlns:a="http://schemas.openxmlformats.org/drawingml/2006/main">
@@ -1042,7 +1042,7 @@
           <a:lstStyle xmlns:a="http://schemas.openxmlformats.org/drawingml/2006/main"/>
           <a:p xmlns:a="http://schemas.openxmlformats.org/drawingml/2006/main">
             <a:r>
-              <a:t>TIME: 22–24 minutes (2 minutes)</a:t>
+              <a:t>TIME: 24.5–26 minutes (1.5 minutes)</a:t>
             </a:r>
           </a:p>
           <a:p xmlns:a="http://schemas.openxmlformats.org/drawingml/2006/main">
@@ -1137,7 +1137,7 @@
           <a:lstStyle xmlns:a="http://schemas.openxmlformats.org/drawingml/2006/main"/>
           <a:p xmlns:a="http://schemas.openxmlformats.org/drawingml/2006/main">
             <a:r>
-              <a:t>TIME: 24–26 minutes (2 minutes)</a:t>
+              <a:t>TIME: 26–27.5 minutes (1.5 minutes)</a:t>
             </a:r>
           </a:p>
           <a:p xmlns:a="http://schemas.openxmlformats.org/drawingml/2006/main">
@@ -1232,7 +1232,7 @@
           <a:lstStyle xmlns:a="http://schemas.openxmlformats.org/drawingml/2006/main"/>
           <a:p xmlns:a="http://schemas.openxmlformats.org/drawingml/2006/main">
             <a:r>
-              <a:t>TIME: 26–28 minutes (2 minutes)</a:t>
+              <a:t>TIME: 27.5–29 minutes (1.5 minutes)</a:t>
             </a:r>
           </a:p>
           <a:p xmlns:a="http://schemas.openxmlformats.org/drawingml/2006/main">
@@ -1327,7 +1327,7 @@
           <a:lstStyle xmlns:a="http://schemas.openxmlformats.org/drawingml/2006/main"/>
           <a:p xmlns:a="http://schemas.openxmlformats.org/drawingml/2006/main">
             <a:r>
-              <a:t>TIME: 28–29 minutes (1 minutes)</a:t>
+              <a:t>TIME: 29–30 minutes (1 minutes)</a:t>
             </a:r>
           </a:p>
           <a:p xmlns:a="http://schemas.openxmlformats.org/drawingml/2006/main">
@@ -1422,7 +1422,7 @@
           <a:lstStyle xmlns:a="http://schemas.openxmlformats.org/drawingml/2006/main"/>
           <a:p xmlns:a="http://schemas.openxmlformats.org/drawingml/2006/main">
             <a:r>
-              <a:t>TIME: 29–30 minutes (1 minutes)</a:t>
+              <a:t>TIME: 30–31 minutes (1 minutes)</a:t>
             </a:r>
           </a:p>
           <a:p xmlns:a="http://schemas.openxmlformats.org/drawingml/2006/main">
@@ -1612,7 +1612,7 @@
           <a:lstStyle xmlns:a="http://schemas.openxmlformats.org/drawingml/2006/main"/>
           <a:p xmlns:a="http://schemas.openxmlformats.org/drawingml/2006/main">
             <a:r>
-              <a:t>TIME: 30–32 minutes (2 minutes)</a:t>
+              <a:t>TIME: 31–33 minutes (2 minutes)</a:t>
             </a:r>
           </a:p>
           <a:p xmlns:a="http://schemas.openxmlformats.org/drawingml/2006/main">
@@ -1707,7 +1707,7 @@
           <a:lstStyle xmlns:a="http://schemas.openxmlformats.org/drawingml/2006/main"/>
           <a:p xmlns:a="http://schemas.openxmlformats.org/drawingml/2006/main">
             <a:r>
-              <a:t>TIME: 32–34 minutes (2 minutes)</a:t>
+              <a:t>TIME: 33–34.5 minutes (1.5 minutes)</a:t>
             </a:r>
           </a:p>
           <a:p xmlns:a="http://schemas.openxmlformats.org/drawingml/2006/main">
@@ -1802,7 +1802,7 @@
           <a:lstStyle xmlns:a="http://schemas.openxmlformats.org/drawingml/2006/main"/>
           <a:p xmlns:a="http://schemas.openxmlformats.org/drawingml/2006/main">
             <a:r>
-              <a:t>TIME: 34–36 minutes (2 minutes)</a:t>
+              <a:t>TIME: 34.5–36 minutes (1.5 minutes)</a:t>
             </a:r>
           </a:p>
           <a:p xmlns:a="http://schemas.openxmlformats.org/drawingml/2006/main">
@@ -2572,7 +2572,7 @@
           </a:p>
           <a:p xmlns:a="http://schemas.openxmlformats.org/drawingml/2006/main">
             <a:r>
-              <a:t>Preview the timing. Tell students that the six experiment introductions are conceptual previews. Detailed procedures and pre-lab requirements come with each experiment. Reserve the exercise time so students practice the distinction between reporting an observation and explaining it.</a:t>
+              <a:t>Preview the timing. The six experiment introductions explain the apparatus, main data-collection steps, expected analysis, and report evidence. Detailed operating procedures and pre-lab requirements come with each experiment. Reserve the exercise time so students practice the distinction between reporting an observation and explaining it.</a:t>
             </a:r>
           </a:p>
           <a:p xmlns:a="http://schemas.openxmlformats.org/drawingml/2006/main">
@@ -3227,7 +3227,7 @@
           <a:lstStyle xmlns:a="http://schemas.openxmlformats.org/drawingml/2006/main"/>
           <a:p xmlns:a="http://schemas.openxmlformats.org/drawingml/2006/main">
             <a:r>
-              <a:t>TIME: 8–10 minutes (2 minutes)</a:t>
+              <a:t>TIME: 8–10.5 minutes (2.5 minutes)</a:t>
             </a:r>
           </a:p>
           <a:p xmlns:a="http://schemas.openxmlformats.org/drawingml/2006/main">
@@ -3237,7 +3237,7 @@
           </a:p>
           <a:p xmlns:a="http://schemas.openxmlformats.org/drawingml/2006/main">
             <a:r>
-              <a:t>Explain that the sensor produces a time signal but the computer stores only selected samples. For an illustrative 100 Hz tone, 150 samples per second can make it appear as a 50 Hz component, while 1000 samples per second represents the oscillation much better. Ask whether taking more samples at the same inadequate sampling rate removes aliasing. It does not. A longer record gives finer FFT-bin spacing, while a sufficiently high sample rate addresses the sampling limit. Keep sampling rate and record length distinct. The report should compare traces and spectra with axes, units, and acquisition settings. This is a preview, not a substitute for the released procedure.</a:t>
+              <a:t>Show the physical chain: sound creates pressure fluctuations, the microphone converts them to voltage, and the data logger stores discrete samples. The procedure compares several sounds and sampling rates, including rates below the Nyquist requirement. For an illustrative 100 Hz tone, 150 samples per second can make it appear as a 50 Hz component, while 1000 samples per second represents the oscillation much better. Ask whether taking more samples at the same inadequate rate removes aliasing. It does not. A longer record gives finer FFT-bin spacing, while a sufficiently high sample rate addresses the sampling limit. Students should verify one clean time record and spectrum before leaving. The report should state the source, sample rate, duration, number of samples, and how the detected peak compares with the expected frequency.</a:t>
             </a:r>
           </a:p>
           <a:p xmlns:a="http://schemas.openxmlformats.org/drawingml/2006/main">
@@ -3322,7 +3322,7 @@
           <a:lstStyle xmlns:a="http://schemas.openxmlformats.org/drawingml/2006/main"/>
           <a:p xmlns:a="http://schemas.openxmlformats.org/drawingml/2006/main">
             <a:r>
-              <a:t>TIME: 10–12 minutes (2 minutes)</a:t>
+              <a:t>TIME: 10.5–13 minutes (2.5 minutes)</a:t>
             </a:r>
           </a:p>
           <a:p xmlns:a="http://schemas.openxmlformats.org/drawingml/2006/main">
@@ -3332,7 +3332,7 @@
           </a:p>
           <a:p xmlns:a="http://schemas.openxmlformats.org/drawingml/2006/main">
             <a:r>
-              <a:t>The actual pendulum contains distributed mass, so do not automatically use the point-mass formula with the rod length. Identify the moment of inertia about the pivot and the center-of-mass distance. For small angular displacement in radians, sin(theta) is approximately theta. Ask students what could change at larger release angles: the linear approximation, and therefore the predicted period. The supplied procedure uses several release-angle ranges and video tracking. Compare the correct initial conditions in the experiment and simulation. A decrease in amplitude can indicate losses absent from the ideal undamped equation. Save the video calibration and angle convention.</a:t>
+              <a:t>The camera records pixels, not angle. Students use the scale reference and pivot location to convert tracked coordinates into physical motion. The procedure calls for releases from rest in three angle ranges and uses a 1000 fps setting unless the released instructions say otherwise. The actual pendulum contains distributed mass, so do not automatically use the point-mass formula with the rod length. Identify the moment of inertia about the pivot and the center-of-mass distance. At small angles, sin(theta) is approximately theta. At larger angles, the linear approximation changes the predicted period. Students should check tracking quality, save the calibration, and record the sign convention. A decrease in amplitude can indicate losses absent from the ideal undamped equation.</a:t>
             </a:r>
           </a:p>
           <a:p xmlns:a="http://schemas.openxmlformats.org/drawingml/2006/main">
@@ -3415,7 +3415,7 @@
   </p:cSld>
   <p:clrMap bg1="lt1" tx1="dk1" bg2="lt2" tx2="dk2" accent1="accent1" accent2="accent2" accent3="accent3" accent4="accent4" accent5="accent5" accent6="accent6" hlink="hlink" folHlink="folHlink"/>
   <p:sldLayoutIdLst>
-    <p:sldLayoutId xmlns:r="http://schemas.openxmlformats.org/officeDocument/2006/relationships" id="2147483649" r:id="Rfd598a04274c42b4"/>
+    <p:sldLayoutId xmlns:r="http://schemas.openxmlformats.org/officeDocument/2006/relationships" id="2147483649" r:id="R5893a51c77a24cc3"/>
   </p:sldLayoutIdLst>
   <p:txStyles>
     <p:titleStyle>
@@ -6012,10 +6012,10 @@
       </p:grpSpPr>
       <p:sp>
         <p:nvSpPr>
-          <p:cNvPr id="11" name="course">
-            <a:extLst xmlns:a="http://schemas.openxmlformats.org/drawingml/2006/main">
-              <a:ext uri="{FF2B5EF4-FFF2-40B4-BE49-F238E27FC236}">
-                <a16:creationId xmlns:a16="http://schemas.microsoft.com/office/drawing/2014/main" id="{00044A58-CD51-47A7-927B-846CAA370E34}"/>
+          <p:cNvPr id="13" name="course">
+            <a:extLst xmlns:a="http://schemas.openxmlformats.org/drawingml/2006/main">
+              <a:ext uri="{FF2B5EF4-FFF2-40B4-BE49-F238E27FC236}">
+                <a16:creationId xmlns:a16="http://schemas.microsoft.com/office/drawing/2014/main" id="{370581A6-5129-4162-AE97-9C0BBF100341}"/>
               </a:ext>
             </a:extLst>
           </p:cNvPr>
@@ -6072,7 +6072,7 @@
           <p:cNvPr id="2" name="title">
             <a:extLst xmlns:a="http://schemas.openxmlformats.org/drawingml/2006/main">
               <a:ext uri="{FF2B5EF4-FFF2-40B4-BE49-F238E27FC236}">
-                <a16:creationId xmlns:a16="http://schemas.microsoft.com/office/drawing/2014/main" id="{F95E1EA2-6B4C-4401-8BCC-9598BD0E14AF}"/>
+                <a16:creationId xmlns:a16="http://schemas.microsoft.com/office/drawing/2014/main" id="{884F021C-46B6-4B52-9A73-C058B0E1C0ED}"/>
               </a:ext>
             </a:extLst>
           </p:cNvPr>
@@ -6129,7 +6129,7 @@
           <p:cNvPr id="3" name="body">
             <a:extLst xmlns:a="http://schemas.openxmlformats.org/drawingml/2006/main">
               <a:ext uri="{FF2B5EF4-FFF2-40B4-BE49-F238E27FC236}">
-                <a16:creationId xmlns:a16="http://schemas.microsoft.com/office/drawing/2014/main" id="{FF15A17A-59D6-40FC-81F5-289B7AABE51B}"/>
+                <a16:creationId xmlns:a16="http://schemas.microsoft.com/office/drawing/2014/main" id="{42463DA0-0EBB-4DD6-BDB3-2EE67FC63FD9}"/>
               </a:ext>
             </a:extLst>
           </p:cNvPr>
@@ -6158,7 +6158,7 @@
           <a:lstStyle xmlns:a="http://schemas.openxmlformats.org/drawingml/2006/main"/>
           <a:p xmlns:a="http://schemas.openxmlformats.org/drawingml/2006/main">
             <a:pPr>
-              <a:defRPr sz="1875" b="1">
+              <a:defRPr sz="1650" b="1">
                 <a:solidFill>
                   <a:srgbClr val="881C1C"/>
                 </a:solidFill>
@@ -6168,7 +6168,7 @@
               </a:defRPr>
             </a:pPr>
             <a:r>
-              <a:rPr sz="1875" b="1">
+              <a:rPr sz="1650" b="1">
                 <a:solidFill>
                   <a:srgbClr val="881C1C"/>
                 </a:solidFill>
@@ -6176,7 +6176,7 @@
                 <a:ea typeface="Calibri"/>
                 <a:cs typeface="Calibri"/>
               </a:rPr>
-              <a:t>Question</a:t>
+              <a:t>Apparatus</a:t>
             </a:r>
           </a:p>
         </p:txBody>
@@ -6186,7 +6186,7 @@
           <p:cNvPr id="4" name="body">
             <a:extLst xmlns:a="http://schemas.openxmlformats.org/drawingml/2006/main">
               <a:ext uri="{FF2B5EF4-FFF2-40B4-BE49-F238E27FC236}">
-                <a16:creationId xmlns:a16="http://schemas.microsoft.com/office/drawing/2014/main" id="{4A9947C8-E9EF-47AC-A903-76354FF9E931}"/>
+                <a16:creationId xmlns:a16="http://schemas.microsoft.com/office/drawing/2014/main" id="{0F0E0AE6-8CFC-4EDA-BBB9-8BA5942479C0}"/>
               </a:ext>
             </a:extLst>
           </p:cNvPr>
@@ -6198,7 +6198,7 @@
         <p:spPr>
           <a:xfrm xmlns:a="http://schemas.openxmlformats.org/drawingml/2006/main">
             <a:off x="495300" y="2057400"/>
-            <a:ext cx="10810875" cy="790575"/>
+            <a:ext cx="10810875" cy="542925"/>
           </a:xfrm>
           <a:prstGeom xmlns:a="http://schemas.openxmlformats.org/drawingml/2006/main" prst="rect">
             <a:avLst/>
@@ -6215,25 +6215,25 @@
           <a:lstStyle xmlns:a="http://schemas.openxmlformats.org/drawingml/2006/main"/>
           <a:p xmlns:a="http://schemas.openxmlformats.org/drawingml/2006/main">
             <a:pPr>
-              <a:defRPr sz="2100" b="0">
-                <a:solidFill>
-                  <a:srgbClr val="111111"/>
-                </a:solidFill>
-                <a:latin typeface="Calibri"/>
-                <a:ea typeface="Calibri"/>
-                <a:cs typeface="Calibri"/>
-              </a:defRPr>
-            </a:pPr>
-            <a:r>
-              <a:rPr sz="2100" b="0">
-                <a:solidFill>
-                  <a:srgbClr val="111111"/>
-                </a:solidFill>
-                <a:latin typeface="Calibri"/>
-                <a:ea typeface="Calibri"/>
-                <a:cs typeface="Calibri"/>
-              </a:rPr>
-              <a:t>How does coupling change the motion of two connected bodies?</a:t>
+              <a:defRPr sz="1725" b="0">
+                <a:solidFill>
+                  <a:srgbClr val="111111"/>
+                </a:solidFill>
+                <a:latin typeface="Calibri"/>
+                <a:ea typeface="Calibri"/>
+                <a:cs typeface="Calibri"/>
+              </a:defRPr>
+            </a:pPr>
+            <a:r>
+              <a:rPr sz="1725" b="0">
+                <a:solidFill>
+                  <a:srgbClr val="111111"/>
+                </a:solidFill>
+                <a:latin typeface="Calibri"/>
+                <a:ea typeface="Calibri"/>
+                <a:cs typeface="Calibri"/>
+              </a:rPr>
+              <a:t>Two-link pendulum, high-speed camera, scale reference, and image tracking for both moving masses.</a:t>
             </a:r>
           </a:p>
         </p:txBody>
@@ -6243,18 +6243,18 @@
           <p:cNvPr id="5" name="body">
             <a:extLst xmlns:a="http://schemas.openxmlformats.org/drawingml/2006/main">
               <a:ext uri="{FF2B5EF4-FFF2-40B4-BE49-F238E27FC236}">
-                <a16:creationId xmlns:a16="http://schemas.microsoft.com/office/drawing/2014/main" id="{83B6A5AB-113E-4A04-993D-375DC3C532E7}"/>
-              </a:ext>
-            </a:extLst>
-          </p:cNvPr>
-          <p:cNvSpPr>
-            <a:spLocks xmlns:a="http://schemas.openxmlformats.org/drawingml/2006/main" noGrp="1"/>
-          </p:cNvSpPr>
-          <p:nvPr/>
-        </p:nvSpPr>
-        <p:spPr>
-          <a:xfrm xmlns:a="http://schemas.openxmlformats.org/drawingml/2006/main">
-            <a:off x="495300" y="2886075"/>
+                <a16:creationId xmlns:a16="http://schemas.microsoft.com/office/drawing/2014/main" id="{7E9E9EDE-B29D-4D48-ADC1-CA534A018EB0}"/>
+              </a:ext>
+            </a:extLst>
+          </p:cNvPr>
+          <p:cNvSpPr>
+            <a:spLocks xmlns:a="http://schemas.openxmlformats.org/drawingml/2006/main" noGrp="1"/>
+          </p:cNvSpPr>
+          <p:nvPr/>
+        </p:nvSpPr>
+        <p:spPr>
+          <a:xfrm xmlns:a="http://schemas.openxmlformats.org/drawingml/2006/main">
+            <a:off x="495300" y="2638425"/>
             <a:ext cx="10810875" cy="361950"/>
           </a:xfrm>
           <a:prstGeom xmlns:a="http://schemas.openxmlformats.org/drawingml/2006/main" prst="rect">
@@ -6272,7 +6272,7 @@
           <a:lstStyle xmlns:a="http://schemas.openxmlformats.org/drawingml/2006/main"/>
           <a:p xmlns:a="http://schemas.openxmlformats.org/drawingml/2006/main">
             <a:pPr>
-              <a:defRPr sz="1875" b="1">
+              <a:defRPr sz="1650" b="1">
                 <a:solidFill>
                   <a:srgbClr val="881C1C"/>
                 </a:solidFill>
@@ -6282,7 +6282,7 @@
               </a:defRPr>
             </a:pPr>
             <a:r>
-              <a:rPr sz="1875" b="1">
+              <a:rPr sz="1650" b="1">
                 <a:solidFill>
                   <a:srgbClr val="881C1C"/>
                 </a:solidFill>
@@ -6290,7 +6290,7 @@
                 <a:ea typeface="Calibri"/>
                 <a:cs typeface="Calibri"/>
               </a:rPr>
-              <a:t>Measurement</a:t>
+              <a:t>Data collection</a:t>
             </a:r>
           </a:p>
         </p:txBody>
@@ -6300,19 +6300,19 @@
           <p:cNvPr id="6" name="body">
             <a:extLst xmlns:a="http://schemas.openxmlformats.org/drawingml/2006/main">
               <a:ext uri="{FF2B5EF4-FFF2-40B4-BE49-F238E27FC236}">
-                <a16:creationId xmlns:a16="http://schemas.microsoft.com/office/drawing/2014/main" id="{DA631368-8596-472A-B854-1C9779230F07}"/>
-              </a:ext>
-            </a:extLst>
-          </p:cNvPr>
-          <p:cNvSpPr>
-            <a:spLocks xmlns:a="http://schemas.openxmlformats.org/drawingml/2006/main" noGrp="1"/>
-          </p:cNvSpPr>
-          <p:nvPr/>
-        </p:nvSpPr>
-        <p:spPr>
-          <a:xfrm xmlns:a="http://schemas.openxmlformats.org/drawingml/2006/main">
-            <a:off x="495300" y="3248025"/>
-            <a:ext cx="10810875" cy="790575"/>
+                <a16:creationId xmlns:a16="http://schemas.microsoft.com/office/drawing/2014/main" id="{72C33899-C737-4158-8C78-8B0FF2D4C925}"/>
+              </a:ext>
+            </a:extLst>
+          </p:cNvPr>
+          <p:cNvSpPr>
+            <a:spLocks xmlns:a="http://schemas.openxmlformats.org/drawingml/2006/main" noGrp="1"/>
+          </p:cNvSpPr>
+          <p:nvPr/>
+        </p:nvSpPr>
+        <p:spPr>
+          <a:xfrm xmlns:a="http://schemas.openxmlformats.org/drawingml/2006/main">
+            <a:off x="495300" y="3000375"/>
+            <a:ext cx="10810875" cy="542925"/>
           </a:xfrm>
           <a:prstGeom xmlns:a="http://schemas.openxmlformats.org/drawingml/2006/main" prst="rect">
             <a:avLst/>
@@ -6329,25 +6329,25 @@
           <a:lstStyle xmlns:a="http://schemas.openxmlformats.org/drawingml/2006/main"/>
           <a:p xmlns:a="http://schemas.openxmlformats.org/drawingml/2006/main">
             <a:pPr>
-              <a:defRPr sz="2100" b="0">
-                <a:solidFill>
-                  <a:srgbClr val="111111"/>
-                </a:solidFill>
-                <a:latin typeface="Calibri"/>
-                <a:ea typeface="Calibri"/>
-                <a:cs typeface="Calibri"/>
-              </a:defRPr>
-            </a:pPr>
-            <a:r>
-              <a:rPr sz="2100" b="0">
-                <a:solidFill>
-                  <a:srgbClr val="111111"/>
-                </a:solidFill>
-                <a:latin typeface="Calibri"/>
-                <a:ea typeface="Calibri"/>
-                <a:cs typeface="Calibri"/>
-              </a:rPr>
-              <a:t>Track both angles and record both initial angles and release conditions.</a:t>
+              <a:defRPr sz="1725" b="0">
+                <a:solidFill>
+                  <a:srgbClr val="111111"/>
+                </a:solidFill>
+                <a:latin typeface="Calibri"/>
+                <a:ea typeface="Calibri"/>
+                <a:cs typeface="Calibri"/>
+              </a:defRPr>
+            </a:pPr>
+            <a:r>
+              <a:rPr sz="1725" b="0">
+                <a:solidFill>
+                  <a:srgbClr val="111111"/>
+                </a:solidFill>
+                <a:latin typeface="Calibri"/>
+                <a:ea typeface="Calibri"/>
+                <a:cs typeface="Calibri"/>
+              </a:rPr>
+              <a:t>Record a small-angle release and at least three large-angle cases. Save both initial angles and release conditions.</a:t>
             </a:r>
           </a:p>
         </p:txBody>
@@ -6357,18 +6357,18 @@
           <p:cNvPr id="7" name="body">
             <a:extLst xmlns:a="http://schemas.openxmlformats.org/drawingml/2006/main">
               <a:ext uri="{FF2B5EF4-FFF2-40B4-BE49-F238E27FC236}">
-                <a16:creationId xmlns:a16="http://schemas.microsoft.com/office/drawing/2014/main" id="{38094D53-1AFD-4558-A5E9-93B3880A9C1B}"/>
-              </a:ext>
-            </a:extLst>
-          </p:cNvPr>
-          <p:cNvSpPr>
-            <a:spLocks xmlns:a="http://schemas.openxmlformats.org/drawingml/2006/main" noGrp="1"/>
-          </p:cNvSpPr>
-          <p:nvPr/>
-        </p:nvSpPr>
-        <p:spPr>
-          <a:xfrm xmlns:a="http://schemas.openxmlformats.org/drawingml/2006/main">
-            <a:off x="495300" y="4076700"/>
+                <a16:creationId xmlns:a16="http://schemas.microsoft.com/office/drawing/2014/main" id="{CEFAD33E-7478-4105-8C15-4B0C42BD5672}"/>
+              </a:ext>
+            </a:extLst>
+          </p:cNvPr>
+          <p:cNvSpPr>
+            <a:spLocks xmlns:a="http://schemas.openxmlformats.org/drawingml/2006/main" noGrp="1"/>
+          </p:cNvSpPr>
+          <p:nvPr/>
+        </p:nvSpPr>
+        <p:spPr>
+          <a:xfrm xmlns:a="http://schemas.openxmlformats.org/drawingml/2006/main">
+            <a:off x="495300" y="3581400"/>
             <a:ext cx="10810875" cy="361950"/>
           </a:xfrm>
           <a:prstGeom xmlns:a="http://schemas.openxmlformats.org/drawingml/2006/main" prst="rect">
@@ -6386,7 +6386,7 @@
           <a:lstStyle xmlns:a="http://schemas.openxmlformats.org/drawingml/2006/main"/>
           <a:p xmlns:a="http://schemas.openxmlformats.org/drawingml/2006/main">
             <a:pPr>
-              <a:defRPr sz="1875" b="1">
+              <a:defRPr sz="1650" b="1">
                 <a:solidFill>
                   <a:srgbClr val="881C1C"/>
                 </a:solidFill>
@@ -6396,7 +6396,7 @@
               </a:defRPr>
             </a:pPr>
             <a:r>
-              <a:rPr sz="1875" b="1">
+              <a:rPr sz="1650" b="1">
                 <a:solidFill>
                   <a:srgbClr val="881C1C"/>
                 </a:solidFill>
@@ -6404,7 +6404,7 @@
                 <a:ea typeface="Calibri"/>
                 <a:cs typeface="Calibri"/>
               </a:rPr>
-              <a:t>Report evidence</a:t>
+              <a:t>Analysis</a:t>
             </a:r>
           </a:p>
         </p:txBody>
@@ -6414,19 +6414,19 @@
           <p:cNvPr id="8" name="body">
             <a:extLst xmlns:a="http://schemas.openxmlformats.org/drawingml/2006/main">
               <a:ext uri="{FF2B5EF4-FFF2-40B4-BE49-F238E27FC236}">
-                <a16:creationId xmlns:a16="http://schemas.microsoft.com/office/drawing/2014/main" id="{B63CB462-DBE5-402F-9986-7C990B7CA825}"/>
-              </a:ext>
-            </a:extLst>
-          </p:cNvPr>
-          <p:cNvSpPr>
-            <a:spLocks xmlns:a="http://schemas.openxmlformats.org/drawingml/2006/main" noGrp="1"/>
-          </p:cNvSpPr>
-          <p:nvPr/>
-        </p:nvSpPr>
-        <p:spPr>
-          <a:xfrm xmlns:a="http://schemas.openxmlformats.org/drawingml/2006/main">
-            <a:off x="495300" y="4438650"/>
-            <a:ext cx="10810875" cy="790575"/>
+                <a16:creationId xmlns:a16="http://schemas.microsoft.com/office/drawing/2014/main" id="{C2571080-6B1F-4DE4-AD14-F1A473A35B93}"/>
+              </a:ext>
+            </a:extLst>
+          </p:cNvPr>
+          <p:cNvSpPr>
+            <a:spLocks xmlns:a="http://schemas.openxmlformats.org/drawingml/2006/main" noGrp="1"/>
+          </p:cNvSpPr>
+          <p:nvPr/>
+        </p:nvSpPr>
+        <p:spPr>
+          <a:xfrm xmlns:a="http://schemas.openxmlformats.org/drawingml/2006/main">
+            <a:off x="495300" y="3943350"/>
+            <a:ext cx="10810875" cy="542925"/>
           </a:xfrm>
           <a:prstGeom xmlns:a="http://schemas.openxmlformats.org/drawingml/2006/main" prst="rect">
             <a:avLst/>
@@ -6443,35 +6443,149 @@
           <a:lstStyle xmlns:a="http://schemas.openxmlformats.org/drawingml/2006/main"/>
           <a:p xmlns:a="http://schemas.openxmlformats.org/drawingml/2006/main">
             <a:pPr>
-              <a:defRPr sz="2100" b="0">
-                <a:solidFill>
-                  <a:srgbClr val="111111"/>
-                </a:solidFill>
-                <a:latin typeface="Calibri"/>
-                <a:ea typeface="Calibri"/>
-                <a:cs typeface="Calibri"/>
-              </a:defRPr>
-            </a:pPr>
-            <a:r>
-              <a:rPr sz="2100" b="0">
-                <a:solidFill>
-                  <a:srgbClr val="111111"/>
-                </a:solidFill>
-                <a:latin typeface="Calibri"/>
-                <a:ea typeface="Calibri"/>
-                <a:cs typeface="Calibri"/>
-              </a:rPr>
-              <a:t>Overlay measured and simulated angle histories. Compare small and large motions and their spectra.</a:t>
-            </a:r>
-          </a:p>
-        </p:txBody>
-      </p:sp>
-      <p:sp>
-        <p:nvSpPr>
-          <p:cNvPr id="9" name="footnote">
-            <a:extLst xmlns:a="http://schemas.openxmlformats.org/drawingml/2006/main">
-              <a:ext uri="{FF2B5EF4-FFF2-40B4-BE49-F238E27FC236}">
-                <a16:creationId xmlns:a16="http://schemas.microsoft.com/office/drawing/2014/main" id="{178021EB-FF37-4E2A-8420-2448A037161E}"/>
+              <a:defRPr sz="1725" b="0">
+                <a:solidFill>
+                  <a:srgbClr val="111111"/>
+                </a:solidFill>
+                <a:latin typeface="Calibri"/>
+                <a:ea typeface="Calibri"/>
+                <a:cs typeface="Calibri"/>
+              </a:defRPr>
+            </a:pPr>
+            <a:r>
+              <a:rPr sz="1725" b="0">
+                <a:solidFill>
+                  <a:srgbClr val="111111"/>
+                </a:solidFill>
+                <a:latin typeface="Calibri"/>
+                <a:ea typeface="Calibri"/>
+                <a:cs typeface="Calibri"/>
+              </a:rPr>
+              <a:t>Compute both angles and angular velocities, then compare time histories and spectra with the coupled numerical model.</a:t>
+            </a:r>
+          </a:p>
+        </p:txBody>
+      </p:sp>
+      <p:sp>
+        <p:nvSpPr>
+          <p:cNvPr id="9" name="body">
+            <a:extLst xmlns:a="http://schemas.openxmlformats.org/drawingml/2006/main">
+              <a:ext uri="{FF2B5EF4-FFF2-40B4-BE49-F238E27FC236}">
+                <a16:creationId xmlns:a16="http://schemas.microsoft.com/office/drawing/2014/main" id="{9A7DB456-C0EC-4B01-82AB-E18D5AD8D2E8}"/>
+              </a:ext>
+            </a:extLst>
+          </p:cNvPr>
+          <p:cNvSpPr>
+            <a:spLocks xmlns:a="http://schemas.openxmlformats.org/drawingml/2006/main" noGrp="1"/>
+          </p:cNvSpPr>
+          <p:nvPr/>
+        </p:nvSpPr>
+        <p:spPr>
+          <a:xfrm xmlns:a="http://schemas.openxmlformats.org/drawingml/2006/main">
+            <a:off x="495300" y="4524375"/>
+            <a:ext cx="10810875" cy="361950"/>
+          </a:xfrm>
+          <a:prstGeom xmlns:a="http://schemas.openxmlformats.org/drawingml/2006/main" prst="rect">
+            <a:avLst/>
+          </a:prstGeom>
+          <a:noFill xmlns:a="http://schemas.openxmlformats.org/drawingml/2006/main"/>
+          <a:ln xmlns:a="http://schemas.openxmlformats.org/drawingml/2006/main" w="0">
+            <a:noFill/>
+          </a:ln>
+        </p:spPr>
+        <p:txBody>
+          <a:bodyPr xmlns:a="http://schemas.openxmlformats.org/drawingml/2006/main">
+            <a:noAutofit/>
+          </a:bodyPr>
+          <a:lstStyle xmlns:a="http://schemas.openxmlformats.org/drawingml/2006/main"/>
+          <a:p xmlns:a="http://schemas.openxmlformats.org/drawingml/2006/main">
+            <a:pPr>
+              <a:defRPr sz="1650" b="1">
+                <a:solidFill>
+                  <a:srgbClr val="881C1C"/>
+                </a:solidFill>
+                <a:latin typeface="Calibri"/>
+                <a:ea typeface="Calibri"/>
+                <a:cs typeface="Calibri"/>
+              </a:defRPr>
+            </a:pPr>
+            <a:r>
+              <a:rPr sz="1650" b="1">
+                <a:solidFill>
+                  <a:srgbClr val="881C1C"/>
+                </a:solidFill>
+                <a:latin typeface="Calibri"/>
+                <a:ea typeface="Calibri"/>
+                <a:cs typeface="Calibri"/>
+              </a:rPr>
+              <a:t>Report focus</a:t>
+            </a:r>
+          </a:p>
+        </p:txBody>
+      </p:sp>
+      <p:sp>
+        <p:nvSpPr>
+          <p:cNvPr id="10" name="body">
+            <a:extLst xmlns:a="http://schemas.openxmlformats.org/drawingml/2006/main">
+              <a:ext uri="{FF2B5EF4-FFF2-40B4-BE49-F238E27FC236}">
+                <a16:creationId xmlns:a16="http://schemas.microsoft.com/office/drawing/2014/main" id="{6FC45A20-6A0A-4274-8AB8-71BBB699CB92}"/>
+              </a:ext>
+            </a:extLst>
+          </p:cNvPr>
+          <p:cNvSpPr>
+            <a:spLocks xmlns:a="http://schemas.openxmlformats.org/drawingml/2006/main" noGrp="1"/>
+          </p:cNvSpPr>
+          <p:nvPr/>
+        </p:nvSpPr>
+        <p:spPr>
+          <a:xfrm xmlns:a="http://schemas.openxmlformats.org/drawingml/2006/main">
+            <a:off x="495300" y="4886325"/>
+            <a:ext cx="10810875" cy="542925"/>
+          </a:xfrm>
+          <a:prstGeom xmlns:a="http://schemas.openxmlformats.org/drawingml/2006/main" prst="rect">
+            <a:avLst/>
+          </a:prstGeom>
+          <a:noFill xmlns:a="http://schemas.openxmlformats.org/drawingml/2006/main"/>
+          <a:ln xmlns:a="http://schemas.openxmlformats.org/drawingml/2006/main" w="0">
+            <a:noFill/>
+          </a:ln>
+        </p:spPr>
+        <p:txBody>
+          <a:bodyPr xmlns:a="http://schemas.openxmlformats.org/drawingml/2006/main">
+            <a:noAutofit/>
+          </a:bodyPr>
+          <a:lstStyle xmlns:a="http://schemas.openxmlformats.org/drawingml/2006/main"/>
+          <a:p xmlns:a="http://schemas.openxmlformats.org/drawingml/2006/main">
+            <a:pPr>
+              <a:defRPr sz="1725" b="0">
+                <a:solidFill>
+                  <a:srgbClr val="111111"/>
+                </a:solidFill>
+                <a:latin typeface="Calibri"/>
+                <a:ea typeface="Calibri"/>
+                <a:cs typeface="Calibri"/>
+              </a:defRPr>
+            </a:pPr>
+            <a:r>
+              <a:rPr sz="1725" b="0">
+                <a:solidFill>
+                  <a:srgbClr val="111111"/>
+                </a:solidFill>
+                <a:latin typeface="Calibri"/>
+                <a:ea typeface="Calibri"/>
+                <a:cs typeface="Calibri"/>
+              </a:rPr>
+              <a:t>Discuss coupling, sensitivity to initial conditions, tracking error, and where measured and simulated trajectories begin to diverge.</a:t>
+            </a:r>
+          </a:p>
+        </p:txBody>
+      </p:sp>
+      <p:sp>
+        <p:nvSpPr>
+          <p:cNvPr id="11" name="footnote">
+            <a:extLst xmlns:a="http://schemas.openxmlformats.org/drawingml/2006/main">
+              <a:ext uri="{FF2B5EF4-FFF2-40B4-BE49-F238E27FC236}">
+                <a16:creationId xmlns:a16="http://schemas.microsoft.com/office/drawing/2014/main" id="{00593BC5-F86C-4412-8C45-F1CC83F4A910}"/>
               </a:ext>
             </a:extLst>
           </p:cNvPr>
@@ -6518,17 +6632,17 @@
                 <a:ea typeface="Calibri"/>
                 <a:cs typeface="Calibri"/>
               </a:rPr>
-              <a:t>Trajectory divergence alone does not establish chaos. Check initial conditions, tracking, and model assumptions.</a:t>
-            </a:r>
-          </a:p>
-        </p:txBody>
-      </p:sp>
-      <p:sp>
-        <p:nvSpPr>
-          <p:cNvPr id="10" name="page">
-            <a:extLst xmlns:a="http://schemas.openxmlformats.org/drawingml/2006/main">
-              <a:ext uri="{FF2B5EF4-FFF2-40B4-BE49-F238E27FC236}">
-                <a16:creationId xmlns:a16="http://schemas.microsoft.com/office/drawing/2014/main" id="{24D76FF0-B4FA-4799-8DC2-D2685099399F}"/>
+              <a:t>A complicated or diverging trajectory alone does not establish chaos. First verify initial conditions, time alignment, and tracking.</a:t>
+            </a:r>
+          </a:p>
+        </p:txBody>
+      </p:sp>
+      <p:sp>
+        <p:nvSpPr>
+          <p:cNvPr id="12" name="page">
+            <a:extLst xmlns:a="http://schemas.openxmlformats.org/drawingml/2006/main">
+              <a:ext uri="{FF2B5EF4-FFF2-40B4-BE49-F238E27FC236}">
+                <a16:creationId xmlns:a16="http://schemas.microsoft.com/office/drawing/2014/main" id="{70F58EA4-010B-4FAC-8137-5991BCA63DD2}"/>
               </a:ext>
             </a:extLst>
           </p:cNvPr>
@@ -6583,7 +6697,7 @@
     </p:spTree>
     <p:extLst>
       <p:ext uri="{BB962C8B-B14F-4D97-AF65-F5344CB8AC3E}">
-        <p14:creationId xmlns:p14="http://schemas.microsoft.com/office/powerpoint/2010/main" val="1474794615"/>
+        <p14:creationId xmlns:p14="http://schemas.microsoft.com/office/powerpoint/2010/main" val="565426296"/>
       </p:ext>
     </p:extLst>
   </p:cSld>
@@ -6611,10 +6725,10 @@
       </p:grpSpPr>
       <p:sp>
         <p:nvSpPr>
-          <p:cNvPr id="12" name="course">
-            <a:extLst xmlns:a="http://schemas.openxmlformats.org/drawingml/2006/main">
-              <a:ext uri="{FF2B5EF4-FFF2-40B4-BE49-F238E27FC236}">
-                <a16:creationId xmlns:a16="http://schemas.microsoft.com/office/drawing/2014/main" id="{6BDA7AEE-BF4F-4966-BB9E-C6069DE91979}"/>
+          <p:cNvPr id="14" name="course">
+            <a:extLst xmlns:a="http://schemas.openxmlformats.org/drawingml/2006/main">
+              <a:ext uri="{FF2B5EF4-FFF2-40B4-BE49-F238E27FC236}">
+                <a16:creationId xmlns:a16="http://schemas.microsoft.com/office/drawing/2014/main" id="{6C409DCF-D512-4770-8D1E-EE10346FEF28}"/>
               </a:ext>
             </a:extLst>
           </p:cNvPr>
@@ -6671,7 +6785,7 @@
           <p:cNvPr id="2" name="title">
             <a:extLst xmlns:a="http://schemas.openxmlformats.org/drawingml/2006/main">
               <a:ext uri="{FF2B5EF4-FFF2-40B4-BE49-F238E27FC236}">
-                <a16:creationId xmlns:a16="http://schemas.microsoft.com/office/drawing/2014/main" id="{10D7D722-153B-4908-B968-E509CFF0D6AF}"/>
+                <a16:creationId xmlns:a16="http://schemas.microsoft.com/office/drawing/2014/main" id="{703C561E-77A5-4D21-937B-69047F38FAE6}"/>
               </a:ext>
             </a:extLst>
           </p:cNvPr>
@@ -6728,7 +6842,7 @@
           <p:cNvPr id="3" name="body">
             <a:extLst xmlns:a="http://schemas.openxmlformats.org/drawingml/2006/main">
               <a:ext uri="{FF2B5EF4-FFF2-40B4-BE49-F238E27FC236}">
-                <a16:creationId xmlns:a16="http://schemas.microsoft.com/office/drawing/2014/main" id="{9BF153E3-793B-43D2-A24C-20062CE3BD9B}"/>
+                <a16:creationId xmlns:a16="http://schemas.microsoft.com/office/drawing/2014/main" id="{FE192A70-19AB-437C-B3D6-77B6F8B27359}"/>
               </a:ext>
             </a:extLst>
           </p:cNvPr>
@@ -6757,7 +6871,7 @@
           <a:lstStyle xmlns:a="http://schemas.openxmlformats.org/drawingml/2006/main"/>
           <a:p xmlns:a="http://schemas.openxmlformats.org/drawingml/2006/main">
             <a:pPr>
-              <a:defRPr sz="1875" b="1">
+              <a:defRPr sz="1650" b="1">
                 <a:solidFill>
                   <a:srgbClr val="881C1C"/>
                 </a:solidFill>
@@ -6767,7 +6881,7 @@
               </a:defRPr>
             </a:pPr>
             <a:r>
-              <a:rPr sz="1875" b="1">
+              <a:rPr sz="1650" b="1">
                 <a:solidFill>
                   <a:srgbClr val="881C1C"/>
                 </a:solidFill>
@@ -6775,7 +6889,7 @@
                 <a:ea typeface="Calibri"/>
                 <a:cs typeface="Calibri"/>
               </a:rPr>
-              <a:t>Question</a:t>
+              <a:t>Apparatus</a:t>
             </a:r>
           </a:p>
         </p:txBody>
@@ -6785,7 +6899,7 @@
           <p:cNvPr id="4" name="body">
             <a:extLst xmlns:a="http://schemas.openxmlformats.org/drawingml/2006/main">
               <a:ext uri="{FF2B5EF4-FFF2-40B4-BE49-F238E27FC236}">
-                <a16:creationId xmlns:a16="http://schemas.microsoft.com/office/drawing/2014/main" id="{543BF15C-3667-4FD5-BC62-087E36B256E0}"/>
+                <a16:creationId xmlns:a16="http://schemas.microsoft.com/office/drawing/2014/main" id="{4C47B19E-85A1-4D69-BBA9-96E365389695}"/>
               </a:ext>
             </a:extLst>
           </p:cNvPr>
@@ -6797,7 +6911,7 @@
         <p:spPr>
           <a:xfrm xmlns:a="http://schemas.openxmlformats.org/drawingml/2006/main">
             <a:off x="495300" y="2057400"/>
-            <a:ext cx="10810875" cy="790575"/>
+            <a:ext cx="10810875" cy="542925"/>
           </a:xfrm>
           <a:prstGeom xmlns:a="http://schemas.openxmlformats.org/drawingml/2006/main" prst="rect">
             <a:avLst/>
@@ -6814,25 +6928,25 @@
           <a:lstStyle xmlns:a="http://schemas.openxmlformats.org/drawingml/2006/main"/>
           <a:p xmlns:a="http://schemas.openxmlformats.org/drawingml/2006/main">
             <a:pPr>
-              <a:defRPr sz="2100" b="0">
-                <a:solidFill>
-                  <a:srgbClr val="111111"/>
-                </a:solidFill>
-                <a:latin typeface="Calibri"/>
-                <a:ea typeface="Calibri"/>
-                <a:cs typeface="Calibri"/>
-              </a:defRPr>
-            </a:pPr>
-            <a:r>
-              <a:rPr sz="2100" b="0">
-                <a:solidFill>
-                  <a:srgbClr val="111111"/>
-                </a:solidFill>
-                <a:latin typeface="Calibri"/>
-                <a:ea typeface="Calibri"/>
-                <a:cs typeface="Calibri"/>
-              </a:rPr>
-              <a:t>What do oscillation period and amplitude decay reveal about the system?</a:t>
+              <a:defRPr sz="1725" b="0">
+                <a:solidFill>
+                  <a:srgbClr val="111111"/>
+                </a:solidFill>
+                <a:latin typeface="Calibri"/>
+                <a:ea typeface="Calibri"/>
+                <a:cs typeface="Calibri"/>
+              </a:defRPr>
+            </a:pPr>
+            <a:r>
+              <a:rPr sz="1725" b="0">
+                <a:solidFill>
+                  <a:srgbClr val="111111"/>
+                </a:solidFill>
+                <a:latin typeface="Calibri"/>
+                <a:ea typeface="Calibri"/>
+                <a:cs typeface="Calibri"/>
+              </a:rPr>
+              <a:t>Vernier cart and position sensor, force sensor, springs, added masses, and eddy-current dampers.</a:t>
             </a:r>
           </a:p>
         </p:txBody>
@@ -6842,18 +6956,18 @@
           <p:cNvPr id="5" name="body">
             <a:extLst xmlns:a="http://schemas.openxmlformats.org/drawingml/2006/main">
               <a:ext uri="{FF2B5EF4-FFF2-40B4-BE49-F238E27FC236}">
-                <a16:creationId xmlns:a16="http://schemas.microsoft.com/office/drawing/2014/main" id="{A25B9CFC-060C-4BC3-85FE-645998705482}"/>
-              </a:ext>
-            </a:extLst>
-          </p:cNvPr>
-          <p:cNvSpPr>
-            <a:spLocks xmlns:a="http://schemas.openxmlformats.org/drawingml/2006/main" noGrp="1"/>
-          </p:cNvSpPr>
-          <p:nvPr/>
-        </p:nvSpPr>
-        <p:spPr>
-          <a:xfrm xmlns:a="http://schemas.openxmlformats.org/drawingml/2006/main">
-            <a:off x="495300" y="2886075"/>
+                <a16:creationId xmlns:a16="http://schemas.microsoft.com/office/drawing/2014/main" id="{C89CB4B0-3DBE-48BE-B592-1C3BDB8C4913}"/>
+              </a:ext>
+            </a:extLst>
+          </p:cNvPr>
+          <p:cNvSpPr>
+            <a:spLocks xmlns:a="http://schemas.openxmlformats.org/drawingml/2006/main" noGrp="1"/>
+          </p:cNvSpPr>
+          <p:nvPr/>
+        </p:nvSpPr>
+        <p:spPr>
+          <a:xfrm xmlns:a="http://schemas.openxmlformats.org/drawingml/2006/main">
+            <a:off x="495300" y="2638425"/>
             <a:ext cx="10810875" cy="361950"/>
           </a:xfrm>
           <a:prstGeom xmlns:a="http://schemas.openxmlformats.org/drawingml/2006/main" prst="rect">
@@ -6871,7 +6985,7 @@
           <a:lstStyle xmlns:a="http://schemas.openxmlformats.org/drawingml/2006/main"/>
           <a:p xmlns:a="http://schemas.openxmlformats.org/drawingml/2006/main">
             <a:pPr>
-              <a:defRPr sz="1875" b="1">
+              <a:defRPr sz="1650" b="1">
                 <a:solidFill>
                   <a:srgbClr val="881C1C"/>
                 </a:solidFill>
@@ -6881,7 +6995,7 @@
               </a:defRPr>
             </a:pPr>
             <a:r>
-              <a:rPr sz="1875" b="1">
+              <a:rPr sz="1650" b="1">
                 <a:solidFill>
                   <a:srgbClr val="881C1C"/>
                 </a:solidFill>
@@ -6889,7 +7003,7 @@
                 <a:ea typeface="Calibri"/>
                 <a:cs typeface="Calibri"/>
               </a:rPr>
-              <a:t>Measurement</a:t>
+              <a:t>Data collection</a:t>
             </a:r>
           </a:p>
         </p:txBody>
@@ -6899,19 +7013,19 @@
           <p:cNvPr id="6" name="body">
             <a:extLst xmlns:a="http://schemas.openxmlformats.org/drawingml/2006/main">
               <a:ext uri="{FF2B5EF4-FFF2-40B4-BE49-F238E27FC236}">
-                <a16:creationId xmlns:a16="http://schemas.microsoft.com/office/drawing/2014/main" id="{663556F3-07E5-4BB5-A903-70CC6259D312}"/>
-              </a:ext>
-            </a:extLst>
-          </p:cNvPr>
-          <p:cNvSpPr>
-            <a:spLocks xmlns:a="http://schemas.openxmlformats.org/drawingml/2006/main" noGrp="1"/>
-          </p:cNvSpPr>
-          <p:nvPr/>
-        </p:nvSpPr>
-        <p:spPr>
-          <a:xfrm xmlns:a="http://schemas.openxmlformats.org/drawingml/2006/main">
-            <a:off x="495300" y="3248025"/>
-            <a:ext cx="10810875" cy="790575"/>
+                <a16:creationId xmlns:a16="http://schemas.microsoft.com/office/drawing/2014/main" id="{CB16C29A-C11F-4028-B8EA-74F9DF512976}"/>
+              </a:ext>
+            </a:extLst>
+          </p:cNvPr>
+          <p:cNvSpPr>
+            <a:spLocks xmlns:a="http://schemas.openxmlformats.org/drawingml/2006/main" noGrp="1"/>
+          </p:cNvSpPr>
+          <p:nvPr/>
+        </p:nvSpPr>
+        <p:spPr>
+          <a:xfrm xmlns:a="http://schemas.openxmlformats.org/drawingml/2006/main">
+            <a:off x="495300" y="3000375"/>
+            <a:ext cx="10810875" cy="542925"/>
           </a:xfrm>
           <a:prstGeom xmlns:a="http://schemas.openxmlformats.org/drawingml/2006/main" prst="rect">
             <a:avLst/>
@@ -6928,25 +7042,25 @@
           <a:lstStyle xmlns:a="http://schemas.openxmlformats.org/drawingml/2006/main"/>
           <a:p xmlns:a="http://schemas.openxmlformats.org/drawingml/2006/main">
             <a:pPr>
-              <a:defRPr sz="2100" b="0">
-                <a:solidFill>
-                  <a:srgbClr val="111111"/>
-                </a:solidFill>
-                <a:latin typeface="Calibri"/>
-                <a:ea typeface="Calibri"/>
-                <a:cs typeface="Calibri"/>
-              </a:defRPr>
-            </a:pPr>
-            <a:r>
-              <a:rPr sz="2100" b="0">
-                <a:solidFill>
-                  <a:srgbClr val="111111"/>
-                </a:solidFill>
-                <a:latin typeface="Calibri"/>
-                <a:ea typeface="Calibri"/>
-                <a:cs typeface="Calibri"/>
-              </a:rPr>
-              <a:t>Displace the cart and release it. Measure mass, effective stiffness, and displacement versus time.</a:t>
+              <a:defRPr sz="1725" b="0">
+                <a:solidFill>
+                  <a:srgbClr val="111111"/>
+                </a:solidFill>
+                <a:latin typeface="Calibri"/>
+                <a:ea typeface="Calibri"/>
+                <a:cs typeface="Calibri"/>
+              </a:defRPr>
+            </a:pPr>
+            <a:r>
+              <a:rPr sz="1725" b="0">
+                <a:solidFill>
+                  <a:srgbClr val="111111"/>
+                </a:solidFill>
+                <a:latin typeface="Calibri"/>
+                <a:ea typeface="Calibri"/>
+                <a:cs typeface="Calibri"/>
+              </a:rPr>
+              <a:t>Measure mass and spring stiffness. Displace the cart, release it, and repeat with changed mass, stiffness, and damping.</a:t>
             </a:r>
           </a:p>
         </p:txBody>
@@ -6956,18 +7070,18 @@
           <p:cNvPr id="7" name="body">
             <a:extLst xmlns:a="http://schemas.openxmlformats.org/drawingml/2006/main">
               <a:ext uri="{FF2B5EF4-FFF2-40B4-BE49-F238E27FC236}">
-                <a16:creationId xmlns:a16="http://schemas.microsoft.com/office/drawing/2014/main" id="{565FA018-1B15-412E-9A8B-FED546CF61E5}"/>
-              </a:ext>
-            </a:extLst>
-          </p:cNvPr>
-          <p:cNvSpPr>
-            <a:spLocks xmlns:a="http://schemas.openxmlformats.org/drawingml/2006/main" noGrp="1"/>
-          </p:cNvSpPr>
-          <p:nvPr/>
-        </p:nvSpPr>
-        <p:spPr>
-          <a:xfrm xmlns:a="http://schemas.openxmlformats.org/drawingml/2006/main">
-            <a:off x="495300" y="4076700"/>
+                <a16:creationId xmlns:a16="http://schemas.microsoft.com/office/drawing/2014/main" id="{164DD002-B93E-473E-9925-A79B16155042}"/>
+              </a:ext>
+            </a:extLst>
+          </p:cNvPr>
+          <p:cNvSpPr>
+            <a:spLocks xmlns:a="http://schemas.openxmlformats.org/drawingml/2006/main" noGrp="1"/>
+          </p:cNvSpPr>
+          <p:nvPr/>
+        </p:nvSpPr>
+        <p:spPr>
+          <a:xfrm xmlns:a="http://schemas.openxmlformats.org/drawingml/2006/main">
+            <a:off x="495300" y="3581400"/>
             <a:ext cx="10810875" cy="361950"/>
           </a:xfrm>
           <a:prstGeom xmlns:a="http://schemas.openxmlformats.org/drawingml/2006/main" prst="rect">
@@ -6985,7 +7099,7 @@
           <a:lstStyle xmlns:a="http://schemas.openxmlformats.org/drawingml/2006/main"/>
           <a:p xmlns:a="http://schemas.openxmlformats.org/drawingml/2006/main">
             <a:pPr>
-              <a:defRPr sz="1875" b="1">
+              <a:defRPr sz="1650" b="1">
                 <a:solidFill>
                   <a:srgbClr val="881C1C"/>
                 </a:solidFill>
@@ -6995,7 +7109,7 @@
               </a:defRPr>
             </a:pPr>
             <a:r>
-              <a:rPr sz="1875" b="1">
+              <a:rPr sz="1650" b="1">
                 <a:solidFill>
                   <a:srgbClr val="881C1C"/>
                 </a:solidFill>
@@ -7003,7 +7117,7 @@
                 <a:ea typeface="Calibri"/>
                 <a:cs typeface="Calibri"/>
               </a:rPr>
-              <a:t>Report evidence</a:t>
+              <a:t>Analysis</a:t>
             </a:r>
           </a:p>
         </p:txBody>
@@ -7013,19 +7127,19 @@
           <p:cNvPr id="8" name="body">
             <a:extLst xmlns:a="http://schemas.openxmlformats.org/drawingml/2006/main">
               <a:ext uri="{FF2B5EF4-FFF2-40B4-BE49-F238E27FC236}">
-                <a16:creationId xmlns:a16="http://schemas.microsoft.com/office/drawing/2014/main" id="{8B448933-B6DE-4236-AE2F-9C79CAACF0FC}"/>
-              </a:ext>
-            </a:extLst>
-          </p:cNvPr>
-          <p:cNvSpPr>
-            <a:spLocks xmlns:a="http://schemas.openxmlformats.org/drawingml/2006/main" noGrp="1"/>
-          </p:cNvSpPr>
-          <p:nvPr/>
-        </p:nvSpPr>
-        <p:spPr>
-          <a:xfrm xmlns:a="http://schemas.openxmlformats.org/drawingml/2006/main">
-            <a:off x="495300" y="4438650"/>
-            <a:ext cx="10810875" cy="790575"/>
+                <a16:creationId xmlns:a16="http://schemas.microsoft.com/office/drawing/2014/main" id="{9E819AC0-00E1-486E-B740-1B81DE4C5680}"/>
+              </a:ext>
+            </a:extLst>
+          </p:cNvPr>
+          <p:cNvSpPr>
+            <a:spLocks xmlns:a="http://schemas.openxmlformats.org/drawingml/2006/main" noGrp="1"/>
+          </p:cNvSpPr>
+          <p:nvPr/>
+        </p:nvSpPr>
+        <p:spPr>
+          <a:xfrm xmlns:a="http://schemas.openxmlformats.org/drawingml/2006/main">
+            <a:off x="495300" y="3943350"/>
+            <a:ext cx="10810875" cy="542925"/>
           </a:xfrm>
           <a:prstGeom xmlns:a="http://schemas.openxmlformats.org/drawingml/2006/main" prst="rect">
             <a:avLst/>
@@ -7042,35 +7156,149 @@
           <a:lstStyle xmlns:a="http://schemas.openxmlformats.org/drawingml/2006/main"/>
           <a:p xmlns:a="http://schemas.openxmlformats.org/drawingml/2006/main">
             <a:pPr>
-              <a:defRPr sz="2100" b="0">
-                <a:solidFill>
-                  <a:srgbClr val="111111"/>
-                </a:solidFill>
-                <a:latin typeface="Calibri"/>
-                <a:ea typeface="Calibri"/>
-                <a:cs typeface="Calibri"/>
-              </a:defRPr>
-            </a:pPr>
-            <a:r>
-              <a:rPr sz="2100" b="0">
-                <a:solidFill>
-                  <a:srgbClr val="111111"/>
-                </a:solidFill>
-                <a:latin typeface="Calibri"/>
-                <a:ea typeface="Calibri"/>
-                <a:cs typeface="Calibri"/>
-              </a:rPr>
-              <a:t>Estimate natural frequency and damping. Compare cases with changed mass, springs, or damping.</a:t>
-            </a:r>
-          </a:p>
-        </p:txBody>
-      </p:sp>
-      <p:sp>
-        <p:nvSpPr>
-          <p:cNvPr id="9" name="equation">
-            <a:extLst xmlns:a="http://schemas.openxmlformats.org/drawingml/2006/main">
-              <a:ext uri="{FF2B5EF4-FFF2-40B4-BE49-F238E27FC236}">
-                <a16:creationId xmlns:a16="http://schemas.microsoft.com/office/drawing/2014/main" id="{DB2991A2-8E42-41EF-9E83-30C046FF1274}"/>
+              <a:defRPr sz="1725" b="0">
+                <a:solidFill>
+                  <a:srgbClr val="111111"/>
+                </a:solidFill>
+                <a:latin typeface="Calibri"/>
+                <a:ea typeface="Calibri"/>
+                <a:cs typeface="Calibri"/>
+              </a:defRPr>
+            </a:pPr>
+            <a:r>
+              <a:rPr sz="1725" b="0">
+                <a:solidFill>
+                  <a:srgbClr val="111111"/>
+                </a:solidFill>
+                <a:latin typeface="Calibri"/>
+                <a:ea typeface="Calibri"/>
+                <a:cs typeface="Calibri"/>
+              </a:rPr>
+              <a:t>Use displacement histories, peak decay, and spectra to estimate damped frequency, natural frequency, and damping ratio.</a:t>
+            </a:r>
+          </a:p>
+        </p:txBody>
+      </p:sp>
+      <p:sp>
+        <p:nvSpPr>
+          <p:cNvPr id="9" name="body">
+            <a:extLst xmlns:a="http://schemas.openxmlformats.org/drawingml/2006/main">
+              <a:ext uri="{FF2B5EF4-FFF2-40B4-BE49-F238E27FC236}">
+                <a16:creationId xmlns:a16="http://schemas.microsoft.com/office/drawing/2014/main" id="{2E0220B5-CAAA-40EE-B1CD-D0681E86B2AC}"/>
+              </a:ext>
+            </a:extLst>
+          </p:cNvPr>
+          <p:cNvSpPr>
+            <a:spLocks xmlns:a="http://schemas.openxmlformats.org/drawingml/2006/main" noGrp="1"/>
+          </p:cNvSpPr>
+          <p:nvPr/>
+        </p:nvSpPr>
+        <p:spPr>
+          <a:xfrm xmlns:a="http://schemas.openxmlformats.org/drawingml/2006/main">
+            <a:off x="495300" y="4524375"/>
+            <a:ext cx="10810875" cy="361950"/>
+          </a:xfrm>
+          <a:prstGeom xmlns:a="http://schemas.openxmlformats.org/drawingml/2006/main" prst="rect">
+            <a:avLst/>
+          </a:prstGeom>
+          <a:noFill xmlns:a="http://schemas.openxmlformats.org/drawingml/2006/main"/>
+          <a:ln xmlns:a="http://schemas.openxmlformats.org/drawingml/2006/main" w="0">
+            <a:noFill/>
+          </a:ln>
+        </p:spPr>
+        <p:txBody>
+          <a:bodyPr xmlns:a="http://schemas.openxmlformats.org/drawingml/2006/main">
+            <a:noAutofit/>
+          </a:bodyPr>
+          <a:lstStyle xmlns:a="http://schemas.openxmlformats.org/drawingml/2006/main"/>
+          <a:p xmlns:a="http://schemas.openxmlformats.org/drawingml/2006/main">
+            <a:pPr>
+              <a:defRPr sz="1650" b="1">
+                <a:solidFill>
+                  <a:srgbClr val="881C1C"/>
+                </a:solidFill>
+                <a:latin typeface="Calibri"/>
+                <a:ea typeface="Calibri"/>
+                <a:cs typeface="Calibri"/>
+              </a:defRPr>
+            </a:pPr>
+            <a:r>
+              <a:rPr sz="1650" b="1">
+                <a:solidFill>
+                  <a:srgbClr val="881C1C"/>
+                </a:solidFill>
+                <a:latin typeface="Calibri"/>
+                <a:ea typeface="Calibri"/>
+                <a:cs typeface="Calibri"/>
+              </a:rPr>
+              <a:t>Report focus</a:t>
+            </a:r>
+          </a:p>
+        </p:txBody>
+      </p:sp>
+      <p:sp>
+        <p:nvSpPr>
+          <p:cNvPr id="10" name="body">
+            <a:extLst xmlns:a="http://schemas.openxmlformats.org/drawingml/2006/main">
+              <a:ext uri="{FF2B5EF4-FFF2-40B4-BE49-F238E27FC236}">
+                <a16:creationId xmlns:a16="http://schemas.microsoft.com/office/drawing/2014/main" id="{E88DE914-D793-40C5-AD16-1D44BD48A8D3}"/>
+              </a:ext>
+            </a:extLst>
+          </p:cNvPr>
+          <p:cNvSpPr>
+            <a:spLocks xmlns:a="http://schemas.openxmlformats.org/drawingml/2006/main" noGrp="1"/>
+          </p:cNvSpPr>
+          <p:nvPr/>
+        </p:nvSpPr>
+        <p:spPr>
+          <a:xfrm xmlns:a="http://schemas.openxmlformats.org/drawingml/2006/main">
+            <a:off x="495300" y="4886325"/>
+            <a:ext cx="10810875" cy="542925"/>
+          </a:xfrm>
+          <a:prstGeom xmlns:a="http://schemas.openxmlformats.org/drawingml/2006/main" prst="rect">
+            <a:avLst/>
+          </a:prstGeom>
+          <a:noFill xmlns:a="http://schemas.openxmlformats.org/drawingml/2006/main"/>
+          <a:ln xmlns:a="http://schemas.openxmlformats.org/drawingml/2006/main" w="0">
+            <a:noFill/>
+          </a:ln>
+        </p:spPr>
+        <p:txBody>
+          <a:bodyPr xmlns:a="http://schemas.openxmlformats.org/drawingml/2006/main">
+            <a:noAutofit/>
+          </a:bodyPr>
+          <a:lstStyle xmlns:a="http://schemas.openxmlformats.org/drawingml/2006/main"/>
+          <a:p xmlns:a="http://schemas.openxmlformats.org/drawingml/2006/main">
+            <a:pPr>
+              <a:defRPr sz="1725" b="0">
+                <a:solidFill>
+                  <a:srgbClr val="111111"/>
+                </a:solidFill>
+                <a:latin typeface="Calibri"/>
+                <a:ea typeface="Calibri"/>
+                <a:cs typeface="Calibri"/>
+              </a:defRPr>
+            </a:pPr>
+            <a:r>
+              <a:rPr sz="1725" b="0">
+                <a:solidFill>
+                  <a:srgbClr val="111111"/>
+                </a:solidFill>
+                <a:latin typeface="Calibri"/>
+                <a:ea typeface="Calibri"/>
+                <a:cs typeface="Calibri"/>
+              </a:rPr>
+              <a:t>Relate each controlled change to the model and document effective stiffness, initial displacement, sampling rate, and peak selection.</a:t>
+            </a:r>
+          </a:p>
+        </p:txBody>
+      </p:sp>
+      <p:sp>
+        <p:nvSpPr>
+          <p:cNvPr id="11" name="equation">
+            <a:extLst xmlns:a="http://schemas.openxmlformats.org/drawingml/2006/main">
+              <a:ext uri="{FF2B5EF4-FFF2-40B4-BE49-F238E27FC236}">
+                <a16:creationId xmlns:a16="http://schemas.microsoft.com/office/drawing/2014/main" id="{A4C86EA1-AD23-4263-9767-B3909F6BA688}"/>
               </a:ext>
             </a:extLst>
           </p:cNvPr>
@@ -7124,10 +7352,10 @@
       </p:sp>
       <p:sp>
         <p:nvSpPr>
-          <p:cNvPr id="10" name="footnote">
-            <a:extLst xmlns:a="http://schemas.openxmlformats.org/drawingml/2006/main">
-              <a:ext uri="{FF2B5EF4-FFF2-40B4-BE49-F238E27FC236}">
-                <a16:creationId xmlns:a16="http://schemas.microsoft.com/office/drawing/2014/main" id="{5CA0BBDC-B898-4949-8FB5-583F7ADEFAEF}"/>
+          <p:cNvPr id="12" name="footnote">
+            <a:extLst xmlns:a="http://schemas.openxmlformats.org/drawingml/2006/main">
+              <a:ext uri="{FF2B5EF4-FFF2-40B4-BE49-F238E27FC236}">
+                <a16:creationId xmlns:a16="http://schemas.microsoft.com/office/drawing/2014/main" id="{5454653F-B21D-4FD2-9B1C-E261EC705869}"/>
               </a:ext>
             </a:extLst>
           </p:cNvPr>
@@ -7174,17 +7402,17 @@
                 <a:ea typeface="Calibri"/>
                 <a:cs typeface="Calibri"/>
               </a:rPr>
-              <a:t>For an underdamped viscous model, ωd = ωn √(1 − ζ²). Natural and damped frequency differ.</a:t>
-            </a:r>
-          </a:p>
-        </p:txBody>
-      </p:sp>
-      <p:sp>
-        <p:nvSpPr>
-          <p:cNvPr id="11" name="page">
-            <a:extLst xmlns:a="http://schemas.openxmlformats.org/drawingml/2006/main">
-              <a:ext uri="{FF2B5EF4-FFF2-40B4-BE49-F238E27FC236}">
-                <a16:creationId xmlns:a16="http://schemas.microsoft.com/office/drawing/2014/main" id="{95768914-A788-4985-87BA-A1F167DF660C}"/>
+              <a:t>The procedure uses a base case plus variations in mass, springs, and dampers. Verify each exported CSV before leaving.</a:t>
+            </a:r>
+          </a:p>
+        </p:txBody>
+      </p:sp>
+      <p:sp>
+        <p:nvSpPr>
+          <p:cNvPr id="13" name="page">
+            <a:extLst xmlns:a="http://schemas.openxmlformats.org/drawingml/2006/main">
+              <a:ext uri="{FF2B5EF4-FFF2-40B4-BE49-F238E27FC236}">
+                <a16:creationId xmlns:a16="http://schemas.microsoft.com/office/drawing/2014/main" id="{53B37475-417C-489E-8853-ADFF74E55319}"/>
               </a:ext>
             </a:extLst>
           </p:cNvPr>
@@ -7239,7 +7467,7 @@
     </p:spTree>
     <p:extLst>
       <p:ext uri="{BB962C8B-B14F-4D97-AF65-F5344CB8AC3E}">
-        <p14:creationId xmlns:p14="http://schemas.microsoft.com/office/powerpoint/2010/main" val="980667071"/>
+        <p14:creationId xmlns:p14="http://schemas.microsoft.com/office/powerpoint/2010/main" val="576235985"/>
       </p:ext>
     </p:extLst>
   </p:cSld>
@@ -7267,10 +7495,10 @@
       </p:grpSpPr>
       <p:sp>
         <p:nvSpPr>
-          <p:cNvPr id="12" name="course">
-            <a:extLst xmlns:a="http://schemas.openxmlformats.org/drawingml/2006/main">
-              <a:ext uri="{FF2B5EF4-FFF2-40B4-BE49-F238E27FC236}">
-                <a16:creationId xmlns:a16="http://schemas.microsoft.com/office/drawing/2014/main" id="{DE6F55F2-4D58-4FB5-9F00-AFDE81E152AA}"/>
+          <p:cNvPr id="14" name="course">
+            <a:extLst xmlns:a="http://schemas.openxmlformats.org/drawingml/2006/main">
+              <a:ext uri="{FF2B5EF4-FFF2-40B4-BE49-F238E27FC236}">
+                <a16:creationId xmlns:a16="http://schemas.microsoft.com/office/drawing/2014/main" id="{0E314BDB-BE0C-43C6-8A13-6EF323F4DBBD}"/>
               </a:ext>
             </a:extLst>
           </p:cNvPr>
@@ -7327,7 +7555,7 @@
           <p:cNvPr id="2" name="title">
             <a:extLst xmlns:a="http://schemas.openxmlformats.org/drawingml/2006/main">
               <a:ext uri="{FF2B5EF4-FFF2-40B4-BE49-F238E27FC236}">
-                <a16:creationId xmlns:a16="http://schemas.microsoft.com/office/drawing/2014/main" id="{CF3B351A-BA80-447B-9CFB-45667D9EB56D}"/>
+                <a16:creationId xmlns:a16="http://schemas.microsoft.com/office/drawing/2014/main" id="{F3371BC6-9938-47BE-AE62-546F7217726A}"/>
               </a:ext>
             </a:extLst>
           </p:cNvPr>
@@ -7384,7 +7612,7 @@
           <p:cNvPr id="3" name="body">
             <a:extLst xmlns:a="http://schemas.openxmlformats.org/drawingml/2006/main">
               <a:ext uri="{FF2B5EF4-FFF2-40B4-BE49-F238E27FC236}">
-                <a16:creationId xmlns:a16="http://schemas.microsoft.com/office/drawing/2014/main" id="{AB88E571-6C6E-4BF1-95BA-C68D6249798D}"/>
+                <a16:creationId xmlns:a16="http://schemas.microsoft.com/office/drawing/2014/main" id="{FF8FA8EB-22C0-444F-86DA-B32F01E042A3}"/>
               </a:ext>
             </a:extLst>
           </p:cNvPr>
@@ -7413,7 +7641,7 @@
           <a:lstStyle xmlns:a="http://schemas.openxmlformats.org/drawingml/2006/main"/>
           <a:p xmlns:a="http://schemas.openxmlformats.org/drawingml/2006/main">
             <a:pPr>
-              <a:defRPr sz="1875" b="1">
+              <a:defRPr sz="1650" b="1">
                 <a:solidFill>
                   <a:srgbClr val="881C1C"/>
                 </a:solidFill>
@@ -7423,7 +7651,7 @@
               </a:defRPr>
             </a:pPr>
             <a:r>
-              <a:rPr sz="1875" b="1">
+              <a:rPr sz="1650" b="1">
                 <a:solidFill>
                   <a:srgbClr val="881C1C"/>
                 </a:solidFill>
@@ -7431,7 +7659,7 @@
                 <a:ea typeface="Calibri"/>
                 <a:cs typeface="Calibri"/>
               </a:rPr>
-              <a:t>Question</a:t>
+              <a:t>Apparatus</a:t>
             </a:r>
           </a:p>
         </p:txBody>
@@ -7441,7 +7669,7 @@
           <p:cNvPr id="4" name="body">
             <a:extLst xmlns:a="http://schemas.openxmlformats.org/drawingml/2006/main">
               <a:ext uri="{FF2B5EF4-FFF2-40B4-BE49-F238E27FC236}">
-                <a16:creationId xmlns:a16="http://schemas.microsoft.com/office/drawing/2014/main" id="{A2E44955-6832-4698-A014-9859849FB83B}"/>
+                <a16:creationId xmlns:a16="http://schemas.microsoft.com/office/drawing/2014/main" id="{EEC6883E-E054-47CE-944A-54F4FBB4DFA7}"/>
               </a:ext>
             </a:extLst>
           </p:cNvPr>
@@ -7453,7 +7681,7 @@
         <p:spPr>
           <a:xfrm xmlns:a="http://schemas.openxmlformats.org/drawingml/2006/main">
             <a:off x="495300" y="2057400"/>
-            <a:ext cx="10810875" cy="790575"/>
+            <a:ext cx="10810875" cy="542925"/>
           </a:xfrm>
           <a:prstGeom xmlns:a="http://schemas.openxmlformats.org/drawingml/2006/main" prst="rect">
             <a:avLst/>
@@ -7470,25 +7698,25 @@
           <a:lstStyle xmlns:a="http://schemas.openxmlformats.org/drawingml/2006/main"/>
           <a:p xmlns:a="http://schemas.openxmlformats.org/drawingml/2006/main">
             <a:pPr>
-              <a:defRPr sz="2100" b="0">
-                <a:solidFill>
-                  <a:srgbClr val="111111"/>
-                </a:solidFill>
-                <a:latin typeface="Calibri"/>
-                <a:ea typeface="Calibri"/>
-                <a:cs typeface="Calibri"/>
-              </a:defRPr>
-            </a:pPr>
-            <a:r>
-              <a:rPr sz="2100" b="0">
-                <a:solidFill>
-                  <a:srgbClr val="111111"/>
-                </a:solidFill>
-                <a:latin typeface="Calibri"/>
-                <a:ea typeface="Calibri"/>
-                <a:cs typeface="Calibri"/>
-              </a:rPr>
-              <a:t>How does excitation frequency affect response amplitude and phase?</a:t>
+              <a:defRPr sz="1725" b="0">
+                <a:solidFill>
+                  <a:srgbClr val="111111"/>
+                </a:solidFill>
+                <a:latin typeface="Calibri"/>
+                <a:ea typeface="Calibri"/>
+                <a:cs typeface="Calibri"/>
+              </a:defRPr>
+            </a:pPr>
+            <a:r>
+              <a:rPr sz="1725" b="0">
+                <a:solidFill>
+                  <a:srgbClr val="111111"/>
+                </a:solidFill>
+                <a:latin typeface="Calibri"/>
+                <a:ea typeface="Calibri"/>
+                <a:cs typeface="Calibri"/>
+              </a:rPr>
+              <a:t>Vernier cart, springs, motor-driven input, magnetic dampers, tachometer, and Graphical Analysis software.</a:t>
             </a:r>
           </a:p>
         </p:txBody>
@@ -7498,18 +7726,18 @@
           <p:cNvPr id="5" name="body">
             <a:extLst xmlns:a="http://schemas.openxmlformats.org/drawingml/2006/main">
               <a:ext uri="{FF2B5EF4-FFF2-40B4-BE49-F238E27FC236}">
-                <a16:creationId xmlns:a16="http://schemas.microsoft.com/office/drawing/2014/main" id="{DB0BFC76-20D8-4713-855B-3004946B526C}"/>
-              </a:ext>
-            </a:extLst>
-          </p:cNvPr>
-          <p:cNvSpPr>
-            <a:spLocks xmlns:a="http://schemas.openxmlformats.org/drawingml/2006/main" noGrp="1"/>
-          </p:cNvSpPr>
-          <p:nvPr/>
-        </p:nvSpPr>
-        <p:spPr>
-          <a:xfrm xmlns:a="http://schemas.openxmlformats.org/drawingml/2006/main">
-            <a:off x="495300" y="2886075"/>
+                <a16:creationId xmlns:a16="http://schemas.microsoft.com/office/drawing/2014/main" id="{A09D678C-D59F-42B3-8E0B-8D31401EB75F}"/>
+              </a:ext>
+            </a:extLst>
+          </p:cNvPr>
+          <p:cNvSpPr>
+            <a:spLocks xmlns:a="http://schemas.openxmlformats.org/drawingml/2006/main" noGrp="1"/>
+          </p:cNvSpPr>
+          <p:nvPr/>
+        </p:nvSpPr>
+        <p:spPr>
+          <a:xfrm xmlns:a="http://schemas.openxmlformats.org/drawingml/2006/main">
+            <a:off x="495300" y="2638425"/>
             <a:ext cx="10810875" cy="361950"/>
           </a:xfrm>
           <a:prstGeom xmlns:a="http://schemas.openxmlformats.org/drawingml/2006/main" prst="rect">
@@ -7527,7 +7755,7 @@
           <a:lstStyle xmlns:a="http://schemas.openxmlformats.org/drawingml/2006/main"/>
           <a:p xmlns:a="http://schemas.openxmlformats.org/drawingml/2006/main">
             <a:pPr>
-              <a:defRPr sz="1875" b="1">
+              <a:defRPr sz="1650" b="1">
                 <a:solidFill>
                   <a:srgbClr val="881C1C"/>
                 </a:solidFill>
@@ -7537,7 +7765,7 @@
               </a:defRPr>
             </a:pPr>
             <a:r>
-              <a:rPr sz="1875" b="1">
+              <a:rPr sz="1650" b="1">
                 <a:solidFill>
                   <a:srgbClr val="881C1C"/>
                 </a:solidFill>
@@ -7545,7 +7773,7 @@
                 <a:ea typeface="Calibri"/>
                 <a:cs typeface="Calibri"/>
               </a:rPr>
-              <a:t>Measurement</a:t>
+              <a:t>Data collection</a:t>
             </a:r>
           </a:p>
         </p:txBody>
@@ -7555,19 +7783,19 @@
           <p:cNvPr id="6" name="body">
             <a:extLst xmlns:a="http://schemas.openxmlformats.org/drawingml/2006/main">
               <a:ext uri="{FF2B5EF4-FFF2-40B4-BE49-F238E27FC236}">
-                <a16:creationId xmlns:a16="http://schemas.microsoft.com/office/drawing/2014/main" id="{4939B6D3-A825-45E4-95B5-771B345F9431}"/>
-              </a:ext>
-            </a:extLst>
-          </p:cNvPr>
-          <p:cNvSpPr>
-            <a:spLocks xmlns:a="http://schemas.openxmlformats.org/drawingml/2006/main" noGrp="1"/>
-          </p:cNvSpPr>
-          <p:nvPr/>
-        </p:nvSpPr>
-        <p:spPr>
-          <a:xfrm xmlns:a="http://schemas.openxmlformats.org/drawingml/2006/main">
-            <a:off x="495300" y="3248025"/>
-            <a:ext cx="10810875" cy="790575"/>
+                <a16:creationId xmlns:a16="http://schemas.microsoft.com/office/drawing/2014/main" id="{86E1242F-E319-45C5-9129-2A1E49C541E2}"/>
+              </a:ext>
+            </a:extLst>
+          </p:cNvPr>
+          <p:cNvSpPr>
+            <a:spLocks xmlns:a="http://schemas.openxmlformats.org/drawingml/2006/main" noGrp="1"/>
+          </p:cNvSpPr>
+          <p:nvPr/>
+        </p:nvSpPr>
+        <p:spPr>
+          <a:xfrm xmlns:a="http://schemas.openxmlformats.org/drawingml/2006/main">
+            <a:off x="495300" y="3000375"/>
+            <a:ext cx="10810875" cy="542925"/>
           </a:xfrm>
           <a:prstGeom xmlns:a="http://schemas.openxmlformats.org/drawingml/2006/main" prst="rect">
             <a:avLst/>
@@ -7584,25 +7812,25 @@
           <a:lstStyle xmlns:a="http://schemas.openxmlformats.org/drawingml/2006/main"/>
           <a:p xmlns:a="http://schemas.openxmlformats.org/drawingml/2006/main">
             <a:pPr>
-              <a:defRPr sz="2100" b="0">
-                <a:solidFill>
-                  <a:srgbClr val="111111"/>
-                </a:solidFill>
-                <a:latin typeface="Calibri"/>
-                <a:ea typeface="Calibri"/>
-                <a:cs typeface="Calibri"/>
-              </a:defRPr>
-            </a:pPr>
-            <a:r>
-              <a:rPr sz="2100" b="0">
-                <a:solidFill>
-                  <a:srgbClr val="111111"/>
-                </a:solidFill>
-                <a:latin typeface="Calibri"/>
-                <a:ea typeface="Calibri"/>
-                <a:cs typeface="Calibri"/>
-              </a:rPr>
-              <a:t>Apply the assigned impulse and harmonic inputs. Record input motion or force and the cart response.</a:t>
+              <a:defRPr sz="1725" b="0">
+                <a:solidFill>
+                  <a:srgbClr val="111111"/>
+                </a:solidFill>
+                <a:latin typeface="Calibri"/>
+                <a:ea typeface="Calibri"/>
+                <a:cs typeface="Calibri"/>
+              </a:defRPr>
+            </a:pPr>
+            <a:r>
+              <a:rPr sz="1725" b="0">
+                <a:solidFill>
+                  <a:srgbClr val="111111"/>
+                </a:solidFill>
+                <a:latin typeface="Calibri"/>
+                <a:ea typeface="Calibri"/>
+                <a:cs typeface="Calibri"/>
+              </a:rPr>
+              <a:t>Record three impulse cases, then harmonic steady-state responses below and above resonance while avoiding prolonged resonance.</a:t>
             </a:r>
           </a:p>
         </p:txBody>
@@ -7612,18 +7840,18 @@
           <p:cNvPr id="7" name="body">
             <a:extLst xmlns:a="http://schemas.openxmlformats.org/drawingml/2006/main">
               <a:ext uri="{FF2B5EF4-FFF2-40B4-BE49-F238E27FC236}">
-                <a16:creationId xmlns:a16="http://schemas.microsoft.com/office/drawing/2014/main" id="{96440966-89FB-41C9-B2E6-D10202357A56}"/>
-              </a:ext>
-            </a:extLst>
-          </p:cNvPr>
-          <p:cNvSpPr>
-            <a:spLocks xmlns:a="http://schemas.openxmlformats.org/drawingml/2006/main" noGrp="1"/>
-          </p:cNvSpPr>
-          <p:nvPr/>
-        </p:nvSpPr>
-        <p:spPr>
-          <a:xfrm xmlns:a="http://schemas.openxmlformats.org/drawingml/2006/main">
-            <a:off x="495300" y="4076700"/>
+                <a16:creationId xmlns:a16="http://schemas.microsoft.com/office/drawing/2014/main" id="{1E5004C4-4A4B-4DD1-8E36-D735532721AA}"/>
+              </a:ext>
+            </a:extLst>
+          </p:cNvPr>
+          <p:cNvSpPr>
+            <a:spLocks xmlns:a="http://schemas.openxmlformats.org/drawingml/2006/main" noGrp="1"/>
+          </p:cNvSpPr>
+          <p:nvPr/>
+        </p:nvSpPr>
+        <p:spPr>
+          <a:xfrm xmlns:a="http://schemas.openxmlformats.org/drawingml/2006/main">
+            <a:off x="495300" y="3581400"/>
             <a:ext cx="10810875" cy="361950"/>
           </a:xfrm>
           <a:prstGeom xmlns:a="http://schemas.openxmlformats.org/drawingml/2006/main" prst="rect">
@@ -7641,7 +7869,7 @@
           <a:lstStyle xmlns:a="http://schemas.openxmlformats.org/drawingml/2006/main"/>
           <a:p xmlns:a="http://schemas.openxmlformats.org/drawingml/2006/main">
             <a:pPr>
-              <a:defRPr sz="1875" b="1">
+              <a:defRPr sz="1650" b="1">
                 <a:solidFill>
                   <a:srgbClr val="881C1C"/>
                 </a:solidFill>
@@ -7651,7 +7879,7 @@
               </a:defRPr>
             </a:pPr>
             <a:r>
-              <a:rPr sz="1875" b="1">
+              <a:rPr sz="1650" b="1">
                 <a:solidFill>
                   <a:srgbClr val="881C1C"/>
                 </a:solidFill>
@@ -7659,7 +7887,7 @@
                 <a:ea typeface="Calibri"/>
                 <a:cs typeface="Calibri"/>
               </a:rPr>
-              <a:t>Report evidence</a:t>
+              <a:t>Analysis</a:t>
             </a:r>
           </a:p>
         </p:txBody>
@@ -7669,19 +7897,19 @@
           <p:cNvPr id="8" name="body">
             <a:extLst xmlns:a="http://schemas.openxmlformats.org/drawingml/2006/main">
               <a:ext uri="{FF2B5EF4-FFF2-40B4-BE49-F238E27FC236}">
-                <a16:creationId xmlns:a16="http://schemas.microsoft.com/office/drawing/2014/main" id="{F01CFEED-A748-41EF-A57C-AAD9B5EBF2C9}"/>
-              </a:ext>
-            </a:extLst>
-          </p:cNvPr>
-          <p:cNvSpPr>
-            <a:spLocks xmlns:a="http://schemas.openxmlformats.org/drawingml/2006/main" noGrp="1"/>
-          </p:cNvSpPr>
-          <p:nvPr/>
-        </p:nvSpPr>
-        <p:spPr>
-          <a:xfrm xmlns:a="http://schemas.openxmlformats.org/drawingml/2006/main">
-            <a:off x="495300" y="4438650"/>
-            <a:ext cx="10810875" cy="790575"/>
+                <a16:creationId xmlns:a16="http://schemas.microsoft.com/office/drawing/2014/main" id="{C9F4F358-5B3E-4F35-9890-3F33727E7ED8}"/>
+              </a:ext>
+            </a:extLst>
+          </p:cNvPr>
+          <p:cNvSpPr>
+            <a:spLocks xmlns:a="http://schemas.openxmlformats.org/drawingml/2006/main" noGrp="1"/>
+          </p:cNvSpPr>
+          <p:nvPr/>
+        </p:nvSpPr>
+        <p:spPr>
+          <a:xfrm xmlns:a="http://schemas.openxmlformats.org/drawingml/2006/main">
+            <a:off x="495300" y="3943350"/>
+            <a:ext cx="10810875" cy="542925"/>
           </a:xfrm>
           <a:prstGeom xmlns:a="http://schemas.openxmlformats.org/drawingml/2006/main" prst="rect">
             <a:avLst/>
@@ -7698,35 +7926,149 @@
           <a:lstStyle xmlns:a="http://schemas.openxmlformats.org/drawingml/2006/main"/>
           <a:p xmlns:a="http://schemas.openxmlformats.org/drawingml/2006/main">
             <a:pPr>
-              <a:defRPr sz="2100" b="0">
-                <a:solidFill>
-                  <a:srgbClr val="111111"/>
-                </a:solidFill>
-                <a:latin typeface="Calibri"/>
-                <a:ea typeface="Calibri"/>
-                <a:cs typeface="Calibri"/>
-              </a:defRPr>
-            </a:pPr>
-            <a:r>
-              <a:rPr sz="2100" b="0">
-                <a:solidFill>
-                  <a:srgbClr val="111111"/>
-                </a:solidFill>
-                <a:latin typeface="Calibri"/>
-                <a:ea typeface="Calibri"/>
-                <a:cs typeface="Calibri"/>
-              </a:rPr>
-              <a:t>Separate the transient from the periodic response. Plot amplitude or gain against excitation frequency.</a:t>
-            </a:r>
-          </a:p>
-        </p:txBody>
-      </p:sp>
-      <p:sp>
-        <p:nvSpPr>
-          <p:cNvPr id="9" name="equation">
-            <a:extLst xmlns:a="http://schemas.openxmlformats.org/drawingml/2006/main">
-              <a:ext uri="{FF2B5EF4-FFF2-40B4-BE49-F238E27FC236}">
-                <a16:creationId xmlns:a16="http://schemas.microsoft.com/office/drawing/2014/main" id="{F155AFB4-E2D4-4C78-B710-3A1985B775A3}"/>
+              <a:defRPr sz="1725" b="0">
+                <a:solidFill>
+                  <a:srgbClr val="111111"/>
+                </a:solidFill>
+                <a:latin typeface="Calibri"/>
+                <a:ea typeface="Calibri"/>
+                <a:cs typeface="Calibri"/>
+              </a:defRPr>
+            </a:pPr>
+            <a:r>
+              <a:rPr sz="1725" b="0">
+                <a:solidFill>
+                  <a:srgbClr val="111111"/>
+                </a:solidFill>
+                <a:latin typeface="Calibri"/>
+                <a:ea typeface="Calibri"/>
+                <a:cs typeface="Calibri"/>
+              </a:rPr>
+              <a:t>Separate transient and steady motion. Compute output-to-input magnitude and compare the experimental Bode plot with the model.</a:t>
+            </a:r>
+          </a:p>
+        </p:txBody>
+      </p:sp>
+      <p:sp>
+        <p:nvSpPr>
+          <p:cNvPr id="9" name="body">
+            <a:extLst xmlns:a="http://schemas.openxmlformats.org/drawingml/2006/main">
+              <a:ext uri="{FF2B5EF4-FFF2-40B4-BE49-F238E27FC236}">
+                <a16:creationId xmlns:a16="http://schemas.microsoft.com/office/drawing/2014/main" id="{F31F50BE-2345-47E7-9E49-8129538A3CB0}"/>
+              </a:ext>
+            </a:extLst>
+          </p:cNvPr>
+          <p:cNvSpPr>
+            <a:spLocks xmlns:a="http://schemas.openxmlformats.org/drawingml/2006/main" noGrp="1"/>
+          </p:cNvSpPr>
+          <p:nvPr/>
+        </p:nvSpPr>
+        <p:spPr>
+          <a:xfrm xmlns:a="http://schemas.openxmlformats.org/drawingml/2006/main">
+            <a:off x="495300" y="4524375"/>
+            <a:ext cx="10810875" cy="361950"/>
+          </a:xfrm>
+          <a:prstGeom xmlns:a="http://schemas.openxmlformats.org/drawingml/2006/main" prst="rect">
+            <a:avLst/>
+          </a:prstGeom>
+          <a:noFill xmlns:a="http://schemas.openxmlformats.org/drawingml/2006/main"/>
+          <a:ln xmlns:a="http://schemas.openxmlformats.org/drawingml/2006/main" w="0">
+            <a:noFill/>
+          </a:ln>
+        </p:spPr>
+        <p:txBody>
+          <a:bodyPr xmlns:a="http://schemas.openxmlformats.org/drawingml/2006/main">
+            <a:noAutofit/>
+          </a:bodyPr>
+          <a:lstStyle xmlns:a="http://schemas.openxmlformats.org/drawingml/2006/main"/>
+          <a:p xmlns:a="http://schemas.openxmlformats.org/drawingml/2006/main">
+            <a:pPr>
+              <a:defRPr sz="1650" b="1">
+                <a:solidFill>
+                  <a:srgbClr val="881C1C"/>
+                </a:solidFill>
+                <a:latin typeface="Calibri"/>
+                <a:ea typeface="Calibri"/>
+                <a:cs typeface="Calibri"/>
+              </a:defRPr>
+            </a:pPr>
+            <a:r>
+              <a:rPr sz="1650" b="1">
+                <a:solidFill>
+                  <a:srgbClr val="881C1C"/>
+                </a:solidFill>
+                <a:latin typeface="Calibri"/>
+                <a:ea typeface="Calibri"/>
+                <a:cs typeface="Calibri"/>
+              </a:rPr>
+              <a:t>Report focus</a:t>
+            </a:r>
+          </a:p>
+        </p:txBody>
+      </p:sp>
+      <p:sp>
+        <p:nvSpPr>
+          <p:cNvPr id="10" name="body">
+            <a:extLst xmlns:a="http://schemas.openxmlformats.org/drawingml/2006/main">
+              <a:ext uri="{FF2B5EF4-FFF2-40B4-BE49-F238E27FC236}">
+                <a16:creationId xmlns:a16="http://schemas.microsoft.com/office/drawing/2014/main" id="{F23E82FB-92EF-46C9-AD9E-A6A146D2774E}"/>
+              </a:ext>
+            </a:extLst>
+          </p:cNvPr>
+          <p:cNvSpPr>
+            <a:spLocks xmlns:a="http://schemas.openxmlformats.org/drawingml/2006/main" noGrp="1"/>
+          </p:cNvSpPr>
+          <p:nvPr/>
+        </p:nvSpPr>
+        <p:spPr>
+          <a:xfrm xmlns:a="http://schemas.openxmlformats.org/drawingml/2006/main">
+            <a:off x="495300" y="4886325"/>
+            <a:ext cx="10810875" cy="542925"/>
+          </a:xfrm>
+          <a:prstGeom xmlns:a="http://schemas.openxmlformats.org/drawingml/2006/main" prst="rect">
+            <a:avLst/>
+          </a:prstGeom>
+          <a:noFill xmlns:a="http://schemas.openxmlformats.org/drawingml/2006/main"/>
+          <a:ln xmlns:a="http://schemas.openxmlformats.org/drawingml/2006/main" w="0">
+            <a:noFill/>
+          </a:ln>
+        </p:spPr>
+        <p:txBody>
+          <a:bodyPr xmlns:a="http://schemas.openxmlformats.org/drawingml/2006/main">
+            <a:noAutofit/>
+          </a:bodyPr>
+          <a:lstStyle xmlns:a="http://schemas.openxmlformats.org/drawingml/2006/main"/>
+          <a:p xmlns:a="http://schemas.openxmlformats.org/drawingml/2006/main">
+            <a:pPr>
+              <a:defRPr sz="1725" b="0">
+                <a:solidFill>
+                  <a:srgbClr val="111111"/>
+                </a:solidFill>
+                <a:latin typeface="Calibri"/>
+                <a:ea typeface="Calibri"/>
+                <a:cs typeface="Calibri"/>
+              </a:defRPr>
+            </a:pPr>
+            <a:r>
+              <a:rPr sz="1725" b="0">
+                <a:solidFill>
+                  <a:srgbClr val="111111"/>
+                </a:solidFill>
+                <a:latin typeface="Calibri"/>
+                <a:ea typeface="Calibri"/>
+                <a:cs typeface="Calibri"/>
+              </a:rPr>
+              <a:t>Use measured input amplitude and frequency for every point. Connect Lab 4 parameter estimates to the forced-response prediction.</a:t>
+            </a:r>
+          </a:p>
+        </p:txBody>
+      </p:sp>
+      <p:sp>
+        <p:nvSpPr>
+          <p:cNvPr id="11" name="equation">
+            <a:extLst xmlns:a="http://schemas.openxmlformats.org/drawingml/2006/main">
+              <a:ext uri="{FF2B5EF4-FFF2-40B4-BE49-F238E27FC236}">
+                <a16:creationId xmlns:a16="http://schemas.microsoft.com/office/drawing/2014/main" id="{A1D54418-1425-463A-BD74-1E00E031DBE8}"/>
               </a:ext>
             </a:extLst>
           </p:cNvPr>
@@ -7780,10 +8122,10 @@
       </p:sp>
       <p:sp>
         <p:nvSpPr>
-          <p:cNvPr id="10" name="footnote">
-            <a:extLst xmlns:a="http://schemas.openxmlformats.org/drawingml/2006/main">
-              <a:ext uri="{FF2B5EF4-FFF2-40B4-BE49-F238E27FC236}">
-                <a16:creationId xmlns:a16="http://schemas.microsoft.com/office/drawing/2014/main" id="{9D39C1C5-2238-4BE9-B0CA-3B92F20CA8F3}"/>
+          <p:cNvPr id="12" name="footnote">
+            <a:extLst xmlns:a="http://schemas.openxmlformats.org/drawingml/2006/main">
+              <a:ext uri="{FF2B5EF4-FFF2-40B4-BE49-F238E27FC236}">
+                <a16:creationId xmlns:a16="http://schemas.microsoft.com/office/drawing/2014/main" id="{E52B638A-51F5-4032-9D41-02ABDB8F00A2}"/>
               </a:ext>
             </a:extLst>
           </p:cNvPr>
@@ -7830,17 +8172,17 @@
                 <a:ea typeface="Calibri"/>
                 <a:cs typeface="Calibri"/>
               </a:rPr>
-              <a:t>This is the force-input model. A moving spring attachment requires the corresponding base-motion input model.</a:t>
-            </a:r>
-          </a:p>
-        </p:txBody>
-      </p:sp>
-      <p:sp>
-        <p:nvSpPr>
-          <p:cNvPr id="11" name="page">
-            <a:extLst xmlns:a="http://schemas.openxmlformats.org/drawingml/2006/main">
-              <a:ext uri="{FF2B5EF4-FFF2-40B4-BE49-F238E27FC236}">
-                <a16:creationId xmlns:a16="http://schemas.microsoft.com/office/drawing/2014/main" id="{98D72619-9B68-464F-84D9-AB28BECCC168}"/>
+              <a:t>Let the response settle before measuring amplitude. Convert tachometer RPM to rad/s and document any configuration changes.</a:t>
+            </a:r>
+          </a:p>
+        </p:txBody>
+      </p:sp>
+      <p:sp>
+        <p:nvSpPr>
+          <p:cNvPr id="13" name="page">
+            <a:extLst xmlns:a="http://schemas.openxmlformats.org/drawingml/2006/main">
+              <a:ext uri="{FF2B5EF4-FFF2-40B4-BE49-F238E27FC236}">
+                <a16:creationId xmlns:a16="http://schemas.microsoft.com/office/drawing/2014/main" id="{722D20BA-EAD8-4E88-9AF7-0A614142166F}"/>
               </a:ext>
             </a:extLst>
           </p:cNvPr>
@@ -7895,7 +8237,7 @@
     </p:spTree>
     <p:extLst>
       <p:ext uri="{BB962C8B-B14F-4D97-AF65-F5344CB8AC3E}">
-        <p14:creationId xmlns:p14="http://schemas.microsoft.com/office/powerpoint/2010/main" val="702513032"/>
+        <p14:creationId xmlns:p14="http://schemas.microsoft.com/office/powerpoint/2010/main" val="1765283028"/>
       </p:ext>
     </p:extLst>
   </p:cSld>
@@ -7923,10 +8265,10 @@
       </p:grpSpPr>
       <p:sp>
         <p:nvSpPr>
-          <p:cNvPr id="12" name="course">
-            <a:extLst xmlns:a="http://schemas.openxmlformats.org/drawingml/2006/main">
-              <a:ext uri="{FF2B5EF4-FFF2-40B4-BE49-F238E27FC236}">
-                <a16:creationId xmlns:a16="http://schemas.microsoft.com/office/drawing/2014/main" id="{B7EEA936-68ED-4F13-B233-D1DABD52A839}"/>
+          <p:cNvPr id="14" name="course">
+            <a:extLst xmlns:a="http://schemas.openxmlformats.org/drawingml/2006/main">
+              <a:ext uri="{FF2B5EF4-FFF2-40B4-BE49-F238E27FC236}">
+                <a16:creationId xmlns:a16="http://schemas.microsoft.com/office/drawing/2014/main" id="{84D1EA99-F4EC-44DF-B18A-A7A6B44D9EEB}"/>
               </a:ext>
             </a:extLst>
           </p:cNvPr>
@@ -7983,7 +8325,7 @@
           <p:cNvPr id="2" name="title">
             <a:extLst xmlns:a="http://schemas.openxmlformats.org/drawingml/2006/main">
               <a:ext uri="{FF2B5EF4-FFF2-40B4-BE49-F238E27FC236}">
-                <a16:creationId xmlns:a16="http://schemas.microsoft.com/office/drawing/2014/main" id="{2EA4A7EA-FCF1-4967-B490-4B7D15C7D143}"/>
+                <a16:creationId xmlns:a16="http://schemas.microsoft.com/office/drawing/2014/main" id="{75F7995A-B2FF-435D-BCB8-461482F32525}"/>
               </a:ext>
             </a:extLst>
           </p:cNvPr>
@@ -8040,7 +8382,7 @@
           <p:cNvPr id="3" name="body">
             <a:extLst xmlns:a="http://schemas.openxmlformats.org/drawingml/2006/main">
               <a:ext uri="{FF2B5EF4-FFF2-40B4-BE49-F238E27FC236}">
-                <a16:creationId xmlns:a16="http://schemas.microsoft.com/office/drawing/2014/main" id="{4E0BD7B1-FE99-420D-AD5A-B30BE96CBFA1}"/>
+                <a16:creationId xmlns:a16="http://schemas.microsoft.com/office/drawing/2014/main" id="{FDB077EC-BCBE-4507-9463-0588F824AA3D}"/>
               </a:ext>
             </a:extLst>
           </p:cNvPr>
@@ -8069,7 +8411,7 @@
           <a:lstStyle xmlns:a="http://schemas.openxmlformats.org/drawingml/2006/main"/>
           <a:p xmlns:a="http://schemas.openxmlformats.org/drawingml/2006/main">
             <a:pPr>
-              <a:defRPr sz="1875" b="1">
+              <a:defRPr sz="1650" b="1">
                 <a:solidFill>
                   <a:srgbClr val="881C1C"/>
                 </a:solidFill>
@@ -8079,7 +8421,7 @@
               </a:defRPr>
             </a:pPr>
             <a:r>
-              <a:rPr sz="1875" b="1">
+              <a:rPr sz="1650" b="1">
                 <a:solidFill>
                   <a:srgbClr val="881C1C"/>
                 </a:solidFill>
@@ -8087,7 +8429,7 @@
                 <a:ea typeface="Calibri"/>
                 <a:cs typeface="Calibri"/>
               </a:rPr>
-              <a:t>Question</a:t>
+              <a:t>Apparatus</a:t>
             </a:r>
           </a:p>
         </p:txBody>
@@ -8097,7 +8439,7 @@
           <p:cNvPr id="4" name="body">
             <a:extLst xmlns:a="http://schemas.openxmlformats.org/drawingml/2006/main">
               <a:ext uri="{FF2B5EF4-FFF2-40B4-BE49-F238E27FC236}">
-                <a16:creationId xmlns:a16="http://schemas.microsoft.com/office/drawing/2014/main" id="{5CB5F66D-85CF-454E-80B2-89DBD38737D8}"/>
+                <a16:creationId xmlns:a16="http://schemas.microsoft.com/office/drawing/2014/main" id="{B5BF4838-E455-4ED2-A337-7800959B9750}"/>
               </a:ext>
             </a:extLst>
           </p:cNvPr>
@@ -8109,7 +8451,7 @@
         <p:spPr>
           <a:xfrm xmlns:a="http://schemas.openxmlformats.org/drawingml/2006/main">
             <a:off x="495300" y="2057400"/>
-            <a:ext cx="10810875" cy="790575"/>
+            <a:ext cx="10810875" cy="542925"/>
           </a:xfrm>
           <a:prstGeom xmlns:a="http://schemas.openxmlformats.org/drawingml/2006/main" prst="rect">
             <a:avLst/>
@@ -8126,25 +8468,25 @@
           <a:lstStyle xmlns:a="http://schemas.openxmlformats.org/drawingml/2006/main"/>
           <a:p xmlns:a="http://schemas.openxmlformats.org/drawingml/2006/main">
             <a:pPr>
-              <a:defRPr sz="2100" b="0">
-                <a:solidFill>
-                  <a:srgbClr val="111111"/>
-                </a:solidFill>
-                <a:latin typeface="Calibri"/>
-                <a:ea typeface="Calibri"/>
-                <a:cs typeface="Calibri"/>
-              </a:defRPr>
-            </a:pPr>
-            <a:r>
-              <a:rPr sz="2100" b="0">
-                <a:solidFill>
-                  <a:srgbClr val="111111"/>
-                </a:solidFill>
-                <a:latin typeface="Calibri"/>
-                <a:ea typeface="Calibri"/>
-                <a:cs typeface="Calibri"/>
-              </a:rPr>
-              <a:t>How does illumination relate to measured rotation over a controlled time window?</a:t>
+              <a:defRPr sz="1725" b="0">
+                <a:solidFill>
+                  <a:srgbClr val="111111"/>
+                </a:solidFill>
+                <a:latin typeface="Calibri"/>
+                <a:ea typeface="Calibri"/>
+                <a:cs typeface="Calibri"/>
+              </a:defRPr>
+            </a:pPr>
+            <a:r>
+              <a:rPr sz="1725" b="0">
+                <a:solidFill>
+                  <a:srgbClr val="111111"/>
+                </a:solidFill>
+                <a:latin typeface="Calibri"/>
+                <a:ea typeface="Calibri"/>
+                <a:cs typeface="Calibri"/>
+              </a:rPr>
+              <a:t>Crookes radiometer, LED light, lux meter, fixed camera, matte black background, ruler, and optional IR thermometer.</a:t>
             </a:r>
           </a:p>
         </p:txBody>
@@ -8154,18 +8496,18 @@
           <p:cNvPr id="5" name="body">
             <a:extLst xmlns:a="http://schemas.openxmlformats.org/drawingml/2006/main">
               <a:ext uri="{FF2B5EF4-FFF2-40B4-BE49-F238E27FC236}">
-                <a16:creationId xmlns:a16="http://schemas.microsoft.com/office/drawing/2014/main" id="{60C15628-806B-4C99-A7A9-E29A088DD5A0}"/>
-              </a:ext>
-            </a:extLst>
-          </p:cNvPr>
-          <p:cNvSpPr>
-            <a:spLocks xmlns:a="http://schemas.openxmlformats.org/drawingml/2006/main" noGrp="1"/>
-          </p:cNvSpPr>
-          <p:nvPr/>
-        </p:nvSpPr>
-        <p:spPr>
-          <a:xfrm xmlns:a="http://schemas.openxmlformats.org/drawingml/2006/main">
-            <a:off x="495300" y="2886075"/>
+                <a16:creationId xmlns:a16="http://schemas.microsoft.com/office/drawing/2014/main" id="{871DD34B-8D6F-44E3-AF02-97B2E90FF313}"/>
+              </a:ext>
+            </a:extLst>
+          </p:cNvPr>
+          <p:cNvSpPr>
+            <a:spLocks xmlns:a="http://schemas.openxmlformats.org/drawingml/2006/main" noGrp="1"/>
+          </p:cNvSpPr>
+          <p:nvPr/>
+        </p:nvSpPr>
+        <p:spPr>
+          <a:xfrm xmlns:a="http://schemas.openxmlformats.org/drawingml/2006/main">
+            <a:off x="495300" y="2638425"/>
             <a:ext cx="10810875" cy="361950"/>
           </a:xfrm>
           <a:prstGeom xmlns:a="http://schemas.openxmlformats.org/drawingml/2006/main" prst="rect">
@@ -8183,7 +8525,7 @@
           <a:lstStyle xmlns:a="http://schemas.openxmlformats.org/drawingml/2006/main"/>
           <a:p xmlns:a="http://schemas.openxmlformats.org/drawingml/2006/main">
             <a:pPr>
-              <a:defRPr sz="1875" b="1">
+              <a:defRPr sz="1650" b="1">
                 <a:solidFill>
                   <a:srgbClr val="881C1C"/>
                 </a:solidFill>
@@ -8193,7 +8535,7 @@
               </a:defRPr>
             </a:pPr>
             <a:r>
-              <a:rPr sz="1875" b="1">
+              <a:rPr sz="1650" b="1">
                 <a:solidFill>
                   <a:srgbClr val="881C1C"/>
                 </a:solidFill>
@@ -8201,7 +8543,7 @@
                 <a:ea typeface="Calibri"/>
                 <a:cs typeface="Calibri"/>
               </a:rPr>
-              <a:t>Measurement</a:t>
+              <a:t>Data collection</a:t>
             </a:r>
           </a:p>
         </p:txBody>
@@ -8211,19 +8553,19 @@
           <p:cNvPr id="6" name="body">
             <a:extLst xmlns:a="http://schemas.openxmlformats.org/drawingml/2006/main">
               <a:ext uri="{FF2B5EF4-FFF2-40B4-BE49-F238E27FC236}">
-                <a16:creationId xmlns:a16="http://schemas.microsoft.com/office/drawing/2014/main" id="{66C454E8-6825-488E-93DF-047E892360D6}"/>
-              </a:ext>
-            </a:extLst>
-          </p:cNvPr>
-          <p:cNvSpPr>
-            <a:spLocks xmlns:a="http://schemas.openxmlformats.org/drawingml/2006/main" noGrp="1"/>
-          </p:cNvSpPr>
-          <p:nvPr/>
-        </p:nvSpPr>
-        <p:spPr>
-          <a:xfrm xmlns:a="http://schemas.openxmlformats.org/drawingml/2006/main">
-            <a:off x="495300" y="3248025"/>
-            <a:ext cx="10810875" cy="790575"/>
+                <a16:creationId xmlns:a16="http://schemas.microsoft.com/office/drawing/2014/main" id="{88B29D71-660B-487A-BD96-01E5B1823B92}"/>
+              </a:ext>
+            </a:extLst>
+          </p:cNvPr>
+          <p:cNvSpPr>
+            <a:spLocks xmlns:a="http://schemas.openxmlformats.org/drawingml/2006/main" noGrp="1"/>
+          </p:cNvSpPr>
+          <p:nvPr/>
+        </p:nvSpPr>
+        <p:spPr>
+          <a:xfrm xmlns:a="http://schemas.openxmlformats.org/drawingml/2006/main">
+            <a:off x="495300" y="3000375"/>
+            <a:ext cx="10810875" cy="542925"/>
           </a:xfrm>
           <a:prstGeom xmlns:a="http://schemas.openxmlformats.org/drawingml/2006/main" prst="rect">
             <a:avLst/>
@@ -8240,25 +8582,25 @@
           <a:lstStyle xmlns:a="http://schemas.openxmlformats.org/drawingml/2006/main"/>
           <a:p xmlns:a="http://schemas.openxmlformats.org/drawingml/2006/main">
             <a:pPr>
-              <a:defRPr sz="2100" b="0">
-                <a:solidFill>
-                  <a:srgbClr val="111111"/>
-                </a:solidFill>
-                <a:latin typeface="Calibri"/>
-                <a:ea typeface="Calibri"/>
-                <a:cs typeface="Calibri"/>
-              </a:defRPr>
-            </a:pPr>
-            <a:r>
-              <a:rPr sz="2100" b="0">
-                <a:solidFill>
-                  <a:srgbClr val="111111"/>
-                </a:solidFill>
-                <a:latin typeface="Calibri"/>
-                <a:ea typeface="Calibri"/>
-                <a:cs typeface="Calibri"/>
-              </a:rPr>
-              <a:t>Track cumulative angle from video. Record illuminance, light position, and thermal history.</a:t>
+              <a:defRPr sz="1725" b="0">
+                <a:solidFill>
+                  <a:srgbClr val="111111"/>
+                </a:solidFill>
+                <a:latin typeface="Calibri"/>
+                <a:ea typeface="Calibri"/>
+                <a:cs typeface="Calibri"/>
+              </a:defRPr>
+            </a:pPr>
+            <a:r>
+              <a:rPr sz="1725" b="0">
+                <a:solidFill>
+                  <a:srgbClr val="111111"/>
+                </a:solidFill>
+                <a:latin typeface="Calibri"/>
+                <a:ea typeface="Calibri"/>
+                <a:cs typeface="Calibri"/>
+              </a:rPr>
+              <a:t>Record a clear 60–90 s video at a close safe light distance. Keep geometry fixed and note lux and thermal history.</a:t>
             </a:r>
           </a:p>
         </p:txBody>
@@ -8268,18 +8610,18 @@
           <p:cNvPr id="7" name="body">
             <a:extLst xmlns:a="http://schemas.openxmlformats.org/drawingml/2006/main">
               <a:ext uri="{FF2B5EF4-FFF2-40B4-BE49-F238E27FC236}">
-                <a16:creationId xmlns:a16="http://schemas.microsoft.com/office/drawing/2014/main" id="{76ADBC4B-DEFA-4E36-84E7-BE3E0A95FBE2}"/>
-              </a:ext>
-            </a:extLst>
-          </p:cNvPr>
-          <p:cNvSpPr>
-            <a:spLocks xmlns:a="http://schemas.openxmlformats.org/drawingml/2006/main" noGrp="1"/>
-          </p:cNvSpPr>
-          <p:nvPr/>
-        </p:nvSpPr>
-        <p:spPr>
-          <a:xfrm xmlns:a="http://schemas.openxmlformats.org/drawingml/2006/main">
-            <a:off x="495300" y="4076700"/>
+                <a16:creationId xmlns:a16="http://schemas.microsoft.com/office/drawing/2014/main" id="{78BAAAF6-DAAB-4B88-B542-BF710B9537BD}"/>
+              </a:ext>
+            </a:extLst>
+          </p:cNvPr>
+          <p:cNvSpPr>
+            <a:spLocks xmlns:a="http://schemas.openxmlformats.org/drawingml/2006/main" noGrp="1"/>
+          </p:cNvSpPr>
+          <p:nvPr/>
+        </p:nvSpPr>
+        <p:spPr>
+          <a:xfrm xmlns:a="http://schemas.openxmlformats.org/drawingml/2006/main">
+            <a:off x="495300" y="3581400"/>
             <a:ext cx="10810875" cy="361950"/>
           </a:xfrm>
           <a:prstGeom xmlns:a="http://schemas.openxmlformats.org/drawingml/2006/main" prst="rect">
@@ -8297,7 +8639,7 @@
           <a:lstStyle xmlns:a="http://schemas.openxmlformats.org/drawingml/2006/main"/>
           <a:p xmlns:a="http://schemas.openxmlformats.org/drawingml/2006/main">
             <a:pPr>
-              <a:defRPr sz="1875" b="1">
+              <a:defRPr sz="1650" b="1">
                 <a:solidFill>
                   <a:srgbClr val="881C1C"/>
                 </a:solidFill>
@@ -8307,7 +8649,7 @@
               </a:defRPr>
             </a:pPr>
             <a:r>
-              <a:rPr sz="1875" b="1">
+              <a:rPr sz="1650" b="1">
                 <a:solidFill>
                   <a:srgbClr val="881C1C"/>
                 </a:solidFill>
@@ -8315,7 +8657,7 @@
                 <a:ea typeface="Calibri"/>
                 <a:cs typeface="Calibri"/>
               </a:rPr>
-              <a:t>Report evidence</a:t>
+              <a:t>Analysis</a:t>
             </a:r>
           </a:p>
         </p:txBody>
@@ -8325,19 +8667,19 @@
           <p:cNvPr id="8" name="body">
             <a:extLst xmlns:a="http://schemas.openxmlformats.org/drawingml/2006/main">
               <a:ext uri="{FF2B5EF4-FFF2-40B4-BE49-F238E27FC236}">
-                <a16:creationId xmlns:a16="http://schemas.microsoft.com/office/drawing/2014/main" id="{8E0A9585-68E4-4828-ADF2-61E72A33900B}"/>
-              </a:ext>
-            </a:extLst>
-          </p:cNvPr>
-          <p:cNvSpPr>
-            <a:spLocks xmlns:a="http://schemas.openxmlformats.org/drawingml/2006/main" noGrp="1"/>
-          </p:cNvSpPr>
-          <p:nvPr/>
-        </p:nvSpPr>
-        <p:spPr>
-          <a:xfrm xmlns:a="http://schemas.openxmlformats.org/drawingml/2006/main">
-            <a:off x="495300" y="4438650"/>
-            <a:ext cx="10810875" cy="790575"/>
+                <a16:creationId xmlns:a16="http://schemas.microsoft.com/office/drawing/2014/main" id="{1AB35E15-6225-40D6-B68F-DB1E4824F844}"/>
+              </a:ext>
+            </a:extLst>
+          </p:cNvPr>
+          <p:cNvSpPr>
+            <a:spLocks xmlns:a="http://schemas.openxmlformats.org/drawingml/2006/main" noGrp="1"/>
+          </p:cNvSpPr>
+          <p:nvPr/>
+        </p:nvSpPr>
+        <p:spPr>
+          <a:xfrm xmlns:a="http://schemas.openxmlformats.org/drawingml/2006/main">
+            <a:off x="495300" y="3943350"/>
+            <a:ext cx="10810875" cy="542925"/>
           </a:xfrm>
           <a:prstGeom xmlns:a="http://schemas.openxmlformats.org/drawingml/2006/main" prst="rect">
             <a:avLst/>
@@ -8354,35 +8696,149 @@
           <a:lstStyle xmlns:a="http://schemas.openxmlformats.org/drawingml/2006/main"/>
           <a:p xmlns:a="http://schemas.openxmlformats.org/drawingml/2006/main">
             <a:pPr>
-              <a:defRPr sz="2100" b="0">
-                <a:solidFill>
-                  <a:srgbClr val="111111"/>
-                </a:solidFill>
-                <a:latin typeface="Calibri"/>
-                <a:ea typeface="Calibri"/>
-                <a:cs typeface="Calibri"/>
-              </a:defRPr>
-            </a:pPr>
-            <a:r>
-              <a:rPr sz="2100" b="0">
-                <a:solidFill>
-                  <a:srgbClr val="111111"/>
-                </a:solidFill>
-                <a:latin typeface="Calibri"/>
-                <a:ea typeface="Calibri"/>
-                <a:cs typeface="Calibri"/>
-              </a:rPr>
-              <a:t>Fit angle versus time to estimate RPM. Compare identical measurement windows and discuss warming.</a:t>
-            </a:r>
-          </a:p>
-        </p:txBody>
-      </p:sp>
-      <p:sp>
-        <p:nvSpPr>
-          <p:cNvPr id="9" name="equation">
-            <a:extLst xmlns:a="http://schemas.openxmlformats.org/drawingml/2006/main">
-              <a:ext uri="{FF2B5EF4-FFF2-40B4-BE49-F238E27FC236}">
-                <a16:creationId xmlns:a16="http://schemas.microsoft.com/office/drawing/2014/main" id="{E9971163-9595-424A-9BCF-D28A6E47F998}"/>
+              <a:defRPr sz="1725" b="0">
+                <a:solidFill>
+                  <a:srgbClr val="111111"/>
+                </a:solidFill>
+                <a:latin typeface="Calibri"/>
+                <a:ea typeface="Calibri"/>
+                <a:cs typeface="Calibri"/>
+              </a:defRPr>
+            </a:pPr>
+            <a:r>
+              <a:rPr sz="1725" b="0">
+                <a:solidFill>
+                  <a:srgbClr val="111111"/>
+                </a:solidFill>
+                <a:latin typeface="Calibri"/>
+                <a:ea typeface="Calibri"/>
+                <a:cs typeface="Calibri"/>
+              </a:rPr>
+              <a:t>Track the vane within an annulus, unwrap cumulative angle, fit its slope for average RPM, and inspect interval RPM for slowdown.</a:t>
+            </a:r>
+          </a:p>
+        </p:txBody>
+      </p:sp>
+      <p:sp>
+        <p:nvSpPr>
+          <p:cNvPr id="9" name="body">
+            <a:extLst xmlns:a="http://schemas.openxmlformats.org/drawingml/2006/main">
+              <a:ext uri="{FF2B5EF4-FFF2-40B4-BE49-F238E27FC236}">
+                <a16:creationId xmlns:a16="http://schemas.microsoft.com/office/drawing/2014/main" id="{4678AB7D-047F-47A3-85E2-B19F7CAA3EBD}"/>
+              </a:ext>
+            </a:extLst>
+          </p:cNvPr>
+          <p:cNvSpPr>
+            <a:spLocks xmlns:a="http://schemas.openxmlformats.org/drawingml/2006/main" noGrp="1"/>
+          </p:cNvSpPr>
+          <p:nvPr/>
+        </p:nvSpPr>
+        <p:spPr>
+          <a:xfrm xmlns:a="http://schemas.openxmlformats.org/drawingml/2006/main">
+            <a:off x="495300" y="4524375"/>
+            <a:ext cx="10810875" cy="361950"/>
+          </a:xfrm>
+          <a:prstGeom xmlns:a="http://schemas.openxmlformats.org/drawingml/2006/main" prst="rect">
+            <a:avLst/>
+          </a:prstGeom>
+          <a:noFill xmlns:a="http://schemas.openxmlformats.org/drawingml/2006/main"/>
+          <a:ln xmlns:a="http://schemas.openxmlformats.org/drawingml/2006/main" w="0">
+            <a:noFill/>
+          </a:ln>
+        </p:spPr>
+        <p:txBody>
+          <a:bodyPr xmlns:a="http://schemas.openxmlformats.org/drawingml/2006/main">
+            <a:noAutofit/>
+          </a:bodyPr>
+          <a:lstStyle xmlns:a="http://schemas.openxmlformats.org/drawingml/2006/main"/>
+          <a:p xmlns:a="http://schemas.openxmlformats.org/drawingml/2006/main">
+            <a:pPr>
+              <a:defRPr sz="1650" b="1">
+                <a:solidFill>
+                  <a:srgbClr val="881C1C"/>
+                </a:solidFill>
+                <a:latin typeface="Calibri"/>
+                <a:ea typeface="Calibri"/>
+                <a:cs typeface="Calibri"/>
+              </a:defRPr>
+            </a:pPr>
+            <a:r>
+              <a:rPr sz="1650" b="1">
+                <a:solidFill>
+                  <a:srgbClr val="881C1C"/>
+                </a:solidFill>
+                <a:latin typeface="Calibri"/>
+                <a:ea typeface="Calibri"/>
+                <a:cs typeface="Calibri"/>
+              </a:rPr>
+              <a:t>Report focus</a:t>
+            </a:r>
+          </a:p>
+        </p:txBody>
+      </p:sp>
+      <p:sp>
+        <p:nvSpPr>
+          <p:cNvPr id="10" name="body">
+            <a:extLst xmlns:a="http://schemas.openxmlformats.org/drawingml/2006/main">
+              <a:ext uri="{FF2B5EF4-FFF2-40B4-BE49-F238E27FC236}">
+                <a16:creationId xmlns:a16="http://schemas.microsoft.com/office/drawing/2014/main" id="{ABB45B65-81AA-4BA0-8752-B6235C345805}"/>
+              </a:ext>
+            </a:extLst>
+          </p:cNvPr>
+          <p:cNvSpPr>
+            <a:spLocks xmlns:a="http://schemas.openxmlformats.org/drawingml/2006/main" noGrp="1"/>
+          </p:cNvSpPr>
+          <p:nvPr/>
+        </p:nvSpPr>
+        <p:spPr>
+          <a:xfrm xmlns:a="http://schemas.openxmlformats.org/drawingml/2006/main">
+            <a:off x="495300" y="4886325"/>
+            <a:ext cx="10810875" cy="542925"/>
+          </a:xfrm>
+          <a:prstGeom xmlns:a="http://schemas.openxmlformats.org/drawingml/2006/main" prst="rect">
+            <a:avLst/>
+          </a:prstGeom>
+          <a:noFill xmlns:a="http://schemas.openxmlformats.org/drawingml/2006/main"/>
+          <a:ln xmlns:a="http://schemas.openxmlformats.org/drawingml/2006/main" w="0">
+            <a:noFill/>
+          </a:ln>
+        </p:spPr>
+        <p:txBody>
+          <a:bodyPr xmlns:a="http://schemas.openxmlformats.org/drawingml/2006/main">
+            <a:noAutofit/>
+          </a:bodyPr>
+          <a:lstStyle xmlns:a="http://schemas.openxmlformats.org/drawingml/2006/main"/>
+          <a:p xmlns:a="http://schemas.openxmlformats.org/drawingml/2006/main">
+            <a:pPr>
+              <a:defRPr sz="1725" b="0">
+                <a:solidFill>
+                  <a:srgbClr val="111111"/>
+                </a:solidFill>
+                <a:latin typeface="Calibri"/>
+                <a:ea typeface="Calibri"/>
+                <a:cs typeface="Calibri"/>
+              </a:defRPr>
+            </a:pPr>
+            <a:r>
+              <a:rPr sz="1725" b="0">
+                <a:solidFill>
+                  <a:srgbClr val="111111"/>
+                </a:solidFill>
+                <a:latin typeface="Calibri"/>
+                <a:ea typeface="Calibri"/>
+                <a:cs typeface="Calibri"/>
+              </a:rPr>
+              <a:t>Connect rotation to rarefied-gas thermal transport. Explain why lux is an imperfect heat-input measure and why warming matters.</a:t>
+            </a:r>
+          </a:p>
+        </p:txBody>
+      </p:sp>
+      <p:sp>
+        <p:nvSpPr>
+          <p:cNvPr id="11" name="equation">
+            <a:extLst xmlns:a="http://schemas.openxmlformats.org/drawingml/2006/main">
+              <a:ext uri="{FF2B5EF4-FFF2-40B4-BE49-F238E27FC236}">
+                <a16:creationId xmlns:a16="http://schemas.microsoft.com/office/drawing/2014/main" id="{898DC05E-3BB4-43C6-9974-37BB6FAA1A1A}"/>
               </a:ext>
             </a:extLst>
           </p:cNvPr>
@@ -8436,10 +8892,10 @@
       </p:sp>
       <p:sp>
         <p:nvSpPr>
-          <p:cNvPr id="10" name="footnote">
-            <a:extLst xmlns:a="http://schemas.openxmlformats.org/drawingml/2006/main">
-              <a:ext uri="{FF2B5EF4-FFF2-40B4-BE49-F238E27FC236}">
-                <a16:creationId xmlns:a16="http://schemas.microsoft.com/office/drawing/2014/main" id="{39503B1F-E065-4ED4-8C5D-E8123D4CCB9A}"/>
+          <p:cNvPr id="12" name="footnote">
+            <a:extLst xmlns:a="http://schemas.openxmlformats.org/drawingml/2006/main">
+              <a:ext uri="{FF2B5EF4-FFF2-40B4-BE49-F238E27FC236}">
+                <a16:creationId xmlns:a16="http://schemas.microsoft.com/office/drawing/2014/main" id="{02513880-1D4C-44AE-AD65-25544F4539A1}"/>
               </a:ext>
             </a:extLst>
           </p:cNvPr>
@@ -8486,17 +8942,17 @@
                 <a:ea typeface="Calibri"/>
                 <a:cs typeface="Calibri"/>
               </a:rPr>
-              <a:t>ωavg is in rad/s. Lux measures illuminance, not absorbed heating power.</a:t>
-            </a:r>
-          </a:p>
-        </p:txBody>
-      </p:sp>
-      <p:sp>
-        <p:nvSpPr>
-          <p:cNvPr id="11" name="page">
-            <a:extLst xmlns:a="http://schemas.openxmlformats.org/drawingml/2006/main">
-              <a:ext uri="{FF2B5EF4-FFF2-40B4-BE49-F238E27FC236}">
-                <a16:creationId xmlns:a16="http://schemas.microsoft.com/office/drawing/2014/main" id="{2493DFC1-898A-4EB3-9885-46CD04DCC47D}"/>
+              <a:t>A practical start is about 15 cm from the light with the background 20–30 cm behind the bulb. Follow the released safety limits.</a:t>
+            </a:r>
+          </a:p>
+        </p:txBody>
+      </p:sp>
+      <p:sp>
+        <p:nvSpPr>
+          <p:cNvPr id="13" name="page">
+            <a:extLst xmlns:a="http://schemas.openxmlformats.org/drawingml/2006/main">
+              <a:ext uri="{FF2B5EF4-FFF2-40B4-BE49-F238E27FC236}">
+                <a16:creationId xmlns:a16="http://schemas.microsoft.com/office/drawing/2014/main" id="{410BAEF1-4BBF-4766-9B6B-F2F365FB1CBF}"/>
               </a:ext>
             </a:extLst>
           </p:cNvPr>
@@ -8551,7 +9007,7 @@
     </p:spTree>
     <p:extLst>
       <p:ext uri="{BB962C8B-B14F-4D97-AF65-F5344CB8AC3E}">
-        <p14:creationId xmlns:p14="http://schemas.microsoft.com/office/powerpoint/2010/main" val="1870949367"/>
+        <p14:creationId xmlns:p14="http://schemas.microsoft.com/office/powerpoint/2010/main" val="139399302"/>
       </p:ext>
     </p:extLst>
   </p:cSld>
@@ -9282,7 +9738,7 @@
           <p:cNvPr id="6" name="course">
             <a:extLst xmlns:a="http://schemas.openxmlformats.org/drawingml/2006/main">
               <a:ext uri="{FF2B5EF4-FFF2-40B4-BE49-F238E27FC236}">
-                <a16:creationId xmlns:a16="http://schemas.microsoft.com/office/drawing/2014/main" id="{80A955ED-8416-4406-BF29-7F84C1AB12CA}"/>
+                <a16:creationId xmlns:a16="http://schemas.microsoft.com/office/drawing/2014/main" id="{3B0934A7-DE88-4ACB-B546-A95DA00EAE7E}"/>
               </a:ext>
             </a:extLst>
           </p:cNvPr>
@@ -9339,7 +9795,7 @@
           <p:cNvPr id="2" name="title">
             <a:extLst xmlns:a="http://schemas.openxmlformats.org/drawingml/2006/main">
               <a:ext uri="{FF2B5EF4-FFF2-40B4-BE49-F238E27FC236}">
-                <a16:creationId xmlns:a16="http://schemas.microsoft.com/office/drawing/2014/main" id="{74A3C0E6-3B1A-4F4E-B36C-86DCBD91E6F2}"/>
+                <a16:creationId xmlns:a16="http://schemas.microsoft.com/office/drawing/2014/main" id="{EB0013EC-8462-4F4D-AA1C-A73D3E6FEF99}"/>
               </a:ext>
             </a:extLst>
           </p:cNvPr>
@@ -10011,7 +10467,7 @@
           <p:cNvPr id="4" name="footnote">
             <a:extLst xmlns:a="http://schemas.openxmlformats.org/drawingml/2006/main">
               <a:ext uri="{FF2B5EF4-FFF2-40B4-BE49-F238E27FC236}">
-                <a16:creationId xmlns:a16="http://schemas.microsoft.com/office/drawing/2014/main" id="{37305A25-E322-4ABA-91AA-B4F228A389A7}"/>
+                <a16:creationId xmlns:a16="http://schemas.microsoft.com/office/drawing/2014/main" id="{CDF7E69E-399A-4C82-9314-971AFE37A6EE}"/>
               </a:ext>
             </a:extLst>
           </p:cNvPr>
@@ -10068,7 +10524,7 @@
           <p:cNvPr id="5" name="page">
             <a:extLst xmlns:a="http://schemas.openxmlformats.org/drawingml/2006/main">
               <a:ext uri="{FF2B5EF4-FFF2-40B4-BE49-F238E27FC236}">
-                <a16:creationId xmlns:a16="http://schemas.microsoft.com/office/drawing/2014/main" id="{7C2643E0-2DA6-4BD3-BB30-48C25D82E4BA}"/>
+                <a16:creationId xmlns:a16="http://schemas.microsoft.com/office/drawing/2014/main" id="{6BF5BD87-617A-4AB7-B59C-A7B3977BB568}"/>
               </a:ext>
             </a:extLst>
           </p:cNvPr>
@@ -10123,7 +10579,7 @@
     </p:spTree>
     <p:extLst>
       <p:ext uri="{BB962C8B-B14F-4D97-AF65-F5344CB8AC3E}">
-        <p14:creationId xmlns:p14="http://schemas.microsoft.com/office/powerpoint/2010/main" val="1095551757"/>
+        <p14:creationId xmlns:p14="http://schemas.microsoft.com/office/powerpoint/2010/main" val="101949646"/>
       </p:ext>
     </p:extLst>
   </p:cSld>
@@ -10154,7 +10610,7 @@
           <p:cNvPr id="11" name="course">
             <a:extLst xmlns:a="http://schemas.openxmlformats.org/drawingml/2006/main">
               <a:ext uri="{FF2B5EF4-FFF2-40B4-BE49-F238E27FC236}">
-                <a16:creationId xmlns:a16="http://schemas.microsoft.com/office/drawing/2014/main" id="{06746896-5E47-4666-B991-BFDA7C9997CC}"/>
+                <a16:creationId xmlns:a16="http://schemas.microsoft.com/office/drawing/2014/main" id="{EC2E5555-DBD5-40BD-B130-AC56C35BEC04}"/>
               </a:ext>
             </a:extLst>
           </p:cNvPr>
@@ -10211,7 +10667,7 @@
           <p:cNvPr id="2" name="title">
             <a:extLst xmlns:a="http://schemas.openxmlformats.org/drawingml/2006/main">
               <a:ext uri="{FF2B5EF4-FFF2-40B4-BE49-F238E27FC236}">
-                <a16:creationId xmlns:a16="http://schemas.microsoft.com/office/drawing/2014/main" id="{48F16CFD-0475-4E6F-B48D-AD7E7104FA5C}"/>
+                <a16:creationId xmlns:a16="http://schemas.microsoft.com/office/drawing/2014/main" id="{52A5FFF4-146C-4028-B114-3DF53D02ACFA}"/>
               </a:ext>
             </a:extLst>
           </p:cNvPr>
@@ -10268,7 +10724,7 @@
           <p:cNvPr id="3" name="body">
             <a:extLst xmlns:a="http://schemas.openxmlformats.org/drawingml/2006/main">
               <a:ext uri="{FF2B5EF4-FFF2-40B4-BE49-F238E27FC236}">
-                <a16:creationId xmlns:a16="http://schemas.microsoft.com/office/drawing/2014/main" id="{4B642081-BCEA-4AB4-8D85-00EE6030C8AE}"/>
+                <a16:creationId xmlns:a16="http://schemas.microsoft.com/office/drawing/2014/main" id="{EADFAA5B-478F-4E85-9C2E-36F16A540B46}"/>
               </a:ext>
             </a:extLst>
           </p:cNvPr>
@@ -10325,7 +10781,7 @@
           <p:cNvPr id="4" name="body">
             <a:extLst xmlns:a="http://schemas.openxmlformats.org/drawingml/2006/main">
               <a:ext uri="{FF2B5EF4-FFF2-40B4-BE49-F238E27FC236}">
-                <a16:creationId xmlns:a16="http://schemas.microsoft.com/office/drawing/2014/main" id="{03BB7F13-2038-42CB-A2BE-78EA7C9D09B3}"/>
+                <a16:creationId xmlns:a16="http://schemas.microsoft.com/office/drawing/2014/main" id="{88454CDC-C2ED-4276-A5F4-3850315C2AB3}"/>
               </a:ext>
             </a:extLst>
           </p:cNvPr>
@@ -10382,7 +10838,7 @@
           <p:cNvPr id="5" name="body">
             <a:extLst xmlns:a="http://schemas.openxmlformats.org/drawingml/2006/main">
               <a:ext uri="{FF2B5EF4-FFF2-40B4-BE49-F238E27FC236}">
-                <a16:creationId xmlns:a16="http://schemas.microsoft.com/office/drawing/2014/main" id="{4056F6B3-C459-403A-8CC8-D714F31F14F2}"/>
+                <a16:creationId xmlns:a16="http://schemas.microsoft.com/office/drawing/2014/main" id="{9039D6E8-924C-4FB0-83A3-11AEAE45E285}"/>
               </a:ext>
             </a:extLst>
           </p:cNvPr>
@@ -10439,7 +10895,7 @@
           <p:cNvPr id="6" name="body">
             <a:extLst xmlns:a="http://schemas.openxmlformats.org/drawingml/2006/main">
               <a:ext uri="{FF2B5EF4-FFF2-40B4-BE49-F238E27FC236}">
-                <a16:creationId xmlns:a16="http://schemas.microsoft.com/office/drawing/2014/main" id="{2AB68C11-A5CB-431F-AED6-E1E2382225CC}"/>
+                <a16:creationId xmlns:a16="http://schemas.microsoft.com/office/drawing/2014/main" id="{EE41A66D-5134-4CC9-8AF5-DC1B76A45DF6}"/>
               </a:ext>
             </a:extLst>
           </p:cNvPr>
@@ -10496,7 +10952,7 @@
           <p:cNvPr id="7" name="body">
             <a:extLst xmlns:a="http://schemas.openxmlformats.org/drawingml/2006/main">
               <a:ext uri="{FF2B5EF4-FFF2-40B4-BE49-F238E27FC236}">
-                <a16:creationId xmlns:a16="http://schemas.microsoft.com/office/drawing/2014/main" id="{A4896DC6-A265-49B2-B2AC-1998729622EA}"/>
+                <a16:creationId xmlns:a16="http://schemas.microsoft.com/office/drawing/2014/main" id="{A3CA29C6-33A2-41DB-8FB7-0934B1A6253E}"/>
               </a:ext>
             </a:extLst>
           </p:cNvPr>
@@ -10553,7 +11009,7 @@
           <p:cNvPr id="8" name="body">
             <a:extLst xmlns:a="http://schemas.openxmlformats.org/drawingml/2006/main">
               <a:ext uri="{FF2B5EF4-FFF2-40B4-BE49-F238E27FC236}">
-                <a16:creationId xmlns:a16="http://schemas.microsoft.com/office/drawing/2014/main" id="{44AE66B2-39C1-4204-B8A3-D8A514B60AFC}"/>
+                <a16:creationId xmlns:a16="http://schemas.microsoft.com/office/drawing/2014/main" id="{65B1BFFC-3A67-4AA8-B2D3-F46B19653CF7}"/>
               </a:ext>
             </a:extLst>
           </p:cNvPr>
@@ -10610,7 +11066,7 @@
           <p:cNvPr id="9" name="footnote">
             <a:extLst xmlns:a="http://schemas.openxmlformats.org/drawingml/2006/main">
               <a:ext uri="{FF2B5EF4-FFF2-40B4-BE49-F238E27FC236}">
-                <a16:creationId xmlns:a16="http://schemas.microsoft.com/office/drawing/2014/main" id="{AC414F71-ED72-4E23-8F30-AD8758CD1E30}"/>
+                <a16:creationId xmlns:a16="http://schemas.microsoft.com/office/drawing/2014/main" id="{2872309C-072A-48D5-BE2F-2EDE8BB9015E}"/>
               </a:ext>
             </a:extLst>
           </p:cNvPr>
@@ -10667,7 +11123,7 @@
           <p:cNvPr id="10" name="page">
             <a:extLst xmlns:a="http://schemas.openxmlformats.org/drawingml/2006/main">
               <a:ext uri="{FF2B5EF4-FFF2-40B4-BE49-F238E27FC236}">
-                <a16:creationId xmlns:a16="http://schemas.microsoft.com/office/drawing/2014/main" id="{4A3EA71B-5086-40E1-8661-BD83AA105473}"/>
+                <a16:creationId xmlns:a16="http://schemas.microsoft.com/office/drawing/2014/main" id="{CA73F540-339D-4B18-8DCA-50FB968321A3}"/>
               </a:ext>
             </a:extLst>
           </p:cNvPr>
@@ -10722,7 +11178,7 @@
     </p:spTree>
     <p:extLst>
       <p:ext uri="{BB962C8B-B14F-4D97-AF65-F5344CB8AC3E}">
-        <p14:creationId xmlns:p14="http://schemas.microsoft.com/office/powerpoint/2010/main" val="63661402"/>
+        <p14:creationId xmlns:p14="http://schemas.microsoft.com/office/powerpoint/2010/main" val="1582163615"/>
       </p:ext>
     </p:extLst>
   </p:cSld>
@@ -10753,7 +11209,7 @@
           <p:cNvPr id="11" name="course">
             <a:extLst xmlns:a="http://schemas.openxmlformats.org/drawingml/2006/main">
               <a:ext uri="{FF2B5EF4-FFF2-40B4-BE49-F238E27FC236}">
-                <a16:creationId xmlns:a16="http://schemas.microsoft.com/office/drawing/2014/main" id="{5B922324-0222-4CA2-BBBC-5B234AE742D9}"/>
+                <a16:creationId xmlns:a16="http://schemas.microsoft.com/office/drawing/2014/main" id="{FAF50E64-C99D-4241-BD00-805C1F7C2F6D}"/>
               </a:ext>
             </a:extLst>
           </p:cNvPr>
@@ -10810,7 +11266,7 @@
           <p:cNvPr id="2" name="title">
             <a:extLst xmlns:a="http://schemas.openxmlformats.org/drawingml/2006/main">
               <a:ext uri="{FF2B5EF4-FFF2-40B4-BE49-F238E27FC236}">
-                <a16:creationId xmlns:a16="http://schemas.microsoft.com/office/drawing/2014/main" id="{83F19C27-2036-40A9-8E11-B1EC948803C5}"/>
+                <a16:creationId xmlns:a16="http://schemas.microsoft.com/office/drawing/2014/main" id="{028B1D70-B5DB-4B9E-AD2E-45961A8E3ED8}"/>
               </a:ext>
             </a:extLst>
           </p:cNvPr>
@@ -10867,7 +11323,7 @@
           <p:cNvPr id="3" name="body">
             <a:extLst xmlns:a="http://schemas.openxmlformats.org/drawingml/2006/main">
               <a:ext uri="{FF2B5EF4-FFF2-40B4-BE49-F238E27FC236}">
-                <a16:creationId xmlns:a16="http://schemas.microsoft.com/office/drawing/2014/main" id="{B9E4C854-0BC1-4891-85F9-E31E6AB30E95}"/>
+                <a16:creationId xmlns:a16="http://schemas.microsoft.com/office/drawing/2014/main" id="{E1786E3D-69CB-4052-8CAB-04F2514095F2}"/>
               </a:ext>
             </a:extLst>
           </p:cNvPr>
@@ -10924,7 +11380,7 @@
           <p:cNvPr id="4" name="body">
             <a:extLst xmlns:a="http://schemas.openxmlformats.org/drawingml/2006/main">
               <a:ext uri="{FF2B5EF4-FFF2-40B4-BE49-F238E27FC236}">
-                <a16:creationId xmlns:a16="http://schemas.microsoft.com/office/drawing/2014/main" id="{70C34988-B754-4D4F-B924-58E48F0C90B9}"/>
+                <a16:creationId xmlns:a16="http://schemas.microsoft.com/office/drawing/2014/main" id="{82B46D8E-1D63-440C-B995-C1F105B68B5A}"/>
               </a:ext>
             </a:extLst>
           </p:cNvPr>
@@ -10981,7 +11437,7 @@
           <p:cNvPr id="5" name="body">
             <a:extLst xmlns:a="http://schemas.openxmlformats.org/drawingml/2006/main">
               <a:ext uri="{FF2B5EF4-FFF2-40B4-BE49-F238E27FC236}">
-                <a16:creationId xmlns:a16="http://schemas.microsoft.com/office/drawing/2014/main" id="{CC16BF18-8309-4AB9-A77A-05D5FF182D00}"/>
+                <a16:creationId xmlns:a16="http://schemas.microsoft.com/office/drawing/2014/main" id="{DF5C6408-9DA8-499C-A140-A5D5B104713C}"/>
               </a:ext>
             </a:extLst>
           </p:cNvPr>
@@ -11038,7 +11494,7 @@
           <p:cNvPr id="6" name="body">
             <a:extLst xmlns:a="http://schemas.openxmlformats.org/drawingml/2006/main">
               <a:ext uri="{FF2B5EF4-FFF2-40B4-BE49-F238E27FC236}">
-                <a16:creationId xmlns:a16="http://schemas.microsoft.com/office/drawing/2014/main" id="{57AFBA50-8646-4CC9-8C96-5D411E29D19F}"/>
+                <a16:creationId xmlns:a16="http://schemas.microsoft.com/office/drawing/2014/main" id="{18E45D8D-734D-4041-917C-B090D6284380}"/>
               </a:ext>
             </a:extLst>
           </p:cNvPr>
@@ -11095,7 +11551,7 @@
           <p:cNvPr id="7" name="body">
             <a:extLst xmlns:a="http://schemas.openxmlformats.org/drawingml/2006/main">
               <a:ext uri="{FF2B5EF4-FFF2-40B4-BE49-F238E27FC236}">
-                <a16:creationId xmlns:a16="http://schemas.microsoft.com/office/drawing/2014/main" id="{64B9EB4C-C389-498A-AE8E-450B5EF1A204}"/>
+                <a16:creationId xmlns:a16="http://schemas.microsoft.com/office/drawing/2014/main" id="{82C86003-76C1-4F83-B70C-52697984F340}"/>
               </a:ext>
             </a:extLst>
           </p:cNvPr>
@@ -11152,7 +11608,7 @@
           <p:cNvPr id="8" name="body">
             <a:extLst xmlns:a="http://schemas.openxmlformats.org/drawingml/2006/main">
               <a:ext uri="{FF2B5EF4-FFF2-40B4-BE49-F238E27FC236}">
-                <a16:creationId xmlns:a16="http://schemas.microsoft.com/office/drawing/2014/main" id="{EEF693C5-1F79-4203-8191-C47235FC25DF}"/>
+                <a16:creationId xmlns:a16="http://schemas.microsoft.com/office/drawing/2014/main" id="{21BCB188-7499-410C-BE3C-FB2760FADBC8}"/>
               </a:ext>
             </a:extLst>
           </p:cNvPr>
@@ -11209,7 +11665,7 @@
           <p:cNvPr id="9" name="footnote">
             <a:extLst xmlns:a="http://schemas.openxmlformats.org/drawingml/2006/main">
               <a:ext uri="{FF2B5EF4-FFF2-40B4-BE49-F238E27FC236}">
-                <a16:creationId xmlns:a16="http://schemas.microsoft.com/office/drawing/2014/main" id="{48BEAA49-FE74-4F98-BD1F-F4AEAE026ACC}"/>
+                <a16:creationId xmlns:a16="http://schemas.microsoft.com/office/drawing/2014/main" id="{3D042294-F9F7-443A-82BB-CFF8D057CDC7}"/>
               </a:ext>
             </a:extLst>
           </p:cNvPr>
@@ -11266,7 +11722,7 @@
           <p:cNvPr id="10" name="page">
             <a:extLst xmlns:a="http://schemas.openxmlformats.org/drawingml/2006/main">
               <a:ext uri="{FF2B5EF4-FFF2-40B4-BE49-F238E27FC236}">
-                <a16:creationId xmlns:a16="http://schemas.microsoft.com/office/drawing/2014/main" id="{48FE5ED1-D22B-4B2A-BB6A-0149AACC5DA8}"/>
+                <a16:creationId xmlns:a16="http://schemas.microsoft.com/office/drawing/2014/main" id="{C6DC1E24-88C4-454F-A5FA-E59F550E2BCE}"/>
               </a:ext>
             </a:extLst>
           </p:cNvPr>
@@ -11321,7 +11777,7 @@
     </p:spTree>
     <p:extLst>
       <p:ext uri="{BB962C8B-B14F-4D97-AF65-F5344CB8AC3E}">
-        <p14:creationId xmlns:p14="http://schemas.microsoft.com/office/powerpoint/2010/main" val="930703595"/>
+        <p14:creationId xmlns:p14="http://schemas.microsoft.com/office/powerpoint/2010/main" val="556312306"/>
       </p:ext>
     </p:extLst>
   </p:cSld>
@@ -11352,7 +11808,7 @@
           <p:cNvPr id="11" name="course">
             <a:extLst xmlns:a="http://schemas.openxmlformats.org/drawingml/2006/main">
               <a:ext uri="{FF2B5EF4-FFF2-40B4-BE49-F238E27FC236}">
-                <a16:creationId xmlns:a16="http://schemas.microsoft.com/office/drawing/2014/main" id="{769A67D4-789C-4BAA-898A-119940B76398}"/>
+                <a16:creationId xmlns:a16="http://schemas.microsoft.com/office/drawing/2014/main" id="{879DFF1D-DBEB-4E6A-AE1D-6180C204A7CD}"/>
               </a:ext>
             </a:extLst>
           </p:cNvPr>
@@ -11409,7 +11865,7 @@
           <p:cNvPr id="2" name="title">
             <a:extLst xmlns:a="http://schemas.openxmlformats.org/drawingml/2006/main">
               <a:ext uri="{FF2B5EF4-FFF2-40B4-BE49-F238E27FC236}">
-                <a16:creationId xmlns:a16="http://schemas.microsoft.com/office/drawing/2014/main" id="{A85CD9F7-B351-45E4-AE27-CB2E79586093}"/>
+                <a16:creationId xmlns:a16="http://schemas.microsoft.com/office/drawing/2014/main" id="{F6B42ED9-A287-44CF-AF1D-82BE09612BE1}"/>
               </a:ext>
             </a:extLst>
           </p:cNvPr>
@@ -11466,7 +11922,7 @@
           <p:cNvPr id="3" name="body">
             <a:extLst xmlns:a="http://schemas.openxmlformats.org/drawingml/2006/main">
               <a:ext uri="{FF2B5EF4-FFF2-40B4-BE49-F238E27FC236}">
-                <a16:creationId xmlns:a16="http://schemas.microsoft.com/office/drawing/2014/main" id="{6F6AB507-C7EF-40BD-A575-8983850375F3}"/>
+                <a16:creationId xmlns:a16="http://schemas.microsoft.com/office/drawing/2014/main" id="{F89321D9-86C5-45CE-BE01-764C24DB925D}"/>
               </a:ext>
             </a:extLst>
           </p:cNvPr>
@@ -11523,7 +11979,7 @@
           <p:cNvPr id="4" name="body">
             <a:extLst xmlns:a="http://schemas.openxmlformats.org/drawingml/2006/main">
               <a:ext uri="{FF2B5EF4-FFF2-40B4-BE49-F238E27FC236}">
-                <a16:creationId xmlns:a16="http://schemas.microsoft.com/office/drawing/2014/main" id="{C551174B-7169-4E33-AFB5-2063D810F07C}"/>
+                <a16:creationId xmlns:a16="http://schemas.microsoft.com/office/drawing/2014/main" id="{1C5290BC-15F8-433E-BEBD-44D0043A3948}"/>
               </a:ext>
             </a:extLst>
           </p:cNvPr>
@@ -11580,7 +12036,7 @@
           <p:cNvPr id="5" name="body">
             <a:extLst xmlns:a="http://schemas.openxmlformats.org/drawingml/2006/main">
               <a:ext uri="{FF2B5EF4-FFF2-40B4-BE49-F238E27FC236}">
-                <a16:creationId xmlns:a16="http://schemas.microsoft.com/office/drawing/2014/main" id="{9720DE92-0082-4185-BC06-2471961275A4}"/>
+                <a16:creationId xmlns:a16="http://schemas.microsoft.com/office/drawing/2014/main" id="{A88760F1-19FF-44EF-AE91-746107609D22}"/>
               </a:ext>
             </a:extLst>
           </p:cNvPr>
@@ -11637,7 +12093,7 @@
           <p:cNvPr id="6" name="body">
             <a:extLst xmlns:a="http://schemas.openxmlformats.org/drawingml/2006/main">
               <a:ext uri="{FF2B5EF4-FFF2-40B4-BE49-F238E27FC236}">
-                <a16:creationId xmlns:a16="http://schemas.microsoft.com/office/drawing/2014/main" id="{12C63E68-6716-4AA9-AAEB-7FAB634D4D1F}"/>
+                <a16:creationId xmlns:a16="http://schemas.microsoft.com/office/drawing/2014/main" id="{461611CE-5BA5-4105-99E2-B86EB16E7046}"/>
               </a:ext>
             </a:extLst>
           </p:cNvPr>
@@ -11694,7 +12150,7 @@
           <p:cNvPr id="7" name="body">
             <a:extLst xmlns:a="http://schemas.openxmlformats.org/drawingml/2006/main">
               <a:ext uri="{FF2B5EF4-FFF2-40B4-BE49-F238E27FC236}">
-                <a16:creationId xmlns:a16="http://schemas.microsoft.com/office/drawing/2014/main" id="{72351866-76ED-45AE-B7D1-ED53E4618406}"/>
+                <a16:creationId xmlns:a16="http://schemas.microsoft.com/office/drawing/2014/main" id="{EA33A5C2-205D-4E95-BADA-866A2DF766B4}"/>
               </a:ext>
             </a:extLst>
           </p:cNvPr>
@@ -11751,7 +12207,7 @@
           <p:cNvPr id="8" name="body">
             <a:extLst xmlns:a="http://schemas.openxmlformats.org/drawingml/2006/main">
               <a:ext uri="{FF2B5EF4-FFF2-40B4-BE49-F238E27FC236}">
-                <a16:creationId xmlns:a16="http://schemas.microsoft.com/office/drawing/2014/main" id="{B01BEC06-D256-4A15-A10A-D7D0A5B7F5DE}"/>
+                <a16:creationId xmlns:a16="http://schemas.microsoft.com/office/drawing/2014/main" id="{42EB0A9E-FD71-4D64-ABC4-A85353AF6F8E}"/>
               </a:ext>
             </a:extLst>
           </p:cNvPr>
@@ -11808,7 +12264,7 @@
           <p:cNvPr id="9" name="footnote">
             <a:extLst xmlns:a="http://schemas.openxmlformats.org/drawingml/2006/main">
               <a:ext uri="{FF2B5EF4-FFF2-40B4-BE49-F238E27FC236}">
-                <a16:creationId xmlns:a16="http://schemas.microsoft.com/office/drawing/2014/main" id="{86C01F23-BA6F-42E5-8D7B-0326C98C2669}"/>
+                <a16:creationId xmlns:a16="http://schemas.microsoft.com/office/drawing/2014/main" id="{BA82D97A-526A-49BB-B75A-D2A27F3B8A6E}"/>
               </a:ext>
             </a:extLst>
           </p:cNvPr>
@@ -11865,7 +12321,7 @@
           <p:cNvPr id="10" name="page">
             <a:extLst xmlns:a="http://schemas.openxmlformats.org/drawingml/2006/main">
               <a:ext uri="{FF2B5EF4-FFF2-40B4-BE49-F238E27FC236}">
-                <a16:creationId xmlns:a16="http://schemas.microsoft.com/office/drawing/2014/main" id="{E0F2CEED-1704-4101-A2AE-39DA385876AD}"/>
+                <a16:creationId xmlns:a16="http://schemas.microsoft.com/office/drawing/2014/main" id="{77F15C0B-FAF4-4CCB-B5D5-4CAD5B750C9A}"/>
               </a:ext>
             </a:extLst>
           </p:cNvPr>
@@ -11920,7 +12376,7 @@
     </p:spTree>
     <p:extLst>
       <p:ext uri="{BB962C8B-B14F-4D97-AF65-F5344CB8AC3E}">
-        <p14:creationId xmlns:p14="http://schemas.microsoft.com/office/powerpoint/2010/main" val="2133497494"/>
+        <p14:creationId xmlns:p14="http://schemas.microsoft.com/office/powerpoint/2010/main" val="1391455322"/>
       </p:ext>
     </p:extLst>
   </p:cSld>
@@ -13641,7 +14097,7 @@
           <p:cNvPr id="6" name="course">
             <a:extLst xmlns:a="http://schemas.openxmlformats.org/drawingml/2006/main">
               <a:ext uri="{FF2B5EF4-FFF2-40B4-BE49-F238E27FC236}">
-                <a16:creationId xmlns:a16="http://schemas.microsoft.com/office/drawing/2014/main" id="{928AA55C-DDA0-4139-88B7-6F95E763DE4A}"/>
+                <a16:creationId xmlns:a16="http://schemas.microsoft.com/office/drawing/2014/main" id="{EAC9901C-737A-4371-901B-965496ABC506}"/>
               </a:ext>
             </a:extLst>
           </p:cNvPr>
@@ -13698,7 +14154,7 @@
           <p:cNvPr id="2" name="title">
             <a:extLst xmlns:a="http://schemas.openxmlformats.org/drawingml/2006/main">
               <a:ext uri="{FF2B5EF4-FFF2-40B4-BE49-F238E27FC236}">
-                <a16:creationId xmlns:a16="http://schemas.microsoft.com/office/drawing/2014/main" id="{A59720AB-CD24-4C8D-AEA7-92F8D51EFC04}"/>
+                <a16:creationId xmlns:a16="http://schemas.microsoft.com/office/drawing/2014/main" id="{F8B102F6-6403-4E01-A578-C620C7A38CD6}"/>
               </a:ext>
             </a:extLst>
           </p:cNvPr>
@@ -13762,7 +14218,7 @@
         </p:xfrm>
         <a:graphic xmlns:a="http://schemas.openxmlformats.org/drawingml/2006/main">
           <a:graphicData uri="http://schemas.openxmlformats.org/drawingml/2006/chart">
-            <c:chart xmlns:r="http://schemas.openxmlformats.org/officeDocument/2006/relationships" xmlns:c="http://schemas.openxmlformats.org/drawingml/2006/chart" r:id="Rd44ab79741a7453d"/>
+            <c:chart xmlns:r="http://schemas.openxmlformats.org/officeDocument/2006/relationships" xmlns:c="http://schemas.openxmlformats.org/drawingml/2006/chart" r:id="Rdf1aafd4f5054147"/>
           </a:graphicData>
         </a:graphic>
       </p:graphicFrame>
@@ -13771,7 +14227,7 @@
           <p:cNvPr id="4" name="footnote">
             <a:extLst xmlns:a="http://schemas.openxmlformats.org/drawingml/2006/main">
               <a:ext uri="{FF2B5EF4-FFF2-40B4-BE49-F238E27FC236}">
-                <a16:creationId xmlns:a16="http://schemas.microsoft.com/office/drawing/2014/main" id="{81200E07-CE69-4EFF-936D-9221A35F4A3C}"/>
+                <a16:creationId xmlns:a16="http://schemas.microsoft.com/office/drawing/2014/main" id="{4E6D2EB0-9F55-4FC5-8C90-F0DE3D2A3124}"/>
               </a:ext>
             </a:extLst>
           </p:cNvPr>
@@ -13828,7 +14284,7 @@
           <p:cNvPr id="5" name="page">
             <a:extLst xmlns:a="http://schemas.openxmlformats.org/drawingml/2006/main">
               <a:ext uri="{FF2B5EF4-FFF2-40B4-BE49-F238E27FC236}">
-                <a16:creationId xmlns:a16="http://schemas.microsoft.com/office/drawing/2014/main" id="{D04119ED-736F-43CC-BF77-57E87D7B7715}"/>
+                <a16:creationId xmlns:a16="http://schemas.microsoft.com/office/drawing/2014/main" id="{011C7234-FC91-49B9-91F3-9268F9F70167}"/>
               </a:ext>
             </a:extLst>
           </p:cNvPr>
@@ -13883,7 +14339,7 @@
     </p:spTree>
     <p:extLst>
       <p:ext uri="{BB962C8B-B14F-4D97-AF65-F5344CB8AC3E}">
-        <p14:creationId xmlns:p14="http://schemas.microsoft.com/office/powerpoint/2010/main" val="507763883"/>
+        <p14:creationId xmlns:p14="http://schemas.microsoft.com/office/powerpoint/2010/main" val="1301399164"/>
       </p:ext>
     </p:extLst>
   </p:cSld>
@@ -13914,7 +14370,7 @@
           <p:cNvPr id="12" name="course">
             <a:extLst xmlns:a="http://schemas.openxmlformats.org/drawingml/2006/main">
               <a:ext uri="{FF2B5EF4-FFF2-40B4-BE49-F238E27FC236}">
-                <a16:creationId xmlns:a16="http://schemas.microsoft.com/office/drawing/2014/main" id="{8161CDFC-C716-4030-AA54-9FD8F0A463A1}"/>
+                <a16:creationId xmlns:a16="http://schemas.microsoft.com/office/drawing/2014/main" id="{3034A77C-1522-4AB5-B373-3081040BE0C1}"/>
               </a:ext>
             </a:extLst>
           </p:cNvPr>
@@ -13971,7 +14427,7 @@
           <p:cNvPr id="2" name="title">
             <a:extLst xmlns:a="http://schemas.openxmlformats.org/drawingml/2006/main">
               <a:ext uri="{FF2B5EF4-FFF2-40B4-BE49-F238E27FC236}">
-                <a16:creationId xmlns:a16="http://schemas.microsoft.com/office/drawing/2014/main" id="{DAB3CDFA-0738-425D-828C-E743A3568020}"/>
+                <a16:creationId xmlns:a16="http://schemas.microsoft.com/office/drawing/2014/main" id="{5638EFF2-C27C-4CD3-AD0D-CA8730E1FEE5}"/>
               </a:ext>
             </a:extLst>
           </p:cNvPr>
@@ -14028,7 +14484,7 @@
           <p:cNvPr id="3" name="body">
             <a:extLst xmlns:a="http://schemas.openxmlformats.org/drawingml/2006/main">
               <a:ext uri="{FF2B5EF4-FFF2-40B4-BE49-F238E27FC236}">
-                <a16:creationId xmlns:a16="http://schemas.microsoft.com/office/drawing/2014/main" id="{BD754908-6B7C-4A2C-9BA4-B6F16CB90A94}"/>
+                <a16:creationId xmlns:a16="http://schemas.microsoft.com/office/drawing/2014/main" id="{7A263DA6-4EF1-479D-9558-7DE12EC70E9D}"/>
               </a:ext>
             </a:extLst>
           </p:cNvPr>
@@ -14085,7 +14541,7 @@
           <p:cNvPr id="4" name="body">
             <a:extLst xmlns:a="http://schemas.openxmlformats.org/drawingml/2006/main">
               <a:ext uri="{FF2B5EF4-FFF2-40B4-BE49-F238E27FC236}">
-                <a16:creationId xmlns:a16="http://schemas.microsoft.com/office/drawing/2014/main" id="{8057F0A9-332C-49B6-92BC-69B2805554F8}"/>
+                <a16:creationId xmlns:a16="http://schemas.microsoft.com/office/drawing/2014/main" id="{DB9EED89-1EB6-4BBB-8EFC-82FCC8D99FBF}"/>
               </a:ext>
             </a:extLst>
           </p:cNvPr>
@@ -14142,7 +14598,7 @@
           <p:cNvPr id="5" name="body">
             <a:extLst xmlns:a="http://schemas.openxmlformats.org/drawingml/2006/main">
               <a:ext uri="{FF2B5EF4-FFF2-40B4-BE49-F238E27FC236}">
-                <a16:creationId xmlns:a16="http://schemas.microsoft.com/office/drawing/2014/main" id="{CAF0CB36-70C4-4D3A-B3CC-C56486164987}"/>
+                <a16:creationId xmlns:a16="http://schemas.microsoft.com/office/drawing/2014/main" id="{29E79087-7880-48EF-AFA4-9FC696DC2ED0}"/>
               </a:ext>
             </a:extLst>
           </p:cNvPr>
@@ -14199,7 +14655,7 @@
           <p:cNvPr id="6" name="body">
             <a:extLst xmlns:a="http://schemas.openxmlformats.org/drawingml/2006/main">
               <a:ext uri="{FF2B5EF4-FFF2-40B4-BE49-F238E27FC236}">
-                <a16:creationId xmlns:a16="http://schemas.microsoft.com/office/drawing/2014/main" id="{2DA43C52-2FCB-437F-9668-16551DE8447A}"/>
+                <a16:creationId xmlns:a16="http://schemas.microsoft.com/office/drawing/2014/main" id="{27486B7F-9F61-45F9-BFB5-6CED6CB10C3A}"/>
               </a:ext>
             </a:extLst>
           </p:cNvPr>
@@ -14256,7 +14712,7 @@
           <p:cNvPr id="7" name="body">
             <a:extLst xmlns:a="http://schemas.openxmlformats.org/drawingml/2006/main">
               <a:ext uri="{FF2B5EF4-FFF2-40B4-BE49-F238E27FC236}">
-                <a16:creationId xmlns:a16="http://schemas.microsoft.com/office/drawing/2014/main" id="{82732CA7-46E0-4131-AB42-5725A9383B71}"/>
+                <a16:creationId xmlns:a16="http://schemas.microsoft.com/office/drawing/2014/main" id="{7E664F1F-7A6C-45EF-9059-A32701060CFA}"/>
               </a:ext>
             </a:extLst>
           </p:cNvPr>
@@ -14313,7 +14769,7 @@
           <p:cNvPr id="8" name="body">
             <a:extLst xmlns:a="http://schemas.openxmlformats.org/drawingml/2006/main">
               <a:ext uri="{FF2B5EF4-FFF2-40B4-BE49-F238E27FC236}">
-                <a16:creationId xmlns:a16="http://schemas.microsoft.com/office/drawing/2014/main" id="{925587AF-B1C1-4049-8757-48DE351B5F51}"/>
+                <a16:creationId xmlns:a16="http://schemas.microsoft.com/office/drawing/2014/main" id="{F497CDC7-12BD-4412-A328-C24FB4AC4D17}"/>
               </a:ext>
             </a:extLst>
           </p:cNvPr>
@@ -14370,7 +14826,7 @@
           <p:cNvPr id="9" name="equation">
             <a:extLst xmlns:a="http://schemas.openxmlformats.org/drawingml/2006/main">
               <a:ext uri="{FF2B5EF4-FFF2-40B4-BE49-F238E27FC236}">
-                <a16:creationId xmlns:a16="http://schemas.microsoft.com/office/drawing/2014/main" id="{BB0D843C-60DB-498A-8222-352A571725A4}"/>
+                <a16:creationId xmlns:a16="http://schemas.microsoft.com/office/drawing/2014/main" id="{058B0CB9-E858-45E1-B450-EFE891ED1FCB}"/>
               </a:ext>
             </a:extLst>
           </p:cNvPr>
@@ -14427,7 +14883,7 @@
           <p:cNvPr id="10" name="footnote">
             <a:extLst xmlns:a="http://schemas.openxmlformats.org/drawingml/2006/main">
               <a:ext uri="{FF2B5EF4-FFF2-40B4-BE49-F238E27FC236}">
-                <a16:creationId xmlns:a16="http://schemas.microsoft.com/office/drawing/2014/main" id="{7816E62E-FE8E-4EF8-821A-25194CF9EFBE}"/>
+                <a16:creationId xmlns:a16="http://schemas.microsoft.com/office/drawing/2014/main" id="{68275D7C-1ADF-443D-A7BA-39E41F0E498D}"/>
               </a:ext>
             </a:extLst>
           </p:cNvPr>
@@ -14484,7 +14940,7 @@
           <p:cNvPr id="11" name="page">
             <a:extLst xmlns:a="http://schemas.openxmlformats.org/drawingml/2006/main">
               <a:ext uri="{FF2B5EF4-FFF2-40B4-BE49-F238E27FC236}">
-                <a16:creationId xmlns:a16="http://schemas.microsoft.com/office/drawing/2014/main" id="{27BA20E1-4D3E-4B3D-ACFF-2F2FC54C79AE}"/>
+                <a16:creationId xmlns:a16="http://schemas.microsoft.com/office/drawing/2014/main" id="{348AF63C-9B1D-40DC-9626-F949A058CADB}"/>
               </a:ext>
             </a:extLst>
           </p:cNvPr>
@@ -14539,7 +14995,7 @@
     </p:spTree>
     <p:extLst>
       <p:ext uri="{BB962C8B-B14F-4D97-AF65-F5344CB8AC3E}">
-        <p14:creationId xmlns:p14="http://schemas.microsoft.com/office/powerpoint/2010/main" val="575169669"/>
+        <p14:creationId xmlns:p14="http://schemas.microsoft.com/office/powerpoint/2010/main" val="204511526"/>
       </p:ext>
     </p:extLst>
   </p:cSld>
@@ -14570,7 +15026,7 @@
           <p:cNvPr id="12" name="course">
             <a:extLst xmlns:a="http://schemas.openxmlformats.org/drawingml/2006/main">
               <a:ext uri="{FF2B5EF4-FFF2-40B4-BE49-F238E27FC236}">
-                <a16:creationId xmlns:a16="http://schemas.microsoft.com/office/drawing/2014/main" id="{8BA42F86-4D3A-4816-ADA9-F907F28FD974}"/>
+                <a16:creationId xmlns:a16="http://schemas.microsoft.com/office/drawing/2014/main" id="{B75643FF-3E41-4352-99E1-4B4DF2FB54CB}"/>
               </a:ext>
             </a:extLst>
           </p:cNvPr>
@@ -14627,7 +15083,7 @@
           <p:cNvPr id="2" name="title">
             <a:extLst xmlns:a="http://schemas.openxmlformats.org/drawingml/2006/main">
               <a:ext uri="{FF2B5EF4-FFF2-40B4-BE49-F238E27FC236}">
-                <a16:creationId xmlns:a16="http://schemas.microsoft.com/office/drawing/2014/main" id="{53A1F7B3-4CB7-4BFF-B0A5-48DA94E118B1}"/>
+                <a16:creationId xmlns:a16="http://schemas.microsoft.com/office/drawing/2014/main" id="{9F33F461-A15A-401E-808A-9C0FF00C94FA}"/>
               </a:ext>
             </a:extLst>
           </p:cNvPr>
@@ -14684,7 +15140,7 @@
           <p:cNvPr id="3" name="body">
             <a:extLst xmlns:a="http://schemas.openxmlformats.org/drawingml/2006/main">
               <a:ext uri="{FF2B5EF4-FFF2-40B4-BE49-F238E27FC236}">
-                <a16:creationId xmlns:a16="http://schemas.microsoft.com/office/drawing/2014/main" id="{B0026F2F-E8A8-49A5-9520-F04CE0CB8431}"/>
+                <a16:creationId xmlns:a16="http://schemas.microsoft.com/office/drawing/2014/main" id="{C16A8D6C-4FA6-490A-9FED-97C467BA0A24}"/>
               </a:ext>
             </a:extLst>
           </p:cNvPr>
@@ -14741,7 +15197,7 @@
           <p:cNvPr id="4" name="body">
             <a:extLst xmlns:a="http://schemas.openxmlformats.org/drawingml/2006/main">
               <a:ext uri="{FF2B5EF4-FFF2-40B4-BE49-F238E27FC236}">
-                <a16:creationId xmlns:a16="http://schemas.microsoft.com/office/drawing/2014/main" id="{4DA5D039-7695-46E6-9C77-7C7AF704BF60}"/>
+                <a16:creationId xmlns:a16="http://schemas.microsoft.com/office/drawing/2014/main" id="{6301A96E-3261-41B5-9DDB-EC3791F421D4}"/>
               </a:ext>
             </a:extLst>
           </p:cNvPr>
@@ -14798,7 +15254,7 @@
           <p:cNvPr id="5" name="body">
             <a:extLst xmlns:a="http://schemas.openxmlformats.org/drawingml/2006/main">
               <a:ext uri="{FF2B5EF4-FFF2-40B4-BE49-F238E27FC236}">
-                <a16:creationId xmlns:a16="http://schemas.microsoft.com/office/drawing/2014/main" id="{6AB0C00D-B041-4405-9857-DC8BBD36F2C6}"/>
+                <a16:creationId xmlns:a16="http://schemas.microsoft.com/office/drawing/2014/main" id="{09DA70CF-4513-49FC-A51B-C7A2D6AFF97F}"/>
               </a:ext>
             </a:extLst>
           </p:cNvPr>
@@ -14855,7 +15311,7 @@
           <p:cNvPr id="6" name="body">
             <a:extLst xmlns:a="http://schemas.openxmlformats.org/drawingml/2006/main">
               <a:ext uri="{FF2B5EF4-FFF2-40B4-BE49-F238E27FC236}">
-                <a16:creationId xmlns:a16="http://schemas.microsoft.com/office/drawing/2014/main" id="{3643D2D6-BAC5-458E-AA70-9BE57BC8EFF2}"/>
+                <a16:creationId xmlns:a16="http://schemas.microsoft.com/office/drawing/2014/main" id="{EEC70B8E-1312-4549-879F-138F9D5ED4D8}"/>
               </a:ext>
             </a:extLst>
           </p:cNvPr>
@@ -14912,7 +15368,7 @@
           <p:cNvPr id="7" name="body">
             <a:extLst xmlns:a="http://schemas.openxmlformats.org/drawingml/2006/main">
               <a:ext uri="{FF2B5EF4-FFF2-40B4-BE49-F238E27FC236}">
-                <a16:creationId xmlns:a16="http://schemas.microsoft.com/office/drawing/2014/main" id="{7DFAD015-86EF-4C35-8CFA-0B60DE7742B8}"/>
+                <a16:creationId xmlns:a16="http://schemas.microsoft.com/office/drawing/2014/main" id="{DB0CDE79-625C-4D18-801B-0AC521DE54A8}"/>
               </a:ext>
             </a:extLst>
           </p:cNvPr>
@@ -14969,7 +15425,7 @@
           <p:cNvPr id="8" name="body">
             <a:extLst xmlns:a="http://schemas.openxmlformats.org/drawingml/2006/main">
               <a:ext uri="{FF2B5EF4-FFF2-40B4-BE49-F238E27FC236}">
-                <a16:creationId xmlns:a16="http://schemas.microsoft.com/office/drawing/2014/main" id="{2CDCA17F-516A-4579-A554-1E53F3FAC535}"/>
+                <a16:creationId xmlns:a16="http://schemas.microsoft.com/office/drawing/2014/main" id="{5DFB80BC-4B90-4379-89CA-242919719498}"/>
               </a:ext>
             </a:extLst>
           </p:cNvPr>
@@ -15026,7 +15482,7 @@
           <p:cNvPr id="9" name="equation">
             <a:extLst xmlns:a="http://schemas.openxmlformats.org/drawingml/2006/main">
               <a:ext uri="{FF2B5EF4-FFF2-40B4-BE49-F238E27FC236}">
-                <a16:creationId xmlns:a16="http://schemas.microsoft.com/office/drawing/2014/main" id="{B9E5EEAD-855B-46E6-AD0A-6316FE87C6AD}"/>
+                <a16:creationId xmlns:a16="http://schemas.microsoft.com/office/drawing/2014/main" id="{47D24B42-0059-4AEC-9F24-757F46232CD1}"/>
               </a:ext>
             </a:extLst>
           </p:cNvPr>
@@ -15083,7 +15539,7 @@
           <p:cNvPr id="10" name="footnote">
             <a:extLst xmlns:a="http://schemas.openxmlformats.org/drawingml/2006/main">
               <a:ext uri="{FF2B5EF4-FFF2-40B4-BE49-F238E27FC236}">
-                <a16:creationId xmlns:a16="http://schemas.microsoft.com/office/drawing/2014/main" id="{7F9FAA2E-2184-42B1-9144-53D1A2FD34DC}"/>
+                <a16:creationId xmlns:a16="http://schemas.microsoft.com/office/drawing/2014/main" id="{BE37EEA3-1A6C-4548-A137-97B40F3FDC7B}"/>
               </a:ext>
             </a:extLst>
           </p:cNvPr>
@@ -15140,7 +15596,7 @@
           <p:cNvPr id="11" name="page">
             <a:extLst xmlns:a="http://schemas.openxmlformats.org/drawingml/2006/main">
               <a:ext uri="{FF2B5EF4-FFF2-40B4-BE49-F238E27FC236}">
-                <a16:creationId xmlns:a16="http://schemas.microsoft.com/office/drawing/2014/main" id="{13C65843-E0C5-4604-AA6D-A317248C7BCC}"/>
+                <a16:creationId xmlns:a16="http://schemas.microsoft.com/office/drawing/2014/main" id="{B2738B21-BAC4-4E46-AE6F-18D1C8E41EC6}"/>
               </a:ext>
             </a:extLst>
           </p:cNvPr>
@@ -15195,7 +15651,7 @@
     </p:spTree>
     <p:extLst>
       <p:ext uri="{BB962C8B-B14F-4D97-AF65-F5344CB8AC3E}">
-        <p14:creationId xmlns:p14="http://schemas.microsoft.com/office/powerpoint/2010/main" val="2009308054"/>
+        <p14:creationId xmlns:p14="http://schemas.microsoft.com/office/powerpoint/2010/main" val="1626695489"/>
       </p:ext>
     </p:extLst>
   </p:cSld>
@@ -15226,7 +15682,7 @@
           <p:cNvPr id="11" name="course">
             <a:extLst xmlns:a="http://schemas.openxmlformats.org/drawingml/2006/main">
               <a:ext uri="{FF2B5EF4-FFF2-40B4-BE49-F238E27FC236}">
-                <a16:creationId xmlns:a16="http://schemas.microsoft.com/office/drawing/2014/main" id="{BC701787-CC0D-4EAC-887D-47BDFB40B086}"/>
+                <a16:creationId xmlns:a16="http://schemas.microsoft.com/office/drawing/2014/main" id="{A9DE745B-03D9-4E60-9594-5A2609083F0A}"/>
               </a:ext>
             </a:extLst>
           </p:cNvPr>
@@ -15283,7 +15739,7 @@
           <p:cNvPr id="2" name="title">
             <a:extLst xmlns:a="http://schemas.openxmlformats.org/drawingml/2006/main">
               <a:ext uri="{FF2B5EF4-FFF2-40B4-BE49-F238E27FC236}">
-                <a16:creationId xmlns:a16="http://schemas.microsoft.com/office/drawing/2014/main" id="{3111ECCA-1301-4C34-9016-E9428B3E3B38}"/>
+                <a16:creationId xmlns:a16="http://schemas.microsoft.com/office/drawing/2014/main" id="{92024096-D792-4EF7-99CE-E8E6FDF6398C}"/>
               </a:ext>
             </a:extLst>
           </p:cNvPr>
@@ -15340,7 +15796,7 @@
           <p:cNvPr id="3" name="body">
             <a:extLst xmlns:a="http://schemas.openxmlformats.org/drawingml/2006/main">
               <a:ext uri="{FF2B5EF4-FFF2-40B4-BE49-F238E27FC236}">
-                <a16:creationId xmlns:a16="http://schemas.microsoft.com/office/drawing/2014/main" id="{C0EC493B-815B-4273-B74C-F63ED7FF38E4}"/>
+                <a16:creationId xmlns:a16="http://schemas.microsoft.com/office/drawing/2014/main" id="{52BBEBD1-C491-4F2A-A4D8-FB9C913F044D}"/>
               </a:ext>
             </a:extLst>
           </p:cNvPr>
@@ -15397,7 +15853,7 @@
           <p:cNvPr id="4" name="body">
             <a:extLst xmlns:a="http://schemas.openxmlformats.org/drawingml/2006/main">
               <a:ext uri="{FF2B5EF4-FFF2-40B4-BE49-F238E27FC236}">
-                <a16:creationId xmlns:a16="http://schemas.microsoft.com/office/drawing/2014/main" id="{2C6CE307-D160-4A8D-8F0E-7E8FF218D79B}"/>
+                <a16:creationId xmlns:a16="http://schemas.microsoft.com/office/drawing/2014/main" id="{0C6AB341-5D30-4024-A811-DAD0527CCC97}"/>
               </a:ext>
             </a:extLst>
           </p:cNvPr>
@@ -15454,7 +15910,7 @@
           <p:cNvPr id="5" name="body">
             <a:extLst xmlns:a="http://schemas.openxmlformats.org/drawingml/2006/main">
               <a:ext uri="{FF2B5EF4-FFF2-40B4-BE49-F238E27FC236}">
-                <a16:creationId xmlns:a16="http://schemas.microsoft.com/office/drawing/2014/main" id="{17F87952-E582-4343-9A6A-8B7241BF84B1}"/>
+                <a16:creationId xmlns:a16="http://schemas.microsoft.com/office/drawing/2014/main" id="{63ECE79E-9805-4809-9364-C6D3EB48AE2F}"/>
               </a:ext>
             </a:extLst>
           </p:cNvPr>
@@ -15511,7 +15967,7 @@
           <p:cNvPr id="6" name="body">
             <a:extLst xmlns:a="http://schemas.openxmlformats.org/drawingml/2006/main">
               <a:ext uri="{FF2B5EF4-FFF2-40B4-BE49-F238E27FC236}">
-                <a16:creationId xmlns:a16="http://schemas.microsoft.com/office/drawing/2014/main" id="{FABCF74C-9A94-4F4B-93A3-F91819F7F1C6}"/>
+                <a16:creationId xmlns:a16="http://schemas.microsoft.com/office/drawing/2014/main" id="{2393E457-71CB-4CE5-9403-E51BA0B3F31E}"/>
               </a:ext>
             </a:extLst>
           </p:cNvPr>
@@ -15568,7 +16024,7 @@
           <p:cNvPr id="7" name="body">
             <a:extLst xmlns:a="http://schemas.openxmlformats.org/drawingml/2006/main">
               <a:ext uri="{FF2B5EF4-FFF2-40B4-BE49-F238E27FC236}">
-                <a16:creationId xmlns:a16="http://schemas.microsoft.com/office/drawing/2014/main" id="{8E0DEF2E-D79E-4534-A316-5A7F408CF1F9}"/>
+                <a16:creationId xmlns:a16="http://schemas.microsoft.com/office/drawing/2014/main" id="{DF0FEB3A-79A2-4329-A171-1C4BCDAA79E4}"/>
               </a:ext>
             </a:extLst>
           </p:cNvPr>
@@ -15625,7 +16081,7 @@
           <p:cNvPr id="8" name="body">
             <a:extLst xmlns:a="http://schemas.openxmlformats.org/drawingml/2006/main">
               <a:ext uri="{FF2B5EF4-FFF2-40B4-BE49-F238E27FC236}">
-                <a16:creationId xmlns:a16="http://schemas.microsoft.com/office/drawing/2014/main" id="{B345F1C1-6659-49DE-B23E-8E51353C071F}"/>
+                <a16:creationId xmlns:a16="http://schemas.microsoft.com/office/drawing/2014/main" id="{E6AD65C7-0259-4760-88D0-BC5DBBA4369D}"/>
               </a:ext>
             </a:extLst>
           </p:cNvPr>
@@ -15682,7 +16138,7 @@
           <p:cNvPr id="9" name="footnote">
             <a:extLst xmlns:a="http://schemas.openxmlformats.org/drawingml/2006/main">
               <a:ext uri="{FF2B5EF4-FFF2-40B4-BE49-F238E27FC236}">
-                <a16:creationId xmlns:a16="http://schemas.microsoft.com/office/drawing/2014/main" id="{C4FC35C3-6B68-44B1-ACF2-47DD8ECE52FF}"/>
+                <a16:creationId xmlns:a16="http://schemas.microsoft.com/office/drawing/2014/main" id="{9F9FC949-9DD1-4BFC-9DBE-585D37E5855E}"/>
               </a:ext>
             </a:extLst>
           </p:cNvPr>
@@ -15739,7 +16195,7 @@
           <p:cNvPr id="10" name="page">
             <a:extLst xmlns:a="http://schemas.openxmlformats.org/drawingml/2006/main">
               <a:ext uri="{FF2B5EF4-FFF2-40B4-BE49-F238E27FC236}">
-                <a16:creationId xmlns:a16="http://schemas.microsoft.com/office/drawing/2014/main" id="{94590A8C-A9B1-4617-8879-47BF87555253}"/>
+                <a16:creationId xmlns:a16="http://schemas.microsoft.com/office/drawing/2014/main" id="{6C2F0526-B520-4953-A520-B4DC3ED4910C}"/>
               </a:ext>
             </a:extLst>
           </p:cNvPr>
@@ -15794,7 +16250,7 @@
     </p:spTree>
     <p:extLst>
       <p:ext uri="{BB962C8B-B14F-4D97-AF65-F5344CB8AC3E}">
-        <p14:creationId xmlns:p14="http://schemas.microsoft.com/office/powerpoint/2010/main" val="1853405047"/>
+        <p14:creationId xmlns:p14="http://schemas.microsoft.com/office/powerpoint/2010/main" val="2032576298"/>
       </p:ext>
     </p:extLst>
   </p:cSld>
@@ -15825,7 +16281,7 @@
           <p:cNvPr id="10" name="course">
             <a:extLst xmlns:a="http://schemas.openxmlformats.org/drawingml/2006/main">
               <a:ext uri="{FF2B5EF4-FFF2-40B4-BE49-F238E27FC236}">
-                <a16:creationId xmlns:a16="http://schemas.microsoft.com/office/drawing/2014/main" id="{AA8E719D-7AC6-41CF-B638-1BDF841054CD}"/>
+                <a16:creationId xmlns:a16="http://schemas.microsoft.com/office/drawing/2014/main" id="{00193082-3B19-42BF-8029-A0D1381BD9B4}"/>
               </a:ext>
             </a:extLst>
           </p:cNvPr>
@@ -15882,7 +16338,7 @@
           <p:cNvPr id="2" name="title">
             <a:extLst xmlns:a="http://schemas.openxmlformats.org/drawingml/2006/main">
               <a:ext uri="{FF2B5EF4-FFF2-40B4-BE49-F238E27FC236}">
-                <a16:creationId xmlns:a16="http://schemas.microsoft.com/office/drawing/2014/main" id="{AB0D41A8-5807-47DC-BCAF-D3DEF18CEC24}"/>
+                <a16:creationId xmlns:a16="http://schemas.microsoft.com/office/drawing/2014/main" id="{154E272B-67F4-4C77-9119-8AC27C163731}"/>
               </a:ext>
             </a:extLst>
           </p:cNvPr>
@@ -15939,7 +16395,7 @@
           <p:cNvPr id="3" name="body">
             <a:extLst xmlns:a="http://schemas.openxmlformats.org/drawingml/2006/main">
               <a:ext uri="{FF2B5EF4-FFF2-40B4-BE49-F238E27FC236}">
-                <a16:creationId xmlns:a16="http://schemas.microsoft.com/office/drawing/2014/main" id="{66EBF546-B89C-402D-AE24-48EC891C3E1A}"/>
+                <a16:creationId xmlns:a16="http://schemas.microsoft.com/office/drawing/2014/main" id="{63DCEE5A-A065-4A75-BA1E-86A2686CDA8F}"/>
               </a:ext>
             </a:extLst>
           </p:cNvPr>
@@ -15996,7 +16452,7 @@
           <p:cNvPr id="4" name="body">
             <a:extLst xmlns:a="http://schemas.openxmlformats.org/drawingml/2006/main">
               <a:ext uri="{FF2B5EF4-FFF2-40B4-BE49-F238E27FC236}">
-                <a16:creationId xmlns:a16="http://schemas.microsoft.com/office/drawing/2014/main" id="{6613CB27-2C1B-4A0F-959C-2691CB02C83E}"/>
+                <a16:creationId xmlns:a16="http://schemas.microsoft.com/office/drawing/2014/main" id="{CFDD06D8-47EA-4D36-919C-BCDBA1FDF4E6}"/>
               </a:ext>
             </a:extLst>
           </p:cNvPr>
@@ -16053,7 +16509,7 @@
           <p:cNvPr id="5" name="body">
             <a:extLst xmlns:a="http://schemas.openxmlformats.org/drawingml/2006/main">
               <a:ext uri="{FF2B5EF4-FFF2-40B4-BE49-F238E27FC236}">
-                <a16:creationId xmlns:a16="http://schemas.microsoft.com/office/drawing/2014/main" id="{EAA2AF10-E54F-4045-9553-04C86AD68817}"/>
+                <a16:creationId xmlns:a16="http://schemas.microsoft.com/office/drawing/2014/main" id="{E4894FA3-0E6D-4419-951E-A239B3675710}"/>
               </a:ext>
             </a:extLst>
           </p:cNvPr>
@@ -16110,7 +16566,7 @@
           <p:cNvPr id="6" name="body">
             <a:extLst xmlns:a="http://schemas.openxmlformats.org/drawingml/2006/main">
               <a:ext uri="{FF2B5EF4-FFF2-40B4-BE49-F238E27FC236}">
-                <a16:creationId xmlns:a16="http://schemas.microsoft.com/office/drawing/2014/main" id="{5FE8EF9D-EEBE-4E2B-B1E8-A1B04B6B850A}"/>
+                <a16:creationId xmlns:a16="http://schemas.microsoft.com/office/drawing/2014/main" id="{85DE8128-8041-4E3F-A444-890F1EC01276}"/>
               </a:ext>
             </a:extLst>
           </p:cNvPr>
@@ -16167,7 +16623,7 @@
           <p:cNvPr id="7" name="body">
             <a:extLst xmlns:a="http://schemas.openxmlformats.org/drawingml/2006/main">
               <a:ext uri="{FF2B5EF4-FFF2-40B4-BE49-F238E27FC236}">
-                <a16:creationId xmlns:a16="http://schemas.microsoft.com/office/drawing/2014/main" id="{396206A4-45EB-4596-B450-27F206308BD8}"/>
+                <a16:creationId xmlns:a16="http://schemas.microsoft.com/office/drawing/2014/main" id="{5F58AA28-313A-4E99-819B-EE461CC2C839}"/>
               </a:ext>
             </a:extLst>
           </p:cNvPr>
@@ -16224,7 +16680,7 @@
           <p:cNvPr id="8" name="body">
             <a:extLst xmlns:a="http://schemas.openxmlformats.org/drawingml/2006/main">
               <a:ext uri="{FF2B5EF4-FFF2-40B4-BE49-F238E27FC236}">
-                <a16:creationId xmlns:a16="http://schemas.microsoft.com/office/drawing/2014/main" id="{DB64AB36-F235-4538-8D47-A170ED45DB7A}"/>
+                <a16:creationId xmlns:a16="http://schemas.microsoft.com/office/drawing/2014/main" id="{EA8B9BC8-7D8F-41BB-A036-A924958E3293}"/>
               </a:ext>
             </a:extLst>
           </p:cNvPr>
@@ -16281,7 +16737,7 @@
           <p:cNvPr id="9" name="page">
             <a:extLst xmlns:a="http://schemas.openxmlformats.org/drawingml/2006/main">
               <a:ext uri="{FF2B5EF4-FFF2-40B4-BE49-F238E27FC236}">
-                <a16:creationId xmlns:a16="http://schemas.microsoft.com/office/drawing/2014/main" id="{73AA4A37-E722-4C6F-B94C-971A278CEF89}"/>
+                <a16:creationId xmlns:a16="http://schemas.microsoft.com/office/drawing/2014/main" id="{257B5272-56F4-47CA-B3C0-C87B30DFBA96}"/>
               </a:ext>
             </a:extLst>
           </p:cNvPr>
@@ -16336,7 +16792,7 @@
     </p:spTree>
     <p:extLst>
       <p:ext uri="{BB962C8B-B14F-4D97-AF65-F5344CB8AC3E}">
-        <p14:creationId xmlns:p14="http://schemas.microsoft.com/office/powerpoint/2010/main" val="900194391"/>
+        <p14:creationId xmlns:p14="http://schemas.microsoft.com/office/powerpoint/2010/main" val="53381173"/>
       </p:ext>
     </p:extLst>
   </p:cSld>
@@ -16367,7 +16823,7 @@
           <p:cNvPr id="11" name="course">
             <a:extLst xmlns:a="http://schemas.openxmlformats.org/drawingml/2006/main">
               <a:ext uri="{FF2B5EF4-FFF2-40B4-BE49-F238E27FC236}">
-                <a16:creationId xmlns:a16="http://schemas.microsoft.com/office/drawing/2014/main" id="{5D892F7B-5918-4FB0-B01A-10E211FC4330}"/>
+                <a16:creationId xmlns:a16="http://schemas.microsoft.com/office/drawing/2014/main" id="{AA3B95AC-A342-4EAA-B0D6-DE84891C7D16}"/>
               </a:ext>
             </a:extLst>
           </p:cNvPr>
@@ -16424,7 +16880,7 @@
           <p:cNvPr id="2" name="title">
             <a:extLst xmlns:a="http://schemas.openxmlformats.org/drawingml/2006/main">
               <a:ext uri="{FF2B5EF4-FFF2-40B4-BE49-F238E27FC236}">
-                <a16:creationId xmlns:a16="http://schemas.microsoft.com/office/drawing/2014/main" id="{4F4C846A-E74D-441F-B8A9-226ECE2094FC}"/>
+                <a16:creationId xmlns:a16="http://schemas.microsoft.com/office/drawing/2014/main" id="{47105D95-E60A-4672-A0C4-A8B95A045F19}"/>
               </a:ext>
             </a:extLst>
           </p:cNvPr>
@@ -16481,7 +16937,7 @@
           <p:cNvPr id="3" name="body">
             <a:extLst xmlns:a="http://schemas.openxmlformats.org/drawingml/2006/main">
               <a:ext uri="{FF2B5EF4-FFF2-40B4-BE49-F238E27FC236}">
-                <a16:creationId xmlns:a16="http://schemas.microsoft.com/office/drawing/2014/main" id="{CF368F3F-BAE7-4459-9F76-4DEE68C50A58}"/>
+                <a16:creationId xmlns:a16="http://schemas.microsoft.com/office/drawing/2014/main" id="{61911CB0-ECBA-43F6-8723-3F1E29AB1CDF}"/>
               </a:ext>
             </a:extLst>
           </p:cNvPr>
@@ -16538,7 +16994,7 @@
           <p:cNvPr id="4" name="body">
             <a:extLst xmlns:a="http://schemas.openxmlformats.org/drawingml/2006/main">
               <a:ext uri="{FF2B5EF4-FFF2-40B4-BE49-F238E27FC236}">
-                <a16:creationId xmlns:a16="http://schemas.microsoft.com/office/drawing/2014/main" id="{2C5132DB-F17D-404E-8655-CD53BDD51CA1}"/>
+                <a16:creationId xmlns:a16="http://schemas.microsoft.com/office/drawing/2014/main" id="{C8963530-8509-4C76-9947-856B0913E875}"/>
               </a:ext>
             </a:extLst>
           </p:cNvPr>
@@ -16595,7 +17051,7 @@
           <p:cNvPr id="5" name="body">
             <a:extLst xmlns:a="http://schemas.openxmlformats.org/drawingml/2006/main">
               <a:ext uri="{FF2B5EF4-FFF2-40B4-BE49-F238E27FC236}">
-                <a16:creationId xmlns:a16="http://schemas.microsoft.com/office/drawing/2014/main" id="{169D80F6-95A2-4115-B352-D817974032D5}"/>
+                <a16:creationId xmlns:a16="http://schemas.microsoft.com/office/drawing/2014/main" id="{A06C4914-E851-4687-8725-EEA532DCB156}"/>
               </a:ext>
             </a:extLst>
           </p:cNvPr>
@@ -16652,7 +17108,7 @@
           <p:cNvPr id="6" name="body">
             <a:extLst xmlns:a="http://schemas.openxmlformats.org/drawingml/2006/main">
               <a:ext uri="{FF2B5EF4-FFF2-40B4-BE49-F238E27FC236}">
-                <a16:creationId xmlns:a16="http://schemas.microsoft.com/office/drawing/2014/main" id="{448667F7-A2C6-4B75-AC5A-FF15CC0C5498}"/>
+                <a16:creationId xmlns:a16="http://schemas.microsoft.com/office/drawing/2014/main" id="{698A3082-C54A-4F43-A075-88A24087F5B8}"/>
               </a:ext>
             </a:extLst>
           </p:cNvPr>
@@ -16709,7 +17165,7 @@
           <p:cNvPr id="7" name="body">
             <a:extLst xmlns:a="http://schemas.openxmlformats.org/drawingml/2006/main">
               <a:ext uri="{FF2B5EF4-FFF2-40B4-BE49-F238E27FC236}">
-                <a16:creationId xmlns:a16="http://schemas.microsoft.com/office/drawing/2014/main" id="{B4708B7E-AC3B-4787-8743-4FD641F77177}"/>
+                <a16:creationId xmlns:a16="http://schemas.microsoft.com/office/drawing/2014/main" id="{F46A75A3-DB70-4E46-9EDC-9EECCD8A9CE4}"/>
               </a:ext>
             </a:extLst>
           </p:cNvPr>
@@ -16766,7 +17222,7 @@
           <p:cNvPr id="8" name="body">
             <a:extLst xmlns:a="http://schemas.openxmlformats.org/drawingml/2006/main">
               <a:ext uri="{FF2B5EF4-FFF2-40B4-BE49-F238E27FC236}">
-                <a16:creationId xmlns:a16="http://schemas.microsoft.com/office/drawing/2014/main" id="{3D6C4009-58DA-4FA5-8EF9-69DD18E4BC49}"/>
+                <a16:creationId xmlns:a16="http://schemas.microsoft.com/office/drawing/2014/main" id="{A024A27E-0875-4ECA-94BB-D8F90AD5E7D9}"/>
               </a:ext>
             </a:extLst>
           </p:cNvPr>
@@ -16823,7 +17279,7 @@
           <p:cNvPr id="9" name="footnote">
             <a:extLst xmlns:a="http://schemas.openxmlformats.org/drawingml/2006/main">
               <a:ext uri="{FF2B5EF4-FFF2-40B4-BE49-F238E27FC236}">
-                <a16:creationId xmlns:a16="http://schemas.microsoft.com/office/drawing/2014/main" id="{6443BD48-0949-46E8-A0FE-AA61987C191E}"/>
+                <a16:creationId xmlns:a16="http://schemas.microsoft.com/office/drawing/2014/main" id="{DE202BBB-8866-478B-927B-AB78BC840910}"/>
               </a:ext>
             </a:extLst>
           </p:cNvPr>
@@ -16880,7 +17336,7 @@
           <p:cNvPr id="10" name="page">
             <a:extLst xmlns:a="http://schemas.openxmlformats.org/drawingml/2006/main">
               <a:ext uri="{FF2B5EF4-FFF2-40B4-BE49-F238E27FC236}">
-                <a16:creationId xmlns:a16="http://schemas.microsoft.com/office/drawing/2014/main" id="{5B16E0C4-661C-4A0F-ADDF-0D0D6F1AD033}"/>
+                <a16:creationId xmlns:a16="http://schemas.microsoft.com/office/drawing/2014/main" id="{41CBB80E-0039-4A43-8AF1-20C8E3CED2CD}"/>
               </a:ext>
             </a:extLst>
           </p:cNvPr>
@@ -16935,7 +17391,7 @@
     </p:spTree>
     <p:extLst>
       <p:ext uri="{BB962C8B-B14F-4D97-AF65-F5344CB8AC3E}">
-        <p14:creationId xmlns:p14="http://schemas.microsoft.com/office/powerpoint/2010/main" val="475711544"/>
+        <p14:creationId xmlns:p14="http://schemas.microsoft.com/office/powerpoint/2010/main" val="424248473"/>
       </p:ext>
     </p:extLst>
   </p:cSld>
@@ -16966,7 +17422,7 @@
           <p:cNvPr id="6" name="course">
             <a:extLst xmlns:a="http://schemas.openxmlformats.org/drawingml/2006/main">
               <a:ext uri="{FF2B5EF4-FFF2-40B4-BE49-F238E27FC236}">
-                <a16:creationId xmlns:a16="http://schemas.microsoft.com/office/drawing/2014/main" id="{423BC952-D9A9-4F04-8F80-493D618AD7D6}"/>
+                <a16:creationId xmlns:a16="http://schemas.microsoft.com/office/drawing/2014/main" id="{513512FC-1523-43DA-8B2F-E0999E60C43E}"/>
               </a:ext>
             </a:extLst>
           </p:cNvPr>
@@ -17023,7 +17479,7 @@
           <p:cNvPr id="2" name="title">
             <a:extLst xmlns:a="http://schemas.openxmlformats.org/drawingml/2006/main">
               <a:ext uri="{FF2B5EF4-FFF2-40B4-BE49-F238E27FC236}">
-                <a16:creationId xmlns:a16="http://schemas.microsoft.com/office/drawing/2014/main" id="{2A2DDBFB-D6B1-40E7-BD29-4497DC8019CC}"/>
+                <a16:creationId xmlns:a16="http://schemas.microsoft.com/office/drawing/2014/main" id="{6FD9D1E8-C058-4626-A52A-2D73CB447BB7}"/>
               </a:ext>
             </a:extLst>
           </p:cNvPr>
@@ -17402,7 +17858,7 @@
           <p:cNvPr id="4" name="footnote">
             <a:extLst xmlns:a="http://schemas.openxmlformats.org/drawingml/2006/main">
               <a:ext uri="{FF2B5EF4-FFF2-40B4-BE49-F238E27FC236}">
-                <a16:creationId xmlns:a16="http://schemas.microsoft.com/office/drawing/2014/main" id="{9E386E99-AB64-4662-A4CD-D7345F39F786}"/>
+                <a16:creationId xmlns:a16="http://schemas.microsoft.com/office/drawing/2014/main" id="{B78918F3-765B-4786-8809-A51D18882A7F}"/>
               </a:ext>
             </a:extLst>
           </p:cNvPr>
@@ -17459,7 +17915,7 @@
           <p:cNvPr id="5" name="page">
             <a:extLst xmlns:a="http://schemas.openxmlformats.org/drawingml/2006/main">
               <a:ext uri="{FF2B5EF4-FFF2-40B4-BE49-F238E27FC236}">
-                <a16:creationId xmlns:a16="http://schemas.microsoft.com/office/drawing/2014/main" id="{51D408FC-2E33-4980-8618-6EBCFAC84AA9}"/>
+                <a16:creationId xmlns:a16="http://schemas.microsoft.com/office/drawing/2014/main" id="{71C3BA34-751F-4B7B-9D45-8D8AD5ACBF10}"/>
               </a:ext>
             </a:extLst>
           </p:cNvPr>
@@ -17514,7 +17970,7 @@
     </p:spTree>
     <p:extLst>
       <p:ext uri="{BB962C8B-B14F-4D97-AF65-F5344CB8AC3E}">
-        <p14:creationId xmlns:p14="http://schemas.microsoft.com/office/powerpoint/2010/main" val="1569864292"/>
+        <p14:creationId xmlns:p14="http://schemas.microsoft.com/office/powerpoint/2010/main" val="1561702835"/>
       </p:ext>
     </p:extLst>
   </p:cSld>
@@ -18383,7 +18839,7 @@
           <p:cNvPr id="11" name="course">
             <a:extLst xmlns:a="http://schemas.openxmlformats.org/drawingml/2006/main">
               <a:ext uri="{FF2B5EF4-FFF2-40B4-BE49-F238E27FC236}">
-                <a16:creationId xmlns:a16="http://schemas.microsoft.com/office/drawing/2014/main" id="{D50FC024-0EA1-4A4B-98EA-E30281F9C782}"/>
+                <a16:creationId xmlns:a16="http://schemas.microsoft.com/office/drawing/2014/main" id="{EB9CD549-CAA8-439C-949D-5F3E72FD2652}"/>
               </a:ext>
             </a:extLst>
           </p:cNvPr>
@@ -18440,7 +18896,7 @@
           <p:cNvPr id="2" name="title">
             <a:extLst xmlns:a="http://schemas.openxmlformats.org/drawingml/2006/main">
               <a:ext uri="{FF2B5EF4-FFF2-40B4-BE49-F238E27FC236}">
-                <a16:creationId xmlns:a16="http://schemas.microsoft.com/office/drawing/2014/main" id="{62CBEED0-1FCE-4164-A534-5B841BB1E29C}"/>
+                <a16:creationId xmlns:a16="http://schemas.microsoft.com/office/drawing/2014/main" id="{84FF884A-AF33-4228-AB84-11CCBF1A9324}"/>
               </a:ext>
             </a:extLst>
           </p:cNvPr>
@@ -18497,7 +18953,7 @@
           <p:cNvPr id="3" name="body">
             <a:extLst xmlns:a="http://schemas.openxmlformats.org/drawingml/2006/main">
               <a:ext uri="{FF2B5EF4-FFF2-40B4-BE49-F238E27FC236}">
-                <a16:creationId xmlns:a16="http://schemas.microsoft.com/office/drawing/2014/main" id="{D5E0B1E1-D653-4130-854C-DF64D84B4A38}"/>
+                <a16:creationId xmlns:a16="http://schemas.microsoft.com/office/drawing/2014/main" id="{5DA93EDA-027B-4E8A-A013-C2F9F3A40B63}"/>
               </a:ext>
             </a:extLst>
           </p:cNvPr>
@@ -18554,7 +19010,7 @@
           <p:cNvPr id="4" name="body">
             <a:extLst xmlns:a="http://schemas.openxmlformats.org/drawingml/2006/main">
               <a:ext uri="{FF2B5EF4-FFF2-40B4-BE49-F238E27FC236}">
-                <a16:creationId xmlns:a16="http://schemas.microsoft.com/office/drawing/2014/main" id="{F46653E9-EB29-46C2-8D22-FF172D7B0FB5}"/>
+                <a16:creationId xmlns:a16="http://schemas.microsoft.com/office/drawing/2014/main" id="{013D1DF0-9E3D-4CD8-9A58-71AC2189B9F0}"/>
               </a:ext>
             </a:extLst>
           </p:cNvPr>
@@ -18611,7 +19067,7 @@
           <p:cNvPr id="5" name="body">
             <a:extLst xmlns:a="http://schemas.openxmlformats.org/drawingml/2006/main">
               <a:ext uri="{FF2B5EF4-FFF2-40B4-BE49-F238E27FC236}">
-                <a16:creationId xmlns:a16="http://schemas.microsoft.com/office/drawing/2014/main" id="{911E06E7-6521-4B1E-ADA5-60233400CF43}"/>
+                <a16:creationId xmlns:a16="http://schemas.microsoft.com/office/drawing/2014/main" id="{4143D484-C41E-40D1-B484-136B5F48C37E}"/>
               </a:ext>
             </a:extLst>
           </p:cNvPr>
@@ -18668,7 +19124,7 @@
           <p:cNvPr id="6" name="body">
             <a:extLst xmlns:a="http://schemas.openxmlformats.org/drawingml/2006/main">
               <a:ext uri="{FF2B5EF4-FFF2-40B4-BE49-F238E27FC236}">
-                <a16:creationId xmlns:a16="http://schemas.microsoft.com/office/drawing/2014/main" id="{7D89BD11-BF87-493E-9893-B1FCE671517B}"/>
+                <a16:creationId xmlns:a16="http://schemas.microsoft.com/office/drawing/2014/main" id="{A01BDDFB-1FBF-471C-95BE-51B56D9319B1}"/>
               </a:ext>
             </a:extLst>
           </p:cNvPr>
@@ -18725,7 +19181,7 @@
           <p:cNvPr id="7" name="body">
             <a:extLst xmlns:a="http://schemas.openxmlformats.org/drawingml/2006/main">
               <a:ext uri="{FF2B5EF4-FFF2-40B4-BE49-F238E27FC236}">
-                <a16:creationId xmlns:a16="http://schemas.microsoft.com/office/drawing/2014/main" id="{E6B13EC8-850E-4358-804B-8BDE48977D15}"/>
+                <a16:creationId xmlns:a16="http://schemas.microsoft.com/office/drawing/2014/main" id="{416B5FB3-91AC-42B2-AE2A-0899EC46345D}"/>
               </a:ext>
             </a:extLst>
           </p:cNvPr>
@@ -18782,7 +19238,7 @@
           <p:cNvPr id="8" name="body">
             <a:extLst xmlns:a="http://schemas.openxmlformats.org/drawingml/2006/main">
               <a:ext uri="{FF2B5EF4-FFF2-40B4-BE49-F238E27FC236}">
-                <a16:creationId xmlns:a16="http://schemas.microsoft.com/office/drawing/2014/main" id="{3AF7DE9E-E55B-40E7-9F9D-121D4732DFC2}"/>
+                <a16:creationId xmlns:a16="http://schemas.microsoft.com/office/drawing/2014/main" id="{59BBB7B7-5A7F-4653-AB99-5EC99F6BD2CF}"/>
               </a:ext>
             </a:extLst>
           </p:cNvPr>
@@ -18839,7 +19295,7 @@
           <p:cNvPr id="9" name="footnote">
             <a:extLst xmlns:a="http://schemas.openxmlformats.org/drawingml/2006/main">
               <a:ext uri="{FF2B5EF4-FFF2-40B4-BE49-F238E27FC236}">
-                <a16:creationId xmlns:a16="http://schemas.microsoft.com/office/drawing/2014/main" id="{D29E698A-E8B2-421B-B506-3478DFC82BE1}"/>
+                <a16:creationId xmlns:a16="http://schemas.microsoft.com/office/drawing/2014/main" id="{6B3F2B33-5FB2-470B-8282-E520796477C4}"/>
               </a:ext>
             </a:extLst>
           </p:cNvPr>
@@ -18896,7 +19352,7 @@
           <p:cNvPr id="10" name="page">
             <a:extLst xmlns:a="http://schemas.openxmlformats.org/drawingml/2006/main">
               <a:ext uri="{FF2B5EF4-FFF2-40B4-BE49-F238E27FC236}">
-                <a16:creationId xmlns:a16="http://schemas.microsoft.com/office/drawing/2014/main" id="{76EBA183-7DF5-4CA7-AEB9-3C3267BF4357}"/>
+                <a16:creationId xmlns:a16="http://schemas.microsoft.com/office/drawing/2014/main" id="{E99556CA-6F67-485C-85D5-DA68C7F7C195}"/>
               </a:ext>
             </a:extLst>
           </p:cNvPr>
@@ -18951,7 +19407,7 @@
     </p:spTree>
     <p:extLst>
       <p:ext uri="{BB962C8B-B14F-4D97-AF65-F5344CB8AC3E}">
-        <p14:creationId xmlns:p14="http://schemas.microsoft.com/office/powerpoint/2010/main" val="1661518404"/>
+        <p14:creationId xmlns:p14="http://schemas.microsoft.com/office/powerpoint/2010/main" val="856276974"/>
       </p:ext>
     </p:extLst>
   </p:cSld>
@@ -18982,7 +19438,7 @@
           <p:cNvPr id="11" name="course">
             <a:extLst xmlns:a="http://schemas.openxmlformats.org/drawingml/2006/main">
               <a:ext uri="{FF2B5EF4-FFF2-40B4-BE49-F238E27FC236}">
-                <a16:creationId xmlns:a16="http://schemas.microsoft.com/office/drawing/2014/main" id="{98B9945F-7E39-4700-9E11-1D5277FA747A}"/>
+                <a16:creationId xmlns:a16="http://schemas.microsoft.com/office/drawing/2014/main" id="{4DE24FB4-5D39-41C4-91D2-59D8B1796151}"/>
               </a:ext>
             </a:extLst>
           </p:cNvPr>
@@ -19039,7 +19495,7 @@
           <p:cNvPr id="2" name="title">
             <a:extLst xmlns:a="http://schemas.openxmlformats.org/drawingml/2006/main">
               <a:ext uri="{FF2B5EF4-FFF2-40B4-BE49-F238E27FC236}">
-                <a16:creationId xmlns:a16="http://schemas.microsoft.com/office/drawing/2014/main" id="{7BC3C653-1DBD-491E-AC76-26EE449D7DC5}"/>
+                <a16:creationId xmlns:a16="http://schemas.microsoft.com/office/drawing/2014/main" id="{593BCB15-6849-4C68-BD47-4815ADD32A9B}"/>
               </a:ext>
             </a:extLst>
           </p:cNvPr>
@@ -19096,7 +19552,7 @@
           <p:cNvPr id="3" name="body">
             <a:extLst xmlns:a="http://schemas.openxmlformats.org/drawingml/2006/main">
               <a:ext uri="{FF2B5EF4-FFF2-40B4-BE49-F238E27FC236}">
-                <a16:creationId xmlns:a16="http://schemas.microsoft.com/office/drawing/2014/main" id="{3A3EE6EA-BB26-465B-BB92-9CBE75D5668E}"/>
+                <a16:creationId xmlns:a16="http://schemas.microsoft.com/office/drawing/2014/main" id="{F5529D96-684B-4910-83C8-1C00508D76A1}"/>
               </a:ext>
             </a:extLst>
           </p:cNvPr>
@@ -19153,7 +19609,7 @@
           <p:cNvPr id="4" name="body">
             <a:extLst xmlns:a="http://schemas.openxmlformats.org/drawingml/2006/main">
               <a:ext uri="{FF2B5EF4-FFF2-40B4-BE49-F238E27FC236}">
-                <a16:creationId xmlns:a16="http://schemas.microsoft.com/office/drawing/2014/main" id="{58A53649-A33E-4D21-895A-B58A9AC29857}"/>
+                <a16:creationId xmlns:a16="http://schemas.microsoft.com/office/drawing/2014/main" id="{50256ED6-EC5F-431E-B66A-98BB831F1371}"/>
               </a:ext>
             </a:extLst>
           </p:cNvPr>
@@ -19210,7 +19666,7 @@
           <p:cNvPr id="5" name="body">
             <a:extLst xmlns:a="http://schemas.openxmlformats.org/drawingml/2006/main">
               <a:ext uri="{FF2B5EF4-FFF2-40B4-BE49-F238E27FC236}">
-                <a16:creationId xmlns:a16="http://schemas.microsoft.com/office/drawing/2014/main" id="{117CAE12-CB0B-409A-BC33-B909606BEFED}"/>
+                <a16:creationId xmlns:a16="http://schemas.microsoft.com/office/drawing/2014/main" id="{CFAD9BCC-9A60-49CD-B37F-3F3FD013A9C9}"/>
               </a:ext>
             </a:extLst>
           </p:cNvPr>
@@ -19267,7 +19723,7 @@
           <p:cNvPr id="6" name="body">
             <a:extLst xmlns:a="http://schemas.openxmlformats.org/drawingml/2006/main">
               <a:ext uri="{FF2B5EF4-FFF2-40B4-BE49-F238E27FC236}">
-                <a16:creationId xmlns:a16="http://schemas.microsoft.com/office/drawing/2014/main" id="{BDD2DEA9-322D-4F41-B732-F341C3EAE62A}"/>
+                <a16:creationId xmlns:a16="http://schemas.microsoft.com/office/drawing/2014/main" id="{64DFD5B4-9986-4D16-98CE-A46867BC00EA}"/>
               </a:ext>
             </a:extLst>
           </p:cNvPr>
@@ -19324,7 +19780,7 @@
           <p:cNvPr id="7" name="body">
             <a:extLst xmlns:a="http://schemas.openxmlformats.org/drawingml/2006/main">
               <a:ext uri="{FF2B5EF4-FFF2-40B4-BE49-F238E27FC236}">
-                <a16:creationId xmlns:a16="http://schemas.microsoft.com/office/drawing/2014/main" id="{46F4ABEE-A249-4EA8-BCB8-ADBB064C7C3F}"/>
+                <a16:creationId xmlns:a16="http://schemas.microsoft.com/office/drawing/2014/main" id="{2F2D7EC2-088D-4360-86D0-206567C073DC}"/>
               </a:ext>
             </a:extLst>
           </p:cNvPr>
@@ -19381,7 +19837,7 @@
           <p:cNvPr id="8" name="body">
             <a:extLst xmlns:a="http://schemas.openxmlformats.org/drawingml/2006/main">
               <a:ext uri="{FF2B5EF4-FFF2-40B4-BE49-F238E27FC236}">
-                <a16:creationId xmlns:a16="http://schemas.microsoft.com/office/drawing/2014/main" id="{C4F16E81-6B67-4578-A489-FC6E4B12978B}"/>
+                <a16:creationId xmlns:a16="http://schemas.microsoft.com/office/drawing/2014/main" id="{BE9DC457-0FBF-4A98-8B88-49BBFEEF4663}"/>
               </a:ext>
             </a:extLst>
           </p:cNvPr>
@@ -19438,7 +19894,7 @@
           <p:cNvPr id="9" name="footnote">
             <a:extLst xmlns:a="http://schemas.openxmlformats.org/drawingml/2006/main">
               <a:ext uri="{FF2B5EF4-FFF2-40B4-BE49-F238E27FC236}">
-                <a16:creationId xmlns:a16="http://schemas.microsoft.com/office/drawing/2014/main" id="{1FC423C9-83CC-41A1-A03C-DEA509C41ECD}"/>
+                <a16:creationId xmlns:a16="http://schemas.microsoft.com/office/drawing/2014/main" id="{F7D93941-5C07-4525-BB63-6A371791B4C2}"/>
               </a:ext>
             </a:extLst>
           </p:cNvPr>
@@ -19495,7 +19951,7 @@
           <p:cNvPr id="10" name="page">
             <a:extLst xmlns:a="http://schemas.openxmlformats.org/drawingml/2006/main">
               <a:ext uri="{FF2B5EF4-FFF2-40B4-BE49-F238E27FC236}">
-                <a16:creationId xmlns:a16="http://schemas.microsoft.com/office/drawing/2014/main" id="{76190287-C027-4993-A5E9-7F81D3792C70}"/>
+                <a16:creationId xmlns:a16="http://schemas.microsoft.com/office/drawing/2014/main" id="{E8D556EC-FFDC-4EAB-90D3-1D384C6CDA8F}"/>
               </a:ext>
             </a:extLst>
           </p:cNvPr>
@@ -19550,7 +20006,7 @@
     </p:spTree>
     <p:extLst>
       <p:ext uri="{BB962C8B-B14F-4D97-AF65-F5344CB8AC3E}">
-        <p14:creationId xmlns:p14="http://schemas.microsoft.com/office/powerpoint/2010/main" val="834011421"/>
+        <p14:creationId xmlns:p14="http://schemas.microsoft.com/office/powerpoint/2010/main" val="1642332447"/>
       </p:ext>
     </p:extLst>
   </p:cSld>
@@ -20035,7 +20491,7 @@
                   <a:srgbClr val="111111"/>
                 </a:solidFill>
               </a:rPr>
-              <a:t>8–20 min: six experiments and their evidence</a:t>
+              <a:t>8–23 min: experiments, apparatus, and analysis</a:t>
             </a:r>
           </a:p>
         </p:txBody>
@@ -20172,7 +20628,7 @@
                   <a:srgbClr val="111111"/>
                 </a:solidFill>
               </a:rPr>
-              <a:t>20–42 min: report writing and comparison</a:t>
+              <a:t>23–42 min: report writing and comparison</a:t>
             </a:r>
           </a:p>
         </p:txBody>
@@ -23181,7 +23637,7 @@
         </p:xfrm>
         <a:graphic xmlns:a="http://schemas.openxmlformats.org/drawingml/2006/main">
           <a:graphicData uri="http://schemas.openxmlformats.org/drawingml/2006/chart">
-            <c:chart xmlns:r="http://schemas.openxmlformats.org/officeDocument/2006/relationships" xmlns:c="http://schemas.openxmlformats.org/drawingml/2006/chart" r:id="R5b20d49ecc3b47d7"/>
+            <c:chart xmlns:r="http://schemas.openxmlformats.org/officeDocument/2006/relationships" xmlns:c="http://schemas.openxmlformats.org/drawingml/2006/chart" r:id="R3e3e43f5415043d4"/>
           </a:graphicData>
         </a:graphic>
       </p:graphicFrame>
@@ -25207,10 +25663,10 @@
       </p:grpSpPr>
       <p:sp>
         <p:nvSpPr>
-          <p:cNvPr id="12" name="course">
-            <a:extLst xmlns:a="http://schemas.openxmlformats.org/drawingml/2006/main">
-              <a:ext uri="{FF2B5EF4-FFF2-40B4-BE49-F238E27FC236}">
-                <a16:creationId xmlns:a16="http://schemas.microsoft.com/office/drawing/2014/main" id="{644075A0-A121-47C0-B59B-6FE7CE555F63}"/>
+          <p:cNvPr id="14" name="course">
+            <a:extLst xmlns:a="http://schemas.openxmlformats.org/drawingml/2006/main">
+              <a:ext uri="{FF2B5EF4-FFF2-40B4-BE49-F238E27FC236}">
+                <a16:creationId xmlns:a16="http://schemas.microsoft.com/office/drawing/2014/main" id="{A6E7D3C2-1D1B-4A39-B973-1A42756B0CB8}"/>
               </a:ext>
             </a:extLst>
           </p:cNvPr>
@@ -25267,7 +25723,7 @@
           <p:cNvPr id="2" name="title">
             <a:extLst xmlns:a="http://schemas.openxmlformats.org/drawingml/2006/main">
               <a:ext uri="{FF2B5EF4-FFF2-40B4-BE49-F238E27FC236}">
-                <a16:creationId xmlns:a16="http://schemas.microsoft.com/office/drawing/2014/main" id="{06F683C6-9F5C-4A40-889B-186FB927BA66}"/>
+                <a16:creationId xmlns:a16="http://schemas.microsoft.com/office/drawing/2014/main" id="{5B8F5247-9F61-4765-8662-D1F818477978}"/>
               </a:ext>
             </a:extLst>
           </p:cNvPr>
@@ -25324,7 +25780,7 @@
           <p:cNvPr id="3" name="body">
             <a:extLst xmlns:a="http://schemas.openxmlformats.org/drawingml/2006/main">
               <a:ext uri="{FF2B5EF4-FFF2-40B4-BE49-F238E27FC236}">
-                <a16:creationId xmlns:a16="http://schemas.microsoft.com/office/drawing/2014/main" id="{CA703D9D-9A44-4F4E-A32B-A8E80147A69C}"/>
+                <a16:creationId xmlns:a16="http://schemas.microsoft.com/office/drawing/2014/main" id="{480D108A-31BC-41F3-89F5-3EA170BAB3A8}"/>
               </a:ext>
             </a:extLst>
           </p:cNvPr>
@@ -25353,7 +25809,7 @@
           <a:lstStyle xmlns:a="http://schemas.openxmlformats.org/drawingml/2006/main"/>
           <a:p xmlns:a="http://schemas.openxmlformats.org/drawingml/2006/main">
             <a:pPr>
-              <a:defRPr sz="1875" b="1">
+              <a:defRPr sz="1650" b="1">
                 <a:solidFill>
                   <a:srgbClr val="881C1C"/>
                 </a:solidFill>
@@ -25363,7 +25819,7 @@
               </a:defRPr>
             </a:pPr>
             <a:r>
-              <a:rPr sz="1875" b="1">
+              <a:rPr sz="1650" b="1">
                 <a:solidFill>
                   <a:srgbClr val="881C1C"/>
                 </a:solidFill>
@@ -25371,7 +25827,7 @@
                 <a:ea typeface="Calibri"/>
                 <a:cs typeface="Calibri"/>
               </a:rPr>
-              <a:t>Question</a:t>
+              <a:t>Apparatus</a:t>
             </a:r>
           </a:p>
         </p:txBody>
@@ -25381,7 +25837,7 @@
           <p:cNvPr id="4" name="body">
             <a:extLst xmlns:a="http://schemas.openxmlformats.org/drawingml/2006/main">
               <a:ext uri="{FF2B5EF4-FFF2-40B4-BE49-F238E27FC236}">
-                <a16:creationId xmlns:a16="http://schemas.microsoft.com/office/drawing/2014/main" id="{2A6D6B89-83AE-48ED-A356-80373E69781A}"/>
+                <a16:creationId xmlns:a16="http://schemas.microsoft.com/office/drawing/2014/main" id="{D64F31C2-77C5-4B6A-AAE8-8B64AE3F21FA}"/>
               </a:ext>
             </a:extLst>
           </p:cNvPr>
@@ -25393,7 +25849,7 @@
         <p:spPr>
           <a:xfrm xmlns:a="http://schemas.openxmlformats.org/drawingml/2006/main">
             <a:off x="495300" y="2057400"/>
-            <a:ext cx="10810875" cy="790575"/>
+            <a:ext cx="10810875" cy="542925"/>
           </a:xfrm>
           <a:prstGeom xmlns:a="http://schemas.openxmlformats.org/drawingml/2006/main" prst="rect">
             <a:avLst/>
@@ -25410,25 +25866,25 @@
           <a:lstStyle xmlns:a="http://schemas.openxmlformats.org/drawingml/2006/main"/>
           <a:p xmlns:a="http://schemas.openxmlformats.org/drawingml/2006/main">
             <a:pPr>
-              <a:defRPr sz="2100" b="0">
-                <a:solidFill>
-                  <a:srgbClr val="111111"/>
-                </a:solidFill>
-                <a:latin typeface="Calibri"/>
-                <a:ea typeface="Calibri"/>
-                <a:cs typeface="Calibri"/>
-              </a:defRPr>
-            </a:pPr>
-            <a:r>
-              <a:rPr sz="2100" b="0">
-                <a:solidFill>
-                  <a:srgbClr val="111111"/>
-                </a:solidFill>
-                <a:latin typeface="Calibri"/>
-                <a:ea typeface="Calibri"/>
-                <a:cs typeface="Calibri"/>
-              </a:rPr>
-              <a:t>How can the same sound produce different sampled signals?</a:t>
+              <a:defRPr sz="1725" b="0">
+                <a:solidFill>
+                  <a:srgbClr val="111111"/>
+                </a:solidFill>
+                <a:latin typeface="Calibri"/>
+                <a:ea typeface="Calibri"/>
+                <a:cs typeface="Calibri"/>
+              </a:defRPr>
+            </a:pPr>
+            <a:r>
+              <a:rPr sz="1725" b="0">
+                <a:solidFill>
+                  <a:srgbClr val="111111"/>
+                </a:solidFill>
+                <a:latin typeface="Calibri"/>
+                <a:ea typeface="Calibri"/>
+                <a:cs typeface="Calibri"/>
+              </a:rPr>
+              <a:t>Moku:Go data logger, microphone, speaker, and sound sources such as a tuning fork.</a:t>
             </a:r>
           </a:p>
         </p:txBody>
@@ -25438,18 +25894,18 @@
           <p:cNvPr id="5" name="body">
             <a:extLst xmlns:a="http://schemas.openxmlformats.org/drawingml/2006/main">
               <a:ext uri="{FF2B5EF4-FFF2-40B4-BE49-F238E27FC236}">
-                <a16:creationId xmlns:a16="http://schemas.microsoft.com/office/drawing/2014/main" id="{23269B9A-57BC-48CA-9659-B5DA3092F03A}"/>
-              </a:ext>
-            </a:extLst>
-          </p:cNvPr>
-          <p:cNvSpPr>
-            <a:spLocks xmlns:a="http://schemas.openxmlformats.org/drawingml/2006/main" noGrp="1"/>
-          </p:cNvSpPr>
-          <p:nvPr/>
-        </p:nvSpPr>
-        <p:spPr>
-          <a:xfrm xmlns:a="http://schemas.openxmlformats.org/drawingml/2006/main">
-            <a:off x="495300" y="2886075"/>
+                <a16:creationId xmlns:a16="http://schemas.microsoft.com/office/drawing/2014/main" id="{05DEEAA6-E020-40EC-ADBB-5036287E7D53}"/>
+              </a:ext>
+            </a:extLst>
+          </p:cNvPr>
+          <p:cNvSpPr>
+            <a:spLocks xmlns:a="http://schemas.openxmlformats.org/drawingml/2006/main" noGrp="1"/>
+          </p:cNvSpPr>
+          <p:nvPr/>
+        </p:nvSpPr>
+        <p:spPr>
+          <a:xfrm xmlns:a="http://schemas.openxmlformats.org/drawingml/2006/main">
+            <a:off x="495300" y="2638425"/>
             <a:ext cx="10810875" cy="361950"/>
           </a:xfrm>
           <a:prstGeom xmlns:a="http://schemas.openxmlformats.org/drawingml/2006/main" prst="rect">
@@ -25467,7 +25923,7 @@
           <a:lstStyle xmlns:a="http://schemas.openxmlformats.org/drawingml/2006/main"/>
           <a:p xmlns:a="http://schemas.openxmlformats.org/drawingml/2006/main">
             <a:pPr>
-              <a:defRPr sz="1875" b="1">
+              <a:defRPr sz="1650" b="1">
                 <a:solidFill>
                   <a:srgbClr val="881C1C"/>
                 </a:solidFill>
@@ -25477,7 +25933,7 @@
               </a:defRPr>
             </a:pPr>
             <a:r>
-              <a:rPr sz="1875" b="1">
+              <a:rPr sz="1650" b="1">
                 <a:solidFill>
                   <a:srgbClr val="881C1C"/>
                 </a:solidFill>
@@ -25485,7 +25941,7 @@
                 <a:ea typeface="Calibri"/>
                 <a:cs typeface="Calibri"/>
               </a:rPr>
-              <a:t>Measurement</a:t>
+              <a:t>Data collection</a:t>
             </a:r>
           </a:p>
         </p:txBody>
@@ -25495,19 +25951,19 @@
           <p:cNvPr id="6" name="body">
             <a:extLst xmlns:a="http://schemas.openxmlformats.org/drawingml/2006/main">
               <a:ext uri="{FF2B5EF4-FFF2-40B4-BE49-F238E27FC236}">
-                <a16:creationId xmlns:a16="http://schemas.microsoft.com/office/drawing/2014/main" id="{325A329A-C525-485E-B657-E60EB34F384A}"/>
-              </a:ext>
-            </a:extLst>
-          </p:cNvPr>
-          <p:cNvSpPr>
-            <a:spLocks xmlns:a="http://schemas.openxmlformats.org/drawingml/2006/main" noGrp="1"/>
-          </p:cNvSpPr>
-          <p:nvPr/>
-        </p:nvSpPr>
-        <p:spPr>
-          <a:xfrm xmlns:a="http://schemas.openxmlformats.org/drawingml/2006/main">
-            <a:off x="495300" y="3248025"/>
-            <a:ext cx="10810875" cy="790575"/>
+                <a16:creationId xmlns:a16="http://schemas.microsoft.com/office/drawing/2014/main" id="{19FB5E3E-54E5-402A-814F-4F9AE3148E50}"/>
+              </a:ext>
+            </a:extLst>
+          </p:cNvPr>
+          <p:cNvSpPr>
+            <a:spLocks xmlns:a="http://schemas.openxmlformats.org/drawingml/2006/main" noGrp="1"/>
+          </p:cNvSpPr>
+          <p:nvPr/>
+        </p:nvSpPr>
+        <p:spPr>
+          <a:xfrm xmlns:a="http://schemas.openxmlformats.org/drawingml/2006/main">
+            <a:off x="495300" y="3000375"/>
+            <a:ext cx="10810875" cy="542925"/>
           </a:xfrm>
           <a:prstGeom xmlns:a="http://schemas.openxmlformats.org/drawingml/2006/main" prst="rect">
             <a:avLst/>
@@ -25524,25 +25980,25 @@
           <a:lstStyle xmlns:a="http://schemas.openxmlformats.org/drawingml/2006/main"/>
           <a:p xmlns:a="http://schemas.openxmlformats.org/drawingml/2006/main">
             <a:pPr>
-              <a:defRPr sz="2100" b="0">
-                <a:solidFill>
-                  <a:srgbClr val="111111"/>
-                </a:solidFill>
-                <a:latin typeface="Calibri"/>
-                <a:ea typeface="Calibri"/>
-                <a:cs typeface="Calibri"/>
-              </a:defRPr>
-            </a:pPr>
-            <a:r>
-              <a:rPr sz="2100" b="0">
-                <a:solidFill>
-                  <a:srgbClr val="111111"/>
-                </a:solidFill>
-                <a:latin typeface="Calibri"/>
-                <a:ea typeface="Calibri"/>
-                <a:cs typeface="Calibri"/>
-              </a:rPr>
-              <a:t>Record microphone voltage and the sampling rate. Compare time traces and spectra.</a:t>
+              <a:defRPr sz="1725" b="0">
+                <a:solidFill>
+                  <a:srgbClr val="111111"/>
+                </a:solidFill>
+                <a:latin typeface="Calibri"/>
+                <a:ea typeface="Calibri"/>
+                <a:cs typeface="Calibri"/>
+              </a:defRPr>
+            </a:pPr>
+            <a:r>
+              <a:rPr sz="1725" b="0">
+                <a:solidFill>
+                  <a:srgbClr val="111111"/>
+                </a:solidFill>
+                <a:latin typeface="Calibri"/>
+                <a:ea typeface="Calibri"/>
+                <a:cs typeface="Calibri"/>
+              </a:rPr>
+              <a:t>Record at least one second at several rates relative to the source frequency, then replay and save each data file.</a:t>
             </a:r>
           </a:p>
         </p:txBody>
@@ -25552,18 +26008,18 @@
           <p:cNvPr id="7" name="body">
             <a:extLst xmlns:a="http://schemas.openxmlformats.org/drawingml/2006/main">
               <a:ext uri="{FF2B5EF4-FFF2-40B4-BE49-F238E27FC236}">
-                <a16:creationId xmlns:a16="http://schemas.microsoft.com/office/drawing/2014/main" id="{5B3D8BC8-D37F-4750-8327-1137604A0A47}"/>
-              </a:ext>
-            </a:extLst>
-          </p:cNvPr>
-          <p:cNvSpPr>
-            <a:spLocks xmlns:a="http://schemas.openxmlformats.org/drawingml/2006/main" noGrp="1"/>
-          </p:cNvSpPr>
-          <p:nvPr/>
-        </p:nvSpPr>
-        <p:spPr>
-          <a:xfrm xmlns:a="http://schemas.openxmlformats.org/drawingml/2006/main">
-            <a:off x="495300" y="4076700"/>
+                <a16:creationId xmlns:a16="http://schemas.microsoft.com/office/drawing/2014/main" id="{4C5BC6D6-08AF-46FC-9DA3-147C27A0EA94}"/>
+              </a:ext>
+            </a:extLst>
+          </p:cNvPr>
+          <p:cNvSpPr>
+            <a:spLocks xmlns:a="http://schemas.openxmlformats.org/drawingml/2006/main" noGrp="1"/>
+          </p:cNvSpPr>
+          <p:nvPr/>
+        </p:nvSpPr>
+        <p:spPr>
+          <a:xfrm xmlns:a="http://schemas.openxmlformats.org/drawingml/2006/main">
+            <a:off x="495300" y="3581400"/>
             <a:ext cx="10810875" cy="361950"/>
           </a:xfrm>
           <a:prstGeom xmlns:a="http://schemas.openxmlformats.org/drawingml/2006/main" prst="rect">
@@ -25581,7 +26037,7 @@
           <a:lstStyle xmlns:a="http://schemas.openxmlformats.org/drawingml/2006/main"/>
           <a:p xmlns:a="http://schemas.openxmlformats.org/drawingml/2006/main">
             <a:pPr>
-              <a:defRPr sz="1875" b="1">
+              <a:defRPr sz="1650" b="1">
                 <a:solidFill>
                   <a:srgbClr val="881C1C"/>
                 </a:solidFill>
@@ -25591,7 +26047,7 @@
               </a:defRPr>
             </a:pPr>
             <a:r>
-              <a:rPr sz="1875" b="1">
+              <a:rPr sz="1650" b="1">
                 <a:solidFill>
                   <a:srgbClr val="881C1C"/>
                 </a:solidFill>
@@ -25599,7 +26055,7 @@
                 <a:ea typeface="Calibri"/>
                 <a:cs typeface="Calibri"/>
               </a:rPr>
-              <a:t>Report evidence</a:t>
+              <a:t>Analysis</a:t>
             </a:r>
           </a:p>
         </p:txBody>
@@ -25609,19 +26065,19 @@
           <p:cNvPr id="8" name="body">
             <a:extLst xmlns:a="http://schemas.openxmlformats.org/drawingml/2006/main">
               <a:ext uri="{FF2B5EF4-FFF2-40B4-BE49-F238E27FC236}">
-                <a16:creationId xmlns:a16="http://schemas.microsoft.com/office/drawing/2014/main" id="{EAF7E2B9-CB69-46D1-AC4A-77E4AE9CB47A}"/>
-              </a:ext>
-            </a:extLst>
-          </p:cNvPr>
-          <p:cNvSpPr>
-            <a:spLocks xmlns:a="http://schemas.openxmlformats.org/drawingml/2006/main" noGrp="1"/>
-          </p:cNvSpPr>
-          <p:nvPr/>
-        </p:nvSpPr>
-        <p:spPr>
-          <a:xfrm xmlns:a="http://schemas.openxmlformats.org/drawingml/2006/main">
-            <a:off x="495300" y="4438650"/>
-            <a:ext cx="10810875" cy="790575"/>
+                <a16:creationId xmlns:a16="http://schemas.microsoft.com/office/drawing/2014/main" id="{B88BD27D-7C17-4BDF-B708-A3A401E06531}"/>
+              </a:ext>
+            </a:extLst>
+          </p:cNvPr>
+          <p:cNvSpPr>
+            <a:spLocks xmlns:a="http://schemas.openxmlformats.org/drawingml/2006/main" noGrp="1"/>
+          </p:cNvSpPr>
+          <p:nvPr/>
+        </p:nvSpPr>
+        <p:spPr>
+          <a:xfrm xmlns:a="http://schemas.openxmlformats.org/drawingml/2006/main">
+            <a:off x="495300" y="3943350"/>
+            <a:ext cx="10810875" cy="542925"/>
           </a:xfrm>
           <a:prstGeom xmlns:a="http://schemas.openxmlformats.org/drawingml/2006/main" prst="rect">
             <a:avLst/>
@@ -25638,35 +26094,149 @@
           <a:lstStyle xmlns:a="http://schemas.openxmlformats.org/drawingml/2006/main"/>
           <a:p xmlns:a="http://schemas.openxmlformats.org/drawingml/2006/main">
             <a:pPr>
-              <a:defRPr sz="2100" b="0">
-                <a:solidFill>
-                  <a:srgbClr val="111111"/>
-                </a:solidFill>
-                <a:latin typeface="Calibri"/>
-                <a:ea typeface="Calibri"/>
-                <a:cs typeface="Calibri"/>
-              </a:defRPr>
-            </a:pPr>
-            <a:r>
-              <a:rPr sz="2100" b="0">
-                <a:solidFill>
-                  <a:srgbClr val="111111"/>
-                </a:solidFill>
-                <a:latin typeface="Calibri"/>
-                <a:ea typeface="Calibri"/>
-                <a:cs typeface="Calibri"/>
-              </a:rPr>
-              <a:t>Show how sample rate and record duration affect the inferred frequency. Identify aliasing.</a:t>
-            </a:r>
-          </a:p>
-        </p:txBody>
-      </p:sp>
-      <p:sp>
-        <p:nvSpPr>
-          <p:cNvPr id="9" name="equation">
-            <a:extLst xmlns:a="http://schemas.openxmlformats.org/drawingml/2006/main">
-              <a:ext uri="{FF2B5EF4-FFF2-40B4-BE49-F238E27FC236}">
-                <a16:creationId xmlns:a16="http://schemas.microsoft.com/office/drawing/2014/main" id="{2B898752-80CA-463A-8C9D-B3097EE3AEC2}"/>
+              <a:defRPr sz="1725" b="0">
+                <a:solidFill>
+                  <a:srgbClr val="111111"/>
+                </a:solidFill>
+                <a:latin typeface="Calibri"/>
+                <a:ea typeface="Calibri"/>
+                <a:cs typeface="Calibri"/>
+              </a:defRPr>
+            </a:pPr>
+            <a:r>
+              <a:rPr sz="1725" b="0">
+                <a:solidFill>
+                  <a:srgbClr val="111111"/>
+                </a:solidFill>
+                <a:latin typeface="Calibri"/>
+                <a:ea typeface="Calibri"/>
+                <a:cs typeface="Calibri"/>
+              </a:rPr>
+              <a:t>Compare time histories and FFT spectra. Identify the fundamental frequency, aliasing, and the effect of record length.</a:t>
+            </a:r>
+          </a:p>
+        </p:txBody>
+      </p:sp>
+      <p:sp>
+        <p:nvSpPr>
+          <p:cNvPr id="9" name="body">
+            <a:extLst xmlns:a="http://schemas.openxmlformats.org/drawingml/2006/main">
+              <a:ext uri="{FF2B5EF4-FFF2-40B4-BE49-F238E27FC236}">
+                <a16:creationId xmlns:a16="http://schemas.microsoft.com/office/drawing/2014/main" id="{B85A3A39-382E-4BC0-8A82-DB81436F8CBF}"/>
+              </a:ext>
+            </a:extLst>
+          </p:cNvPr>
+          <p:cNvSpPr>
+            <a:spLocks xmlns:a="http://schemas.openxmlformats.org/drawingml/2006/main" noGrp="1"/>
+          </p:cNvSpPr>
+          <p:nvPr/>
+        </p:nvSpPr>
+        <p:spPr>
+          <a:xfrm xmlns:a="http://schemas.openxmlformats.org/drawingml/2006/main">
+            <a:off x="495300" y="4524375"/>
+            <a:ext cx="10810875" cy="361950"/>
+          </a:xfrm>
+          <a:prstGeom xmlns:a="http://schemas.openxmlformats.org/drawingml/2006/main" prst="rect">
+            <a:avLst/>
+          </a:prstGeom>
+          <a:noFill xmlns:a="http://schemas.openxmlformats.org/drawingml/2006/main"/>
+          <a:ln xmlns:a="http://schemas.openxmlformats.org/drawingml/2006/main" w="0">
+            <a:noFill/>
+          </a:ln>
+        </p:spPr>
+        <p:txBody>
+          <a:bodyPr xmlns:a="http://schemas.openxmlformats.org/drawingml/2006/main">
+            <a:noAutofit/>
+          </a:bodyPr>
+          <a:lstStyle xmlns:a="http://schemas.openxmlformats.org/drawingml/2006/main"/>
+          <a:p xmlns:a="http://schemas.openxmlformats.org/drawingml/2006/main">
+            <a:pPr>
+              <a:defRPr sz="1650" b="1">
+                <a:solidFill>
+                  <a:srgbClr val="881C1C"/>
+                </a:solidFill>
+                <a:latin typeface="Calibri"/>
+                <a:ea typeface="Calibri"/>
+                <a:cs typeface="Calibri"/>
+              </a:defRPr>
+            </a:pPr>
+            <a:r>
+              <a:rPr sz="1650" b="1">
+                <a:solidFill>
+                  <a:srgbClr val="881C1C"/>
+                </a:solidFill>
+                <a:latin typeface="Calibri"/>
+                <a:ea typeface="Calibri"/>
+                <a:cs typeface="Calibri"/>
+              </a:rPr>
+              <a:t>Report focus</a:t>
+            </a:r>
+          </a:p>
+        </p:txBody>
+      </p:sp>
+      <p:sp>
+        <p:nvSpPr>
+          <p:cNvPr id="10" name="body">
+            <a:extLst xmlns:a="http://schemas.openxmlformats.org/drawingml/2006/main">
+              <a:ext uri="{FF2B5EF4-FFF2-40B4-BE49-F238E27FC236}">
+                <a16:creationId xmlns:a16="http://schemas.microsoft.com/office/drawing/2014/main" id="{3CBCA6C7-B7AA-45BD-B6E5-2D65433957E4}"/>
+              </a:ext>
+            </a:extLst>
+          </p:cNvPr>
+          <p:cNvSpPr>
+            <a:spLocks xmlns:a="http://schemas.openxmlformats.org/drawingml/2006/main" noGrp="1"/>
+          </p:cNvSpPr>
+          <p:nvPr/>
+        </p:nvSpPr>
+        <p:spPr>
+          <a:xfrm xmlns:a="http://schemas.openxmlformats.org/drawingml/2006/main">
+            <a:off x="495300" y="4886325"/>
+            <a:ext cx="10810875" cy="542925"/>
+          </a:xfrm>
+          <a:prstGeom xmlns:a="http://schemas.openxmlformats.org/drawingml/2006/main" prst="rect">
+            <a:avLst/>
+          </a:prstGeom>
+          <a:noFill xmlns:a="http://schemas.openxmlformats.org/drawingml/2006/main"/>
+          <a:ln xmlns:a="http://schemas.openxmlformats.org/drawingml/2006/main" w="0">
+            <a:noFill/>
+          </a:ln>
+        </p:spPr>
+        <p:txBody>
+          <a:bodyPr xmlns:a="http://schemas.openxmlformats.org/drawingml/2006/main">
+            <a:noAutofit/>
+          </a:bodyPr>
+          <a:lstStyle xmlns:a="http://schemas.openxmlformats.org/drawingml/2006/main"/>
+          <a:p xmlns:a="http://schemas.openxmlformats.org/drawingml/2006/main">
+            <a:pPr>
+              <a:defRPr sz="1725" b="0">
+                <a:solidFill>
+                  <a:srgbClr val="111111"/>
+                </a:solidFill>
+                <a:latin typeface="Calibri"/>
+                <a:ea typeface="Calibri"/>
+                <a:cs typeface="Calibri"/>
+              </a:defRPr>
+            </a:pPr>
+            <a:r>
+              <a:rPr sz="1725" b="0">
+                <a:solidFill>
+                  <a:srgbClr val="111111"/>
+                </a:solidFill>
+                <a:latin typeface="Calibri"/>
+                <a:ea typeface="Calibri"/>
+                <a:cs typeface="Calibri"/>
+              </a:rPr>
+              <a:t>Explain why sampling rate controls representation while record duration controls frequency resolution.</a:t>
+            </a:r>
+          </a:p>
+        </p:txBody>
+      </p:sp>
+      <p:sp>
+        <p:nvSpPr>
+          <p:cNvPr id="11" name="equation">
+            <a:extLst xmlns:a="http://schemas.openxmlformats.org/drawingml/2006/main">
+              <a:ext uri="{FF2B5EF4-FFF2-40B4-BE49-F238E27FC236}">
+                <a16:creationId xmlns:a16="http://schemas.microsoft.com/office/drawing/2014/main" id="{80F98D1D-5A72-4B93-8AE6-A30DDDCEF4FC}"/>
               </a:ext>
             </a:extLst>
           </p:cNvPr>
@@ -25720,10 +26290,10 @@
       </p:sp>
       <p:sp>
         <p:nvSpPr>
-          <p:cNvPr id="10" name="footnote">
-            <a:extLst xmlns:a="http://schemas.openxmlformats.org/drawingml/2006/main">
-              <a:ext uri="{FF2B5EF4-FFF2-40B4-BE49-F238E27FC236}">
-                <a16:creationId xmlns:a16="http://schemas.microsoft.com/office/drawing/2014/main" id="{BE36D5BC-1CF0-47EE-9283-89E45E4A55DB}"/>
+          <p:cNvPr id="12" name="footnote">
+            <a:extLst xmlns:a="http://schemas.openxmlformats.org/drawingml/2006/main">
+              <a:ext uri="{FF2B5EF4-FFF2-40B4-BE49-F238E27FC236}">
+                <a16:creationId xmlns:a16="http://schemas.microsoft.com/office/drawing/2014/main" id="{1ACEA15A-9988-4030-8BFC-1E917CB345F3}"/>
               </a:ext>
             </a:extLst>
           </p:cNvPr>
@@ -25770,17 +26340,17 @@
                 <a:ea typeface="Calibri"/>
                 <a:cs typeface="Calibri"/>
               </a:rPr>
-              <a:t>The Nyquist condition assumes a band-limited input. Practical acquisition needs filtering and margin.</a:t>
-            </a:r>
-          </a:p>
-        </p:txBody>
-      </p:sp>
-      <p:sp>
-        <p:nvSpPr>
-          <p:cNvPr id="11" name="page">
-            <a:extLst xmlns:a="http://schemas.openxmlformats.org/drawingml/2006/main">
-              <a:ext uri="{FF2B5EF4-FFF2-40B4-BE49-F238E27FC236}">
-                <a16:creationId xmlns:a16="http://schemas.microsoft.com/office/drawing/2014/main" id="{0E80DC56-D88D-4B35-8674-C86B275A5D62}"/>
+              <a:t>The procedure includes rates such as 100f, 10f, 3f, 1.4f, and 1f. Record the actual settings for every run.</a:t>
+            </a:r>
+          </a:p>
+        </p:txBody>
+      </p:sp>
+      <p:sp>
+        <p:nvSpPr>
+          <p:cNvPr id="13" name="page">
+            <a:extLst xmlns:a="http://schemas.openxmlformats.org/drawingml/2006/main">
+              <a:ext uri="{FF2B5EF4-FFF2-40B4-BE49-F238E27FC236}">
+                <a16:creationId xmlns:a16="http://schemas.microsoft.com/office/drawing/2014/main" id="{C1F782B6-AC75-4520-9785-4F484C62F029}"/>
               </a:ext>
             </a:extLst>
           </p:cNvPr>
@@ -25835,7 +26405,7 @@
     </p:spTree>
     <p:extLst>
       <p:ext uri="{BB962C8B-B14F-4D97-AF65-F5344CB8AC3E}">
-        <p14:creationId xmlns:p14="http://schemas.microsoft.com/office/powerpoint/2010/main" val="1715495833"/>
+        <p14:creationId xmlns:p14="http://schemas.microsoft.com/office/powerpoint/2010/main" val="1979803338"/>
       </p:ext>
     </p:extLst>
   </p:cSld>
@@ -25863,10 +26433,10 @@
       </p:grpSpPr>
       <p:sp>
         <p:nvSpPr>
-          <p:cNvPr id="12" name="course">
-            <a:extLst xmlns:a="http://schemas.openxmlformats.org/drawingml/2006/main">
-              <a:ext uri="{FF2B5EF4-FFF2-40B4-BE49-F238E27FC236}">
-                <a16:creationId xmlns:a16="http://schemas.microsoft.com/office/drawing/2014/main" id="{70EA9162-D344-4AAB-8115-422AC8D04F87}"/>
+          <p:cNvPr id="14" name="course">
+            <a:extLst xmlns:a="http://schemas.openxmlformats.org/drawingml/2006/main">
+              <a:ext uri="{FF2B5EF4-FFF2-40B4-BE49-F238E27FC236}">
+                <a16:creationId xmlns:a16="http://schemas.microsoft.com/office/drawing/2014/main" id="{546487D9-6161-46E3-8C58-EBB93FA8F6CA}"/>
               </a:ext>
             </a:extLst>
           </p:cNvPr>
@@ -25923,7 +26493,7 @@
           <p:cNvPr id="2" name="title">
             <a:extLst xmlns:a="http://schemas.openxmlformats.org/drawingml/2006/main">
               <a:ext uri="{FF2B5EF4-FFF2-40B4-BE49-F238E27FC236}">
-                <a16:creationId xmlns:a16="http://schemas.microsoft.com/office/drawing/2014/main" id="{431DF7C7-56D6-4B9E-A0DF-F4FA2F0EF44D}"/>
+                <a16:creationId xmlns:a16="http://schemas.microsoft.com/office/drawing/2014/main" id="{07CCA7AC-F273-47F7-8A5D-8ED26B05ED3A}"/>
               </a:ext>
             </a:extLst>
           </p:cNvPr>
@@ -25980,7 +26550,7 @@
           <p:cNvPr id="3" name="body">
             <a:extLst xmlns:a="http://schemas.openxmlformats.org/drawingml/2006/main">
               <a:ext uri="{FF2B5EF4-FFF2-40B4-BE49-F238E27FC236}">
-                <a16:creationId xmlns:a16="http://schemas.microsoft.com/office/drawing/2014/main" id="{23AA244F-2C5B-4390-8A6F-6A89ED4E6C5B}"/>
+                <a16:creationId xmlns:a16="http://schemas.microsoft.com/office/drawing/2014/main" id="{02DDA3EB-94A8-4E15-A624-9DA40A89E150}"/>
               </a:ext>
             </a:extLst>
           </p:cNvPr>
@@ -26009,7 +26579,7 @@
           <a:lstStyle xmlns:a="http://schemas.openxmlformats.org/drawingml/2006/main"/>
           <a:p xmlns:a="http://schemas.openxmlformats.org/drawingml/2006/main">
             <a:pPr>
-              <a:defRPr sz="1875" b="1">
+              <a:defRPr sz="1650" b="1">
                 <a:solidFill>
                   <a:srgbClr val="881C1C"/>
                 </a:solidFill>
@@ -26019,7 +26589,7 @@
               </a:defRPr>
             </a:pPr>
             <a:r>
-              <a:rPr sz="1875" b="1">
+              <a:rPr sz="1650" b="1">
                 <a:solidFill>
                   <a:srgbClr val="881C1C"/>
                 </a:solidFill>
@@ -26027,7 +26597,7 @@
                 <a:ea typeface="Calibri"/>
                 <a:cs typeface="Calibri"/>
               </a:rPr>
-              <a:t>Question</a:t>
+              <a:t>Apparatus</a:t>
             </a:r>
           </a:p>
         </p:txBody>
@@ -26037,7 +26607,7 @@
           <p:cNvPr id="4" name="body">
             <a:extLst xmlns:a="http://schemas.openxmlformats.org/drawingml/2006/main">
               <a:ext uri="{FF2B5EF4-FFF2-40B4-BE49-F238E27FC236}">
-                <a16:creationId xmlns:a16="http://schemas.microsoft.com/office/drawing/2014/main" id="{7DCC54F8-1BD8-42FE-B643-C36F0A9A6B02}"/>
+                <a16:creationId xmlns:a16="http://schemas.microsoft.com/office/drawing/2014/main" id="{9D32E5A9-8B09-43D7-BF20-425CE6B874F4}"/>
               </a:ext>
             </a:extLst>
           </p:cNvPr>
@@ -26049,7 +26619,7 @@
         <p:spPr>
           <a:xfrm xmlns:a="http://schemas.openxmlformats.org/drawingml/2006/main">
             <a:off x="495300" y="2057400"/>
-            <a:ext cx="10810875" cy="790575"/>
+            <a:ext cx="10810875" cy="542925"/>
           </a:xfrm>
           <a:prstGeom xmlns:a="http://schemas.openxmlformats.org/drawingml/2006/main" prst="rect">
             <a:avLst/>
@@ -26066,25 +26636,25 @@
           <a:lstStyle xmlns:a="http://schemas.openxmlformats.org/drawingml/2006/main"/>
           <a:p xmlns:a="http://schemas.openxmlformats.org/drawingml/2006/main">
             <a:pPr>
-              <a:defRPr sz="2100" b="0">
-                <a:solidFill>
-                  <a:srgbClr val="111111"/>
-                </a:solidFill>
-                <a:latin typeface="Calibri"/>
-                <a:ea typeface="Calibri"/>
-                <a:cs typeface="Calibri"/>
-              </a:defRPr>
-            </a:pPr>
-            <a:r>
-              <a:rPr sz="2100" b="0">
-                <a:solidFill>
-                  <a:srgbClr val="111111"/>
-                </a:solidFill>
-                <a:latin typeface="Calibri"/>
-                <a:ea typeface="Calibri"/>
-                <a:cs typeface="Calibri"/>
-              </a:rPr>
-              <a:t>When does a small-angle model predict the measured motion?</a:t>
+              <a:defRPr sz="1725" b="0">
+                <a:solidFill>
+                  <a:srgbClr val="111111"/>
+                </a:solidFill>
+                <a:latin typeface="Calibri"/>
+                <a:ea typeface="Calibri"/>
+                <a:cs typeface="Calibri"/>
+              </a:defRPr>
+            </a:pPr>
+            <a:r>
+              <a:rPr sz="1725" b="0">
+                <a:solidFill>
+                  <a:srgbClr val="111111"/>
+                </a:solidFill>
+                <a:latin typeface="Calibri"/>
+                <a:ea typeface="Calibri"/>
+                <a:cs typeface="Calibri"/>
+              </a:rPr>
+              <a:t>Single pendulum, high-speed camera at the assigned frame rate, scale reference, and the MATLAB tracking app.</a:t>
             </a:r>
           </a:p>
         </p:txBody>
@@ -26094,18 +26664,18 @@
           <p:cNvPr id="5" name="body">
             <a:extLst xmlns:a="http://schemas.openxmlformats.org/drawingml/2006/main">
               <a:ext uri="{FF2B5EF4-FFF2-40B4-BE49-F238E27FC236}">
-                <a16:creationId xmlns:a16="http://schemas.microsoft.com/office/drawing/2014/main" id="{430B9C3A-3753-4089-B42C-2CE53B25FCFE}"/>
-              </a:ext>
-            </a:extLst>
-          </p:cNvPr>
-          <p:cNvSpPr>
-            <a:spLocks xmlns:a="http://schemas.openxmlformats.org/drawingml/2006/main" noGrp="1"/>
-          </p:cNvSpPr>
-          <p:nvPr/>
-        </p:nvSpPr>
-        <p:spPr>
-          <a:xfrm xmlns:a="http://schemas.openxmlformats.org/drawingml/2006/main">
-            <a:off x="495300" y="2886075"/>
+                <a16:creationId xmlns:a16="http://schemas.microsoft.com/office/drawing/2014/main" id="{7681BAA3-6DBE-4C24-AA19-CCEA938C50C0}"/>
+              </a:ext>
+            </a:extLst>
+          </p:cNvPr>
+          <p:cNvSpPr>
+            <a:spLocks xmlns:a="http://schemas.openxmlformats.org/drawingml/2006/main" noGrp="1"/>
+          </p:cNvSpPr>
+          <p:nvPr/>
+        </p:nvSpPr>
+        <p:spPr>
+          <a:xfrm xmlns:a="http://schemas.openxmlformats.org/drawingml/2006/main">
+            <a:off x="495300" y="2638425"/>
             <a:ext cx="10810875" cy="361950"/>
           </a:xfrm>
           <a:prstGeom xmlns:a="http://schemas.openxmlformats.org/drawingml/2006/main" prst="rect">
@@ -26123,7 +26693,7 @@
           <a:lstStyle xmlns:a="http://schemas.openxmlformats.org/drawingml/2006/main"/>
           <a:p xmlns:a="http://schemas.openxmlformats.org/drawingml/2006/main">
             <a:pPr>
-              <a:defRPr sz="1875" b="1">
+              <a:defRPr sz="1650" b="1">
                 <a:solidFill>
                   <a:srgbClr val="881C1C"/>
                 </a:solidFill>
@@ -26133,7 +26703,7 @@
               </a:defRPr>
             </a:pPr>
             <a:r>
-              <a:rPr sz="1875" b="1">
+              <a:rPr sz="1650" b="1">
                 <a:solidFill>
                   <a:srgbClr val="881C1C"/>
                 </a:solidFill>
@@ -26141,7 +26711,7 @@
                 <a:ea typeface="Calibri"/>
                 <a:cs typeface="Calibri"/>
               </a:rPr>
-              <a:t>Measurement</a:t>
+              <a:t>Data collection</a:t>
             </a:r>
           </a:p>
         </p:txBody>
@@ -26151,19 +26721,19 @@
           <p:cNvPr id="6" name="body">
             <a:extLst xmlns:a="http://schemas.openxmlformats.org/drawingml/2006/main">
               <a:ext uri="{FF2B5EF4-FFF2-40B4-BE49-F238E27FC236}">
-                <a16:creationId xmlns:a16="http://schemas.microsoft.com/office/drawing/2014/main" id="{3120E00C-AD74-4B2C-9377-6852D7DB57D2}"/>
-              </a:ext>
-            </a:extLst>
-          </p:cNvPr>
-          <p:cNvSpPr>
-            <a:spLocks xmlns:a="http://schemas.openxmlformats.org/drawingml/2006/main" noGrp="1"/>
-          </p:cNvSpPr>
-          <p:nvPr/>
-        </p:nvSpPr>
-        <p:spPr>
-          <a:xfrm xmlns:a="http://schemas.openxmlformats.org/drawingml/2006/main">
-            <a:off x="495300" y="3248025"/>
-            <a:ext cx="10810875" cy="790575"/>
+                <a16:creationId xmlns:a16="http://schemas.microsoft.com/office/drawing/2014/main" id="{296556F3-2424-412F-9C9F-DA964DADEFA2}"/>
+              </a:ext>
+            </a:extLst>
+          </p:cNvPr>
+          <p:cNvSpPr>
+            <a:spLocks xmlns:a="http://schemas.openxmlformats.org/drawingml/2006/main" noGrp="1"/>
+          </p:cNvSpPr>
+          <p:nvPr/>
+        </p:nvSpPr>
+        <p:spPr>
+          <a:xfrm xmlns:a="http://schemas.openxmlformats.org/drawingml/2006/main">
+            <a:off x="495300" y="3000375"/>
+            <a:ext cx="10810875" cy="542925"/>
           </a:xfrm>
           <a:prstGeom xmlns:a="http://schemas.openxmlformats.org/drawingml/2006/main" prst="rect">
             <a:avLst/>
@@ -26180,25 +26750,25 @@
           <a:lstStyle xmlns:a="http://schemas.openxmlformats.org/drawingml/2006/main"/>
           <a:p xmlns:a="http://schemas.openxmlformats.org/drawingml/2006/main">
             <a:pPr>
-              <a:defRPr sz="2100" b="0">
-                <a:solidFill>
-                  <a:srgbClr val="111111"/>
-                </a:solidFill>
-                <a:latin typeface="Calibri"/>
-                <a:ea typeface="Calibri"/>
-                <a:cs typeface="Calibri"/>
-              </a:defRPr>
-            </a:pPr>
-            <a:r>
-              <a:rPr sz="2100" b="0">
-                <a:solidFill>
-                  <a:srgbClr val="111111"/>
-                </a:solidFill>
-                <a:latin typeface="Calibri"/>
-                <a:ea typeface="Calibri"/>
-                <a:cs typeface="Calibri"/>
-              </a:rPr>
-              <a:t>Track angle from video. Record geometry, mass properties, frame rate, and release angle.</a:t>
+              <a:defRPr sz="1725" b="0">
+                <a:solidFill>
+                  <a:srgbClr val="111111"/>
+                </a:solidFill>
+                <a:latin typeface="Calibri"/>
+                <a:ea typeface="Calibri"/>
+                <a:cs typeface="Calibri"/>
+              </a:defRPr>
+            </a:pPr>
+            <a:r>
+              <a:rPr sz="1725" b="0">
+                <a:solidFill>
+                  <a:srgbClr val="111111"/>
+                </a:solidFill>
+                <a:latin typeface="Calibri"/>
+                <a:ea typeface="Calibri"/>
+                <a:cs typeface="Calibri"/>
+              </a:rPr>
+              <a:t>Release from rest at small, medium, and large initial angles. Record the angle, geometry, masses, and video settings.</a:t>
             </a:r>
           </a:p>
         </p:txBody>
@@ -26208,18 +26778,18 @@
           <p:cNvPr id="7" name="body">
             <a:extLst xmlns:a="http://schemas.openxmlformats.org/drawingml/2006/main">
               <a:ext uri="{FF2B5EF4-FFF2-40B4-BE49-F238E27FC236}">
-                <a16:creationId xmlns:a16="http://schemas.microsoft.com/office/drawing/2014/main" id="{F1DF01C3-9477-4CE2-999F-2531590283B0}"/>
-              </a:ext>
-            </a:extLst>
-          </p:cNvPr>
-          <p:cNvSpPr>
-            <a:spLocks xmlns:a="http://schemas.openxmlformats.org/drawingml/2006/main" noGrp="1"/>
-          </p:cNvSpPr>
-          <p:nvPr/>
-        </p:nvSpPr>
-        <p:spPr>
-          <a:xfrm xmlns:a="http://schemas.openxmlformats.org/drawingml/2006/main">
-            <a:off x="495300" y="4076700"/>
+                <a16:creationId xmlns:a16="http://schemas.microsoft.com/office/drawing/2014/main" id="{10D2EDBF-3B1E-4A0E-A6B1-7D6C09C06999}"/>
+              </a:ext>
+            </a:extLst>
+          </p:cNvPr>
+          <p:cNvSpPr>
+            <a:spLocks xmlns:a="http://schemas.openxmlformats.org/drawingml/2006/main" noGrp="1"/>
+          </p:cNvSpPr>
+          <p:nvPr/>
+        </p:nvSpPr>
+        <p:spPr>
+          <a:xfrm xmlns:a="http://schemas.openxmlformats.org/drawingml/2006/main">
+            <a:off x="495300" y="3581400"/>
             <a:ext cx="10810875" cy="361950"/>
           </a:xfrm>
           <a:prstGeom xmlns:a="http://schemas.openxmlformats.org/drawingml/2006/main" prst="rect">
@@ -26237,7 +26807,7 @@
           <a:lstStyle xmlns:a="http://schemas.openxmlformats.org/drawingml/2006/main"/>
           <a:p xmlns:a="http://schemas.openxmlformats.org/drawingml/2006/main">
             <a:pPr>
-              <a:defRPr sz="1875" b="1">
+              <a:defRPr sz="1650" b="1">
                 <a:solidFill>
                   <a:srgbClr val="881C1C"/>
                 </a:solidFill>
@@ -26247,7 +26817,7 @@
               </a:defRPr>
             </a:pPr>
             <a:r>
-              <a:rPr sz="1875" b="1">
+              <a:rPr sz="1650" b="1">
                 <a:solidFill>
                   <a:srgbClr val="881C1C"/>
                 </a:solidFill>
@@ -26255,7 +26825,7 @@
                 <a:ea typeface="Calibri"/>
                 <a:cs typeface="Calibri"/>
               </a:rPr>
-              <a:t>Report evidence</a:t>
+              <a:t>Analysis</a:t>
             </a:r>
           </a:p>
         </p:txBody>
@@ -26265,19 +26835,19 @@
           <p:cNvPr id="8" name="body">
             <a:extLst xmlns:a="http://schemas.openxmlformats.org/drawingml/2006/main">
               <a:ext uri="{FF2B5EF4-FFF2-40B4-BE49-F238E27FC236}">
-                <a16:creationId xmlns:a16="http://schemas.microsoft.com/office/drawing/2014/main" id="{90B82DBF-D6C9-4709-B039-CD944D1C2880}"/>
-              </a:ext>
-            </a:extLst>
-          </p:cNvPr>
-          <p:cNvSpPr>
-            <a:spLocks xmlns:a="http://schemas.openxmlformats.org/drawingml/2006/main" noGrp="1"/>
-          </p:cNvSpPr>
-          <p:nvPr/>
-        </p:nvSpPr>
-        <p:spPr>
-          <a:xfrm xmlns:a="http://schemas.openxmlformats.org/drawingml/2006/main">
-            <a:off x="495300" y="4438650"/>
-            <a:ext cx="10810875" cy="790575"/>
+                <a16:creationId xmlns:a16="http://schemas.microsoft.com/office/drawing/2014/main" id="{CC5CDFB2-FBD7-43A8-89F9-DBC657D70958}"/>
+              </a:ext>
+            </a:extLst>
+          </p:cNvPr>
+          <p:cNvSpPr>
+            <a:spLocks xmlns:a="http://schemas.openxmlformats.org/drawingml/2006/main" noGrp="1"/>
+          </p:cNvSpPr>
+          <p:nvPr/>
+        </p:nvSpPr>
+        <p:spPr>
+          <a:xfrm xmlns:a="http://schemas.openxmlformats.org/drawingml/2006/main">
+            <a:off x="495300" y="3943350"/>
+            <a:ext cx="10810875" cy="542925"/>
           </a:xfrm>
           <a:prstGeom xmlns:a="http://schemas.openxmlformats.org/drawingml/2006/main" prst="rect">
             <a:avLst/>
@@ -26294,35 +26864,149 @@
           <a:lstStyle xmlns:a="http://schemas.openxmlformats.org/drawingml/2006/main"/>
           <a:p xmlns:a="http://schemas.openxmlformats.org/drawingml/2006/main">
             <a:pPr>
-              <a:defRPr sz="2100" b="0">
-                <a:solidFill>
-                  <a:srgbClr val="111111"/>
-                </a:solidFill>
-                <a:latin typeface="Calibri"/>
-                <a:ea typeface="Calibri"/>
-                <a:cs typeface="Calibri"/>
-              </a:defRPr>
-            </a:pPr>
-            <a:r>
-              <a:rPr sz="2100" b="0">
-                <a:solidFill>
-                  <a:srgbClr val="111111"/>
-                </a:solidFill>
-                <a:latin typeface="Calibri"/>
-                <a:ea typeface="Calibri"/>
-                <a:cs typeface="Calibri"/>
-              </a:rPr>
-              <a:t>Compare measured and predicted angle histories and periods for small and larger releases.</a:t>
-            </a:r>
-          </a:p>
-        </p:txBody>
-      </p:sp>
-      <p:sp>
-        <p:nvSpPr>
-          <p:cNvPr id="9" name="equation">
-            <a:extLst xmlns:a="http://schemas.openxmlformats.org/drawingml/2006/main">
-              <a:ext uri="{FF2B5EF4-FFF2-40B4-BE49-F238E27FC236}">
-                <a16:creationId xmlns:a16="http://schemas.microsoft.com/office/drawing/2014/main" id="{358BB9E5-7D71-4EC7-8D7E-8B42F661A143}"/>
+              <a:defRPr sz="1725" b="0">
+                <a:solidFill>
+                  <a:srgbClr val="111111"/>
+                </a:solidFill>
+                <a:latin typeface="Calibri"/>
+                <a:ea typeface="Calibri"/>
+                <a:cs typeface="Calibri"/>
+              </a:defRPr>
+            </a:pPr>
+            <a:r>
+              <a:rPr sz="1725" b="0">
+                <a:solidFill>
+                  <a:srgbClr val="111111"/>
+                </a:solidFill>
+                <a:latin typeface="Calibri"/>
+                <a:ea typeface="Calibri"/>
+                <a:cs typeface="Calibri"/>
+              </a:rPr>
+              <a:t>Convert tracked coordinates to angle and angular velocity. Compare time histories, spectra, period, and numerical prediction.</a:t>
+            </a:r>
+          </a:p>
+        </p:txBody>
+      </p:sp>
+      <p:sp>
+        <p:nvSpPr>
+          <p:cNvPr id="9" name="body">
+            <a:extLst xmlns:a="http://schemas.openxmlformats.org/drawingml/2006/main">
+              <a:ext uri="{FF2B5EF4-FFF2-40B4-BE49-F238E27FC236}">
+                <a16:creationId xmlns:a16="http://schemas.microsoft.com/office/drawing/2014/main" id="{C591F37D-76D6-4EA8-9994-B9B82461DA37}"/>
+              </a:ext>
+            </a:extLst>
+          </p:cNvPr>
+          <p:cNvSpPr>
+            <a:spLocks xmlns:a="http://schemas.openxmlformats.org/drawingml/2006/main" noGrp="1"/>
+          </p:cNvSpPr>
+          <p:nvPr/>
+        </p:nvSpPr>
+        <p:spPr>
+          <a:xfrm xmlns:a="http://schemas.openxmlformats.org/drawingml/2006/main">
+            <a:off x="495300" y="4524375"/>
+            <a:ext cx="10810875" cy="361950"/>
+          </a:xfrm>
+          <a:prstGeom xmlns:a="http://schemas.openxmlformats.org/drawingml/2006/main" prst="rect">
+            <a:avLst/>
+          </a:prstGeom>
+          <a:noFill xmlns:a="http://schemas.openxmlformats.org/drawingml/2006/main"/>
+          <a:ln xmlns:a="http://schemas.openxmlformats.org/drawingml/2006/main" w="0">
+            <a:noFill/>
+          </a:ln>
+        </p:spPr>
+        <p:txBody>
+          <a:bodyPr xmlns:a="http://schemas.openxmlformats.org/drawingml/2006/main">
+            <a:noAutofit/>
+          </a:bodyPr>
+          <a:lstStyle xmlns:a="http://schemas.openxmlformats.org/drawingml/2006/main"/>
+          <a:p xmlns:a="http://schemas.openxmlformats.org/drawingml/2006/main">
+            <a:pPr>
+              <a:defRPr sz="1650" b="1">
+                <a:solidFill>
+                  <a:srgbClr val="881C1C"/>
+                </a:solidFill>
+                <a:latin typeface="Calibri"/>
+                <a:ea typeface="Calibri"/>
+                <a:cs typeface="Calibri"/>
+              </a:defRPr>
+            </a:pPr>
+            <a:r>
+              <a:rPr sz="1650" b="1">
+                <a:solidFill>
+                  <a:srgbClr val="881C1C"/>
+                </a:solidFill>
+                <a:latin typeface="Calibri"/>
+                <a:ea typeface="Calibri"/>
+                <a:cs typeface="Calibri"/>
+              </a:rPr>
+              <a:t>Report focus</a:t>
+            </a:r>
+          </a:p>
+        </p:txBody>
+      </p:sp>
+      <p:sp>
+        <p:nvSpPr>
+          <p:cNvPr id="10" name="body">
+            <a:extLst xmlns:a="http://schemas.openxmlformats.org/drawingml/2006/main">
+              <a:ext uri="{FF2B5EF4-FFF2-40B4-BE49-F238E27FC236}">
+                <a16:creationId xmlns:a16="http://schemas.microsoft.com/office/drawing/2014/main" id="{E9AA5ECA-C013-4F39-9373-B559E0F7BE79}"/>
+              </a:ext>
+            </a:extLst>
+          </p:cNvPr>
+          <p:cNvSpPr>
+            <a:spLocks xmlns:a="http://schemas.openxmlformats.org/drawingml/2006/main" noGrp="1"/>
+          </p:cNvSpPr>
+          <p:nvPr/>
+        </p:nvSpPr>
+        <p:spPr>
+          <a:xfrm xmlns:a="http://schemas.openxmlformats.org/drawingml/2006/main">
+            <a:off x="495300" y="4886325"/>
+            <a:ext cx="10810875" cy="542925"/>
+          </a:xfrm>
+          <a:prstGeom xmlns:a="http://schemas.openxmlformats.org/drawingml/2006/main" prst="rect">
+            <a:avLst/>
+          </a:prstGeom>
+          <a:noFill xmlns:a="http://schemas.openxmlformats.org/drawingml/2006/main"/>
+          <a:ln xmlns:a="http://schemas.openxmlformats.org/drawingml/2006/main" w="0">
+            <a:noFill/>
+          </a:ln>
+        </p:spPr>
+        <p:txBody>
+          <a:bodyPr xmlns:a="http://schemas.openxmlformats.org/drawingml/2006/main">
+            <a:noAutofit/>
+          </a:bodyPr>
+          <a:lstStyle xmlns:a="http://schemas.openxmlformats.org/drawingml/2006/main"/>
+          <a:p xmlns:a="http://schemas.openxmlformats.org/drawingml/2006/main">
+            <a:pPr>
+              <a:defRPr sz="1725" b="0">
+                <a:solidFill>
+                  <a:srgbClr val="111111"/>
+                </a:solidFill>
+                <a:latin typeface="Calibri"/>
+                <a:ea typeface="Calibri"/>
+                <a:cs typeface="Calibri"/>
+              </a:defRPr>
+            </a:pPr>
+            <a:r>
+              <a:rPr sz="1725" b="0">
+                <a:solidFill>
+                  <a:srgbClr val="111111"/>
+                </a:solidFill>
+                <a:latin typeface="Calibri"/>
+                <a:ea typeface="Calibri"/>
+                <a:cs typeface="Calibri"/>
+              </a:rPr>
+              <a:t>Explain when the small-angle model works and how inertia, damping, calibration, and release angle affect agreement.</a:t>
+            </a:r>
+          </a:p>
+        </p:txBody>
+      </p:sp>
+      <p:sp>
+        <p:nvSpPr>
+          <p:cNvPr id="11" name="equation">
+            <a:extLst xmlns:a="http://schemas.openxmlformats.org/drawingml/2006/main">
+              <a:ext uri="{FF2B5EF4-FFF2-40B4-BE49-F238E27FC236}">
+                <a16:creationId xmlns:a16="http://schemas.microsoft.com/office/drawing/2014/main" id="{AE12789A-019B-44F2-BE2E-3DD93B82B3DE}"/>
               </a:ext>
             </a:extLst>
           </p:cNvPr>
@@ -26376,10 +27060,10 @@
       </p:sp>
       <p:sp>
         <p:nvSpPr>
-          <p:cNvPr id="10" name="footnote">
-            <a:extLst xmlns:a="http://schemas.openxmlformats.org/drawingml/2006/main">
-              <a:ext uri="{FF2B5EF4-FFF2-40B4-BE49-F238E27FC236}">
-                <a16:creationId xmlns:a16="http://schemas.microsoft.com/office/drawing/2014/main" id="{73A54F28-7210-4E89-82EE-5598033EABDD}"/>
+          <p:cNvPr id="12" name="footnote">
+            <a:extLst xmlns:a="http://schemas.openxmlformats.org/drawingml/2006/main">
+              <a:ext uri="{FF2B5EF4-FFF2-40B4-BE49-F238E27FC236}">
+                <a16:creationId xmlns:a16="http://schemas.microsoft.com/office/drawing/2014/main" id="{15BD6C56-2DD7-4E25-8728-645253FCE494}"/>
               </a:ext>
             </a:extLst>
           </p:cNvPr>
@@ -26426,17 +27110,17 @@
                 <a:ea typeface="Calibri"/>
                 <a:cs typeface="Calibri"/>
               </a:rPr>
-              <a:t>Iₚ is inertia about the pivot. d is the pivot-to-center-of-mass distance. The model neglects losses.</a:t>
-            </a:r>
-          </a:p>
-        </p:txBody>
-      </p:sp>
-      <p:sp>
-        <p:nvSpPr>
-          <p:cNvPr id="11" name="page">
-            <a:extLst xmlns:a="http://schemas.openxmlformats.org/drawingml/2006/main">
-              <a:ext uri="{FF2B5EF4-FFF2-40B4-BE49-F238E27FC236}">
-                <a16:creationId xmlns:a16="http://schemas.microsoft.com/office/drawing/2014/main" id="{2ED32C72-DFFB-49FE-8682-80958773A14B}"/>
+              <a:t>The procedure uses releases below 10°, from 10° to 90°, and from 90° to 180°. Match simulation and experiment initial conditions.</a:t>
+            </a:r>
+          </a:p>
+        </p:txBody>
+      </p:sp>
+      <p:sp>
+        <p:nvSpPr>
+          <p:cNvPr id="13" name="page">
+            <a:extLst xmlns:a="http://schemas.openxmlformats.org/drawingml/2006/main">
+              <a:ext uri="{FF2B5EF4-FFF2-40B4-BE49-F238E27FC236}">
+                <a16:creationId xmlns:a16="http://schemas.microsoft.com/office/drawing/2014/main" id="{9C1CF8F5-CBBC-4BB7-B061-64929B2BCCA7}"/>
               </a:ext>
             </a:extLst>
           </p:cNvPr>
@@ -26491,7 +27175,7 @@
     </p:spTree>
     <p:extLst>
       <p:ext uri="{BB962C8B-B14F-4D97-AF65-F5344CB8AC3E}">
-        <p14:creationId xmlns:p14="http://schemas.microsoft.com/office/powerpoint/2010/main" val="228907474"/>
+        <p14:creationId xmlns:p14="http://schemas.microsoft.com/office/powerpoint/2010/main" val="1799311702"/>
       </p:ext>
     </p:extLst>
   </p:cSld>

</xml_diff>

<commit_message>
Clarify pre-lab release and section deadlines
</commit_message>
<xml_diff>
--- a/site/docs/MIE402_Lecture01_Report_Writing_Fall2026_v1.pptx
+++ b/site/docs/MIE402_Lecture01_Report_Writing_Fall2026_v1.pptx
@@ -2,49 +2,49 @@
 <file path=ppt/presentation.xml><?xml version="1.0" encoding="utf-8"?>
 <p:presentation xmlns:p="http://schemas.openxmlformats.org/presentationml/2006/main">
   <p:sldMasterIdLst>
-    <p:sldMasterId xmlns:r="http://schemas.openxmlformats.org/officeDocument/2006/relationships" id="2147483648" r:id="R3e91ecc2a9bc4374"/>
+    <p:sldMasterId xmlns:r="http://schemas.openxmlformats.org/officeDocument/2006/relationships" id="2147483648" r:id="R43e3b4d0397d4136"/>
   </p:sldMasterIdLst>
   <p:notesMasterIdLst>
-    <p:notesMasterId xmlns:r="http://schemas.openxmlformats.org/officeDocument/2006/relationships" r:id="R256461efcdba443e"/>
+    <p:notesMasterId xmlns:r="http://schemas.openxmlformats.org/officeDocument/2006/relationships" r:id="R1122b9c29ec7453e"/>
   </p:notesMasterIdLst>
   <p:sldIdLst>
-    <p:sldId xmlns:r="http://schemas.openxmlformats.org/officeDocument/2006/relationships" id="256" r:id="R7bc843fe0e014f79"/>
-    <p:sldId xmlns:r="http://schemas.openxmlformats.org/officeDocument/2006/relationships" id="257" r:id="R83d39bd873c44c33"/>
-    <p:sldId xmlns:r="http://schemas.openxmlformats.org/officeDocument/2006/relationships" id="258" r:id="Ra9bab13941da427a"/>
-    <p:sldId xmlns:r="http://schemas.openxmlformats.org/officeDocument/2006/relationships" id="259" r:id="R3ac287934899415c"/>
-    <p:sldId xmlns:r="http://schemas.openxmlformats.org/officeDocument/2006/relationships" id="260" r:id="R52f8a34d6e9b4b68"/>
-    <p:sldId xmlns:r="http://schemas.openxmlformats.org/officeDocument/2006/relationships" id="261" r:id="Rc3169b8b0b4349d9"/>
-    <p:sldId xmlns:r="http://schemas.openxmlformats.org/officeDocument/2006/relationships" id="262" r:id="R2102e58a199d4f4e"/>
-    <p:sldId xmlns:r="http://schemas.openxmlformats.org/officeDocument/2006/relationships" id="263" r:id="R519d444f2c5b40c3"/>
-    <p:sldId xmlns:r="http://schemas.openxmlformats.org/officeDocument/2006/relationships" id="264" r:id="Rac3e3535111e45ca"/>
-    <p:sldId xmlns:r="http://schemas.openxmlformats.org/officeDocument/2006/relationships" id="265" r:id="Re41f1d77534846fe"/>
-    <p:sldId xmlns:r="http://schemas.openxmlformats.org/officeDocument/2006/relationships" id="266" r:id="Rfceb5fddee844245"/>
-    <p:sldId xmlns:r="http://schemas.openxmlformats.org/officeDocument/2006/relationships" id="267" r:id="R7c09a2abe6d4466d"/>
-    <p:sldId xmlns:r="http://schemas.openxmlformats.org/officeDocument/2006/relationships" id="268" r:id="R904d9f8edf3e4ef2"/>
-    <p:sldId xmlns:r="http://schemas.openxmlformats.org/officeDocument/2006/relationships" id="269" r:id="R7c1d1dc4d20b47cd"/>
-    <p:sldId xmlns:r="http://schemas.openxmlformats.org/officeDocument/2006/relationships" id="270" r:id="R268256f161ef45e7"/>
-    <p:sldId xmlns:r="http://schemas.openxmlformats.org/officeDocument/2006/relationships" id="271" r:id="R584cf2d8651348dd"/>
-    <p:sldId xmlns:r="http://schemas.openxmlformats.org/officeDocument/2006/relationships" id="272" r:id="R96bd3efe6cca4442"/>
-    <p:sldId xmlns:r="http://schemas.openxmlformats.org/officeDocument/2006/relationships" id="273" r:id="R3d8967be2cb3422e"/>
-    <p:sldId xmlns:r="http://schemas.openxmlformats.org/officeDocument/2006/relationships" id="274" r:id="R9920f98c20094b54"/>
-    <p:sldId xmlns:r="http://schemas.openxmlformats.org/officeDocument/2006/relationships" id="275" r:id="Ra04359be0b9b44f6"/>
-    <p:sldId xmlns:r="http://schemas.openxmlformats.org/officeDocument/2006/relationships" id="276" r:id="Rd78ac31bd0644442"/>
-    <p:sldId xmlns:r="http://schemas.openxmlformats.org/officeDocument/2006/relationships" id="277" r:id="R6898bcec22ab4b50"/>
-    <p:sldId xmlns:r="http://schemas.openxmlformats.org/officeDocument/2006/relationships" id="278" r:id="R7eef6d0127524d3d"/>
-    <p:sldId xmlns:r="http://schemas.openxmlformats.org/officeDocument/2006/relationships" id="279" r:id="Rf1839b05b9e74fc3"/>
-    <p:sldId xmlns:r="http://schemas.openxmlformats.org/officeDocument/2006/relationships" id="280" r:id="R42c3a2153f96496a"/>
-    <p:sldId xmlns:r="http://schemas.openxmlformats.org/officeDocument/2006/relationships" id="281" r:id="Rc0161df66db6459b"/>
-    <p:sldId xmlns:r="http://schemas.openxmlformats.org/officeDocument/2006/relationships" id="282" r:id="R4e4a9618d6a741d6"/>
-    <p:sldId xmlns:r="http://schemas.openxmlformats.org/officeDocument/2006/relationships" id="283" r:id="R71873a5080c747ae"/>
-    <p:sldId xmlns:r="http://schemas.openxmlformats.org/officeDocument/2006/relationships" id="284" r:id="Rfc74b585c9c649d0"/>
-    <p:sldId xmlns:r="http://schemas.openxmlformats.org/officeDocument/2006/relationships" id="285" r:id="R57b598831ef447ec"/>
-    <p:sldId xmlns:r="http://schemas.openxmlformats.org/officeDocument/2006/relationships" id="286" r:id="R27505ffda63340be"/>
-    <p:sldId xmlns:r="http://schemas.openxmlformats.org/officeDocument/2006/relationships" id="287" r:id="R9d6bf6cfdc9f4b11"/>
-    <p:sldId xmlns:r="http://schemas.openxmlformats.org/officeDocument/2006/relationships" id="288" r:id="Rd913cb26d9364c0d"/>
-    <p:sldId xmlns:r="http://schemas.openxmlformats.org/officeDocument/2006/relationships" id="289" r:id="R933468d308cd4819"/>
-    <p:sldId xmlns:r="http://schemas.openxmlformats.org/officeDocument/2006/relationships" id="290" r:id="Re491b2d4667b4341"/>
-    <p:sldId xmlns:r="http://schemas.openxmlformats.org/officeDocument/2006/relationships" id="291" r:id="R99dcabb7f63c41f2"/>
-    <p:sldId xmlns:r="http://schemas.openxmlformats.org/officeDocument/2006/relationships" id="292" r:id="Ra65d927d45e946c3"/>
+    <p:sldId xmlns:r="http://schemas.openxmlformats.org/officeDocument/2006/relationships" id="256" r:id="Rc71ddeda1e1a4dbe"/>
+    <p:sldId xmlns:r="http://schemas.openxmlformats.org/officeDocument/2006/relationships" id="257" r:id="Rbbcae8af25404741"/>
+    <p:sldId xmlns:r="http://schemas.openxmlformats.org/officeDocument/2006/relationships" id="258" r:id="Re1b75f7f00a74ef8"/>
+    <p:sldId xmlns:r="http://schemas.openxmlformats.org/officeDocument/2006/relationships" id="259" r:id="R9b2be31b898a4895"/>
+    <p:sldId xmlns:r="http://schemas.openxmlformats.org/officeDocument/2006/relationships" id="260" r:id="R5f7adeefb1554b95"/>
+    <p:sldId xmlns:r="http://schemas.openxmlformats.org/officeDocument/2006/relationships" id="261" r:id="R8a20f8c44b304b9c"/>
+    <p:sldId xmlns:r="http://schemas.openxmlformats.org/officeDocument/2006/relationships" id="262" r:id="R8765b33f6d9746f6"/>
+    <p:sldId xmlns:r="http://schemas.openxmlformats.org/officeDocument/2006/relationships" id="263" r:id="R517d55f810cc40cb"/>
+    <p:sldId xmlns:r="http://schemas.openxmlformats.org/officeDocument/2006/relationships" id="264" r:id="R9db1dffbc395487a"/>
+    <p:sldId xmlns:r="http://schemas.openxmlformats.org/officeDocument/2006/relationships" id="265" r:id="R62aa298433ce44ae"/>
+    <p:sldId xmlns:r="http://schemas.openxmlformats.org/officeDocument/2006/relationships" id="266" r:id="R71b3b1ada65941a0"/>
+    <p:sldId xmlns:r="http://schemas.openxmlformats.org/officeDocument/2006/relationships" id="267" r:id="R09d5413bd523476a"/>
+    <p:sldId xmlns:r="http://schemas.openxmlformats.org/officeDocument/2006/relationships" id="268" r:id="Rd316ebf74028436d"/>
+    <p:sldId xmlns:r="http://schemas.openxmlformats.org/officeDocument/2006/relationships" id="269" r:id="Rfe77db2243be4f2d"/>
+    <p:sldId xmlns:r="http://schemas.openxmlformats.org/officeDocument/2006/relationships" id="270" r:id="R9569ee6399254b13"/>
+    <p:sldId xmlns:r="http://schemas.openxmlformats.org/officeDocument/2006/relationships" id="271" r:id="Rcd6a162f66bf4231"/>
+    <p:sldId xmlns:r="http://schemas.openxmlformats.org/officeDocument/2006/relationships" id="272" r:id="R56b7ab79952f4832"/>
+    <p:sldId xmlns:r="http://schemas.openxmlformats.org/officeDocument/2006/relationships" id="273" r:id="Rcb699c63500d47b5"/>
+    <p:sldId xmlns:r="http://schemas.openxmlformats.org/officeDocument/2006/relationships" id="274" r:id="R002b518e5f0c4254"/>
+    <p:sldId xmlns:r="http://schemas.openxmlformats.org/officeDocument/2006/relationships" id="275" r:id="Rf9b81f0f342a4e63"/>
+    <p:sldId xmlns:r="http://schemas.openxmlformats.org/officeDocument/2006/relationships" id="276" r:id="R86f86d02d1114fa6"/>
+    <p:sldId xmlns:r="http://schemas.openxmlformats.org/officeDocument/2006/relationships" id="277" r:id="R030ac110bc364e7f"/>
+    <p:sldId xmlns:r="http://schemas.openxmlformats.org/officeDocument/2006/relationships" id="278" r:id="Rea1fb25ae72d48be"/>
+    <p:sldId xmlns:r="http://schemas.openxmlformats.org/officeDocument/2006/relationships" id="279" r:id="R8b62740da3c2419e"/>
+    <p:sldId xmlns:r="http://schemas.openxmlformats.org/officeDocument/2006/relationships" id="280" r:id="R1c85eb909ea24819"/>
+    <p:sldId xmlns:r="http://schemas.openxmlformats.org/officeDocument/2006/relationships" id="281" r:id="R69a0a39d0ff048fd"/>
+    <p:sldId xmlns:r="http://schemas.openxmlformats.org/officeDocument/2006/relationships" id="282" r:id="R6deae3600f594e9e"/>
+    <p:sldId xmlns:r="http://schemas.openxmlformats.org/officeDocument/2006/relationships" id="283" r:id="Ra044f6c4a78a40d2"/>
+    <p:sldId xmlns:r="http://schemas.openxmlformats.org/officeDocument/2006/relationships" id="284" r:id="R16ef5147515d4e28"/>
+    <p:sldId xmlns:r="http://schemas.openxmlformats.org/officeDocument/2006/relationships" id="285" r:id="R5192da05d5ec46ad"/>
+    <p:sldId xmlns:r="http://schemas.openxmlformats.org/officeDocument/2006/relationships" id="286" r:id="R8363184e09a94d19"/>
+    <p:sldId xmlns:r="http://schemas.openxmlformats.org/officeDocument/2006/relationships" id="287" r:id="R3f977ea4ba8d4e79"/>
+    <p:sldId xmlns:r="http://schemas.openxmlformats.org/officeDocument/2006/relationships" id="288" r:id="Rbcfc9130923d42da"/>
+    <p:sldId xmlns:r="http://schemas.openxmlformats.org/officeDocument/2006/relationships" id="289" r:id="R27927f42ff864253"/>
+    <p:sldId xmlns:r="http://schemas.openxmlformats.org/officeDocument/2006/relationships" id="290" r:id="Rdbb72b7d2cad4639"/>
+    <p:sldId xmlns:r="http://schemas.openxmlformats.org/officeDocument/2006/relationships" id="291" r:id="Racaa03b1dcf6467e"/>
+    <p:sldId xmlns:r="http://schemas.openxmlformats.org/officeDocument/2006/relationships" id="292" r:id="R648d08ffd72448e8"/>
   </p:sldIdLst>
   <p:sldSz cx="12192000" cy="6858000"/>
   <p:notesSz cx="6858000" cy="9144000"/>
@@ -2958,7 +2958,7 @@
           </a:p>
           <a:p xmlns:a="http://schemas.openxmlformats.org/drawingml/2006/main">
             <a:r>
-              <a:t>State the policy as written in the syllabus without inventing an additional penalty or AI rule. Any pre-lab or report may include a brief oral verification. Students should be able to explain their model, processing choices, and conclusions. Make-ups require instructor or GTA availability and the correct equipment. Notify the instructor within the first two weeks about approved schedule conflicts or accommodation needs. Canvas is the submission system and the place for section-specific updates.</a:t>
+              <a:t>State the policy as written in the syllabus without inventing an additional penalty or AI rule. Any pre-lab or report may include a brief oral verification. Students should be able to explain their model, processing choices, and conclusions. Make-ups require instructor or GTA availability and the correct equipment. Notify the instructor within the first two weeks about approved schedule conflicts or accommodation needs. Canvas is the submission system and the place for section-specific updates. Emphasize that one release date applies to all sections, while each student submits before their own Tuesday-through-Friday meeting. Tuesday students therefore submit first. Earlier sections collect their data sooner and have more time before the common report deadline.</a:t>
             </a:r>
           </a:p>
           <a:p xmlns:a="http://schemas.openxmlformats.org/drawingml/2006/main">
@@ -3338,7 +3338,7 @@
           </a:p>
           <a:p xmlns:a="http://schemas.openxmlformats.org/drawingml/2006/main">
             <a:r>
-              <a:t>Close with one student answer to the opening trust question. A complete answer can mention the sampling rate, record duration, calibration, analysis method, model assumptions, and uncertainty. Ask students to locate the syllabus and report template before the next meeting. Remind them that public course materials are on GitHub and submissions, deadlines updates, and grades stay in Canvas. Leave any remaining seconds for a practical question about the first laboratory.</a:t>
+              <a:t>Close with one student answer to the opening trust question. A complete answer can mention the sampling rate, record duration, calibration, analysis method, model assumptions, and uncertainty. Ask students to locate the syllabus and report template before the next meeting. Remind them that public course materials are on GitHub and submissions, deadlines updates, and grades stay in Canvas. Leave any remaining seconds for a practical question about the first laboratory. Remind students that Pre-lab 1 is normally posted on Canvas on Monday before the Lab 1 week and is due before their own section begins.</a:t>
             </a:r>
           </a:p>
           <a:p xmlns:a="http://schemas.openxmlformats.org/drawingml/2006/main">
@@ -3991,7 +3991,7 @@
   </p:cSld>
   <p:clrMap bg1="lt1" tx1="dk1" bg2="lt2" tx2="dk2" accent1="accent1" accent2="accent2" accent3="accent3" accent4="accent4" accent5="accent5" accent6="accent6" hlink="hlink" folHlink="folHlink"/>
   <p:sldLayoutIdLst>
-    <p:sldLayoutId xmlns:r="http://schemas.openxmlformats.org/officeDocument/2006/relationships" id="2147483649" r:id="R22a4164566664103"/>
+    <p:sldLayoutId xmlns:r="http://schemas.openxmlformats.org/officeDocument/2006/relationships" id="2147483649" r:id="R106b3557f06f485e"/>
   </p:sldLayoutIdLst>
   <p:txStyles>
     <p:titleStyle>
@@ -6591,7 +6591,7 @@
           <p:cNvPr id="12" name="course">
             <a:extLst xmlns:a="http://schemas.openxmlformats.org/drawingml/2006/main">
               <a:ext uri="{FF2B5EF4-FFF2-40B4-BE49-F238E27FC236}">
-                <a16:creationId xmlns:a16="http://schemas.microsoft.com/office/drawing/2014/main" id="{73808B84-22F8-4ED5-8414-06906FC3DE82}"/>
+                <a16:creationId xmlns:a16="http://schemas.microsoft.com/office/drawing/2014/main" id="{E04CF2F4-23EF-4AFD-9DEE-8E477AA7A48D}"/>
               </a:ext>
             </a:extLst>
           </p:cNvPr>
@@ -6648,7 +6648,7 @@
           <p:cNvPr id="2" name="title">
             <a:extLst xmlns:a="http://schemas.openxmlformats.org/drawingml/2006/main">
               <a:ext uri="{FF2B5EF4-FFF2-40B4-BE49-F238E27FC236}">
-                <a16:creationId xmlns:a16="http://schemas.microsoft.com/office/drawing/2014/main" id="{DAC33222-70D8-4D48-B015-3504324E6768}"/>
+                <a16:creationId xmlns:a16="http://schemas.microsoft.com/office/drawing/2014/main" id="{656F5DA2-45FC-47CC-8CD2-AF332649C343}"/>
               </a:ext>
             </a:extLst>
           </p:cNvPr>
@@ -6705,7 +6705,7 @@
           <p:cNvPr id="3" name="body">
             <a:extLst xmlns:a="http://schemas.openxmlformats.org/drawingml/2006/main">
               <a:ext uri="{FF2B5EF4-FFF2-40B4-BE49-F238E27FC236}">
-                <a16:creationId xmlns:a16="http://schemas.microsoft.com/office/drawing/2014/main" id="{AB7B55F2-AB27-48B7-B0AC-33CB6B5FAC3A}"/>
+                <a16:creationId xmlns:a16="http://schemas.microsoft.com/office/drawing/2014/main" id="{207D109D-79CE-4C13-9964-3A10A3940467}"/>
               </a:ext>
             </a:extLst>
           </p:cNvPr>
@@ -6762,7 +6762,7 @@
           <p:cNvPr id="4" name="body">
             <a:extLst xmlns:a="http://schemas.openxmlformats.org/drawingml/2006/main">
               <a:ext uri="{FF2B5EF4-FFF2-40B4-BE49-F238E27FC236}">
-                <a16:creationId xmlns:a16="http://schemas.microsoft.com/office/drawing/2014/main" id="{42B29576-3CEF-4A08-B398-82D43805F198}"/>
+                <a16:creationId xmlns:a16="http://schemas.microsoft.com/office/drawing/2014/main" id="{01992A7D-259B-4838-80ED-02432628243C}"/>
               </a:ext>
             </a:extLst>
           </p:cNvPr>
@@ -6819,7 +6819,7 @@
           <p:cNvPr id="5" name="body">
             <a:extLst xmlns:a="http://schemas.openxmlformats.org/drawingml/2006/main">
               <a:ext uri="{FF2B5EF4-FFF2-40B4-BE49-F238E27FC236}">
-                <a16:creationId xmlns:a16="http://schemas.microsoft.com/office/drawing/2014/main" id="{4DB84FA3-C55B-45D5-AB7C-B0D7679F44BF}"/>
+                <a16:creationId xmlns:a16="http://schemas.microsoft.com/office/drawing/2014/main" id="{A56ABA1A-C64E-422A-B64E-CB7B52FC38CE}"/>
               </a:ext>
             </a:extLst>
           </p:cNvPr>
@@ -6876,7 +6876,7 @@
           <p:cNvPr id="6" name="body">
             <a:extLst xmlns:a="http://schemas.openxmlformats.org/drawingml/2006/main">
               <a:ext uri="{FF2B5EF4-FFF2-40B4-BE49-F238E27FC236}">
-                <a16:creationId xmlns:a16="http://schemas.microsoft.com/office/drawing/2014/main" id="{88FB6A36-DB48-41E7-945F-1D0ABC274D20}"/>
+                <a16:creationId xmlns:a16="http://schemas.microsoft.com/office/drawing/2014/main" id="{125C82C7-49C4-4DEC-8D49-03F6DCEC6B9B}"/>
               </a:ext>
             </a:extLst>
           </p:cNvPr>
@@ -6933,7 +6933,7 @@
           <p:cNvPr id="7" name="body">
             <a:extLst xmlns:a="http://schemas.openxmlformats.org/drawingml/2006/main">
               <a:ext uri="{FF2B5EF4-FFF2-40B4-BE49-F238E27FC236}">
-                <a16:creationId xmlns:a16="http://schemas.microsoft.com/office/drawing/2014/main" id="{2C6919DC-4ADA-49C4-9772-E918685DDA0B}"/>
+                <a16:creationId xmlns:a16="http://schemas.microsoft.com/office/drawing/2014/main" id="{DAFA035E-C818-495C-A56B-8F87FBF1EAC8}"/>
               </a:ext>
             </a:extLst>
           </p:cNvPr>
@@ -6990,7 +6990,7 @@
           <p:cNvPr id="8" name="body">
             <a:extLst xmlns:a="http://schemas.openxmlformats.org/drawingml/2006/main">
               <a:ext uri="{FF2B5EF4-FFF2-40B4-BE49-F238E27FC236}">
-                <a16:creationId xmlns:a16="http://schemas.microsoft.com/office/drawing/2014/main" id="{5900355B-BA57-4FB0-B55A-A95E57EAA593}"/>
+                <a16:creationId xmlns:a16="http://schemas.microsoft.com/office/drawing/2014/main" id="{DFA7A57C-8F51-4FFF-81BC-97D4B9A5BAD8}"/>
               </a:ext>
             </a:extLst>
           </p:cNvPr>
@@ -7051,7 +7051,7 @@
           <p:nvPr/>
         </p:nvPicPr>
         <p:blipFill>
-          <a:blip xmlns:r="http://schemas.openxmlformats.org/officeDocument/2006/relationships" xmlns:a="http://schemas.openxmlformats.org/drawingml/2006/main" r:embed="R66725395ba1941c4"/>
+          <a:blip xmlns:r="http://schemas.openxmlformats.org/officeDocument/2006/relationships" xmlns:a="http://schemas.openxmlformats.org/drawingml/2006/main" r:embed="Ra80ef90dba174194"/>
           <a:stretch xmlns:a="http://schemas.openxmlformats.org/drawingml/2006/main"/>
         </p:blipFill>
         <p:spPr>
@@ -7069,7 +7069,7 @@
           <p:cNvPr id="10" name="photo-caption">
             <a:extLst xmlns:a="http://schemas.openxmlformats.org/drawingml/2006/main">
               <a:ext uri="{FF2B5EF4-FFF2-40B4-BE49-F238E27FC236}">
-                <a16:creationId xmlns:a16="http://schemas.microsoft.com/office/drawing/2014/main" id="{2B59B2E0-9ACF-4901-9194-30B7B8FE63E2}"/>
+                <a16:creationId xmlns:a16="http://schemas.microsoft.com/office/drawing/2014/main" id="{0F315B1C-4CC6-4396-A3B7-818943FE7F0C}"/>
               </a:ext>
             </a:extLst>
           </p:cNvPr>
@@ -7126,7 +7126,7 @@
           <p:cNvPr id="11" name="page">
             <a:extLst xmlns:a="http://schemas.openxmlformats.org/drawingml/2006/main">
               <a:ext uri="{FF2B5EF4-FFF2-40B4-BE49-F238E27FC236}">
-                <a16:creationId xmlns:a16="http://schemas.microsoft.com/office/drawing/2014/main" id="{886BCB86-287E-4F9E-9E79-0B4EBDF4E635}"/>
+                <a16:creationId xmlns:a16="http://schemas.microsoft.com/office/drawing/2014/main" id="{D116355C-5A34-4AEE-B28B-139034CB1224}"/>
               </a:ext>
             </a:extLst>
           </p:cNvPr>
@@ -7181,7 +7181,7 @@
     </p:spTree>
     <p:extLst>
       <p:ext uri="{BB962C8B-B14F-4D97-AF65-F5344CB8AC3E}">
-        <p14:creationId xmlns:p14="http://schemas.microsoft.com/office/powerpoint/2010/main" val="1024838002"/>
+        <p14:creationId xmlns:p14="http://schemas.microsoft.com/office/powerpoint/2010/main" val="643998434"/>
       </p:ext>
     </p:extLst>
   </p:cSld>
@@ -7212,7 +7212,7 @@
           <p:cNvPr id="11" name="course">
             <a:extLst xmlns:a="http://schemas.openxmlformats.org/drawingml/2006/main">
               <a:ext uri="{FF2B5EF4-FFF2-40B4-BE49-F238E27FC236}">
-                <a16:creationId xmlns:a16="http://schemas.microsoft.com/office/drawing/2014/main" id="{864E90A0-1999-4207-8EA7-2884A58FC1D2}"/>
+                <a16:creationId xmlns:a16="http://schemas.microsoft.com/office/drawing/2014/main" id="{19A04E9B-F903-4480-AFD3-FDE8F09AF885}"/>
               </a:ext>
             </a:extLst>
           </p:cNvPr>
@@ -7269,7 +7269,7 @@
           <p:cNvPr id="2" name="title">
             <a:extLst xmlns:a="http://schemas.openxmlformats.org/drawingml/2006/main">
               <a:ext uri="{FF2B5EF4-FFF2-40B4-BE49-F238E27FC236}">
-                <a16:creationId xmlns:a16="http://schemas.microsoft.com/office/drawing/2014/main" id="{1867F78D-39D3-4121-9B04-0749A0133782}"/>
+                <a16:creationId xmlns:a16="http://schemas.microsoft.com/office/drawing/2014/main" id="{26F814E4-2EC9-4041-8339-EE6E2C5F74B1}"/>
               </a:ext>
             </a:extLst>
           </p:cNvPr>
@@ -7326,7 +7326,7 @@
           <p:cNvPr id="3" name="body">
             <a:extLst xmlns:a="http://schemas.openxmlformats.org/drawingml/2006/main">
               <a:ext uri="{FF2B5EF4-FFF2-40B4-BE49-F238E27FC236}">
-                <a16:creationId xmlns:a16="http://schemas.microsoft.com/office/drawing/2014/main" id="{4CAC1148-30D5-4D2A-9D10-66CA956E5859}"/>
+                <a16:creationId xmlns:a16="http://schemas.microsoft.com/office/drawing/2014/main" id="{9ED6C0CC-3213-4F7A-810F-7FDFF1ACC29C}"/>
               </a:ext>
             </a:extLst>
           </p:cNvPr>
@@ -7383,7 +7383,7 @@
           <p:cNvPr id="4" name="body">
             <a:extLst xmlns:a="http://schemas.openxmlformats.org/drawingml/2006/main">
               <a:ext uri="{FF2B5EF4-FFF2-40B4-BE49-F238E27FC236}">
-                <a16:creationId xmlns:a16="http://schemas.microsoft.com/office/drawing/2014/main" id="{7B041CE0-2317-4638-8976-B0D069464BAF}"/>
+                <a16:creationId xmlns:a16="http://schemas.microsoft.com/office/drawing/2014/main" id="{2FC872CA-1D22-4306-B0B5-B094142307E7}"/>
               </a:ext>
             </a:extLst>
           </p:cNvPr>
@@ -7440,7 +7440,7 @@
           <p:cNvPr id="5" name="body">
             <a:extLst xmlns:a="http://schemas.openxmlformats.org/drawingml/2006/main">
               <a:ext uri="{FF2B5EF4-FFF2-40B4-BE49-F238E27FC236}">
-                <a16:creationId xmlns:a16="http://schemas.microsoft.com/office/drawing/2014/main" id="{C75C16AA-5E3F-4C80-8A05-F29CF645F46C}"/>
+                <a16:creationId xmlns:a16="http://schemas.microsoft.com/office/drawing/2014/main" id="{2F54B281-B345-4E36-AFE4-F4880306B5C5}"/>
               </a:ext>
             </a:extLst>
           </p:cNvPr>
@@ -7497,7 +7497,7 @@
           <p:cNvPr id="6" name="body">
             <a:extLst xmlns:a="http://schemas.openxmlformats.org/drawingml/2006/main">
               <a:ext uri="{FF2B5EF4-FFF2-40B4-BE49-F238E27FC236}">
-                <a16:creationId xmlns:a16="http://schemas.microsoft.com/office/drawing/2014/main" id="{6AC3D6F1-D050-4CAA-B467-93E80CEB43FE}"/>
+                <a16:creationId xmlns:a16="http://schemas.microsoft.com/office/drawing/2014/main" id="{803D07C2-96D3-4DB1-9FCE-D132266F7F8B}"/>
               </a:ext>
             </a:extLst>
           </p:cNvPr>
@@ -7554,7 +7554,7 @@
           <p:cNvPr id="7" name="body">
             <a:extLst xmlns:a="http://schemas.openxmlformats.org/drawingml/2006/main">
               <a:ext uri="{FF2B5EF4-FFF2-40B4-BE49-F238E27FC236}">
-                <a16:creationId xmlns:a16="http://schemas.microsoft.com/office/drawing/2014/main" id="{78744E32-F78B-459C-8256-2603D768FBAE}"/>
+                <a16:creationId xmlns:a16="http://schemas.microsoft.com/office/drawing/2014/main" id="{8EB97DA9-334E-40CB-A70E-61312ED44E65}"/>
               </a:ext>
             </a:extLst>
           </p:cNvPr>
@@ -7611,7 +7611,7 @@
           <p:cNvPr id="8" name="body">
             <a:extLst xmlns:a="http://schemas.openxmlformats.org/drawingml/2006/main">
               <a:ext uri="{FF2B5EF4-FFF2-40B4-BE49-F238E27FC236}">
-                <a16:creationId xmlns:a16="http://schemas.microsoft.com/office/drawing/2014/main" id="{48474766-CFF9-4626-8890-63FC8FE0275E}"/>
+                <a16:creationId xmlns:a16="http://schemas.microsoft.com/office/drawing/2014/main" id="{069D78C0-F74F-4BA5-B0CF-117E7710DE9F}"/>
               </a:ext>
             </a:extLst>
           </p:cNvPr>
@@ -7668,7 +7668,7 @@
           <p:cNvPr id="9" name="footnote">
             <a:extLst xmlns:a="http://schemas.openxmlformats.org/drawingml/2006/main">
               <a:ext uri="{FF2B5EF4-FFF2-40B4-BE49-F238E27FC236}">
-                <a16:creationId xmlns:a16="http://schemas.microsoft.com/office/drawing/2014/main" id="{D4E05905-638E-4CBB-871E-A6E788C0D0E3}"/>
+                <a16:creationId xmlns:a16="http://schemas.microsoft.com/office/drawing/2014/main" id="{AC619AC2-8EAB-47F1-957C-38E9E50511BE}"/>
               </a:ext>
             </a:extLst>
           </p:cNvPr>
@@ -7725,7 +7725,7 @@
           <p:cNvPr id="10" name="page">
             <a:extLst xmlns:a="http://schemas.openxmlformats.org/drawingml/2006/main">
               <a:ext uri="{FF2B5EF4-FFF2-40B4-BE49-F238E27FC236}">
-                <a16:creationId xmlns:a16="http://schemas.microsoft.com/office/drawing/2014/main" id="{EBBB24D7-7738-4E04-B849-D57251E15C40}"/>
+                <a16:creationId xmlns:a16="http://schemas.microsoft.com/office/drawing/2014/main" id="{D88B2FEC-6AD2-4694-A88A-1199789D2314}"/>
               </a:ext>
             </a:extLst>
           </p:cNvPr>
@@ -7780,7 +7780,7 @@
     </p:spTree>
     <p:extLst>
       <p:ext uri="{BB962C8B-B14F-4D97-AF65-F5344CB8AC3E}">
-        <p14:creationId xmlns:p14="http://schemas.microsoft.com/office/powerpoint/2010/main" val="1987079059"/>
+        <p14:creationId xmlns:p14="http://schemas.microsoft.com/office/powerpoint/2010/main" val="818588037"/>
       </p:ext>
     </p:extLst>
   </p:cSld>
@@ -7811,7 +7811,7 @@
           <p:cNvPr id="12" name="course">
             <a:extLst xmlns:a="http://schemas.openxmlformats.org/drawingml/2006/main">
               <a:ext uri="{FF2B5EF4-FFF2-40B4-BE49-F238E27FC236}">
-                <a16:creationId xmlns:a16="http://schemas.microsoft.com/office/drawing/2014/main" id="{38A43B57-B7B0-41CA-AD48-35FA43073D5A}"/>
+                <a16:creationId xmlns:a16="http://schemas.microsoft.com/office/drawing/2014/main" id="{8C8629BE-5BE0-4783-878D-01D827B49955}"/>
               </a:ext>
             </a:extLst>
           </p:cNvPr>
@@ -7868,7 +7868,7 @@
           <p:cNvPr id="2" name="title">
             <a:extLst xmlns:a="http://schemas.openxmlformats.org/drawingml/2006/main">
               <a:ext uri="{FF2B5EF4-FFF2-40B4-BE49-F238E27FC236}">
-                <a16:creationId xmlns:a16="http://schemas.microsoft.com/office/drawing/2014/main" id="{DE29ACB8-8B59-44C9-9246-34DB16EBCBBA}"/>
+                <a16:creationId xmlns:a16="http://schemas.microsoft.com/office/drawing/2014/main" id="{8B70A69C-14EF-4EFD-B8C3-D2E8A0553F62}"/>
               </a:ext>
             </a:extLst>
           </p:cNvPr>
@@ -7925,7 +7925,7 @@
           <p:cNvPr id="3" name="body">
             <a:extLst xmlns:a="http://schemas.openxmlformats.org/drawingml/2006/main">
               <a:ext uri="{FF2B5EF4-FFF2-40B4-BE49-F238E27FC236}">
-                <a16:creationId xmlns:a16="http://schemas.microsoft.com/office/drawing/2014/main" id="{507DE227-C7B7-4814-A2CC-0D9DB412AA87}"/>
+                <a16:creationId xmlns:a16="http://schemas.microsoft.com/office/drawing/2014/main" id="{EEA25DE5-BBC7-4611-BC87-BBDBB3C6FF21}"/>
               </a:ext>
             </a:extLst>
           </p:cNvPr>
@@ -7982,7 +7982,7 @@
           <p:cNvPr id="4" name="body">
             <a:extLst xmlns:a="http://schemas.openxmlformats.org/drawingml/2006/main">
               <a:ext uri="{FF2B5EF4-FFF2-40B4-BE49-F238E27FC236}">
-                <a16:creationId xmlns:a16="http://schemas.microsoft.com/office/drawing/2014/main" id="{D8255457-890C-4E94-93DD-8912175DDB94}"/>
+                <a16:creationId xmlns:a16="http://schemas.microsoft.com/office/drawing/2014/main" id="{530AED8D-3C86-4833-9679-881DBD1A0119}"/>
               </a:ext>
             </a:extLst>
           </p:cNvPr>
@@ -8039,7 +8039,7 @@
           <p:cNvPr id="5" name="body">
             <a:extLst xmlns:a="http://schemas.openxmlformats.org/drawingml/2006/main">
               <a:ext uri="{FF2B5EF4-FFF2-40B4-BE49-F238E27FC236}">
-                <a16:creationId xmlns:a16="http://schemas.microsoft.com/office/drawing/2014/main" id="{71953045-147A-4A0E-90C5-3EB50420D047}"/>
+                <a16:creationId xmlns:a16="http://schemas.microsoft.com/office/drawing/2014/main" id="{27D236D9-E7DB-45BD-A8F9-A7442DC798F5}"/>
               </a:ext>
             </a:extLst>
           </p:cNvPr>
@@ -8096,7 +8096,7 @@
           <p:cNvPr id="6" name="body">
             <a:extLst xmlns:a="http://schemas.openxmlformats.org/drawingml/2006/main">
               <a:ext uri="{FF2B5EF4-FFF2-40B4-BE49-F238E27FC236}">
-                <a16:creationId xmlns:a16="http://schemas.microsoft.com/office/drawing/2014/main" id="{FE5CD20E-897F-4929-B9F7-04D35C064D64}"/>
+                <a16:creationId xmlns:a16="http://schemas.microsoft.com/office/drawing/2014/main" id="{0E0B9440-94DF-4F96-9697-A633D5D4F12C}"/>
               </a:ext>
             </a:extLst>
           </p:cNvPr>
@@ -8153,7 +8153,7 @@
           <p:cNvPr id="7" name="body">
             <a:extLst xmlns:a="http://schemas.openxmlformats.org/drawingml/2006/main">
               <a:ext uri="{FF2B5EF4-FFF2-40B4-BE49-F238E27FC236}">
-                <a16:creationId xmlns:a16="http://schemas.microsoft.com/office/drawing/2014/main" id="{CB718B8B-3138-4C76-8376-9B2D5ABC327E}"/>
+                <a16:creationId xmlns:a16="http://schemas.microsoft.com/office/drawing/2014/main" id="{1AD2B33E-DFFD-45B2-9140-EEBC5033EB36}"/>
               </a:ext>
             </a:extLst>
           </p:cNvPr>
@@ -8210,7 +8210,7 @@
           <p:cNvPr id="8" name="body">
             <a:extLst xmlns:a="http://schemas.openxmlformats.org/drawingml/2006/main">
               <a:ext uri="{FF2B5EF4-FFF2-40B4-BE49-F238E27FC236}">
-                <a16:creationId xmlns:a16="http://schemas.microsoft.com/office/drawing/2014/main" id="{0F5535CB-B221-476D-B6A3-19BC73336991}"/>
+                <a16:creationId xmlns:a16="http://schemas.microsoft.com/office/drawing/2014/main" id="{B1C65991-FCA3-49A6-B1FF-E81E9BB59586}"/>
               </a:ext>
             </a:extLst>
           </p:cNvPr>
@@ -8271,7 +8271,7 @@
           <p:nvPr/>
         </p:nvPicPr>
         <p:blipFill>
-          <a:blip xmlns:r="http://schemas.openxmlformats.org/officeDocument/2006/relationships" xmlns:a="http://schemas.openxmlformats.org/drawingml/2006/main" r:embed="R213ab82c00a64cad"/>
+          <a:blip xmlns:r="http://schemas.openxmlformats.org/officeDocument/2006/relationships" xmlns:a="http://schemas.openxmlformats.org/drawingml/2006/main" r:embed="R57f2d07817fe4515"/>
           <a:stretch xmlns:a="http://schemas.openxmlformats.org/drawingml/2006/main"/>
         </p:blipFill>
         <p:spPr>
@@ -8289,7 +8289,7 @@
           <p:cNvPr id="10" name="photo-caption">
             <a:extLst xmlns:a="http://schemas.openxmlformats.org/drawingml/2006/main">
               <a:ext uri="{FF2B5EF4-FFF2-40B4-BE49-F238E27FC236}">
-                <a16:creationId xmlns:a16="http://schemas.microsoft.com/office/drawing/2014/main" id="{384FF9F3-BBD2-445B-AE7B-8DC1CF777C02}"/>
+                <a16:creationId xmlns:a16="http://schemas.microsoft.com/office/drawing/2014/main" id="{6ABACC59-2CD8-4AD4-B355-85364CAB07E2}"/>
               </a:ext>
             </a:extLst>
           </p:cNvPr>
@@ -8346,7 +8346,7 @@
           <p:cNvPr id="11" name="page">
             <a:extLst xmlns:a="http://schemas.openxmlformats.org/drawingml/2006/main">
               <a:ext uri="{FF2B5EF4-FFF2-40B4-BE49-F238E27FC236}">
-                <a16:creationId xmlns:a16="http://schemas.microsoft.com/office/drawing/2014/main" id="{709F4F23-526A-4A47-80D9-7ABED733CA99}"/>
+                <a16:creationId xmlns:a16="http://schemas.microsoft.com/office/drawing/2014/main" id="{7DC53515-0D2B-41B2-A919-B03A57A5B658}"/>
               </a:ext>
             </a:extLst>
           </p:cNvPr>
@@ -8401,7 +8401,7 @@
     </p:spTree>
     <p:extLst>
       <p:ext uri="{BB962C8B-B14F-4D97-AF65-F5344CB8AC3E}">
-        <p14:creationId xmlns:p14="http://schemas.microsoft.com/office/powerpoint/2010/main" val="722137536"/>
+        <p14:creationId xmlns:p14="http://schemas.microsoft.com/office/powerpoint/2010/main" val="91336231"/>
       </p:ext>
     </p:extLst>
   </p:cSld>
@@ -8432,7 +8432,7 @@
           <p:cNvPr id="11" name="course">
             <a:extLst xmlns:a="http://schemas.openxmlformats.org/drawingml/2006/main">
               <a:ext uri="{FF2B5EF4-FFF2-40B4-BE49-F238E27FC236}">
-                <a16:creationId xmlns:a16="http://schemas.microsoft.com/office/drawing/2014/main" id="{F68DBA6E-22D0-4092-8FDF-EF00DE5ACBCD}"/>
+                <a16:creationId xmlns:a16="http://schemas.microsoft.com/office/drawing/2014/main" id="{ECEA512E-15BC-4DC3-A525-5730E49FEA60}"/>
               </a:ext>
             </a:extLst>
           </p:cNvPr>
@@ -8489,7 +8489,7 @@
           <p:cNvPr id="2" name="title">
             <a:extLst xmlns:a="http://schemas.openxmlformats.org/drawingml/2006/main">
               <a:ext uri="{FF2B5EF4-FFF2-40B4-BE49-F238E27FC236}">
-                <a16:creationId xmlns:a16="http://schemas.microsoft.com/office/drawing/2014/main" id="{4311241A-8AAC-4A94-AB82-82939D8D26B0}"/>
+                <a16:creationId xmlns:a16="http://schemas.microsoft.com/office/drawing/2014/main" id="{23AE65E0-87EF-4539-A67D-DBF0E4F58CC6}"/>
               </a:ext>
             </a:extLst>
           </p:cNvPr>
@@ -8546,7 +8546,7 @@
           <p:cNvPr id="3" name="body">
             <a:extLst xmlns:a="http://schemas.openxmlformats.org/drawingml/2006/main">
               <a:ext uri="{FF2B5EF4-FFF2-40B4-BE49-F238E27FC236}">
-                <a16:creationId xmlns:a16="http://schemas.microsoft.com/office/drawing/2014/main" id="{A0B3178D-FDD8-4653-8FA3-A09933A26A1D}"/>
+                <a16:creationId xmlns:a16="http://schemas.microsoft.com/office/drawing/2014/main" id="{A25C24CA-39D0-492A-A20D-A75934A45D51}"/>
               </a:ext>
             </a:extLst>
           </p:cNvPr>
@@ -8603,7 +8603,7 @@
           <p:cNvPr id="4" name="body">
             <a:extLst xmlns:a="http://schemas.openxmlformats.org/drawingml/2006/main">
               <a:ext uri="{FF2B5EF4-FFF2-40B4-BE49-F238E27FC236}">
-                <a16:creationId xmlns:a16="http://schemas.microsoft.com/office/drawing/2014/main" id="{FF3BDB11-6A67-4F69-9C58-7A0150E367F1}"/>
+                <a16:creationId xmlns:a16="http://schemas.microsoft.com/office/drawing/2014/main" id="{8F422C07-9952-472A-964B-B29A3F66852F}"/>
               </a:ext>
             </a:extLst>
           </p:cNvPr>
@@ -8660,7 +8660,7 @@
           <p:cNvPr id="5" name="body">
             <a:extLst xmlns:a="http://schemas.openxmlformats.org/drawingml/2006/main">
               <a:ext uri="{FF2B5EF4-FFF2-40B4-BE49-F238E27FC236}">
-                <a16:creationId xmlns:a16="http://schemas.microsoft.com/office/drawing/2014/main" id="{26B5821C-6F9C-49DA-880B-C2F1DCC55ADC}"/>
+                <a16:creationId xmlns:a16="http://schemas.microsoft.com/office/drawing/2014/main" id="{07D71BA2-21AB-4816-9BA3-251513716060}"/>
               </a:ext>
             </a:extLst>
           </p:cNvPr>
@@ -8717,7 +8717,7 @@
           <p:cNvPr id="6" name="body">
             <a:extLst xmlns:a="http://schemas.openxmlformats.org/drawingml/2006/main">
               <a:ext uri="{FF2B5EF4-FFF2-40B4-BE49-F238E27FC236}">
-                <a16:creationId xmlns:a16="http://schemas.microsoft.com/office/drawing/2014/main" id="{926F7F11-E73A-4D71-AFDB-DCF379D28938}"/>
+                <a16:creationId xmlns:a16="http://schemas.microsoft.com/office/drawing/2014/main" id="{1098BCDD-4021-4B6B-B93E-BFBA40369B00}"/>
               </a:ext>
             </a:extLst>
           </p:cNvPr>
@@ -8774,7 +8774,7 @@
           <p:cNvPr id="7" name="body">
             <a:extLst xmlns:a="http://schemas.openxmlformats.org/drawingml/2006/main">
               <a:ext uri="{FF2B5EF4-FFF2-40B4-BE49-F238E27FC236}">
-                <a16:creationId xmlns:a16="http://schemas.microsoft.com/office/drawing/2014/main" id="{CFB2BC2F-159B-4140-B280-7FBAC31815DE}"/>
+                <a16:creationId xmlns:a16="http://schemas.microsoft.com/office/drawing/2014/main" id="{0B1EDEF4-F518-4757-92A0-0CF8E0F64FBC}"/>
               </a:ext>
             </a:extLst>
           </p:cNvPr>
@@ -8831,7 +8831,7 @@
           <p:cNvPr id="8" name="body">
             <a:extLst xmlns:a="http://schemas.openxmlformats.org/drawingml/2006/main">
               <a:ext uri="{FF2B5EF4-FFF2-40B4-BE49-F238E27FC236}">
-                <a16:creationId xmlns:a16="http://schemas.microsoft.com/office/drawing/2014/main" id="{2D188676-7F1A-40E3-A991-EA1BE253F381}"/>
+                <a16:creationId xmlns:a16="http://schemas.microsoft.com/office/drawing/2014/main" id="{CA4753C4-98B9-4AA2-972E-A8F54FF3B993}"/>
               </a:ext>
             </a:extLst>
           </p:cNvPr>
@@ -8888,7 +8888,7 @@
           <p:cNvPr id="9" name="footnote">
             <a:extLst xmlns:a="http://schemas.openxmlformats.org/drawingml/2006/main">
               <a:ext uri="{FF2B5EF4-FFF2-40B4-BE49-F238E27FC236}">
-                <a16:creationId xmlns:a16="http://schemas.microsoft.com/office/drawing/2014/main" id="{5B724F05-967E-442F-A14E-6957053D50D6}"/>
+                <a16:creationId xmlns:a16="http://schemas.microsoft.com/office/drawing/2014/main" id="{CEC799EF-B6E1-46F4-AFBB-BA0451F4CAD1}"/>
               </a:ext>
             </a:extLst>
           </p:cNvPr>
@@ -8945,7 +8945,7 @@
           <p:cNvPr id="10" name="page">
             <a:extLst xmlns:a="http://schemas.openxmlformats.org/drawingml/2006/main">
               <a:ext uri="{FF2B5EF4-FFF2-40B4-BE49-F238E27FC236}">
-                <a16:creationId xmlns:a16="http://schemas.microsoft.com/office/drawing/2014/main" id="{49C92C9D-349F-4BEC-B9B8-9A8282E32FD3}"/>
+                <a16:creationId xmlns:a16="http://schemas.microsoft.com/office/drawing/2014/main" id="{50209702-63A1-497C-B053-7F43F4010926}"/>
               </a:ext>
             </a:extLst>
           </p:cNvPr>
@@ -9000,7 +9000,7 @@
     </p:spTree>
     <p:extLst>
       <p:ext uri="{BB962C8B-B14F-4D97-AF65-F5344CB8AC3E}">
-        <p14:creationId xmlns:p14="http://schemas.microsoft.com/office/powerpoint/2010/main" val="1699624303"/>
+        <p14:creationId xmlns:p14="http://schemas.microsoft.com/office/powerpoint/2010/main" val="1296951281"/>
       </p:ext>
     </p:extLst>
   </p:cSld>
@@ -9031,7 +9031,7 @@
           <p:cNvPr id="12" name="course">
             <a:extLst xmlns:a="http://schemas.openxmlformats.org/drawingml/2006/main">
               <a:ext uri="{FF2B5EF4-FFF2-40B4-BE49-F238E27FC236}">
-                <a16:creationId xmlns:a16="http://schemas.microsoft.com/office/drawing/2014/main" id="{EB475F75-3C3A-44B9-91D6-2709CEACBD20}"/>
+                <a16:creationId xmlns:a16="http://schemas.microsoft.com/office/drawing/2014/main" id="{E69FBF41-C235-4F49-94E1-31BC30495C3D}"/>
               </a:ext>
             </a:extLst>
           </p:cNvPr>
@@ -9088,7 +9088,7 @@
           <p:cNvPr id="2" name="title">
             <a:extLst xmlns:a="http://schemas.openxmlformats.org/drawingml/2006/main">
               <a:ext uri="{FF2B5EF4-FFF2-40B4-BE49-F238E27FC236}">
-                <a16:creationId xmlns:a16="http://schemas.microsoft.com/office/drawing/2014/main" id="{68189376-F6DA-4FC7-9436-E2B9FB3C40AA}"/>
+                <a16:creationId xmlns:a16="http://schemas.microsoft.com/office/drawing/2014/main" id="{980F3BA9-4310-4393-8400-9AB85836E0C7}"/>
               </a:ext>
             </a:extLst>
           </p:cNvPr>
@@ -9145,7 +9145,7 @@
           <p:cNvPr id="3" name="body">
             <a:extLst xmlns:a="http://schemas.openxmlformats.org/drawingml/2006/main">
               <a:ext uri="{FF2B5EF4-FFF2-40B4-BE49-F238E27FC236}">
-                <a16:creationId xmlns:a16="http://schemas.microsoft.com/office/drawing/2014/main" id="{9911466B-20AD-4F3D-8247-5DD1F93A4495}"/>
+                <a16:creationId xmlns:a16="http://schemas.microsoft.com/office/drawing/2014/main" id="{B356DB49-36F4-4462-9286-34AF0A900AFB}"/>
               </a:ext>
             </a:extLst>
           </p:cNvPr>
@@ -9202,7 +9202,7 @@
           <p:cNvPr id="4" name="body">
             <a:extLst xmlns:a="http://schemas.openxmlformats.org/drawingml/2006/main">
               <a:ext uri="{FF2B5EF4-FFF2-40B4-BE49-F238E27FC236}">
-                <a16:creationId xmlns:a16="http://schemas.microsoft.com/office/drawing/2014/main" id="{20359AC6-D8E0-4027-BD7F-B3DD1B82159E}"/>
+                <a16:creationId xmlns:a16="http://schemas.microsoft.com/office/drawing/2014/main" id="{CE4DEF4A-B6A7-4CF2-9EBA-9042E2686330}"/>
               </a:ext>
             </a:extLst>
           </p:cNvPr>
@@ -9259,7 +9259,7 @@
           <p:cNvPr id="5" name="body">
             <a:extLst xmlns:a="http://schemas.openxmlformats.org/drawingml/2006/main">
               <a:ext uri="{FF2B5EF4-FFF2-40B4-BE49-F238E27FC236}">
-                <a16:creationId xmlns:a16="http://schemas.microsoft.com/office/drawing/2014/main" id="{D0ABB051-9E3E-4DA2-9754-490B023704FC}"/>
+                <a16:creationId xmlns:a16="http://schemas.microsoft.com/office/drawing/2014/main" id="{E53903D5-AA70-4F4D-9C9F-CCA007E4E8F7}"/>
               </a:ext>
             </a:extLst>
           </p:cNvPr>
@@ -9316,7 +9316,7 @@
           <p:cNvPr id="6" name="body">
             <a:extLst xmlns:a="http://schemas.openxmlformats.org/drawingml/2006/main">
               <a:ext uri="{FF2B5EF4-FFF2-40B4-BE49-F238E27FC236}">
-                <a16:creationId xmlns:a16="http://schemas.microsoft.com/office/drawing/2014/main" id="{BF4B4D89-D886-40A5-B036-4B7E61543F7C}"/>
+                <a16:creationId xmlns:a16="http://schemas.microsoft.com/office/drawing/2014/main" id="{00B40D4B-9C06-41E8-AE39-A65B10344A5E}"/>
               </a:ext>
             </a:extLst>
           </p:cNvPr>
@@ -9373,7 +9373,7 @@
           <p:cNvPr id="7" name="body">
             <a:extLst xmlns:a="http://schemas.openxmlformats.org/drawingml/2006/main">
               <a:ext uri="{FF2B5EF4-FFF2-40B4-BE49-F238E27FC236}">
-                <a16:creationId xmlns:a16="http://schemas.microsoft.com/office/drawing/2014/main" id="{6F87C4A2-98C4-437F-9BDD-D5FBBD312187}"/>
+                <a16:creationId xmlns:a16="http://schemas.microsoft.com/office/drawing/2014/main" id="{7037534B-0B32-4947-A499-5F5996622250}"/>
               </a:ext>
             </a:extLst>
           </p:cNvPr>
@@ -9430,7 +9430,7 @@
           <p:cNvPr id="8" name="body">
             <a:extLst xmlns:a="http://schemas.openxmlformats.org/drawingml/2006/main">
               <a:ext uri="{FF2B5EF4-FFF2-40B4-BE49-F238E27FC236}">
-                <a16:creationId xmlns:a16="http://schemas.microsoft.com/office/drawing/2014/main" id="{0FE4189E-0D72-41C5-A6BF-7D8687B3F936}"/>
+                <a16:creationId xmlns:a16="http://schemas.microsoft.com/office/drawing/2014/main" id="{9125FF2D-7627-4049-884A-74FAFD6FB2E8}"/>
               </a:ext>
             </a:extLst>
           </p:cNvPr>
@@ -9491,7 +9491,7 @@
           <p:nvPr/>
         </p:nvPicPr>
         <p:blipFill>
-          <a:blip xmlns:r="http://schemas.openxmlformats.org/officeDocument/2006/relationships" xmlns:a="http://schemas.openxmlformats.org/drawingml/2006/main" r:embed="Raf69a9acf40d4f10"/>
+          <a:blip xmlns:r="http://schemas.openxmlformats.org/officeDocument/2006/relationships" xmlns:a="http://schemas.openxmlformats.org/drawingml/2006/main" r:embed="R8c9d29e172794d20"/>
           <a:stretch xmlns:a="http://schemas.openxmlformats.org/drawingml/2006/main"/>
         </p:blipFill>
         <p:spPr>
@@ -9509,7 +9509,7 @@
           <p:cNvPr id="10" name="photo-caption">
             <a:extLst xmlns:a="http://schemas.openxmlformats.org/drawingml/2006/main">
               <a:ext uri="{FF2B5EF4-FFF2-40B4-BE49-F238E27FC236}">
-                <a16:creationId xmlns:a16="http://schemas.microsoft.com/office/drawing/2014/main" id="{39870E92-3F9E-46D5-983B-4470E0496B9F}"/>
+                <a16:creationId xmlns:a16="http://schemas.microsoft.com/office/drawing/2014/main" id="{62E651B5-FBD8-4FF6-A513-85FE5D93CD4D}"/>
               </a:ext>
             </a:extLst>
           </p:cNvPr>
@@ -9566,7 +9566,7 @@
           <p:cNvPr id="11" name="page">
             <a:extLst xmlns:a="http://schemas.openxmlformats.org/drawingml/2006/main">
               <a:ext uri="{FF2B5EF4-FFF2-40B4-BE49-F238E27FC236}">
-                <a16:creationId xmlns:a16="http://schemas.microsoft.com/office/drawing/2014/main" id="{849FCEF8-FDD9-4C9B-A2BC-14C2B7D97608}"/>
+                <a16:creationId xmlns:a16="http://schemas.microsoft.com/office/drawing/2014/main" id="{88702144-E22B-481E-B42C-F4BB6CBEAB96}"/>
               </a:ext>
             </a:extLst>
           </p:cNvPr>
@@ -9621,7 +9621,7 @@
     </p:spTree>
     <p:extLst>
       <p:ext uri="{BB962C8B-B14F-4D97-AF65-F5344CB8AC3E}">
-        <p14:creationId xmlns:p14="http://schemas.microsoft.com/office/powerpoint/2010/main" val="601731290"/>
+        <p14:creationId xmlns:p14="http://schemas.microsoft.com/office/powerpoint/2010/main" val="1980339067"/>
       </p:ext>
     </p:extLst>
   </p:cSld>
@@ -9652,7 +9652,7 @@
           <p:cNvPr id="11" name="course">
             <a:extLst xmlns:a="http://schemas.openxmlformats.org/drawingml/2006/main">
               <a:ext uri="{FF2B5EF4-FFF2-40B4-BE49-F238E27FC236}">
-                <a16:creationId xmlns:a16="http://schemas.microsoft.com/office/drawing/2014/main" id="{A0455AC4-DFD2-45C5-9FB9-2DF3261277F4}"/>
+                <a16:creationId xmlns:a16="http://schemas.microsoft.com/office/drawing/2014/main" id="{324D3244-3288-43FF-87B3-10C43BC04E64}"/>
               </a:ext>
             </a:extLst>
           </p:cNvPr>
@@ -9709,7 +9709,7 @@
           <p:cNvPr id="2" name="title">
             <a:extLst xmlns:a="http://schemas.openxmlformats.org/drawingml/2006/main">
               <a:ext uri="{FF2B5EF4-FFF2-40B4-BE49-F238E27FC236}">
-                <a16:creationId xmlns:a16="http://schemas.microsoft.com/office/drawing/2014/main" id="{17737C00-A282-4B06-AFEF-1237E5E68CA1}"/>
+                <a16:creationId xmlns:a16="http://schemas.microsoft.com/office/drawing/2014/main" id="{88AD8FA1-6EC5-41E2-AE9A-B3B297855613}"/>
               </a:ext>
             </a:extLst>
           </p:cNvPr>
@@ -9766,7 +9766,7 @@
           <p:cNvPr id="3" name="body">
             <a:extLst xmlns:a="http://schemas.openxmlformats.org/drawingml/2006/main">
               <a:ext uri="{FF2B5EF4-FFF2-40B4-BE49-F238E27FC236}">
-                <a16:creationId xmlns:a16="http://schemas.microsoft.com/office/drawing/2014/main" id="{0A6AB1D5-720D-4C37-88D5-FF4BA5D68C19}"/>
+                <a16:creationId xmlns:a16="http://schemas.microsoft.com/office/drawing/2014/main" id="{92C43604-B5BC-49DF-8524-73507E96F539}"/>
               </a:ext>
             </a:extLst>
           </p:cNvPr>
@@ -9823,7 +9823,7 @@
           <p:cNvPr id="4" name="body">
             <a:extLst xmlns:a="http://schemas.openxmlformats.org/drawingml/2006/main">
               <a:ext uri="{FF2B5EF4-FFF2-40B4-BE49-F238E27FC236}">
-                <a16:creationId xmlns:a16="http://schemas.microsoft.com/office/drawing/2014/main" id="{0E505F9E-3233-474F-8A1C-CEB57CA94FE8}"/>
+                <a16:creationId xmlns:a16="http://schemas.microsoft.com/office/drawing/2014/main" id="{3902E9F4-A890-4830-B42C-90269C5CAEB8}"/>
               </a:ext>
             </a:extLst>
           </p:cNvPr>
@@ -9880,7 +9880,7 @@
           <p:cNvPr id="5" name="body">
             <a:extLst xmlns:a="http://schemas.openxmlformats.org/drawingml/2006/main">
               <a:ext uri="{FF2B5EF4-FFF2-40B4-BE49-F238E27FC236}">
-                <a16:creationId xmlns:a16="http://schemas.microsoft.com/office/drawing/2014/main" id="{B1D06538-557C-4A17-8EA1-53E8BB32493E}"/>
+                <a16:creationId xmlns:a16="http://schemas.microsoft.com/office/drawing/2014/main" id="{9DEEE5FA-1A7A-4DC5-B54F-9BB93CC751B0}"/>
               </a:ext>
             </a:extLst>
           </p:cNvPr>
@@ -9937,7 +9937,7 @@
           <p:cNvPr id="6" name="body">
             <a:extLst xmlns:a="http://schemas.openxmlformats.org/drawingml/2006/main">
               <a:ext uri="{FF2B5EF4-FFF2-40B4-BE49-F238E27FC236}">
-                <a16:creationId xmlns:a16="http://schemas.microsoft.com/office/drawing/2014/main" id="{9596EF09-A864-433E-9EF2-4D4C7720473A}"/>
+                <a16:creationId xmlns:a16="http://schemas.microsoft.com/office/drawing/2014/main" id="{8702BEF2-1F24-4A2B-9706-8E1BA969BD09}"/>
               </a:ext>
             </a:extLst>
           </p:cNvPr>
@@ -9994,7 +9994,7 @@
           <p:cNvPr id="7" name="body">
             <a:extLst xmlns:a="http://schemas.openxmlformats.org/drawingml/2006/main">
               <a:ext uri="{FF2B5EF4-FFF2-40B4-BE49-F238E27FC236}">
-                <a16:creationId xmlns:a16="http://schemas.microsoft.com/office/drawing/2014/main" id="{C8683452-94D3-41B0-8F91-6D8FDBC46AF4}"/>
+                <a16:creationId xmlns:a16="http://schemas.microsoft.com/office/drawing/2014/main" id="{2E94EB84-2FE2-4E1E-B4D2-CB837D77D3F8}"/>
               </a:ext>
             </a:extLst>
           </p:cNvPr>
@@ -10051,7 +10051,7 @@
           <p:cNvPr id="8" name="body">
             <a:extLst xmlns:a="http://schemas.openxmlformats.org/drawingml/2006/main">
               <a:ext uri="{FF2B5EF4-FFF2-40B4-BE49-F238E27FC236}">
-                <a16:creationId xmlns:a16="http://schemas.microsoft.com/office/drawing/2014/main" id="{018DED83-A9F0-4B64-A621-439C2A39B43F}"/>
+                <a16:creationId xmlns:a16="http://schemas.microsoft.com/office/drawing/2014/main" id="{E72453B1-713E-4B95-8B27-E11E00212FD0}"/>
               </a:ext>
             </a:extLst>
           </p:cNvPr>
@@ -10108,7 +10108,7 @@
           <p:cNvPr id="9" name="footnote">
             <a:extLst xmlns:a="http://schemas.openxmlformats.org/drawingml/2006/main">
               <a:ext uri="{FF2B5EF4-FFF2-40B4-BE49-F238E27FC236}">
-                <a16:creationId xmlns:a16="http://schemas.microsoft.com/office/drawing/2014/main" id="{97C49BE8-851C-4F48-A433-04DB6A4257C2}"/>
+                <a16:creationId xmlns:a16="http://schemas.microsoft.com/office/drawing/2014/main" id="{56F9E247-4C70-48F5-B29E-F882827F4761}"/>
               </a:ext>
             </a:extLst>
           </p:cNvPr>
@@ -10165,7 +10165,7 @@
           <p:cNvPr id="10" name="page">
             <a:extLst xmlns:a="http://schemas.openxmlformats.org/drawingml/2006/main">
               <a:ext uri="{FF2B5EF4-FFF2-40B4-BE49-F238E27FC236}">
-                <a16:creationId xmlns:a16="http://schemas.microsoft.com/office/drawing/2014/main" id="{1FD3F986-52FE-4969-9790-6E15AFA4698A}"/>
+                <a16:creationId xmlns:a16="http://schemas.microsoft.com/office/drawing/2014/main" id="{C497AE5D-2F97-4F4E-A718-C7141EFDE43B}"/>
               </a:ext>
             </a:extLst>
           </p:cNvPr>
@@ -10220,7 +10220,7 @@
     </p:spTree>
     <p:extLst>
       <p:ext uri="{BB962C8B-B14F-4D97-AF65-F5344CB8AC3E}">
-        <p14:creationId xmlns:p14="http://schemas.microsoft.com/office/powerpoint/2010/main" val="332716202"/>
+        <p14:creationId xmlns:p14="http://schemas.microsoft.com/office/powerpoint/2010/main" val="1203418105"/>
       </p:ext>
     </p:extLst>
   </p:cSld>
@@ -10251,7 +10251,7 @@
           <p:cNvPr id="12" name="course">
             <a:extLst xmlns:a="http://schemas.openxmlformats.org/drawingml/2006/main">
               <a:ext uri="{FF2B5EF4-FFF2-40B4-BE49-F238E27FC236}">
-                <a16:creationId xmlns:a16="http://schemas.microsoft.com/office/drawing/2014/main" id="{D45F46E8-76D0-4707-BA6E-6A16BDE4EC2D}"/>
+                <a16:creationId xmlns:a16="http://schemas.microsoft.com/office/drawing/2014/main" id="{14D8D168-3395-4323-B896-F1E950D214E2}"/>
               </a:ext>
             </a:extLst>
           </p:cNvPr>
@@ -10308,7 +10308,7 @@
           <p:cNvPr id="2" name="title">
             <a:extLst xmlns:a="http://schemas.openxmlformats.org/drawingml/2006/main">
               <a:ext uri="{FF2B5EF4-FFF2-40B4-BE49-F238E27FC236}">
-                <a16:creationId xmlns:a16="http://schemas.microsoft.com/office/drawing/2014/main" id="{C9E6BA24-329F-40B5-ACC0-BE7F30254EF5}"/>
+                <a16:creationId xmlns:a16="http://schemas.microsoft.com/office/drawing/2014/main" id="{68217066-B6A2-401D-A5DE-7F551CC5097C}"/>
               </a:ext>
             </a:extLst>
           </p:cNvPr>
@@ -10365,7 +10365,7 @@
           <p:cNvPr id="3" name="body">
             <a:extLst xmlns:a="http://schemas.openxmlformats.org/drawingml/2006/main">
               <a:ext uri="{FF2B5EF4-FFF2-40B4-BE49-F238E27FC236}">
-                <a16:creationId xmlns:a16="http://schemas.microsoft.com/office/drawing/2014/main" id="{7DD52812-D50E-44D5-BB70-30D5F90963EA}"/>
+                <a16:creationId xmlns:a16="http://schemas.microsoft.com/office/drawing/2014/main" id="{E9299BF3-A922-46DF-B9BE-2618736B54B1}"/>
               </a:ext>
             </a:extLst>
           </p:cNvPr>
@@ -10422,7 +10422,7 @@
           <p:cNvPr id="4" name="body">
             <a:extLst xmlns:a="http://schemas.openxmlformats.org/drawingml/2006/main">
               <a:ext uri="{FF2B5EF4-FFF2-40B4-BE49-F238E27FC236}">
-                <a16:creationId xmlns:a16="http://schemas.microsoft.com/office/drawing/2014/main" id="{236F1AB5-8265-4386-B374-BF5A217643C0}"/>
+                <a16:creationId xmlns:a16="http://schemas.microsoft.com/office/drawing/2014/main" id="{E83F0D24-3279-4D18-81AD-72AC72DE58E1}"/>
               </a:ext>
             </a:extLst>
           </p:cNvPr>
@@ -10479,7 +10479,7 @@
           <p:cNvPr id="5" name="body">
             <a:extLst xmlns:a="http://schemas.openxmlformats.org/drawingml/2006/main">
               <a:ext uri="{FF2B5EF4-FFF2-40B4-BE49-F238E27FC236}">
-                <a16:creationId xmlns:a16="http://schemas.microsoft.com/office/drawing/2014/main" id="{B9C6D797-79FB-4A8B-B83A-88EECFE370C1}"/>
+                <a16:creationId xmlns:a16="http://schemas.microsoft.com/office/drawing/2014/main" id="{2DE02B47-AF9F-4510-A7D7-F99F3FFFC9ED}"/>
               </a:ext>
             </a:extLst>
           </p:cNvPr>
@@ -10536,7 +10536,7 @@
           <p:cNvPr id="6" name="body">
             <a:extLst xmlns:a="http://schemas.openxmlformats.org/drawingml/2006/main">
               <a:ext uri="{FF2B5EF4-FFF2-40B4-BE49-F238E27FC236}">
-                <a16:creationId xmlns:a16="http://schemas.microsoft.com/office/drawing/2014/main" id="{8DAF1674-05D2-45F0-A0C7-F0FB337EE2FC}"/>
+                <a16:creationId xmlns:a16="http://schemas.microsoft.com/office/drawing/2014/main" id="{828912EB-C749-4BE1-8CCE-5E69EC01C546}"/>
               </a:ext>
             </a:extLst>
           </p:cNvPr>
@@ -10593,7 +10593,7 @@
           <p:cNvPr id="7" name="body">
             <a:extLst xmlns:a="http://schemas.openxmlformats.org/drawingml/2006/main">
               <a:ext uri="{FF2B5EF4-FFF2-40B4-BE49-F238E27FC236}">
-                <a16:creationId xmlns:a16="http://schemas.microsoft.com/office/drawing/2014/main" id="{033F1DE2-669C-4EE0-AE0D-90B1F82E6CDA}"/>
+                <a16:creationId xmlns:a16="http://schemas.microsoft.com/office/drawing/2014/main" id="{9EFA7D3D-1C10-41EC-AF5E-F64CC5C7D035}"/>
               </a:ext>
             </a:extLst>
           </p:cNvPr>
@@ -10650,7 +10650,7 @@
           <p:cNvPr id="8" name="body">
             <a:extLst xmlns:a="http://schemas.openxmlformats.org/drawingml/2006/main">
               <a:ext uri="{FF2B5EF4-FFF2-40B4-BE49-F238E27FC236}">
-                <a16:creationId xmlns:a16="http://schemas.microsoft.com/office/drawing/2014/main" id="{681753E9-475F-4A74-B8CE-76CB67FD91A4}"/>
+                <a16:creationId xmlns:a16="http://schemas.microsoft.com/office/drawing/2014/main" id="{EC076EF0-419C-458D-8AE6-B269A42D900D}"/>
               </a:ext>
             </a:extLst>
           </p:cNvPr>
@@ -10711,7 +10711,7 @@
           <p:nvPr/>
         </p:nvPicPr>
         <p:blipFill>
-          <a:blip xmlns:r="http://schemas.openxmlformats.org/officeDocument/2006/relationships" xmlns:a="http://schemas.openxmlformats.org/drawingml/2006/main" r:embed="Rbecb0813134e4287"/>
+          <a:blip xmlns:r="http://schemas.openxmlformats.org/officeDocument/2006/relationships" xmlns:a="http://schemas.openxmlformats.org/drawingml/2006/main" r:embed="R2aa7023a0fc946b0"/>
           <a:stretch xmlns:a="http://schemas.openxmlformats.org/drawingml/2006/main"/>
         </p:blipFill>
         <p:spPr>
@@ -10729,7 +10729,7 @@
           <p:cNvPr id="10" name="photo-caption">
             <a:extLst xmlns:a="http://schemas.openxmlformats.org/drawingml/2006/main">
               <a:ext uri="{FF2B5EF4-FFF2-40B4-BE49-F238E27FC236}">
-                <a16:creationId xmlns:a16="http://schemas.microsoft.com/office/drawing/2014/main" id="{57692567-4C00-4600-B0DD-A644CF466470}"/>
+                <a16:creationId xmlns:a16="http://schemas.microsoft.com/office/drawing/2014/main" id="{6EBB6168-CF49-4E45-9739-F9272D9388FF}"/>
               </a:ext>
             </a:extLst>
           </p:cNvPr>
@@ -10786,7 +10786,7 @@
           <p:cNvPr id="11" name="page">
             <a:extLst xmlns:a="http://schemas.openxmlformats.org/drawingml/2006/main">
               <a:ext uri="{FF2B5EF4-FFF2-40B4-BE49-F238E27FC236}">
-                <a16:creationId xmlns:a16="http://schemas.microsoft.com/office/drawing/2014/main" id="{6CF5DBD2-72ED-4502-A2DE-1A56DB6B6DE3}"/>
+                <a16:creationId xmlns:a16="http://schemas.microsoft.com/office/drawing/2014/main" id="{84AF543F-FFDC-468F-A895-1F41B86D5233}"/>
               </a:ext>
             </a:extLst>
           </p:cNvPr>
@@ -10841,7 +10841,7 @@
     </p:spTree>
     <p:extLst>
       <p:ext uri="{BB962C8B-B14F-4D97-AF65-F5344CB8AC3E}">
-        <p14:creationId xmlns:p14="http://schemas.microsoft.com/office/powerpoint/2010/main" val="878221832"/>
+        <p14:creationId xmlns:p14="http://schemas.microsoft.com/office/powerpoint/2010/main" val="570956071"/>
       </p:ext>
     </p:extLst>
   </p:cSld>
@@ -10872,7 +10872,7 @@
           <p:cNvPr id="11" name="course">
             <a:extLst xmlns:a="http://schemas.openxmlformats.org/drawingml/2006/main">
               <a:ext uri="{FF2B5EF4-FFF2-40B4-BE49-F238E27FC236}">
-                <a16:creationId xmlns:a16="http://schemas.microsoft.com/office/drawing/2014/main" id="{06CC2EE1-428C-4AF8-B591-F5713A8FD648}"/>
+                <a16:creationId xmlns:a16="http://schemas.microsoft.com/office/drawing/2014/main" id="{879A1377-58EA-4A73-B438-DC17CC91D489}"/>
               </a:ext>
             </a:extLst>
           </p:cNvPr>
@@ -10929,7 +10929,7 @@
           <p:cNvPr id="2" name="title">
             <a:extLst xmlns:a="http://schemas.openxmlformats.org/drawingml/2006/main">
               <a:ext uri="{FF2B5EF4-FFF2-40B4-BE49-F238E27FC236}">
-                <a16:creationId xmlns:a16="http://schemas.microsoft.com/office/drawing/2014/main" id="{C348F943-4D5F-46F9-B731-B99E52637F1F}"/>
+                <a16:creationId xmlns:a16="http://schemas.microsoft.com/office/drawing/2014/main" id="{2D01DD11-D2AC-4406-8D1B-FD23F9BABEA3}"/>
               </a:ext>
             </a:extLst>
           </p:cNvPr>
@@ -10986,7 +10986,7 @@
           <p:cNvPr id="3" name="body">
             <a:extLst xmlns:a="http://schemas.openxmlformats.org/drawingml/2006/main">
               <a:ext uri="{FF2B5EF4-FFF2-40B4-BE49-F238E27FC236}">
-                <a16:creationId xmlns:a16="http://schemas.microsoft.com/office/drawing/2014/main" id="{3DA3E7CA-151E-4438-8AAA-EC98B5363738}"/>
+                <a16:creationId xmlns:a16="http://schemas.microsoft.com/office/drawing/2014/main" id="{D463B09D-3D7A-47FA-B58C-0649045736D5}"/>
               </a:ext>
             </a:extLst>
           </p:cNvPr>
@@ -11043,7 +11043,7 @@
           <p:cNvPr id="4" name="body">
             <a:extLst xmlns:a="http://schemas.openxmlformats.org/drawingml/2006/main">
               <a:ext uri="{FF2B5EF4-FFF2-40B4-BE49-F238E27FC236}">
-                <a16:creationId xmlns:a16="http://schemas.microsoft.com/office/drawing/2014/main" id="{B86AE341-A789-4755-BE50-34E96C403FC7}"/>
+                <a16:creationId xmlns:a16="http://schemas.microsoft.com/office/drawing/2014/main" id="{19853F55-01F1-47A2-ADEC-F9884BFD34B4}"/>
               </a:ext>
             </a:extLst>
           </p:cNvPr>
@@ -11100,7 +11100,7 @@
           <p:cNvPr id="5" name="body">
             <a:extLst xmlns:a="http://schemas.openxmlformats.org/drawingml/2006/main">
               <a:ext uri="{FF2B5EF4-FFF2-40B4-BE49-F238E27FC236}">
-                <a16:creationId xmlns:a16="http://schemas.microsoft.com/office/drawing/2014/main" id="{3BF06D92-2AB1-4983-A143-1EE4D3BB7BB6}"/>
+                <a16:creationId xmlns:a16="http://schemas.microsoft.com/office/drawing/2014/main" id="{2AF41CBE-C7E4-47C5-AEFA-3C8291E74880}"/>
               </a:ext>
             </a:extLst>
           </p:cNvPr>
@@ -11157,7 +11157,7 @@
           <p:cNvPr id="6" name="body">
             <a:extLst xmlns:a="http://schemas.openxmlformats.org/drawingml/2006/main">
               <a:ext uri="{FF2B5EF4-FFF2-40B4-BE49-F238E27FC236}">
-                <a16:creationId xmlns:a16="http://schemas.microsoft.com/office/drawing/2014/main" id="{04BB9D6B-6BED-4B6A-8CC4-748E1292A7D6}"/>
+                <a16:creationId xmlns:a16="http://schemas.microsoft.com/office/drawing/2014/main" id="{F6D3E2C1-0CC7-4C30-A6D7-9AA67425A549}"/>
               </a:ext>
             </a:extLst>
           </p:cNvPr>
@@ -11214,7 +11214,7 @@
           <p:cNvPr id="7" name="body">
             <a:extLst xmlns:a="http://schemas.openxmlformats.org/drawingml/2006/main">
               <a:ext uri="{FF2B5EF4-FFF2-40B4-BE49-F238E27FC236}">
-                <a16:creationId xmlns:a16="http://schemas.microsoft.com/office/drawing/2014/main" id="{93CA1E60-117B-4B38-8503-A2C45D1CACAA}"/>
+                <a16:creationId xmlns:a16="http://schemas.microsoft.com/office/drawing/2014/main" id="{8DCD7E2A-F489-4D30-9547-A2B3E96872F3}"/>
               </a:ext>
             </a:extLst>
           </p:cNvPr>
@@ -11271,7 +11271,7 @@
           <p:cNvPr id="8" name="body">
             <a:extLst xmlns:a="http://schemas.openxmlformats.org/drawingml/2006/main">
               <a:ext uri="{FF2B5EF4-FFF2-40B4-BE49-F238E27FC236}">
-                <a16:creationId xmlns:a16="http://schemas.microsoft.com/office/drawing/2014/main" id="{0CEA34EE-38AC-4FD7-B5D9-5D534866B848}"/>
+                <a16:creationId xmlns:a16="http://schemas.microsoft.com/office/drawing/2014/main" id="{438BD58A-DF34-4FCE-9699-B6431ABF38AD}"/>
               </a:ext>
             </a:extLst>
           </p:cNvPr>
@@ -11328,7 +11328,7 @@
           <p:cNvPr id="9" name="footnote">
             <a:extLst xmlns:a="http://schemas.openxmlformats.org/drawingml/2006/main">
               <a:ext uri="{FF2B5EF4-FFF2-40B4-BE49-F238E27FC236}">
-                <a16:creationId xmlns:a16="http://schemas.microsoft.com/office/drawing/2014/main" id="{11CD3821-87E8-42A0-8340-563149A1759F}"/>
+                <a16:creationId xmlns:a16="http://schemas.microsoft.com/office/drawing/2014/main" id="{A37F5FE2-6005-45D2-B9D3-AED6ACA1532A}"/>
               </a:ext>
             </a:extLst>
           </p:cNvPr>
@@ -11385,7 +11385,7 @@
           <p:cNvPr id="10" name="page">
             <a:extLst xmlns:a="http://schemas.openxmlformats.org/drawingml/2006/main">
               <a:ext uri="{FF2B5EF4-FFF2-40B4-BE49-F238E27FC236}">
-                <a16:creationId xmlns:a16="http://schemas.microsoft.com/office/drawing/2014/main" id="{7A457352-77E1-46CD-94FD-D9F0864BB976}"/>
+                <a16:creationId xmlns:a16="http://schemas.microsoft.com/office/drawing/2014/main" id="{FE52919F-FAA6-41DB-814C-6CAE63A19DE7}"/>
               </a:ext>
             </a:extLst>
           </p:cNvPr>
@@ -11440,7 +11440,7 @@
     </p:spTree>
     <p:extLst>
       <p:ext uri="{BB962C8B-B14F-4D97-AF65-F5344CB8AC3E}">
-        <p14:creationId xmlns:p14="http://schemas.microsoft.com/office/powerpoint/2010/main" val="220793941"/>
+        <p14:creationId xmlns:p14="http://schemas.microsoft.com/office/powerpoint/2010/main" val="1215701850"/>
       </p:ext>
     </p:extLst>
   </p:cSld>
@@ -11471,7 +11471,7 @@
           <p:cNvPr id="12" name="course">
             <a:extLst xmlns:a="http://schemas.openxmlformats.org/drawingml/2006/main">
               <a:ext uri="{FF2B5EF4-FFF2-40B4-BE49-F238E27FC236}">
-                <a16:creationId xmlns:a16="http://schemas.microsoft.com/office/drawing/2014/main" id="{EAECC9F0-F512-4C0D-BE01-990195B4DCE1}"/>
+                <a16:creationId xmlns:a16="http://schemas.microsoft.com/office/drawing/2014/main" id="{6769C847-AD74-4807-B70A-A1C42A4A98F0}"/>
               </a:ext>
             </a:extLst>
           </p:cNvPr>
@@ -11528,7 +11528,7 @@
           <p:cNvPr id="2" name="title">
             <a:extLst xmlns:a="http://schemas.openxmlformats.org/drawingml/2006/main">
               <a:ext uri="{FF2B5EF4-FFF2-40B4-BE49-F238E27FC236}">
-                <a16:creationId xmlns:a16="http://schemas.microsoft.com/office/drawing/2014/main" id="{F5FD4DE8-0193-4393-BD01-DCCFA4169635}"/>
+                <a16:creationId xmlns:a16="http://schemas.microsoft.com/office/drawing/2014/main" id="{298D6EB3-848D-4A1F-B44A-34177AC5D0D2}"/>
               </a:ext>
             </a:extLst>
           </p:cNvPr>
@@ -11585,7 +11585,7 @@
           <p:cNvPr id="3" name="body">
             <a:extLst xmlns:a="http://schemas.openxmlformats.org/drawingml/2006/main">
               <a:ext uri="{FF2B5EF4-FFF2-40B4-BE49-F238E27FC236}">
-                <a16:creationId xmlns:a16="http://schemas.microsoft.com/office/drawing/2014/main" id="{914F8F65-57AC-4801-BCC7-87E501D5822A}"/>
+                <a16:creationId xmlns:a16="http://schemas.microsoft.com/office/drawing/2014/main" id="{F1C49F3F-B641-4904-B313-A066ACB790C5}"/>
               </a:ext>
             </a:extLst>
           </p:cNvPr>
@@ -11642,7 +11642,7 @@
           <p:cNvPr id="4" name="body">
             <a:extLst xmlns:a="http://schemas.openxmlformats.org/drawingml/2006/main">
               <a:ext uri="{FF2B5EF4-FFF2-40B4-BE49-F238E27FC236}">
-                <a16:creationId xmlns:a16="http://schemas.microsoft.com/office/drawing/2014/main" id="{4B7E4F0B-7DA6-4613-AD0C-311F43ABCDAE}"/>
+                <a16:creationId xmlns:a16="http://schemas.microsoft.com/office/drawing/2014/main" id="{35FC91E1-B74B-49D0-BACF-F7D25DA71D93}"/>
               </a:ext>
             </a:extLst>
           </p:cNvPr>
@@ -11699,7 +11699,7 @@
           <p:cNvPr id="5" name="body">
             <a:extLst xmlns:a="http://schemas.openxmlformats.org/drawingml/2006/main">
               <a:ext uri="{FF2B5EF4-FFF2-40B4-BE49-F238E27FC236}">
-                <a16:creationId xmlns:a16="http://schemas.microsoft.com/office/drawing/2014/main" id="{EC552CF6-020D-4A02-82A8-085264689D9B}"/>
+                <a16:creationId xmlns:a16="http://schemas.microsoft.com/office/drawing/2014/main" id="{2D9854F0-FF1D-491B-9575-80948E536FEF}"/>
               </a:ext>
             </a:extLst>
           </p:cNvPr>
@@ -11756,7 +11756,7 @@
           <p:cNvPr id="6" name="body">
             <a:extLst xmlns:a="http://schemas.openxmlformats.org/drawingml/2006/main">
               <a:ext uri="{FF2B5EF4-FFF2-40B4-BE49-F238E27FC236}">
-                <a16:creationId xmlns:a16="http://schemas.microsoft.com/office/drawing/2014/main" id="{7C1E0D61-8E99-485D-B1A1-14256F3C6509}"/>
+                <a16:creationId xmlns:a16="http://schemas.microsoft.com/office/drawing/2014/main" id="{57E4282C-A4A5-4ED2-8E9E-7B14BAAF4FE8}"/>
               </a:ext>
             </a:extLst>
           </p:cNvPr>
@@ -11813,7 +11813,7 @@
           <p:cNvPr id="7" name="body">
             <a:extLst xmlns:a="http://schemas.openxmlformats.org/drawingml/2006/main">
               <a:ext uri="{FF2B5EF4-FFF2-40B4-BE49-F238E27FC236}">
-                <a16:creationId xmlns:a16="http://schemas.microsoft.com/office/drawing/2014/main" id="{E59ED913-3DED-4F75-8C40-AE1EAA8EF3D1}"/>
+                <a16:creationId xmlns:a16="http://schemas.microsoft.com/office/drawing/2014/main" id="{829F9CB8-4892-4D3B-9D0D-B344CB516E70}"/>
               </a:ext>
             </a:extLst>
           </p:cNvPr>
@@ -11870,7 +11870,7 @@
           <p:cNvPr id="8" name="body">
             <a:extLst xmlns:a="http://schemas.openxmlformats.org/drawingml/2006/main">
               <a:ext uri="{FF2B5EF4-FFF2-40B4-BE49-F238E27FC236}">
-                <a16:creationId xmlns:a16="http://schemas.microsoft.com/office/drawing/2014/main" id="{7BD0FF35-D188-4B98-911E-8E95C6AB1D66}"/>
+                <a16:creationId xmlns:a16="http://schemas.microsoft.com/office/drawing/2014/main" id="{A8437496-827F-4DB9-B0A0-715DD97EF8A8}"/>
               </a:ext>
             </a:extLst>
           </p:cNvPr>
@@ -11931,7 +11931,7 @@
           <p:nvPr/>
         </p:nvPicPr>
         <p:blipFill>
-          <a:blip xmlns:r="http://schemas.openxmlformats.org/officeDocument/2006/relationships" xmlns:a="http://schemas.openxmlformats.org/drawingml/2006/main" r:embed="R1e203c2cb0d94136"/>
+          <a:blip xmlns:r="http://schemas.openxmlformats.org/officeDocument/2006/relationships" xmlns:a="http://schemas.openxmlformats.org/drawingml/2006/main" r:embed="R9559377af68f45ea"/>
           <a:stretch xmlns:a="http://schemas.openxmlformats.org/drawingml/2006/main"/>
         </p:blipFill>
         <p:spPr>
@@ -11949,7 +11949,7 @@
           <p:cNvPr id="10" name="photo-caption">
             <a:extLst xmlns:a="http://schemas.openxmlformats.org/drawingml/2006/main">
               <a:ext uri="{FF2B5EF4-FFF2-40B4-BE49-F238E27FC236}">
-                <a16:creationId xmlns:a16="http://schemas.microsoft.com/office/drawing/2014/main" id="{E8E78CAE-2ED8-41A0-9C79-8CF0248A7AFE}"/>
+                <a16:creationId xmlns:a16="http://schemas.microsoft.com/office/drawing/2014/main" id="{C055E7B8-325B-4A9E-B0D3-8443ECE22B7F}"/>
               </a:ext>
             </a:extLst>
           </p:cNvPr>
@@ -12006,7 +12006,7 @@
           <p:cNvPr id="11" name="page">
             <a:extLst xmlns:a="http://schemas.openxmlformats.org/drawingml/2006/main">
               <a:ext uri="{FF2B5EF4-FFF2-40B4-BE49-F238E27FC236}">
-                <a16:creationId xmlns:a16="http://schemas.microsoft.com/office/drawing/2014/main" id="{3B1F62F3-141F-4C40-AAE1-F20B426390D6}"/>
+                <a16:creationId xmlns:a16="http://schemas.microsoft.com/office/drawing/2014/main" id="{60E12094-1B97-4F4A-8155-49C9D4C68D63}"/>
               </a:ext>
             </a:extLst>
           </p:cNvPr>
@@ -12061,7 +12061,7 @@
     </p:spTree>
     <p:extLst>
       <p:ext uri="{BB962C8B-B14F-4D97-AF65-F5344CB8AC3E}">
-        <p14:creationId xmlns:p14="http://schemas.microsoft.com/office/powerpoint/2010/main" val="1633158575"/>
+        <p14:creationId xmlns:p14="http://schemas.microsoft.com/office/powerpoint/2010/main" val="1421444476"/>
       </p:ext>
     </p:extLst>
   </p:cSld>
@@ -12092,7 +12092,7 @@
           <p:cNvPr id="11" name="course">
             <a:extLst xmlns:a="http://schemas.openxmlformats.org/drawingml/2006/main">
               <a:ext uri="{FF2B5EF4-FFF2-40B4-BE49-F238E27FC236}">
-                <a16:creationId xmlns:a16="http://schemas.microsoft.com/office/drawing/2014/main" id="{F4CEACC0-7407-44F7-9509-3A318A7BAF93}"/>
+                <a16:creationId xmlns:a16="http://schemas.microsoft.com/office/drawing/2014/main" id="{894DB2FB-8784-460C-8796-E2B80F8F1E7F}"/>
               </a:ext>
             </a:extLst>
           </p:cNvPr>
@@ -12149,7 +12149,7 @@
           <p:cNvPr id="2" name="title">
             <a:extLst xmlns:a="http://schemas.openxmlformats.org/drawingml/2006/main">
               <a:ext uri="{FF2B5EF4-FFF2-40B4-BE49-F238E27FC236}">
-                <a16:creationId xmlns:a16="http://schemas.microsoft.com/office/drawing/2014/main" id="{580AD124-7312-4898-9C83-2AE72F8BCA45}"/>
+                <a16:creationId xmlns:a16="http://schemas.microsoft.com/office/drawing/2014/main" id="{90E96A20-D1C3-4552-AC01-224CC8AB3983}"/>
               </a:ext>
             </a:extLst>
           </p:cNvPr>
@@ -12206,7 +12206,7 @@
           <p:cNvPr id="3" name="body">
             <a:extLst xmlns:a="http://schemas.openxmlformats.org/drawingml/2006/main">
               <a:ext uri="{FF2B5EF4-FFF2-40B4-BE49-F238E27FC236}">
-                <a16:creationId xmlns:a16="http://schemas.microsoft.com/office/drawing/2014/main" id="{8A307913-5F30-423B-9003-6D5ADDA0BD93}"/>
+                <a16:creationId xmlns:a16="http://schemas.microsoft.com/office/drawing/2014/main" id="{700DABD4-2551-43CA-A5FA-F237E8F0A29E}"/>
               </a:ext>
             </a:extLst>
           </p:cNvPr>
@@ -12263,7 +12263,7 @@
           <p:cNvPr id="4" name="body">
             <a:extLst xmlns:a="http://schemas.openxmlformats.org/drawingml/2006/main">
               <a:ext uri="{FF2B5EF4-FFF2-40B4-BE49-F238E27FC236}">
-                <a16:creationId xmlns:a16="http://schemas.microsoft.com/office/drawing/2014/main" id="{42A90398-4EF2-46F9-87CB-CF687826D9C7}"/>
+                <a16:creationId xmlns:a16="http://schemas.microsoft.com/office/drawing/2014/main" id="{88CE0163-CA8C-4410-9D26-A0924B912662}"/>
               </a:ext>
             </a:extLst>
           </p:cNvPr>
@@ -12320,7 +12320,7 @@
           <p:cNvPr id="5" name="body">
             <a:extLst xmlns:a="http://schemas.openxmlformats.org/drawingml/2006/main">
               <a:ext uri="{FF2B5EF4-FFF2-40B4-BE49-F238E27FC236}">
-                <a16:creationId xmlns:a16="http://schemas.microsoft.com/office/drawing/2014/main" id="{E2AE34A2-80FD-4BD8-ABB7-9BF13444EB87}"/>
+                <a16:creationId xmlns:a16="http://schemas.microsoft.com/office/drawing/2014/main" id="{34C8F3E1-AFAC-4FE4-AAAE-D3834FAC60F6}"/>
               </a:ext>
             </a:extLst>
           </p:cNvPr>
@@ -12377,7 +12377,7 @@
           <p:cNvPr id="6" name="body">
             <a:extLst xmlns:a="http://schemas.openxmlformats.org/drawingml/2006/main">
               <a:ext uri="{FF2B5EF4-FFF2-40B4-BE49-F238E27FC236}">
-                <a16:creationId xmlns:a16="http://schemas.microsoft.com/office/drawing/2014/main" id="{526BD9F8-05EB-46BA-A224-C6806C7566F2}"/>
+                <a16:creationId xmlns:a16="http://schemas.microsoft.com/office/drawing/2014/main" id="{6BF603AC-FB0F-42BA-BC46-4222A4E927CE}"/>
               </a:ext>
             </a:extLst>
           </p:cNvPr>
@@ -12434,7 +12434,7 @@
           <p:cNvPr id="7" name="body">
             <a:extLst xmlns:a="http://schemas.openxmlformats.org/drawingml/2006/main">
               <a:ext uri="{FF2B5EF4-FFF2-40B4-BE49-F238E27FC236}">
-                <a16:creationId xmlns:a16="http://schemas.microsoft.com/office/drawing/2014/main" id="{06A8DACC-6E35-4224-83D2-F67B5328AC86}"/>
+                <a16:creationId xmlns:a16="http://schemas.microsoft.com/office/drawing/2014/main" id="{36D3B8EF-4577-4380-8D54-3D1FCF1E5E62}"/>
               </a:ext>
             </a:extLst>
           </p:cNvPr>
@@ -12491,7 +12491,7 @@
           <p:cNvPr id="8" name="body">
             <a:extLst xmlns:a="http://schemas.openxmlformats.org/drawingml/2006/main">
               <a:ext uri="{FF2B5EF4-FFF2-40B4-BE49-F238E27FC236}">
-                <a16:creationId xmlns:a16="http://schemas.microsoft.com/office/drawing/2014/main" id="{81AC088D-D907-4AAF-9826-BE4FCF6C0E95}"/>
+                <a16:creationId xmlns:a16="http://schemas.microsoft.com/office/drawing/2014/main" id="{0D2543D8-D9AF-4FCA-936D-0AA526B6B66D}"/>
               </a:ext>
             </a:extLst>
           </p:cNvPr>
@@ -12548,7 +12548,7 @@
           <p:cNvPr id="9" name="footnote">
             <a:extLst xmlns:a="http://schemas.openxmlformats.org/drawingml/2006/main">
               <a:ext uri="{FF2B5EF4-FFF2-40B4-BE49-F238E27FC236}">
-                <a16:creationId xmlns:a16="http://schemas.microsoft.com/office/drawing/2014/main" id="{4485FA28-D6AC-4A4B-92D1-7376E47996EB}"/>
+                <a16:creationId xmlns:a16="http://schemas.microsoft.com/office/drawing/2014/main" id="{70F4BCCB-48C2-48A6-8DCD-B8D3BB830592}"/>
               </a:ext>
             </a:extLst>
           </p:cNvPr>
@@ -12605,7 +12605,7 @@
           <p:cNvPr id="10" name="page">
             <a:extLst xmlns:a="http://schemas.openxmlformats.org/drawingml/2006/main">
               <a:ext uri="{FF2B5EF4-FFF2-40B4-BE49-F238E27FC236}">
-                <a16:creationId xmlns:a16="http://schemas.microsoft.com/office/drawing/2014/main" id="{BC0BE6B0-E117-45BC-A642-407956523A3D}"/>
+                <a16:creationId xmlns:a16="http://schemas.microsoft.com/office/drawing/2014/main" id="{2D9AB7BA-2591-4D5C-9EAB-1ADCF1BBEE8F}"/>
               </a:ext>
             </a:extLst>
           </p:cNvPr>
@@ -12660,7 +12660,7 @@
     </p:spTree>
     <p:extLst>
       <p:ext uri="{BB962C8B-B14F-4D97-AF65-F5344CB8AC3E}">
-        <p14:creationId xmlns:p14="http://schemas.microsoft.com/office/powerpoint/2010/main" val="1520630892"/>
+        <p14:creationId xmlns:p14="http://schemas.microsoft.com/office/powerpoint/2010/main" val="1119829180"/>
       </p:ext>
     </p:extLst>
   </p:cSld>
@@ -14458,7 +14458,7 @@
           <p:cNvPr id="6" name="course">
             <a:extLst xmlns:a="http://schemas.openxmlformats.org/drawingml/2006/main">
               <a:ext uri="{FF2B5EF4-FFF2-40B4-BE49-F238E27FC236}">
-                <a16:creationId xmlns:a16="http://schemas.microsoft.com/office/drawing/2014/main" id="{EEC4809F-0880-41A8-9622-7A9122521F4C}"/>
+                <a16:creationId xmlns:a16="http://schemas.microsoft.com/office/drawing/2014/main" id="{EA9A4A83-EE63-40CA-88DC-B63AA5F0CD5A}"/>
               </a:ext>
             </a:extLst>
           </p:cNvPr>
@@ -14515,7 +14515,7 @@
           <p:cNvPr id="2" name="title">
             <a:extLst xmlns:a="http://schemas.openxmlformats.org/drawingml/2006/main">
               <a:ext uri="{FF2B5EF4-FFF2-40B4-BE49-F238E27FC236}">
-                <a16:creationId xmlns:a16="http://schemas.microsoft.com/office/drawing/2014/main" id="{A03C019B-BB3B-4849-96C3-D926581F6ADB}"/>
+                <a16:creationId xmlns:a16="http://schemas.microsoft.com/office/drawing/2014/main" id="{538A3203-5C4A-4E9E-B4F0-280CF7B3F5C6}"/>
               </a:ext>
             </a:extLst>
           </p:cNvPr>
@@ -15187,7 +15187,7 @@
           <p:cNvPr id="4" name="footnote">
             <a:extLst xmlns:a="http://schemas.openxmlformats.org/drawingml/2006/main">
               <a:ext uri="{FF2B5EF4-FFF2-40B4-BE49-F238E27FC236}">
-                <a16:creationId xmlns:a16="http://schemas.microsoft.com/office/drawing/2014/main" id="{150AC672-5749-4E63-AB93-9D501FAEA0B3}"/>
+                <a16:creationId xmlns:a16="http://schemas.microsoft.com/office/drawing/2014/main" id="{774EC788-C0D5-4C41-9AD9-43C64F864616}"/>
               </a:ext>
             </a:extLst>
           </p:cNvPr>
@@ -15244,7 +15244,7 @@
           <p:cNvPr id="5" name="page">
             <a:extLst xmlns:a="http://schemas.openxmlformats.org/drawingml/2006/main">
               <a:ext uri="{FF2B5EF4-FFF2-40B4-BE49-F238E27FC236}">
-                <a16:creationId xmlns:a16="http://schemas.microsoft.com/office/drawing/2014/main" id="{BBB0613B-C847-483D-B7DB-8157E7A9A7BA}"/>
+                <a16:creationId xmlns:a16="http://schemas.microsoft.com/office/drawing/2014/main" id="{0381F13C-C71D-4F93-902D-517543B4B5B2}"/>
               </a:ext>
             </a:extLst>
           </p:cNvPr>
@@ -15299,7 +15299,7 @@
     </p:spTree>
     <p:extLst>
       <p:ext uri="{BB962C8B-B14F-4D97-AF65-F5344CB8AC3E}">
-        <p14:creationId xmlns:p14="http://schemas.microsoft.com/office/powerpoint/2010/main" val="1557232333"/>
+        <p14:creationId xmlns:p14="http://schemas.microsoft.com/office/powerpoint/2010/main" val="95166247"/>
       </p:ext>
     </p:extLst>
   </p:cSld>
@@ -15330,7 +15330,7 @@
           <p:cNvPr id="11" name="course">
             <a:extLst xmlns:a="http://schemas.openxmlformats.org/drawingml/2006/main">
               <a:ext uri="{FF2B5EF4-FFF2-40B4-BE49-F238E27FC236}">
-                <a16:creationId xmlns:a16="http://schemas.microsoft.com/office/drawing/2014/main" id="{30609BA9-026D-40EB-B0C3-23FCBB04E513}"/>
+                <a16:creationId xmlns:a16="http://schemas.microsoft.com/office/drawing/2014/main" id="{A6F7FDB5-37BD-4E39-B471-B1DA15797E2A}"/>
               </a:ext>
             </a:extLst>
           </p:cNvPr>
@@ -15387,7 +15387,7 @@
           <p:cNvPr id="2" name="title">
             <a:extLst xmlns:a="http://schemas.openxmlformats.org/drawingml/2006/main">
               <a:ext uri="{FF2B5EF4-FFF2-40B4-BE49-F238E27FC236}">
-                <a16:creationId xmlns:a16="http://schemas.microsoft.com/office/drawing/2014/main" id="{54778C1D-45F8-448F-8105-EB63A26C1385}"/>
+                <a16:creationId xmlns:a16="http://schemas.microsoft.com/office/drawing/2014/main" id="{37081C7D-54DC-4708-83BC-E815245548E9}"/>
               </a:ext>
             </a:extLst>
           </p:cNvPr>
@@ -15444,7 +15444,7 @@
           <p:cNvPr id="3" name="body">
             <a:extLst xmlns:a="http://schemas.openxmlformats.org/drawingml/2006/main">
               <a:ext uri="{FF2B5EF4-FFF2-40B4-BE49-F238E27FC236}">
-                <a16:creationId xmlns:a16="http://schemas.microsoft.com/office/drawing/2014/main" id="{3FBECADD-3678-49A2-90B7-EE6EDDAA9DD9}"/>
+                <a16:creationId xmlns:a16="http://schemas.microsoft.com/office/drawing/2014/main" id="{C6EEA090-12F1-4F21-9897-D2492F0B28AD}"/>
               </a:ext>
             </a:extLst>
           </p:cNvPr>
@@ -15501,7 +15501,7 @@
           <p:cNvPr id="4" name="body">
             <a:extLst xmlns:a="http://schemas.openxmlformats.org/drawingml/2006/main">
               <a:ext uri="{FF2B5EF4-FFF2-40B4-BE49-F238E27FC236}">
-                <a16:creationId xmlns:a16="http://schemas.microsoft.com/office/drawing/2014/main" id="{DBD97F20-7FA5-4597-964E-D8689AA67438}"/>
+                <a16:creationId xmlns:a16="http://schemas.microsoft.com/office/drawing/2014/main" id="{96D659AE-470B-4EBA-A485-8A819048F731}"/>
               </a:ext>
             </a:extLst>
           </p:cNvPr>
@@ -15558,7 +15558,7 @@
           <p:cNvPr id="5" name="body">
             <a:extLst xmlns:a="http://schemas.openxmlformats.org/drawingml/2006/main">
               <a:ext uri="{FF2B5EF4-FFF2-40B4-BE49-F238E27FC236}">
-                <a16:creationId xmlns:a16="http://schemas.microsoft.com/office/drawing/2014/main" id="{8BDD3926-D7F8-46C0-A912-50F05D4459B3}"/>
+                <a16:creationId xmlns:a16="http://schemas.microsoft.com/office/drawing/2014/main" id="{4C4CEF7E-887E-4AB3-921F-F6BC75A33DF5}"/>
               </a:ext>
             </a:extLst>
           </p:cNvPr>
@@ -15615,7 +15615,7 @@
           <p:cNvPr id="6" name="body">
             <a:extLst xmlns:a="http://schemas.openxmlformats.org/drawingml/2006/main">
               <a:ext uri="{FF2B5EF4-FFF2-40B4-BE49-F238E27FC236}">
-                <a16:creationId xmlns:a16="http://schemas.microsoft.com/office/drawing/2014/main" id="{DBCE6BD6-57D1-4E02-A3E2-F162655EADAB}"/>
+                <a16:creationId xmlns:a16="http://schemas.microsoft.com/office/drawing/2014/main" id="{683512A7-1C3D-4C01-A36D-D1269ECF8832}"/>
               </a:ext>
             </a:extLst>
           </p:cNvPr>
@@ -15672,7 +15672,7 @@
           <p:cNvPr id="7" name="body">
             <a:extLst xmlns:a="http://schemas.openxmlformats.org/drawingml/2006/main">
               <a:ext uri="{FF2B5EF4-FFF2-40B4-BE49-F238E27FC236}">
-                <a16:creationId xmlns:a16="http://schemas.microsoft.com/office/drawing/2014/main" id="{ACE29976-BC18-4EFB-8F3E-0A2ABF475616}"/>
+                <a16:creationId xmlns:a16="http://schemas.microsoft.com/office/drawing/2014/main" id="{B7005724-EF30-4B9B-9FFD-9D699895CED7}"/>
               </a:ext>
             </a:extLst>
           </p:cNvPr>
@@ -15729,7 +15729,7 @@
           <p:cNvPr id="8" name="body">
             <a:extLst xmlns:a="http://schemas.openxmlformats.org/drawingml/2006/main">
               <a:ext uri="{FF2B5EF4-FFF2-40B4-BE49-F238E27FC236}">
-                <a16:creationId xmlns:a16="http://schemas.microsoft.com/office/drawing/2014/main" id="{CE573F83-EAE0-48D7-AE81-155290975536}"/>
+                <a16:creationId xmlns:a16="http://schemas.microsoft.com/office/drawing/2014/main" id="{A2FAEB68-7510-4E59-BC49-735515A4C632}"/>
               </a:ext>
             </a:extLst>
           </p:cNvPr>
@@ -15786,7 +15786,7 @@
           <p:cNvPr id="9" name="footnote">
             <a:extLst xmlns:a="http://schemas.openxmlformats.org/drawingml/2006/main">
               <a:ext uri="{FF2B5EF4-FFF2-40B4-BE49-F238E27FC236}">
-                <a16:creationId xmlns:a16="http://schemas.microsoft.com/office/drawing/2014/main" id="{080B84E1-B6C2-437F-82D2-D75E7121DC99}"/>
+                <a16:creationId xmlns:a16="http://schemas.microsoft.com/office/drawing/2014/main" id="{0B5D3F12-BA77-4E81-A0C8-EF58141A3715}"/>
               </a:ext>
             </a:extLst>
           </p:cNvPr>
@@ -15843,7 +15843,7 @@
           <p:cNvPr id="10" name="page">
             <a:extLst xmlns:a="http://schemas.openxmlformats.org/drawingml/2006/main">
               <a:ext uri="{FF2B5EF4-FFF2-40B4-BE49-F238E27FC236}">
-                <a16:creationId xmlns:a16="http://schemas.microsoft.com/office/drawing/2014/main" id="{3F6F1520-41D5-41B7-AC74-0ED40FB7275E}"/>
+                <a16:creationId xmlns:a16="http://schemas.microsoft.com/office/drawing/2014/main" id="{1E72CD4D-99CA-4534-8A04-634B45E74A35}"/>
               </a:ext>
             </a:extLst>
           </p:cNvPr>
@@ -15898,7 +15898,7 @@
     </p:spTree>
     <p:extLst>
       <p:ext uri="{BB962C8B-B14F-4D97-AF65-F5344CB8AC3E}">
-        <p14:creationId xmlns:p14="http://schemas.microsoft.com/office/powerpoint/2010/main" val="1691800772"/>
+        <p14:creationId xmlns:p14="http://schemas.microsoft.com/office/powerpoint/2010/main" val="1506680381"/>
       </p:ext>
     </p:extLst>
   </p:cSld>
@@ -15929,7 +15929,7 @@
           <p:cNvPr id="11" name="course">
             <a:extLst xmlns:a="http://schemas.openxmlformats.org/drawingml/2006/main">
               <a:ext uri="{FF2B5EF4-FFF2-40B4-BE49-F238E27FC236}">
-                <a16:creationId xmlns:a16="http://schemas.microsoft.com/office/drawing/2014/main" id="{1771845A-FFDE-4A89-8B0A-331C4DBEF88E}"/>
+                <a16:creationId xmlns:a16="http://schemas.microsoft.com/office/drawing/2014/main" id="{9E411BD5-2DE3-46DC-87CD-9A4B1AB5CF2F}"/>
               </a:ext>
             </a:extLst>
           </p:cNvPr>
@@ -15986,7 +15986,7 @@
           <p:cNvPr id="2" name="title">
             <a:extLst xmlns:a="http://schemas.openxmlformats.org/drawingml/2006/main">
               <a:ext uri="{FF2B5EF4-FFF2-40B4-BE49-F238E27FC236}">
-                <a16:creationId xmlns:a16="http://schemas.microsoft.com/office/drawing/2014/main" id="{2B2208B8-0E21-41E4-8461-A7F93FC2B4AA}"/>
+                <a16:creationId xmlns:a16="http://schemas.microsoft.com/office/drawing/2014/main" id="{4352571C-D851-494B-A44D-47CD2661ADF2}"/>
               </a:ext>
             </a:extLst>
           </p:cNvPr>
@@ -16043,7 +16043,7 @@
           <p:cNvPr id="3" name="body">
             <a:extLst xmlns:a="http://schemas.openxmlformats.org/drawingml/2006/main">
               <a:ext uri="{FF2B5EF4-FFF2-40B4-BE49-F238E27FC236}">
-                <a16:creationId xmlns:a16="http://schemas.microsoft.com/office/drawing/2014/main" id="{783A3AD1-D884-4886-A02A-5E1B7D8275A1}"/>
+                <a16:creationId xmlns:a16="http://schemas.microsoft.com/office/drawing/2014/main" id="{0FB92843-B36E-43D6-9F62-81019959193D}"/>
               </a:ext>
             </a:extLst>
           </p:cNvPr>
@@ -16100,7 +16100,7 @@
           <p:cNvPr id="4" name="body">
             <a:extLst xmlns:a="http://schemas.openxmlformats.org/drawingml/2006/main">
               <a:ext uri="{FF2B5EF4-FFF2-40B4-BE49-F238E27FC236}">
-                <a16:creationId xmlns:a16="http://schemas.microsoft.com/office/drawing/2014/main" id="{41CBEB0E-01AA-487E-8E56-9836950C54C6}"/>
+                <a16:creationId xmlns:a16="http://schemas.microsoft.com/office/drawing/2014/main" id="{14567E8D-7692-439F-A8A8-F808C781728F}"/>
               </a:ext>
             </a:extLst>
           </p:cNvPr>
@@ -16157,7 +16157,7 @@
           <p:cNvPr id="5" name="body">
             <a:extLst xmlns:a="http://schemas.openxmlformats.org/drawingml/2006/main">
               <a:ext uri="{FF2B5EF4-FFF2-40B4-BE49-F238E27FC236}">
-                <a16:creationId xmlns:a16="http://schemas.microsoft.com/office/drawing/2014/main" id="{8A0B4412-F688-43C3-914C-E442BD429FDB}"/>
+                <a16:creationId xmlns:a16="http://schemas.microsoft.com/office/drawing/2014/main" id="{62A42409-52E2-4547-9AFB-C69AAB7DDC37}"/>
               </a:ext>
             </a:extLst>
           </p:cNvPr>
@@ -16214,7 +16214,7 @@
           <p:cNvPr id="6" name="body">
             <a:extLst xmlns:a="http://schemas.openxmlformats.org/drawingml/2006/main">
               <a:ext uri="{FF2B5EF4-FFF2-40B4-BE49-F238E27FC236}">
-                <a16:creationId xmlns:a16="http://schemas.microsoft.com/office/drawing/2014/main" id="{A2457B63-9D29-4133-A047-91EDA07A8E50}"/>
+                <a16:creationId xmlns:a16="http://schemas.microsoft.com/office/drawing/2014/main" id="{6E22A9D7-BEE1-4CA9-A108-501A5FAC6D70}"/>
               </a:ext>
             </a:extLst>
           </p:cNvPr>
@@ -16271,7 +16271,7 @@
           <p:cNvPr id="7" name="body">
             <a:extLst xmlns:a="http://schemas.openxmlformats.org/drawingml/2006/main">
               <a:ext uri="{FF2B5EF4-FFF2-40B4-BE49-F238E27FC236}">
-                <a16:creationId xmlns:a16="http://schemas.microsoft.com/office/drawing/2014/main" id="{FB7C68BD-F7EA-409D-AD11-D2A25CFD7A4F}"/>
+                <a16:creationId xmlns:a16="http://schemas.microsoft.com/office/drawing/2014/main" id="{46ED7304-C713-49DD-A2FA-C43054600E2D}"/>
               </a:ext>
             </a:extLst>
           </p:cNvPr>
@@ -16328,7 +16328,7 @@
           <p:cNvPr id="8" name="body">
             <a:extLst xmlns:a="http://schemas.openxmlformats.org/drawingml/2006/main">
               <a:ext uri="{FF2B5EF4-FFF2-40B4-BE49-F238E27FC236}">
-                <a16:creationId xmlns:a16="http://schemas.microsoft.com/office/drawing/2014/main" id="{DB5A1805-6647-4BA2-A40B-16528D19AC49}"/>
+                <a16:creationId xmlns:a16="http://schemas.microsoft.com/office/drawing/2014/main" id="{37DA0392-DD60-4F34-BE97-D788B1312AB7}"/>
               </a:ext>
             </a:extLst>
           </p:cNvPr>
@@ -16385,7 +16385,7 @@
           <p:cNvPr id="9" name="footnote">
             <a:extLst xmlns:a="http://schemas.openxmlformats.org/drawingml/2006/main">
               <a:ext uri="{FF2B5EF4-FFF2-40B4-BE49-F238E27FC236}">
-                <a16:creationId xmlns:a16="http://schemas.microsoft.com/office/drawing/2014/main" id="{3BF9C392-A0D1-46DC-9420-08B8211F0161}"/>
+                <a16:creationId xmlns:a16="http://schemas.microsoft.com/office/drawing/2014/main" id="{AF0F8EB7-A070-4AD0-8609-3602A87B2FB5}"/>
               </a:ext>
             </a:extLst>
           </p:cNvPr>
@@ -16442,7 +16442,7 @@
           <p:cNvPr id="10" name="page">
             <a:extLst xmlns:a="http://schemas.openxmlformats.org/drawingml/2006/main">
               <a:ext uri="{FF2B5EF4-FFF2-40B4-BE49-F238E27FC236}">
-                <a16:creationId xmlns:a16="http://schemas.microsoft.com/office/drawing/2014/main" id="{48B2BD2E-738D-40E5-8C41-BAC6450A7A6B}"/>
+                <a16:creationId xmlns:a16="http://schemas.microsoft.com/office/drawing/2014/main" id="{09199DA3-D7BF-4497-A69A-974CB5313F48}"/>
               </a:ext>
             </a:extLst>
           </p:cNvPr>
@@ -16497,7 +16497,7 @@
     </p:spTree>
     <p:extLst>
       <p:ext uri="{BB962C8B-B14F-4D97-AF65-F5344CB8AC3E}">
-        <p14:creationId xmlns:p14="http://schemas.microsoft.com/office/powerpoint/2010/main" val="445973316"/>
+        <p14:creationId xmlns:p14="http://schemas.microsoft.com/office/powerpoint/2010/main" val="2106044482"/>
       </p:ext>
     </p:extLst>
   </p:cSld>
@@ -16528,7 +16528,7 @@
           <p:cNvPr id="11" name="course">
             <a:extLst xmlns:a="http://schemas.openxmlformats.org/drawingml/2006/main">
               <a:ext uri="{FF2B5EF4-FFF2-40B4-BE49-F238E27FC236}">
-                <a16:creationId xmlns:a16="http://schemas.microsoft.com/office/drawing/2014/main" id="{EE0BE93D-0D20-42BD-BF98-60D71C453843}"/>
+                <a16:creationId xmlns:a16="http://schemas.microsoft.com/office/drawing/2014/main" id="{9C1E1927-98BB-4FBF-80FD-EF046125980C}"/>
               </a:ext>
             </a:extLst>
           </p:cNvPr>
@@ -16585,7 +16585,7 @@
           <p:cNvPr id="2" name="title">
             <a:extLst xmlns:a="http://schemas.openxmlformats.org/drawingml/2006/main">
               <a:ext uri="{FF2B5EF4-FFF2-40B4-BE49-F238E27FC236}">
-                <a16:creationId xmlns:a16="http://schemas.microsoft.com/office/drawing/2014/main" id="{0C3E1570-CF1B-4E49-BBDD-328D08797133}"/>
+                <a16:creationId xmlns:a16="http://schemas.microsoft.com/office/drawing/2014/main" id="{2ADDC111-CED5-4C38-8F02-9D24C4E170A0}"/>
               </a:ext>
             </a:extLst>
           </p:cNvPr>
@@ -16642,7 +16642,7 @@
           <p:cNvPr id="3" name="body">
             <a:extLst xmlns:a="http://schemas.openxmlformats.org/drawingml/2006/main">
               <a:ext uri="{FF2B5EF4-FFF2-40B4-BE49-F238E27FC236}">
-                <a16:creationId xmlns:a16="http://schemas.microsoft.com/office/drawing/2014/main" id="{C8129344-A5A7-45CF-9771-52F8282580DC}"/>
+                <a16:creationId xmlns:a16="http://schemas.microsoft.com/office/drawing/2014/main" id="{6EE7C07C-A2DA-4014-A7A5-AAB03F57C3F1}"/>
               </a:ext>
             </a:extLst>
           </p:cNvPr>
@@ -16699,7 +16699,7 @@
           <p:cNvPr id="4" name="body">
             <a:extLst xmlns:a="http://schemas.openxmlformats.org/drawingml/2006/main">
               <a:ext uri="{FF2B5EF4-FFF2-40B4-BE49-F238E27FC236}">
-                <a16:creationId xmlns:a16="http://schemas.microsoft.com/office/drawing/2014/main" id="{C88820AD-0942-49BC-BD20-ECAC5C281526}"/>
+                <a16:creationId xmlns:a16="http://schemas.microsoft.com/office/drawing/2014/main" id="{E388AD31-1D7B-4FC3-B8A4-C1DF0A28BC6F}"/>
               </a:ext>
             </a:extLst>
           </p:cNvPr>
@@ -16756,7 +16756,7 @@
           <p:cNvPr id="5" name="body">
             <a:extLst xmlns:a="http://schemas.openxmlformats.org/drawingml/2006/main">
               <a:ext uri="{FF2B5EF4-FFF2-40B4-BE49-F238E27FC236}">
-                <a16:creationId xmlns:a16="http://schemas.microsoft.com/office/drawing/2014/main" id="{7BA5B5B3-1D0D-46D1-BFE3-F61E19D9FF78}"/>
+                <a16:creationId xmlns:a16="http://schemas.microsoft.com/office/drawing/2014/main" id="{B1F55F56-AEA7-415D-8113-1A55A7ACC902}"/>
               </a:ext>
             </a:extLst>
           </p:cNvPr>
@@ -16813,7 +16813,7 @@
           <p:cNvPr id="6" name="body">
             <a:extLst xmlns:a="http://schemas.openxmlformats.org/drawingml/2006/main">
               <a:ext uri="{FF2B5EF4-FFF2-40B4-BE49-F238E27FC236}">
-                <a16:creationId xmlns:a16="http://schemas.microsoft.com/office/drawing/2014/main" id="{5288CD7C-4560-4E21-BAF6-5DD376414D94}"/>
+                <a16:creationId xmlns:a16="http://schemas.microsoft.com/office/drawing/2014/main" id="{0AAF42C3-C8AC-4EBE-9C38-F877D5D2CB14}"/>
               </a:ext>
             </a:extLst>
           </p:cNvPr>
@@ -16870,7 +16870,7 @@
           <p:cNvPr id="7" name="body">
             <a:extLst xmlns:a="http://schemas.openxmlformats.org/drawingml/2006/main">
               <a:ext uri="{FF2B5EF4-FFF2-40B4-BE49-F238E27FC236}">
-                <a16:creationId xmlns:a16="http://schemas.microsoft.com/office/drawing/2014/main" id="{28AF9BFF-82DD-428C-97BF-646D4EA377E4}"/>
+                <a16:creationId xmlns:a16="http://schemas.microsoft.com/office/drawing/2014/main" id="{927A3BE8-5FCC-4FDB-A057-EF9F34558AB2}"/>
               </a:ext>
             </a:extLst>
           </p:cNvPr>
@@ -16927,7 +16927,7 @@
           <p:cNvPr id="8" name="body">
             <a:extLst xmlns:a="http://schemas.openxmlformats.org/drawingml/2006/main">
               <a:ext uri="{FF2B5EF4-FFF2-40B4-BE49-F238E27FC236}">
-                <a16:creationId xmlns:a16="http://schemas.microsoft.com/office/drawing/2014/main" id="{42A675A5-4BE6-4DE9-9DB2-FCDD4F7B47DA}"/>
+                <a16:creationId xmlns:a16="http://schemas.microsoft.com/office/drawing/2014/main" id="{2C56F970-EC8A-48AF-B4ED-E5CBA9A7887B}"/>
               </a:ext>
             </a:extLst>
           </p:cNvPr>
@@ -16984,7 +16984,7 @@
           <p:cNvPr id="9" name="footnote">
             <a:extLst xmlns:a="http://schemas.openxmlformats.org/drawingml/2006/main">
               <a:ext uri="{FF2B5EF4-FFF2-40B4-BE49-F238E27FC236}">
-                <a16:creationId xmlns:a16="http://schemas.microsoft.com/office/drawing/2014/main" id="{72282EB9-2932-45FA-BE23-011EC5584384}"/>
+                <a16:creationId xmlns:a16="http://schemas.microsoft.com/office/drawing/2014/main" id="{474B0496-1B24-426C-8CA7-1F8EB209C976}"/>
               </a:ext>
             </a:extLst>
           </p:cNvPr>
@@ -17041,7 +17041,7 @@
           <p:cNvPr id="10" name="page">
             <a:extLst xmlns:a="http://schemas.openxmlformats.org/drawingml/2006/main">
               <a:ext uri="{FF2B5EF4-FFF2-40B4-BE49-F238E27FC236}">
-                <a16:creationId xmlns:a16="http://schemas.microsoft.com/office/drawing/2014/main" id="{CC43DA47-1F4B-4DEE-9EF2-A080B57AC06A}"/>
+                <a16:creationId xmlns:a16="http://schemas.microsoft.com/office/drawing/2014/main" id="{E84E2363-0FAB-46FC-AFF8-DAA973EB94E1}"/>
               </a:ext>
             </a:extLst>
           </p:cNvPr>
@@ -17096,7 +17096,7 @@
     </p:spTree>
     <p:extLst>
       <p:ext uri="{BB962C8B-B14F-4D97-AF65-F5344CB8AC3E}">
-        <p14:creationId xmlns:p14="http://schemas.microsoft.com/office/powerpoint/2010/main" val="1871819945"/>
+        <p14:creationId xmlns:p14="http://schemas.microsoft.com/office/powerpoint/2010/main" val="1590408056"/>
       </p:ext>
     </p:extLst>
   </p:cSld>
@@ -17750,7 +17750,7 @@
           <p:cNvPr id="6" name="course">
             <a:extLst xmlns:a="http://schemas.openxmlformats.org/drawingml/2006/main">
               <a:ext uri="{FF2B5EF4-FFF2-40B4-BE49-F238E27FC236}">
-                <a16:creationId xmlns:a16="http://schemas.microsoft.com/office/drawing/2014/main" id="{ADC7E8A6-4B1D-45AD-899D-39189E60EAF4}"/>
+                <a16:creationId xmlns:a16="http://schemas.microsoft.com/office/drawing/2014/main" id="{C6DCFE1A-AB91-4426-8FAD-40E0E52470B0}"/>
               </a:ext>
             </a:extLst>
           </p:cNvPr>
@@ -17807,7 +17807,7 @@
           <p:cNvPr id="2" name="title">
             <a:extLst xmlns:a="http://schemas.openxmlformats.org/drawingml/2006/main">
               <a:ext uri="{FF2B5EF4-FFF2-40B4-BE49-F238E27FC236}">
-                <a16:creationId xmlns:a16="http://schemas.microsoft.com/office/drawing/2014/main" id="{6BC4FD7C-D4AB-4179-949C-EECB37C6F2E9}"/>
+                <a16:creationId xmlns:a16="http://schemas.microsoft.com/office/drawing/2014/main" id="{1022B827-8798-442A-A049-EB0F8E863A17}"/>
               </a:ext>
             </a:extLst>
           </p:cNvPr>
@@ -17871,7 +17871,7 @@
         </p:xfrm>
         <a:graphic xmlns:a="http://schemas.openxmlformats.org/drawingml/2006/main">
           <a:graphicData uri="http://schemas.openxmlformats.org/drawingml/2006/chart">
-            <c:chart xmlns:r="http://schemas.openxmlformats.org/officeDocument/2006/relationships" xmlns:c="http://schemas.openxmlformats.org/drawingml/2006/chart" r:id="R2f06755fa5e2408f"/>
+            <c:chart xmlns:r="http://schemas.openxmlformats.org/officeDocument/2006/relationships" xmlns:c="http://schemas.openxmlformats.org/drawingml/2006/chart" r:id="Reb1618f0792d4afc"/>
           </a:graphicData>
         </a:graphic>
       </p:graphicFrame>
@@ -17880,7 +17880,7 @@
           <p:cNvPr id="4" name="footnote">
             <a:extLst xmlns:a="http://schemas.openxmlformats.org/drawingml/2006/main">
               <a:ext uri="{FF2B5EF4-FFF2-40B4-BE49-F238E27FC236}">
-                <a16:creationId xmlns:a16="http://schemas.microsoft.com/office/drawing/2014/main" id="{A859A62C-596F-4D30-8E39-5FDEEBCAD1C1}"/>
+                <a16:creationId xmlns:a16="http://schemas.microsoft.com/office/drawing/2014/main" id="{4C5F8037-BBBE-474F-8F3E-C544F78C0770}"/>
               </a:ext>
             </a:extLst>
           </p:cNvPr>
@@ -17937,7 +17937,7 @@
           <p:cNvPr id="5" name="page">
             <a:extLst xmlns:a="http://schemas.openxmlformats.org/drawingml/2006/main">
               <a:ext uri="{FF2B5EF4-FFF2-40B4-BE49-F238E27FC236}">
-                <a16:creationId xmlns:a16="http://schemas.microsoft.com/office/drawing/2014/main" id="{0A77A616-05E2-4271-ABE0-40B4FFBA683E}"/>
+                <a16:creationId xmlns:a16="http://schemas.microsoft.com/office/drawing/2014/main" id="{B59C6EEE-F9BF-4F7F-A4EB-F90B4FF093DD}"/>
               </a:ext>
             </a:extLst>
           </p:cNvPr>
@@ -17992,7 +17992,7 @@
     </p:spTree>
     <p:extLst>
       <p:ext uri="{BB962C8B-B14F-4D97-AF65-F5344CB8AC3E}">
-        <p14:creationId xmlns:p14="http://schemas.microsoft.com/office/powerpoint/2010/main" val="1723300289"/>
+        <p14:creationId xmlns:p14="http://schemas.microsoft.com/office/powerpoint/2010/main" val="61246321"/>
       </p:ext>
     </p:extLst>
   </p:cSld>
@@ -18023,7 +18023,7 @@
           <p:cNvPr id="12" name="course">
             <a:extLst xmlns:a="http://schemas.openxmlformats.org/drawingml/2006/main">
               <a:ext uri="{FF2B5EF4-FFF2-40B4-BE49-F238E27FC236}">
-                <a16:creationId xmlns:a16="http://schemas.microsoft.com/office/drawing/2014/main" id="{B8B304D3-DDE7-4134-838A-83B33573F655}"/>
+                <a16:creationId xmlns:a16="http://schemas.microsoft.com/office/drawing/2014/main" id="{A11A86AC-D18D-4E0D-94B9-C61FE7538B4E}"/>
               </a:ext>
             </a:extLst>
           </p:cNvPr>
@@ -18080,7 +18080,7 @@
           <p:cNvPr id="2" name="title">
             <a:extLst xmlns:a="http://schemas.openxmlformats.org/drawingml/2006/main">
               <a:ext uri="{FF2B5EF4-FFF2-40B4-BE49-F238E27FC236}">
-                <a16:creationId xmlns:a16="http://schemas.microsoft.com/office/drawing/2014/main" id="{594DC244-1FD1-4320-A5CD-CBAED23161B3}"/>
+                <a16:creationId xmlns:a16="http://schemas.microsoft.com/office/drawing/2014/main" id="{953599C5-EBA2-4C17-A4DB-3C6BD08A4ED4}"/>
               </a:ext>
             </a:extLst>
           </p:cNvPr>
@@ -18137,7 +18137,7 @@
           <p:cNvPr id="3" name="body">
             <a:extLst xmlns:a="http://schemas.openxmlformats.org/drawingml/2006/main">
               <a:ext uri="{FF2B5EF4-FFF2-40B4-BE49-F238E27FC236}">
-                <a16:creationId xmlns:a16="http://schemas.microsoft.com/office/drawing/2014/main" id="{B3667B12-49CA-4C25-BE51-1F4C8C766EE1}"/>
+                <a16:creationId xmlns:a16="http://schemas.microsoft.com/office/drawing/2014/main" id="{338B6F6F-32B4-49A6-8110-928ED94741FF}"/>
               </a:ext>
             </a:extLst>
           </p:cNvPr>
@@ -18194,7 +18194,7 @@
           <p:cNvPr id="4" name="body">
             <a:extLst xmlns:a="http://schemas.openxmlformats.org/drawingml/2006/main">
               <a:ext uri="{FF2B5EF4-FFF2-40B4-BE49-F238E27FC236}">
-                <a16:creationId xmlns:a16="http://schemas.microsoft.com/office/drawing/2014/main" id="{43779E47-60CC-44C5-8632-C9569E1CD34E}"/>
+                <a16:creationId xmlns:a16="http://schemas.microsoft.com/office/drawing/2014/main" id="{79FA5802-FAC3-40E0-BC97-763E9B62E121}"/>
               </a:ext>
             </a:extLst>
           </p:cNvPr>
@@ -18251,7 +18251,7 @@
           <p:cNvPr id="5" name="body">
             <a:extLst xmlns:a="http://schemas.openxmlformats.org/drawingml/2006/main">
               <a:ext uri="{FF2B5EF4-FFF2-40B4-BE49-F238E27FC236}">
-                <a16:creationId xmlns:a16="http://schemas.microsoft.com/office/drawing/2014/main" id="{0EABF132-DDAE-4588-9B07-AA447489D69B}"/>
+                <a16:creationId xmlns:a16="http://schemas.microsoft.com/office/drawing/2014/main" id="{B367F81D-B25B-4AA3-8702-AE828DAEBDA0}"/>
               </a:ext>
             </a:extLst>
           </p:cNvPr>
@@ -18308,7 +18308,7 @@
           <p:cNvPr id="6" name="body">
             <a:extLst xmlns:a="http://schemas.openxmlformats.org/drawingml/2006/main">
               <a:ext uri="{FF2B5EF4-FFF2-40B4-BE49-F238E27FC236}">
-                <a16:creationId xmlns:a16="http://schemas.microsoft.com/office/drawing/2014/main" id="{FC0BA2BD-CBE6-4C63-A616-30715078B264}"/>
+                <a16:creationId xmlns:a16="http://schemas.microsoft.com/office/drawing/2014/main" id="{9597A48A-C27E-46E9-9AA2-4EDB95A3E4D3}"/>
               </a:ext>
             </a:extLst>
           </p:cNvPr>
@@ -18365,7 +18365,7 @@
           <p:cNvPr id="7" name="body">
             <a:extLst xmlns:a="http://schemas.openxmlformats.org/drawingml/2006/main">
               <a:ext uri="{FF2B5EF4-FFF2-40B4-BE49-F238E27FC236}">
-                <a16:creationId xmlns:a16="http://schemas.microsoft.com/office/drawing/2014/main" id="{3C58F714-F292-4CE6-AF56-D169EECD0919}"/>
+                <a16:creationId xmlns:a16="http://schemas.microsoft.com/office/drawing/2014/main" id="{24DA46CD-5269-4562-8B2A-FFBA90FD4DEA}"/>
               </a:ext>
             </a:extLst>
           </p:cNvPr>
@@ -18422,7 +18422,7 @@
           <p:cNvPr id="8" name="body">
             <a:extLst xmlns:a="http://schemas.openxmlformats.org/drawingml/2006/main">
               <a:ext uri="{FF2B5EF4-FFF2-40B4-BE49-F238E27FC236}">
-                <a16:creationId xmlns:a16="http://schemas.microsoft.com/office/drawing/2014/main" id="{C1BC5B72-56BB-4BBD-94C1-F01C687ABD7C}"/>
+                <a16:creationId xmlns:a16="http://schemas.microsoft.com/office/drawing/2014/main" id="{C8A8444C-6958-45E7-80B2-FC098E437144}"/>
               </a:ext>
             </a:extLst>
           </p:cNvPr>
@@ -18479,7 +18479,7 @@
           <p:cNvPr id="9" name="equation">
             <a:extLst xmlns:a="http://schemas.openxmlformats.org/drawingml/2006/main">
               <a:ext uri="{FF2B5EF4-FFF2-40B4-BE49-F238E27FC236}">
-                <a16:creationId xmlns:a16="http://schemas.microsoft.com/office/drawing/2014/main" id="{27FB6F7C-3158-42F0-B9CA-55EA8D04B50D}"/>
+                <a16:creationId xmlns:a16="http://schemas.microsoft.com/office/drawing/2014/main" id="{8D74E7D9-03AC-4AC4-A902-7094B462266A}"/>
               </a:ext>
             </a:extLst>
           </p:cNvPr>
@@ -18536,7 +18536,7 @@
           <p:cNvPr id="10" name="footnote">
             <a:extLst xmlns:a="http://schemas.openxmlformats.org/drawingml/2006/main">
               <a:ext uri="{FF2B5EF4-FFF2-40B4-BE49-F238E27FC236}">
-                <a16:creationId xmlns:a16="http://schemas.microsoft.com/office/drawing/2014/main" id="{57FA22C2-474A-4BCD-BC6B-DEFDFBB0B2D1}"/>
+                <a16:creationId xmlns:a16="http://schemas.microsoft.com/office/drawing/2014/main" id="{90A660DC-DBF7-4419-880A-BEC983A9AA70}"/>
               </a:ext>
             </a:extLst>
           </p:cNvPr>
@@ -18593,7 +18593,7 @@
           <p:cNvPr id="11" name="page">
             <a:extLst xmlns:a="http://schemas.openxmlformats.org/drawingml/2006/main">
               <a:ext uri="{FF2B5EF4-FFF2-40B4-BE49-F238E27FC236}">
-                <a16:creationId xmlns:a16="http://schemas.microsoft.com/office/drawing/2014/main" id="{22D4CA65-9B53-4FDA-8B62-4935E8BE4C70}"/>
+                <a16:creationId xmlns:a16="http://schemas.microsoft.com/office/drawing/2014/main" id="{E790233A-56A8-4AE4-AA31-5218FFF624DD}"/>
               </a:ext>
             </a:extLst>
           </p:cNvPr>
@@ -18648,7 +18648,7 @@
     </p:spTree>
     <p:extLst>
       <p:ext uri="{BB962C8B-B14F-4D97-AF65-F5344CB8AC3E}">
-        <p14:creationId xmlns:p14="http://schemas.microsoft.com/office/powerpoint/2010/main" val="413984546"/>
+        <p14:creationId xmlns:p14="http://schemas.microsoft.com/office/powerpoint/2010/main" val="2032883015"/>
       </p:ext>
     </p:extLst>
   </p:cSld>
@@ -18679,7 +18679,7 @@
           <p:cNvPr id="12" name="course">
             <a:extLst xmlns:a="http://schemas.openxmlformats.org/drawingml/2006/main">
               <a:ext uri="{FF2B5EF4-FFF2-40B4-BE49-F238E27FC236}">
-                <a16:creationId xmlns:a16="http://schemas.microsoft.com/office/drawing/2014/main" id="{4699073C-C0FE-4D04-B947-BEB2382BF9D4}"/>
+                <a16:creationId xmlns:a16="http://schemas.microsoft.com/office/drawing/2014/main" id="{F698F704-8D9F-4426-B159-72B7CB4D738D}"/>
               </a:ext>
             </a:extLst>
           </p:cNvPr>
@@ -18736,7 +18736,7 @@
           <p:cNvPr id="2" name="title">
             <a:extLst xmlns:a="http://schemas.openxmlformats.org/drawingml/2006/main">
               <a:ext uri="{FF2B5EF4-FFF2-40B4-BE49-F238E27FC236}">
-                <a16:creationId xmlns:a16="http://schemas.microsoft.com/office/drawing/2014/main" id="{C4CC3D35-D8F4-4F8C-B34A-C9E355319968}"/>
+                <a16:creationId xmlns:a16="http://schemas.microsoft.com/office/drawing/2014/main" id="{94F71E7F-16F7-4738-8ED6-D40552A23AA4}"/>
               </a:ext>
             </a:extLst>
           </p:cNvPr>
@@ -18793,7 +18793,7 @@
           <p:cNvPr id="3" name="body">
             <a:extLst xmlns:a="http://schemas.openxmlformats.org/drawingml/2006/main">
               <a:ext uri="{FF2B5EF4-FFF2-40B4-BE49-F238E27FC236}">
-                <a16:creationId xmlns:a16="http://schemas.microsoft.com/office/drawing/2014/main" id="{3CF8A5EE-FCC0-4458-8BDF-D885E384B2C8}"/>
+                <a16:creationId xmlns:a16="http://schemas.microsoft.com/office/drawing/2014/main" id="{13C7E38E-148C-4219-BE6D-D2810BFD66D8}"/>
               </a:ext>
             </a:extLst>
           </p:cNvPr>
@@ -18850,7 +18850,7 @@
           <p:cNvPr id="4" name="body">
             <a:extLst xmlns:a="http://schemas.openxmlformats.org/drawingml/2006/main">
               <a:ext uri="{FF2B5EF4-FFF2-40B4-BE49-F238E27FC236}">
-                <a16:creationId xmlns:a16="http://schemas.microsoft.com/office/drawing/2014/main" id="{04E1C323-E031-482D-87CC-58FE7FEBADE5}"/>
+                <a16:creationId xmlns:a16="http://schemas.microsoft.com/office/drawing/2014/main" id="{C384A7FA-34A9-482C-A4E0-6704FB6F9454}"/>
               </a:ext>
             </a:extLst>
           </p:cNvPr>
@@ -18907,7 +18907,7 @@
           <p:cNvPr id="5" name="body">
             <a:extLst xmlns:a="http://schemas.openxmlformats.org/drawingml/2006/main">
               <a:ext uri="{FF2B5EF4-FFF2-40B4-BE49-F238E27FC236}">
-                <a16:creationId xmlns:a16="http://schemas.microsoft.com/office/drawing/2014/main" id="{8965D221-E1B1-487A-A832-1889F4B65C2B}"/>
+                <a16:creationId xmlns:a16="http://schemas.microsoft.com/office/drawing/2014/main" id="{64B4F40B-B1DD-4A94-A1E8-5901ABE3A0E2}"/>
               </a:ext>
             </a:extLst>
           </p:cNvPr>
@@ -18964,7 +18964,7 @@
           <p:cNvPr id="6" name="body">
             <a:extLst xmlns:a="http://schemas.openxmlformats.org/drawingml/2006/main">
               <a:ext uri="{FF2B5EF4-FFF2-40B4-BE49-F238E27FC236}">
-                <a16:creationId xmlns:a16="http://schemas.microsoft.com/office/drawing/2014/main" id="{179DD79F-1C08-491F-B6B6-C61711E8E0BC}"/>
+                <a16:creationId xmlns:a16="http://schemas.microsoft.com/office/drawing/2014/main" id="{058D126D-AC8F-48FF-9B11-5D9042AD91F4}"/>
               </a:ext>
             </a:extLst>
           </p:cNvPr>
@@ -19021,7 +19021,7 @@
           <p:cNvPr id="7" name="body">
             <a:extLst xmlns:a="http://schemas.openxmlformats.org/drawingml/2006/main">
               <a:ext uri="{FF2B5EF4-FFF2-40B4-BE49-F238E27FC236}">
-                <a16:creationId xmlns:a16="http://schemas.microsoft.com/office/drawing/2014/main" id="{AFEB6C24-C8EE-462F-B260-684C2B889288}"/>
+                <a16:creationId xmlns:a16="http://schemas.microsoft.com/office/drawing/2014/main" id="{AE6E6A95-74F3-4879-88B1-739ABF657C09}"/>
               </a:ext>
             </a:extLst>
           </p:cNvPr>
@@ -19078,7 +19078,7 @@
           <p:cNvPr id="8" name="body">
             <a:extLst xmlns:a="http://schemas.openxmlformats.org/drawingml/2006/main">
               <a:ext uri="{FF2B5EF4-FFF2-40B4-BE49-F238E27FC236}">
-                <a16:creationId xmlns:a16="http://schemas.microsoft.com/office/drawing/2014/main" id="{FE7B75F8-52D5-4978-B6D2-63758BC3A9C1}"/>
+                <a16:creationId xmlns:a16="http://schemas.microsoft.com/office/drawing/2014/main" id="{61BE022C-56B5-4825-870F-7B09515A0154}"/>
               </a:ext>
             </a:extLst>
           </p:cNvPr>
@@ -19135,7 +19135,7 @@
           <p:cNvPr id="9" name="equation">
             <a:extLst xmlns:a="http://schemas.openxmlformats.org/drawingml/2006/main">
               <a:ext uri="{FF2B5EF4-FFF2-40B4-BE49-F238E27FC236}">
-                <a16:creationId xmlns:a16="http://schemas.microsoft.com/office/drawing/2014/main" id="{7BB02A82-D708-4EF3-B41D-3531E11FF095}"/>
+                <a16:creationId xmlns:a16="http://schemas.microsoft.com/office/drawing/2014/main" id="{D687F28E-C9A8-4FD3-BCC8-FAC3639C9124}"/>
               </a:ext>
             </a:extLst>
           </p:cNvPr>
@@ -19192,7 +19192,7 @@
           <p:cNvPr id="10" name="footnote">
             <a:extLst xmlns:a="http://schemas.openxmlformats.org/drawingml/2006/main">
               <a:ext uri="{FF2B5EF4-FFF2-40B4-BE49-F238E27FC236}">
-                <a16:creationId xmlns:a16="http://schemas.microsoft.com/office/drawing/2014/main" id="{9EDFB6ED-86BF-492C-987F-4A0F00E9AD5A}"/>
+                <a16:creationId xmlns:a16="http://schemas.microsoft.com/office/drawing/2014/main" id="{E02F64FD-CA7B-4D0A-B32D-278D41CACA4C}"/>
               </a:ext>
             </a:extLst>
           </p:cNvPr>
@@ -19249,7 +19249,7 @@
           <p:cNvPr id="11" name="page">
             <a:extLst xmlns:a="http://schemas.openxmlformats.org/drawingml/2006/main">
               <a:ext uri="{FF2B5EF4-FFF2-40B4-BE49-F238E27FC236}">
-                <a16:creationId xmlns:a16="http://schemas.microsoft.com/office/drawing/2014/main" id="{7E4F5108-AFEE-40B6-AE8E-E3860F09B365}"/>
+                <a16:creationId xmlns:a16="http://schemas.microsoft.com/office/drawing/2014/main" id="{74AF52EB-D0E2-4AF1-97B0-B8082D17D882}"/>
               </a:ext>
             </a:extLst>
           </p:cNvPr>
@@ -19304,7 +19304,7 @@
     </p:spTree>
     <p:extLst>
       <p:ext uri="{BB962C8B-B14F-4D97-AF65-F5344CB8AC3E}">
-        <p14:creationId xmlns:p14="http://schemas.microsoft.com/office/powerpoint/2010/main" val="475059652"/>
+        <p14:creationId xmlns:p14="http://schemas.microsoft.com/office/powerpoint/2010/main" val="268659924"/>
       </p:ext>
     </p:extLst>
   </p:cSld>
@@ -19335,7 +19335,7 @@
           <p:cNvPr id="11" name="course">
             <a:extLst xmlns:a="http://schemas.openxmlformats.org/drawingml/2006/main">
               <a:ext uri="{FF2B5EF4-FFF2-40B4-BE49-F238E27FC236}">
-                <a16:creationId xmlns:a16="http://schemas.microsoft.com/office/drawing/2014/main" id="{F40F8147-E17D-415C-BAB9-A420B622FFAC}"/>
+                <a16:creationId xmlns:a16="http://schemas.microsoft.com/office/drawing/2014/main" id="{BEF3FFA3-33E8-4C5F-9C39-D87718DC536B}"/>
               </a:ext>
             </a:extLst>
           </p:cNvPr>
@@ -19392,7 +19392,7 @@
           <p:cNvPr id="2" name="title">
             <a:extLst xmlns:a="http://schemas.openxmlformats.org/drawingml/2006/main">
               <a:ext uri="{FF2B5EF4-FFF2-40B4-BE49-F238E27FC236}">
-                <a16:creationId xmlns:a16="http://schemas.microsoft.com/office/drawing/2014/main" id="{732C97B5-6328-47F0-8CE8-9DC7B6F9302D}"/>
+                <a16:creationId xmlns:a16="http://schemas.microsoft.com/office/drawing/2014/main" id="{342A5B80-F9F6-49A5-BC8B-FB8C31ADDE79}"/>
               </a:ext>
             </a:extLst>
           </p:cNvPr>
@@ -19449,7 +19449,7 @@
           <p:cNvPr id="3" name="body">
             <a:extLst xmlns:a="http://schemas.openxmlformats.org/drawingml/2006/main">
               <a:ext uri="{FF2B5EF4-FFF2-40B4-BE49-F238E27FC236}">
-                <a16:creationId xmlns:a16="http://schemas.microsoft.com/office/drawing/2014/main" id="{D26FB4A3-98BB-47DD-B15D-4B11C1363EEB}"/>
+                <a16:creationId xmlns:a16="http://schemas.microsoft.com/office/drawing/2014/main" id="{242DEAC3-5C88-4DA7-8FA8-F14821525B9B}"/>
               </a:ext>
             </a:extLst>
           </p:cNvPr>
@@ -19506,7 +19506,7 @@
           <p:cNvPr id="4" name="body">
             <a:extLst xmlns:a="http://schemas.openxmlformats.org/drawingml/2006/main">
               <a:ext uri="{FF2B5EF4-FFF2-40B4-BE49-F238E27FC236}">
-                <a16:creationId xmlns:a16="http://schemas.microsoft.com/office/drawing/2014/main" id="{34195267-AE54-413D-8F40-34099BE527A3}"/>
+                <a16:creationId xmlns:a16="http://schemas.microsoft.com/office/drawing/2014/main" id="{D305D48A-1458-42B6-A0B3-6AD9C65AACDE}"/>
               </a:ext>
             </a:extLst>
           </p:cNvPr>
@@ -19563,7 +19563,7 @@
           <p:cNvPr id="5" name="body">
             <a:extLst xmlns:a="http://schemas.openxmlformats.org/drawingml/2006/main">
               <a:ext uri="{FF2B5EF4-FFF2-40B4-BE49-F238E27FC236}">
-                <a16:creationId xmlns:a16="http://schemas.microsoft.com/office/drawing/2014/main" id="{A698E2FE-F42A-45C9-8665-2302033308EE}"/>
+                <a16:creationId xmlns:a16="http://schemas.microsoft.com/office/drawing/2014/main" id="{A33E6D04-700C-4381-8564-EA684701DC89}"/>
               </a:ext>
             </a:extLst>
           </p:cNvPr>
@@ -19620,7 +19620,7 @@
           <p:cNvPr id="6" name="body">
             <a:extLst xmlns:a="http://schemas.openxmlformats.org/drawingml/2006/main">
               <a:ext uri="{FF2B5EF4-FFF2-40B4-BE49-F238E27FC236}">
-                <a16:creationId xmlns:a16="http://schemas.microsoft.com/office/drawing/2014/main" id="{BA999D1A-BF57-456D-AB6D-99007967EFE3}"/>
+                <a16:creationId xmlns:a16="http://schemas.microsoft.com/office/drawing/2014/main" id="{857F95BD-EA78-4B7D-BBD1-A36199E2B01F}"/>
               </a:ext>
             </a:extLst>
           </p:cNvPr>
@@ -19677,7 +19677,7 @@
           <p:cNvPr id="7" name="body">
             <a:extLst xmlns:a="http://schemas.openxmlformats.org/drawingml/2006/main">
               <a:ext uri="{FF2B5EF4-FFF2-40B4-BE49-F238E27FC236}">
-                <a16:creationId xmlns:a16="http://schemas.microsoft.com/office/drawing/2014/main" id="{2B7990B5-0B39-45B6-8E03-C261926BCB67}"/>
+                <a16:creationId xmlns:a16="http://schemas.microsoft.com/office/drawing/2014/main" id="{C19C7313-E15B-490D-AED2-34E8EFFCB2EA}"/>
               </a:ext>
             </a:extLst>
           </p:cNvPr>
@@ -19734,7 +19734,7 @@
           <p:cNvPr id="8" name="body">
             <a:extLst xmlns:a="http://schemas.openxmlformats.org/drawingml/2006/main">
               <a:ext uri="{FF2B5EF4-FFF2-40B4-BE49-F238E27FC236}">
-                <a16:creationId xmlns:a16="http://schemas.microsoft.com/office/drawing/2014/main" id="{8B818F29-5B58-4E80-91D1-22067D2D520A}"/>
+                <a16:creationId xmlns:a16="http://schemas.microsoft.com/office/drawing/2014/main" id="{B4CCD04B-DF0B-43F1-9A1A-54941D8008D0}"/>
               </a:ext>
             </a:extLst>
           </p:cNvPr>
@@ -19791,7 +19791,7 @@
           <p:cNvPr id="9" name="footnote">
             <a:extLst xmlns:a="http://schemas.openxmlformats.org/drawingml/2006/main">
               <a:ext uri="{FF2B5EF4-FFF2-40B4-BE49-F238E27FC236}">
-                <a16:creationId xmlns:a16="http://schemas.microsoft.com/office/drawing/2014/main" id="{494D4E58-5B78-4D56-9709-9FFEAA30E605}"/>
+                <a16:creationId xmlns:a16="http://schemas.microsoft.com/office/drawing/2014/main" id="{3CCA8A6E-5D98-4CF0-8621-758C9479FA84}"/>
               </a:ext>
             </a:extLst>
           </p:cNvPr>
@@ -19848,7 +19848,7 @@
           <p:cNvPr id="10" name="page">
             <a:extLst xmlns:a="http://schemas.openxmlformats.org/drawingml/2006/main">
               <a:ext uri="{FF2B5EF4-FFF2-40B4-BE49-F238E27FC236}">
-                <a16:creationId xmlns:a16="http://schemas.microsoft.com/office/drawing/2014/main" id="{BA4E7130-88A2-476F-A367-F13D352F6F36}"/>
+                <a16:creationId xmlns:a16="http://schemas.microsoft.com/office/drawing/2014/main" id="{4839E75C-8D62-4DCF-98BF-1463B2F979B5}"/>
               </a:ext>
             </a:extLst>
           </p:cNvPr>
@@ -19903,7 +19903,7 @@
     </p:spTree>
     <p:extLst>
       <p:ext uri="{BB962C8B-B14F-4D97-AF65-F5344CB8AC3E}">
-        <p14:creationId xmlns:p14="http://schemas.microsoft.com/office/powerpoint/2010/main" val="836630377"/>
+        <p14:creationId xmlns:p14="http://schemas.microsoft.com/office/powerpoint/2010/main" val="822996911"/>
       </p:ext>
     </p:extLst>
   </p:cSld>
@@ -20838,7 +20838,7 @@
           <p:cNvPr id="10" name="course">
             <a:extLst xmlns:a="http://schemas.openxmlformats.org/drawingml/2006/main">
               <a:ext uri="{FF2B5EF4-FFF2-40B4-BE49-F238E27FC236}">
-                <a16:creationId xmlns:a16="http://schemas.microsoft.com/office/drawing/2014/main" id="{671417F5-7396-4D07-8FA9-DEA86F5950E8}"/>
+                <a16:creationId xmlns:a16="http://schemas.microsoft.com/office/drawing/2014/main" id="{E3EB2663-F8D7-4C40-A054-15A2F6B8ED57}"/>
               </a:ext>
             </a:extLst>
           </p:cNvPr>
@@ -20895,7 +20895,7 @@
           <p:cNvPr id="2" name="title">
             <a:extLst xmlns:a="http://schemas.openxmlformats.org/drawingml/2006/main">
               <a:ext uri="{FF2B5EF4-FFF2-40B4-BE49-F238E27FC236}">
-                <a16:creationId xmlns:a16="http://schemas.microsoft.com/office/drawing/2014/main" id="{200D1202-7511-4E84-801B-C13E1E58955F}"/>
+                <a16:creationId xmlns:a16="http://schemas.microsoft.com/office/drawing/2014/main" id="{1DE14DA3-FCF2-4217-9A09-E1D8452D8E67}"/>
               </a:ext>
             </a:extLst>
           </p:cNvPr>
@@ -20952,7 +20952,7 @@
           <p:cNvPr id="3" name="body">
             <a:extLst xmlns:a="http://schemas.openxmlformats.org/drawingml/2006/main">
               <a:ext uri="{FF2B5EF4-FFF2-40B4-BE49-F238E27FC236}">
-                <a16:creationId xmlns:a16="http://schemas.microsoft.com/office/drawing/2014/main" id="{FD02CF0D-4FC3-40CF-B391-2246AF5A645C}"/>
+                <a16:creationId xmlns:a16="http://schemas.microsoft.com/office/drawing/2014/main" id="{0146A183-5230-4C0D-93F8-34B8EFB70C8E}"/>
               </a:ext>
             </a:extLst>
           </p:cNvPr>
@@ -21009,7 +21009,7 @@
           <p:cNvPr id="4" name="body">
             <a:extLst xmlns:a="http://schemas.openxmlformats.org/drawingml/2006/main">
               <a:ext uri="{FF2B5EF4-FFF2-40B4-BE49-F238E27FC236}">
-                <a16:creationId xmlns:a16="http://schemas.microsoft.com/office/drawing/2014/main" id="{C0447E3B-51DA-40F7-8BF6-BEF1468ECA34}"/>
+                <a16:creationId xmlns:a16="http://schemas.microsoft.com/office/drawing/2014/main" id="{E6211AF5-4ED6-44AD-85C4-8DED2FF1FBFC}"/>
               </a:ext>
             </a:extLst>
           </p:cNvPr>
@@ -21066,7 +21066,7 @@
           <p:cNvPr id="5" name="body">
             <a:extLst xmlns:a="http://schemas.openxmlformats.org/drawingml/2006/main">
               <a:ext uri="{FF2B5EF4-FFF2-40B4-BE49-F238E27FC236}">
-                <a16:creationId xmlns:a16="http://schemas.microsoft.com/office/drawing/2014/main" id="{B1A98C6B-B0F9-4C77-BCBC-EC389D4AE512}"/>
+                <a16:creationId xmlns:a16="http://schemas.microsoft.com/office/drawing/2014/main" id="{6BC88D45-C569-4C37-B446-8A30DE1306F5}"/>
               </a:ext>
             </a:extLst>
           </p:cNvPr>
@@ -21123,7 +21123,7 @@
           <p:cNvPr id="6" name="body">
             <a:extLst xmlns:a="http://schemas.openxmlformats.org/drawingml/2006/main">
               <a:ext uri="{FF2B5EF4-FFF2-40B4-BE49-F238E27FC236}">
-                <a16:creationId xmlns:a16="http://schemas.microsoft.com/office/drawing/2014/main" id="{6B82641A-1CEA-449A-AD32-A7F6595FB97D}"/>
+                <a16:creationId xmlns:a16="http://schemas.microsoft.com/office/drawing/2014/main" id="{B886A4C0-F98B-4729-BFED-2688248BDB79}"/>
               </a:ext>
             </a:extLst>
           </p:cNvPr>
@@ -21180,7 +21180,7 @@
           <p:cNvPr id="7" name="body">
             <a:extLst xmlns:a="http://schemas.openxmlformats.org/drawingml/2006/main">
               <a:ext uri="{FF2B5EF4-FFF2-40B4-BE49-F238E27FC236}">
-                <a16:creationId xmlns:a16="http://schemas.microsoft.com/office/drawing/2014/main" id="{0032B3C3-4FF9-4951-9CB0-3DDE77C4ED63}"/>
+                <a16:creationId xmlns:a16="http://schemas.microsoft.com/office/drawing/2014/main" id="{9D460A2B-456E-48AC-8FD5-BFA4C7EB28BF}"/>
               </a:ext>
             </a:extLst>
           </p:cNvPr>
@@ -21237,7 +21237,7 @@
           <p:cNvPr id="8" name="body">
             <a:extLst xmlns:a="http://schemas.openxmlformats.org/drawingml/2006/main">
               <a:ext uri="{FF2B5EF4-FFF2-40B4-BE49-F238E27FC236}">
-                <a16:creationId xmlns:a16="http://schemas.microsoft.com/office/drawing/2014/main" id="{75A83A62-FCBA-4444-8209-A479D22A5F3F}"/>
+                <a16:creationId xmlns:a16="http://schemas.microsoft.com/office/drawing/2014/main" id="{8A066DB0-D533-466B-B70B-04E20D11DA9C}"/>
               </a:ext>
             </a:extLst>
           </p:cNvPr>
@@ -21294,7 +21294,7 @@
           <p:cNvPr id="9" name="page">
             <a:extLst xmlns:a="http://schemas.openxmlformats.org/drawingml/2006/main">
               <a:ext uri="{FF2B5EF4-FFF2-40B4-BE49-F238E27FC236}">
-                <a16:creationId xmlns:a16="http://schemas.microsoft.com/office/drawing/2014/main" id="{D6CDF726-E99D-4B8B-8B0C-316554942457}"/>
+                <a16:creationId xmlns:a16="http://schemas.microsoft.com/office/drawing/2014/main" id="{66B1BBB0-68A6-47AD-BFF2-D0854A570608}"/>
               </a:ext>
             </a:extLst>
           </p:cNvPr>
@@ -21349,7 +21349,7 @@
     </p:spTree>
     <p:extLst>
       <p:ext uri="{BB962C8B-B14F-4D97-AF65-F5344CB8AC3E}">
-        <p14:creationId xmlns:p14="http://schemas.microsoft.com/office/powerpoint/2010/main" val="55361629"/>
+        <p14:creationId xmlns:p14="http://schemas.microsoft.com/office/powerpoint/2010/main" val="1645901957"/>
       </p:ext>
     </p:extLst>
   </p:cSld>
@@ -21380,7 +21380,7 @@
           <p:cNvPr id="11" name="course">
             <a:extLst xmlns:a="http://schemas.openxmlformats.org/drawingml/2006/main">
               <a:ext uri="{FF2B5EF4-FFF2-40B4-BE49-F238E27FC236}">
-                <a16:creationId xmlns:a16="http://schemas.microsoft.com/office/drawing/2014/main" id="{5B888717-7567-4F92-8AC2-6A406B1447FB}"/>
+                <a16:creationId xmlns:a16="http://schemas.microsoft.com/office/drawing/2014/main" id="{59A1074D-D0F0-44F4-9F4E-1F26B9BDFB4A}"/>
               </a:ext>
             </a:extLst>
           </p:cNvPr>
@@ -21437,7 +21437,7 @@
           <p:cNvPr id="2" name="title">
             <a:extLst xmlns:a="http://schemas.openxmlformats.org/drawingml/2006/main">
               <a:ext uri="{FF2B5EF4-FFF2-40B4-BE49-F238E27FC236}">
-                <a16:creationId xmlns:a16="http://schemas.microsoft.com/office/drawing/2014/main" id="{0B35D47E-A007-436A-9186-7B2A087DF460}"/>
+                <a16:creationId xmlns:a16="http://schemas.microsoft.com/office/drawing/2014/main" id="{92356765-8D59-4A17-B355-8470909B5497}"/>
               </a:ext>
             </a:extLst>
           </p:cNvPr>
@@ -21494,7 +21494,7 @@
           <p:cNvPr id="3" name="body">
             <a:extLst xmlns:a="http://schemas.openxmlformats.org/drawingml/2006/main">
               <a:ext uri="{FF2B5EF4-FFF2-40B4-BE49-F238E27FC236}">
-                <a16:creationId xmlns:a16="http://schemas.microsoft.com/office/drawing/2014/main" id="{7C39B60C-1818-4A74-BC14-7C64BDEF9BB5}"/>
+                <a16:creationId xmlns:a16="http://schemas.microsoft.com/office/drawing/2014/main" id="{CAAC6465-0BC9-4610-9041-5A60620265E7}"/>
               </a:ext>
             </a:extLst>
           </p:cNvPr>
@@ -21551,7 +21551,7 @@
           <p:cNvPr id="4" name="body">
             <a:extLst xmlns:a="http://schemas.openxmlformats.org/drawingml/2006/main">
               <a:ext uri="{FF2B5EF4-FFF2-40B4-BE49-F238E27FC236}">
-                <a16:creationId xmlns:a16="http://schemas.microsoft.com/office/drawing/2014/main" id="{8E7C25D3-9CF3-43CF-967E-788D826AA74F}"/>
+                <a16:creationId xmlns:a16="http://schemas.microsoft.com/office/drawing/2014/main" id="{139D80CA-0FDC-4AE3-89A3-7F8F07CCEDEE}"/>
               </a:ext>
             </a:extLst>
           </p:cNvPr>
@@ -21608,7 +21608,7 @@
           <p:cNvPr id="5" name="body">
             <a:extLst xmlns:a="http://schemas.openxmlformats.org/drawingml/2006/main">
               <a:ext uri="{FF2B5EF4-FFF2-40B4-BE49-F238E27FC236}">
-                <a16:creationId xmlns:a16="http://schemas.microsoft.com/office/drawing/2014/main" id="{E8DC98CD-9DFD-4D90-92E8-B10C41D3F7FD}"/>
+                <a16:creationId xmlns:a16="http://schemas.microsoft.com/office/drawing/2014/main" id="{9BF6AB5A-BC92-48DB-8A36-8DED31F7A114}"/>
               </a:ext>
             </a:extLst>
           </p:cNvPr>
@@ -21665,7 +21665,7 @@
           <p:cNvPr id="6" name="body">
             <a:extLst xmlns:a="http://schemas.openxmlformats.org/drawingml/2006/main">
               <a:ext uri="{FF2B5EF4-FFF2-40B4-BE49-F238E27FC236}">
-                <a16:creationId xmlns:a16="http://schemas.microsoft.com/office/drawing/2014/main" id="{69194093-6C39-43AA-AECF-96B3669821CB}"/>
+                <a16:creationId xmlns:a16="http://schemas.microsoft.com/office/drawing/2014/main" id="{50663DA8-A95A-4A80-897C-595D5BFF2767}"/>
               </a:ext>
             </a:extLst>
           </p:cNvPr>
@@ -21722,7 +21722,7 @@
           <p:cNvPr id="7" name="body">
             <a:extLst xmlns:a="http://schemas.openxmlformats.org/drawingml/2006/main">
               <a:ext uri="{FF2B5EF4-FFF2-40B4-BE49-F238E27FC236}">
-                <a16:creationId xmlns:a16="http://schemas.microsoft.com/office/drawing/2014/main" id="{76E7C1CA-E456-4D03-9820-654DAE0EA6C6}"/>
+                <a16:creationId xmlns:a16="http://schemas.microsoft.com/office/drawing/2014/main" id="{FCF52CD0-859D-456A-8E83-46B765C752F6}"/>
               </a:ext>
             </a:extLst>
           </p:cNvPr>
@@ -21779,7 +21779,7 @@
           <p:cNvPr id="8" name="body">
             <a:extLst xmlns:a="http://schemas.openxmlformats.org/drawingml/2006/main">
               <a:ext uri="{FF2B5EF4-FFF2-40B4-BE49-F238E27FC236}">
-                <a16:creationId xmlns:a16="http://schemas.microsoft.com/office/drawing/2014/main" id="{FEEEB00E-ECDD-4EE7-9661-9B7DAC2F027D}"/>
+                <a16:creationId xmlns:a16="http://schemas.microsoft.com/office/drawing/2014/main" id="{FBEF8334-5289-45E1-A93C-0B6ED0658344}"/>
               </a:ext>
             </a:extLst>
           </p:cNvPr>
@@ -21836,7 +21836,7 @@
           <p:cNvPr id="9" name="footnote">
             <a:extLst xmlns:a="http://schemas.openxmlformats.org/drawingml/2006/main">
               <a:ext uri="{FF2B5EF4-FFF2-40B4-BE49-F238E27FC236}">
-                <a16:creationId xmlns:a16="http://schemas.microsoft.com/office/drawing/2014/main" id="{977674C3-C62C-42B3-9814-036CCE043A43}"/>
+                <a16:creationId xmlns:a16="http://schemas.microsoft.com/office/drawing/2014/main" id="{720CA241-B60D-48A8-8F53-8BC8A55D42FB}"/>
               </a:ext>
             </a:extLst>
           </p:cNvPr>
@@ -21893,7 +21893,7 @@
           <p:cNvPr id="10" name="page">
             <a:extLst xmlns:a="http://schemas.openxmlformats.org/drawingml/2006/main">
               <a:ext uri="{FF2B5EF4-FFF2-40B4-BE49-F238E27FC236}">
-                <a16:creationId xmlns:a16="http://schemas.microsoft.com/office/drawing/2014/main" id="{29A73611-6F32-4A3D-8229-5671E79FA05C}"/>
+                <a16:creationId xmlns:a16="http://schemas.microsoft.com/office/drawing/2014/main" id="{6AA6FF61-D4E7-48C4-BA9F-C248A98361BA}"/>
               </a:ext>
             </a:extLst>
           </p:cNvPr>
@@ -21948,7 +21948,7 @@
     </p:spTree>
     <p:extLst>
       <p:ext uri="{BB962C8B-B14F-4D97-AF65-F5344CB8AC3E}">
-        <p14:creationId xmlns:p14="http://schemas.microsoft.com/office/powerpoint/2010/main" val="515734104"/>
+        <p14:creationId xmlns:p14="http://schemas.microsoft.com/office/powerpoint/2010/main" val="1145565486"/>
       </p:ext>
     </p:extLst>
   </p:cSld>
@@ -21979,7 +21979,7 @@
           <p:cNvPr id="6" name="course">
             <a:extLst xmlns:a="http://schemas.openxmlformats.org/drawingml/2006/main">
               <a:ext uri="{FF2B5EF4-FFF2-40B4-BE49-F238E27FC236}">
-                <a16:creationId xmlns:a16="http://schemas.microsoft.com/office/drawing/2014/main" id="{D7678028-8698-41C4-A5DC-764C32C42F47}"/>
+                <a16:creationId xmlns:a16="http://schemas.microsoft.com/office/drawing/2014/main" id="{5117C30C-350D-45FA-A260-D91B359AD186}"/>
               </a:ext>
             </a:extLst>
           </p:cNvPr>
@@ -22036,7 +22036,7 @@
           <p:cNvPr id="2" name="title">
             <a:extLst xmlns:a="http://schemas.openxmlformats.org/drawingml/2006/main">
               <a:ext uri="{FF2B5EF4-FFF2-40B4-BE49-F238E27FC236}">
-                <a16:creationId xmlns:a16="http://schemas.microsoft.com/office/drawing/2014/main" id="{17172BC0-BB36-4F61-8D24-5E1580FFECEB}"/>
+                <a16:creationId xmlns:a16="http://schemas.microsoft.com/office/drawing/2014/main" id="{CC5CEDB8-DE57-45EE-B329-80A0EB27BABA}"/>
               </a:ext>
             </a:extLst>
           </p:cNvPr>
@@ -22415,7 +22415,7 @@
           <p:cNvPr id="4" name="footnote">
             <a:extLst xmlns:a="http://schemas.openxmlformats.org/drawingml/2006/main">
               <a:ext uri="{FF2B5EF4-FFF2-40B4-BE49-F238E27FC236}">
-                <a16:creationId xmlns:a16="http://schemas.microsoft.com/office/drawing/2014/main" id="{70798845-2E30-4FE6-B563-9F4B38071CB8}"/>
+                <a16:creationId xmlns:a16="http://schemas.microsoft.com/office/drawing/2014/main" id="{B26718D0-8506-4863-8C0E-4E0075E7BE3F}"/>
               </a:ext>
             </a:extLst>
           </p:cNvPr>
@@ -22472,7 +22472,7 @@
           <p:cNvPr id="5" name="page">
             <a:extLst xmlns:a="http://schemas.openxmlformats.org/drawingml/2006/main">
               <a:ext uri="{FF2B5EF4-FFF2-40B4-BE49-F238E27FC236}">
-                <a16:creationId xmlns:a16="http://schemas.microsoft.com/office/drawing/2014/main" id="{EEDFA442-D5AA-429A-A9F5-CCF7A439CEF3}"/>
+                <a16:creationId xmlns:a16="http://schemas.microsoft.com/office/drawing/2014/main" id="{441B70BA-87D2-4BEC-9F09-4CF01BE66E23}"/>
               </a:ext>
             </a:extLst>
           </p:cNvPr>
@@ -22527,7 +22527,7 @@
     </p:spTree>
     <p:extLst>
       <p:ext uri="{BB962C8B-B14F-4D97-AF65-F5344CB8AC3E}">
-        <p14:creationId xmlns:p14="http://schemas.microsoft.com/office/powerpoint/2010/main" val="534570244"/>
+        <p14:creationId xmlns:p14="http://schemas.microsoft.com/office/powerpoint/2010/main" val="1683342723"/>
       </p:ext>
     </p:extLst>
   </p:cSld>
@@ -22844,7 +22844,8 @@
                   <a:srgbClr val="5F6368"/>
                 </a:solidFill>
               </a:rPr>
-              <a:t>No late pre-labs.</a:t>
+              <a:t>Normally posted Monday before the laboratory.
+Due before your own section; no late pre-labs.</a:t>
             </a:r>
           </a:p>
           <a:p xmlns:a="http://schemas.openxmlformats.org/drawingml/2006/main">
@@ -23396,7 +23397,7 @@
           <p:cNvPr id="11" name="course">
             <a:extLst xmlns:a="http://schemas.openxmlformats.org/drawingml/2006/main">
               <a:ext uri="{FF2B5EF4-FFF2-40B4-BE49-F238E27FC236}">
-                <a16:creationId xmlns:a16="http://schemas.microsoft.com/office/drawing/2014/main" id="{1B634E4A-0BBF-4D0C-B702-0EBABE720388}"/>
+                <a16:creationId xmlns:a16="http://schemas.microsoft.com/office/drawing/2014/main" id="{30CFB6C5-4F95-49ED-A6B1-E7776746F828}"/>
               </a:ext>
             </a:extLst>
           </p:cNvPr>
@@ -23453,7 +23454,7 @@
           <p:cNvPr id="2" name="title">
             <a:extLst xmlns:a="http://schemas.openxmlformats.org/drawingml/2006/main">
               <a:ext uri="{FF2B5EF4-FFF2-40B4-BE49-F238E27FC236}">
-                <a16:creationId xmlns:a16="http://schemas.microsoft.com/office/drawing/2014/main" id="{C590F210-C681-4F8B-AD1E-E17A5606F006}"/>
+                <a16:creationId xmlns:a16="http://schemas.microsoft.com/office/drawing/2014/main" id="{3B8CE610-7168-4156-9382-CCEB855F8A27}"/>
               </a:ext>
             </a:extLst>
           </p:cNvPr>
@@ -23510,7 +23511,7 @@
           <p:cNvPr id="3" name="body">
             <a:extLst xmlns:a="http://schemas.openxmlformats.org/drawingml/2006/main">
               <a:ext uri="{FF2B5EF4-FFF2-40B4-BE49-F238E27FC236}">
-                <a16:creationId xmlns:a16="http://schemas.microsoft.com/office/drawing/2014/main" id="{72B5A04F-EEED-4D86-8576-6EE08851C818}"/>
+                <a16:creationId xmlns:a16="http://schemas.microsoft.com/office/drawing/2014/main" id="{FD7B242C-22AE-40A1-9C5E-D75F7C933585}"/>
               </a:ext>
             </a:extLst>
           </p:cNvPr>
@@ -23567,7 +23568,7 @@
           <p:cNvPr id="4" name="body">
             <a:extLst xmlns:a="http://schemas.openxmlformats.org/drawingml/2006/main">
               <a:ext uri="{FF2B5EF4-FFF2-40B4-BE49-F238E27FC236}">
-                <a16:creationId xmlns:a16="http://schemas.microsoft.com/office/drawing/2014/main" id="{E972A015-7194-4C96-AC35-C7FD761035E6}"/>
+                <a16:creationId xmlns:a16="http://schemas.microsoft.com/office/drawing/2014/main" id="{629C6CB3-AD19-41D6-8872-A2091D65E0C1}"/>
               </a:ext>
             </a:extLst>
           </p:cNvPr>
@@ -23624,7 +23625,7 @@
           <p:cNvPr id="5" name="body">
             <a:extLst xmlns:a="http://schemas.openxmlformats.org/drawingml/2006/main">
               <a:ext uri="{FF2B5EF4-FFF2-40B4-BE49-F238E27FC236}">
-                <a16:creationId xmlns:a16="http://schemas.microsoft.com/office/drawing/2014/main" id="{1994BF93-E40B-4FB8-991F-965CFE393299}"/>
+                <a16:creationId xmlns:a16="http://schemas.microsoft.com/office/drawing/2014/main" id="{82905CBD-554C-4CD0-A5AD-72FD56B176B9}"/>
               </a:ext>
             </a:extLst>
           </p:cNvPr>
@@ -23681,7 +23682,7 @@
           <p:cNvPr id="6" name="body">
             <a:extLst xmlns:a="http://schemas.openxmlformats.org/drawingml/2006/main">
               <a:ext uri="{FF2B5EF4-FFF2-40B4-BE49-F238E27FC236}">
-                <a16:creationId xmlns:a16="http://schemas.microsoft.com/office/drawing/2014/main" id="{7EBA0A18-7F20-4A1D-A9C3-B5F34D5901DE}"/>
+                <a16:creationId xmlns:a16="http://schemas.microsoft.com/office/drawing/2014/main" id="{A98B0E7F-C32A-4C5D-9809-9B07C850C43E}"/>
               </a:ext>
             </a:extLst>
           </p:cNvPr>
@@ -23738,7 +23739,7 @@
           <p:cNvPr id="7" name="body">
             <a:extLst xmlns:a="http://schemas.openxmlformats.org/drawingml/2006/main">
               <a:ext uri="{FF2B5EF4-FFF2-40B4-BE49-F238E27FC236}">
-                <a16:creationId xmlns:a16="http://schemas.microsoft.com/office/drawing/2014/main" id="{E2854FE5-2D1B-4422-9F34-A43990EA573D}"/>
+                <a16:creationId xmlns:a16="http://schemas.microsoft.com/office/drawing/2014/main" id="{60FC8806-7433-46D4-B164-8C7548E44E1F}"/>
               </a:ext>
             </a:extLst>
           </p:cNvPr>
@@ -23795,7 +23796,7 @@
           <p:cNvPr id="8" name="body">
             <a:extLst xmlns:a="http://schemas.openxmlformats.org/drawingml/2006/main">
               <a:ext uri="{FF2B5EF4-FFF2-40B4-BE49-F238E27FC236}">
-                <a16:creationId xmlns:a16="http://schemas.microsoft.com/office/drawing/2014/main" id="{C3F2638D-7DA8-4447-B085-262BBBB1162A}"/>
+                <a16:creationId xmlns:a16="http://schemas.microsoft.com/office/drawing/2014/main" id="{31C6D262-A9FA-41FC-A70E-873DCF92A22C}"/>
               </a:ext>
             </a:extLst>
           </p:cNvPr>
@@ -23852,7 +23853,7 @@
           <p:cNvPr id="9" name="footnote">
             <a:extLst xmlns:a="http://schemas.openxmlformats.org/drawingml/2006/main">
               <a:ext uri="{FF2B5EF4-FFF2-40B4-BE49-F238E27FC236}">
-                <a16:creationId xmlns:a16="http://schemas.microsoft.com/office/drawing/2014/main" id="{FC3C0D0F-8CEB-4217-8BCF-345B74FEF920}"/>
+                <a16:creationId xmlns:a16="http://schemas.microsoft.com/office/drawing/2014/main" id="{8DEEC4DE-8AB2-48F1-AF4A-E02DF9F55347}"/>
               </a:ext>
             </a:extLst>
           </p:cNvPr>
@@ -23909,7 +23910,7 @@
           <p:cNvPr id="10" name="page">
             <a:extLst xmlns:a="http://schemas.openxmlformats.org/drawingml/2006/main">
               <a:ext uri="{FF2B5EF4-FFF2-40B4-BE49-F238E27FC236}">
-                <a16:creationId xmlns:a16="http://schemas.microsoft.com/office/drawing/2014/main" id="{FA6DD1CB-2EEC-42D2-8CFC-D6AE726B62D9}"/>
+                <a16:creationId xmlns:a16="http://schemas.microsoft.com/office/drawing/2014/main" id="{5581A54E-56A3-496C-8AA0-790B17AE69B2}"/>
               </a:ext>
             </a:extLst>
           </p:cNvPr>
@@ -23964,7 +23965,7 @@
     </p:spTree>
     <p:extLst>
       <p:ext uri="{BB962C8B-B14F-4D97-AF65-F5344CB8AC3E}">
-        <p14:creationId xmlns:p14="http://schemas.microsoft.com/office/powerpoint/2010/main" val="796245083"/>
+        <p14:creationId xmlns:p14="http://schemas.microsoft.com/office/powerpoint/2010/main" val="1065747006"/>
       </p:ext>
     </p:extLst>
   </p:cSld>
@@ -23995,7 +23996,7 @@
           <p:cNvPr id="11" name="course">
             <a:extLst xmlns:a="http://schemas.openxmlformats.org/drawingml/2006/main">
               <a:ext uri="{FF2B5EF4-FFF2-40B4-BE49-F238E27FC236}">
-                <a16:creationId xmlns:a16="http://schemas.microsoft.com/office/drawing/2014/main" id="{DFC73C0E-F070-4856-8C3E-4DAD8878C85D}"/>
+                <a16:creationId xmlns:a16="http://schemas.microsoft.com/office/drawing/2014/main" id="{E3CD8B2A-2A78-4743-B232-DCC07E072560}"/>
               </a:ext>
             </a:extLst>
           </p:cNvPr>
@@ -24052,7 +24053,7 @@
           <p:cNvPr id="2" name="title">
             <a:extLst xmlns:a="http://schemas.openxmlformats.org/drawingml/2006/main">
               <a:ext uri="{FF2B5EF4-FFF2-40B4-BE49-F238E27FC236}">
-                <a16:creationId xmlns:a16="http://schemas.microsoft.com/office/drawing/2014/main" id="{4BE48972-BAE4-4A47-8BBB-8EEC08BEE499}"/>
+                <a16:creationId xmlns:a16="http://schemas.microsoft.com/office/drawing/2014/main" id="{2FA2E2D7-BE60-4245-96B8-C04260A6810E}"/>
               </a:ext>
             </a:extLst>
           </p:cNvPr>
@@ -24109,7 +24110,7 @@
           <p:cNvPr id="3" name="body">
             <a:extLst xmlns:a="http://schemas.openxmlformats.org/drawingml/2006/main">
               <a:ext uri="{FF2B5EF4-FFF2-40B4-BE49-F238E27FC236}">
-                <a16:creationId xmlns:a16="http://schemas.microsoft.com/office/drawing/2014/main" id="{ADBE3110-DAAB-4AF5-A651-DFBDB5595241}"/>
+                <a16:creationId xmlns:a16="http://schemas.microsoft.com/office/drawing/2014/main" id="{93584969-2851-4BC8-8B92-4DED8365A351}"/>
               </a:ext>
             </a:extLst>
           </p:cNvPr>
@@ -24166,7 +24167,7 @@
           <p:cNvPr id="4" name="body">
             <a:extLst xmlns:a="http://schemas.openxmlformats.org/drawingml/2006/main">
               <a:ext uri="{FF2B5EF4-FFF2-40B4-BE49-F238E27FC236}">
-                <a16:creationId xmlns:a16="http://schemas.microsoft.com/office/drawing/2014/main" id="{2303A7BD-9660-4AAF-931B-7D1E53350A27}"/>
+                <a16:creationId xmlns:a16="http://schemas.microsoft.com/office/drawing/2014/main" id="{C629852F-2C8A-45C1-ADFC-219BD3424164}"/>
               </a:ext>
             </a:extLst>
           </p:cNvPr>
@@ -24223,7 +24224,7 @@
           <p:cNvPr id="5" name="body">
             <a:extLst xmlns:a="http://schemas.openxmlformats.org/drawingml/2006/main">
               <a:ext uri="{FF2B5EF4-FFF2-40B4-BE49-F238E27FC236}">
-                <a16:creationId xmlns:a16="http://schemas.microsoft.com/office/drawing/2014/main" id="{5C4B173E-AF02-4DF1-B85B-1202CF93F638}"/>
+                <a16:creationId xmlns:a16="http://schemas.microsoft.com/office/drawing/2014/main" id="{BBCACCB5-C3CE-4592-B4BC-5F5C1FD1AA8B}"/>
               </a:ext>
             </a:extLst>
           </p:cNvPr>
@@ -24280,7 +24281,7 @@
           <p:cNvPr id="6" name="body">
             <a:extLst xmlns:a="http://schemas.openxmlformats.org/drawingml/2006/main">
               <a:ext uri="{FF2B5EF4-FFF2-40B4-BE49-F238E27FC236}">
-                <a16:creationId xmlns:a16="http://schemas.microsoft.com/office/drawing/2014/main" id="{FBE4CF2B-F811-40C7-94DB-FD18DB493260}"/>
+                <a16:creationId xmlns:a16="http://schemas.microsoft.com/office/drawing/2014/main" id="{80867E0A-0C3A-45CE-98A3-B37FAE52B1C1}"/>
               </a:ext>
             </a:extLst>
           </p:cNvPr>
@@ -24337,7 +24338,7 @@
           <p:cNvPr id="7" name="body">
             <a:extLst xmlns:a="http://schemas.openxmlformats.org/drawingml/2006/main">
               <a:ext uri="{FF2B5EF4-FFF2-40B4-BE49-F238E27FC236}">
-                <a16:creationId xmlns:a16="http://schemas.microsoft.com/office/drawing/2014/main" id="{3C768F6C-8963-4149-AD9B-8998A046E82B}"/>
+                <a16:creationId xmlns:a16="http://schemas.microsoft.com/office/drawing/2014/main" id="{A7F0FDBC-C38E-4644-8E71-48F3E55375FC}"/>
               </a:ext>
             </a:extLst>
           </p:cNvPr>
@@ -24394,7 +24395,7 @@
           <p:cNvPr id="8" name="body">
             <a:extLst xmlns:a="http://schemas.openxmlformats.org/drawingml/2006/main">
               <a:ext uri="{FF2B5EF4-FFF2-40B4-BE49-F238E27FC236}">
-                <a16:creationId xmlns:a16="http://schemas.microsoft.com/office/drawing/2014/main" id="{8D763647-9FE6-4397-AAED-94A343CAA359}"/>
+                <a16:creationId xmlns:a16="http://schemas.microsoft.com/office/drawing/2014/main" id="{CE745577-F70A-45CA-9866-78E8CC02BF97}"/>
               </a:ext>
             </a:extLst>
           </p:cNvPr>
@@ -24451,7 +24452,7 @@
           <p:cNvPr id="9" name="footnote">
             <a:extLst xmlns:a="http://schemas.openxmlformats.org/drawingml/2006/main">
               <a:ext uri="{FF2B5EF4-FFF2-40B4-BE49-F238E27FC236}">
-                <a16:creationId xmlns:a16="http://schemas.microsoft.com/office/drawing/2014/main" id="{4ACBE119-FE12-4D4E-96E5-D9087D69B69D}"/>
+                <a16:creationId xmlns:a16="http://schemas.microsoft.com/office/drawing/2014/main" id="{4E0EC0C7-2163-427C-9F1A-BDDEF8863DD2}"/>
               </a:ext>
             </a:extLst>
           </p:cNvPr>
@@ -24508,7 +24509,7 @@
           <p:cNvPr id="10" name="page">
             <a:extLst xmlns:a="http://schemas.openxmlformats.org/drawingml/2006/main">
               <a:ext uri="{FF2B5EF4-FFF2-40B4-BE49-F238E27FC236}">
-                <a16:creationId xmlns:a16="http://schemas.microsoft.com/office/drawing/2014/main" id="{1A533BB0-9187-429F-A15D-FFC99C2956B7}"/>
+                <a16:creationId xmlns:a16="http://schemas.microsoft.com/office/drawing/2014/main" id="{39D6688E-8296-472E-A563-AE3D0C8B00D8}"/>
               </a:ext>
             </a:extLst>
           </p:cNvPr>
@@ -24563,7 +24564,7 @@
     </p:spTree>
     <p:extLst>
       <p:ext uri="{BB962C8B-B14F-4D97-AF65-F5344CB8AC3E}">
-        <p14:creationId xmlns:p14="http://schemas.microsoft.com/office/powerpoint/2010/main" val="872310022"/>
+        <p14:creationId xmlns:p14="http://schemas.microsoft.com/office/powerpoint/2010/main" val="944891078"/>
       </p:ext>
     </p:extLst>
   </p:cSld>
@@ -27290,7 +27291,7 @@
         </p:xfrm>
         <a:graphic xmlns:a="http://schemas.openxmlformats.org/drawingml/2006/main">
           <a:graphicData uri="http://schemas.openxmlformats.org/drawingml/2006/chart">
-            <c:chart xmlns:r="http://schemas.openxmlformats.org/officeDocument/2006/relationships" xmlns:c="http://schemas.openxmlformats.org/drawingml/2006/chart" r:id="Rd8c0ca7edded41b0"/>
+            <c:chart xmlns:r="http://schemas.openxmlformats.org/officeDocument/2006/relationships" xmlns:c="http://schemas.openxmlformats.org/drawingml/2006/chart" r:id="R5615ce2415144fbd"/>
           </a:graphicData>
         </a:graphic>
       </p:graphicFrame>
@@ -29319,7 +29320,7 @@
           <p:cNvPr id="12" name="course">
             <a:extLst xmlns:a="http://schemas.openxmlformats.org/drawingml/2006/main">
               <a:ext uri="{FF2B5EF4-FFF2-40B4-BE49-F238E27FC236}">
-                <a16:creationId xmlns:a16="http://schemas.microsoft.com/office/drawing/2014/main" id="{A683599E-3476-4178-98E4-E56513945549}"/>
+                <a16:creationId xmlns:a16="http://schemas.microsoft.com/office/drawing/2014/main" id="{84C76367-F85E-407D-9802-90067D27E5DD}"/>
               </a:ext>
             </a:extLst>
           </p:cNvPr>
@@ -29376,7 +29377,7 @@
           <p:cNvPr id="2" name="title">
             <a:extLst xmlns:a="http://schemas.openxmlformats.org/drawingml/2006/main">
               <a:ext uri="{FF2B5EF4-FFF2-40B4-BE49-F238E27FC236}">
-                <a16:creationId xmlns:a16="http://schemas.microsoft.com/office/drawing/2014/main" id="{09DA8013-BFFF-4DC8-BB4B-B09243AC4FEE}"/>
+                <a16:creationId xmlns:a16="http://schemas.microsoft.com/office/drawing/2014/main" id="{3B0FE4FF-3908-4CBB-864C-F3BFFA35D8A4}"/>
               </a:ext>
             </a:extLst>
           </p:cNvPr>
@@ -29433,7 +29434,7 @@
           <p:cNvPr id="3" name="body">
             <a:extLst xmlns:a="http://schemas.openxmlformats.org/drawingml/2006/main">
               <a:ext uri="{FF2B5EF4-FFF2-40B4-BE49-F238E27FC236}">
-                <a16:creationId xmlns:a16="http://schemas.microsoft.com/office/drawing/2014/main" id="{710DA679-1014-4849-970C-0917BA727ADE}"/>
+                <a16:creationId xmlns:a16="http://schemas.microsoft.com/office/drawing/2014/main" id="{E43A43EF-D624-4AB7-8054-85250648C797}"/>
               </a:ext>
             </a:extLst>
           </p:cNvPr>
@@ -29490,7 +29491,7 @@
           <p:cNvPr id="4" name="body">
             <a:extLst xmlns:a="http://schemas.openxmlformats.org/drawingml/2006/main">
               <a:ext uri="{FF2B5EF4-FFF2-40B4-BE49-F238E27FC236}">
-                <a16:creationId xmlns:a16="http://schemas.microsoft.com/office/drawing/2014/main" id="{6BDAB269-F99B-460D-80C5-88503BEC6957}"/>
+                <a16:creationId xmlns:a16="http://schemas.microsoft.com/office/drawing/2014/main" id="{AB0AE87E-6551-46D3-9BAD-EEF53835D188}"/>
               </a:ext>
             </a:extLst>
           </p:cNvPr>
@@ -29547,7 +29548,7 @@
           <p:cNvPr id="5" name="body">
             <a:extLst xmlns:a="http://schemas.openxmlformats.org/drawingml/2006/main">
               <a:ext uri="{FF2B5EF4-FFF2-40B4-BE49-F238E27FC236}">
-                <a16:creationId xmlns:a16="http://schemas.microsoft.com/office/drawing/2014/main" id="{B84662F2-F81D-4A0C-8AF1-2210F945381F}"/>
+                <a16:creationId xmlns:a16="http://schemas.microsoft.com/office/drawing/2014/main" id="{53FB74CD-7420-4F08-9CC2-2F47E879AC2B}"/>
               </a:ext>
             </a:extLst>
           </p:cNvPr>
@@ -29604,7 +29605,7 @@
           <p:cNvPr id="6" name="body">
             <a:extLst xmlns:a="http://schemas.openxmlformats.org/drawingml/2006/main">
               <a:ext uri="{FF2B5EF4-FFF2-40B4-BE49-F238E27FC236}">
-                <a16:creationId xmlns:a16="http://schemas.microsoft.com/office/drawing/2014/main" id="{07AF3301-5D69-4A6E-A979-A4A861B96433}"/>
+                <a16:creationId xmlns:a16="http://schemas.microsoft.com/office/drawing/2014/main" id="{0CA3C730-0EDB-441C-ADE5-1D73EB545F34}"/>
               </a:ext>
             </a:extLst>
           </p:cNvPr>
@@ -29661,7 +29662,7 @@
           <p:cNvPr id="7" name="body">
             <a:extLst xmlns:a="http://schemas.openxmlformats.org/drawingml/2006/main">
               <a:ext uri="{FF2B5EF4-FFF2-40B4-BE49-F238E27FC236}">
-                <a16:creationId xmlns:a16="http://schemas.microsoft.com/office/drawing/2014/main" id="{CF290BF8-C0CC-4879-AF3F-68958D2D64CF}"/>
+                <a16:creationId xmlns:a16="http://schemas.microsoft.com/office/drawing/2014/main" id="{860333B5-46E2-4224-9507-DFC11AFABCC0}"/>
               </a:ext>
             </a:extLst>
           </p:cNvPr>
@@ -29718,7 +29719,7 @@
           <p:cNvPr id="8" name="body">
             <a:extLst xmlns:a="http://schemas.openxmlformats.org/drawingml/2006/main">
               <a:ext uri="{FF2B5EF4-FFF2-40B4-BE49-F238E27FC236}">
-                <a16:creationId xmlns:a16="http://schemas.microsoft.com/office/drawing/2014/main" id="{DD8639A0-E164-4CC9-BF08-E7D8044587F7}"/>
+                <a16:creationId xmlns:a16="http://schemas.microsoft.com/office/drawing/2014/main" id="{019CF63E-7849-475D-BD37-EA78B99745B2}"/>
               </a:ext>
             </a:extLst>
           </p:cNvPr>
@@ -29779,7 +29780,7 @@
           <p:nvPr/>
         </p:nvPicPr>
         <p:blipFill>
-          <a:blip xmlns:r="http://schemas.openxmlformats.org/officeDocument/2006/relationships" xmlns:a="http://schemas.openxmlformats.org/drawingml/2006/main" r:embed="Rc0a73c13207944ba"/>
+          <a:blip xmlns:r="http://schemas.openxmlformats.org/officeDocument/2006/relationships" xmlns:a="http://schemas.openxmlformats.org/drawingml/2006/main" r:embed="R98a19d64009b4279"/>
           <a:stretch xmlns:a="http://schemas.openxmlformats.org/drawingml/2006/main"/>
         </p:blipFill>
         <p:spPr>
@@ -29797,7 +29798,7 @@
           <p:cNvPr id="10" name="photo-caption">
             <a:extLst xmlns:a="http://schemas.openxmlformats.org/drawingml/2006/main">
               <a:ext uri="{FF2B5EF4-FFF2-40B4-BE49-F238E27FC236}">
-                <a16:creationId xmlns:a16="http://schemas.microsoft.com/office/drawing/2014/main" id="{8E773E22-2FED-4D6E-8DE2-65FEEEFBC317}"/>
+                <a16:creationId xmlns:a16="http://schemas.microsoft.com/office/drawing/2014/main" id="{BA30F2E0-D874-403A-9943-B49A0F072B02}"/>
               </a:ext>
             </a:extLst>
           </p:cNvPr>
@@ -29854,7 +29855,7 @@
           <p:cNvPr id="11" name="page">
             <a:extLst xmlns:a="http://schemas.openxmlformats.org/drawingml/2006/main">
               <a:ext uri="{FF2B5EF4-FFF2-40B4-BE49-F238E27FC236}">
-                <a16:creationId xmlns:a16="http://schemas.microsoft.com/office/drawing/2014/main" id="{EE698237-D96A-4C78-8165-994AD22ABA64}"/>
+                <a16:creationId xmlns:a16="http://schemas.microsoft.com/office/drawing/2014/main" id="{CC359895-F49A-4E22-82F7-5C764CA886E9}"/>
               </a:ext>
             </a:extLst>
           </p:cNvPr>
@@ -29909,7 +29910,7 @@
     </p:spTree>
     <p:extLst>
       <p:ext uri="{BB962C8B-B14F-4D97-AF65-F5344CB8AC3E}">
-        <p14:creationId xmlns:p14="http://schemas.microsoft.com/office/powerpoint/2010/main" val="104766980"/>
+        <p14:creationId xmlns:p14="http://schemas.microsoft.com/office/powerpoint/2010/main" val="55414761"/>
       </p:ext>
     </p:extLst>
   </p:cSld>
@@ -29940,7 +29941,7 @@
           <p:cNvPr id="11" name="course">
             <a:extLst xmlns:a="http://schemas.openxmlformats.org/drawingml/2006/main">
               <a:ext uri="{FF2B5EF4-FFF2-40B4-BE49-F238E27FC236}">
-                <a16:creationId xmlns:a16="http://schemas.microsoft.com/office/drawing/2014/main" id="{5F6EE250-15B9-4E39-9B32-50B8711C353F}"/>
+                <a16:creationId xmlns:a16="http://schemas.microsoft.com/office/drawing/2014/main" id="{15D29B2F-F92F-4CAD-AB58-9235B785B3A8}"/>
               </a:ext>
             </a:extLst>
           </p:cNvPr>
@@ -29997,7 +29998,7 @@
           <p:cNvPr id="2" name="title">
             <a:extLst xmlns:a="http://schemas.openxmlformats.org/drawingml/2006/main">
               <a:ext uri="{FF2B5EF4-FFF2-40B4-BE49-F238E27FC236}">
-                <a16:creationId xmlns:a16="http://schemas.microsoft.com/office/drawing/2014/main" id="{3EBDAC3D-15F6-485E-8F32-82311C041510}"/>
+                <a16:creationId xmlns:a16="http://schemas.microsoft.com/office/drawing/2014/main" id="{C9F252C5-CB8B-468D-B7BF-807D4EF91C09}"/>
               </a:ext>
             </a:extLst>
           </p:cNvPr>
@@ -30054,7 +30055,7 @@
           <p:cNvPr id="3" name="body">
             <a:extLst xmlns:a="http://schemas.openxmlformats.org/drawingml/2006/main">
               <a:ext uri="{FF2B5EF4-FFF2-40B4-BE49-F238E27FC236}">
-                <a16:creationId xmlns:a16="http://schemas.microsoft.com/office/drawing/2014/main" id="{55ADFD84-6CEF-4768-BA77-ACE8E4E4F693}"/>
+                <a16:creationId xmlns:a16="http://schemas.microsoft.com/office/drawing/2014/main" id="{B8B9D986-C844-47DD-B8DF-E76CE8101DDC}"/>
               </a:ext>
             </a:extLst>
           </p:cNvPr>
@@ -30111,7 +30112,7 @@
           <p:cNvPr id="4" name="body">
             <a:extLst xmlns:a="http://schemas.openxmlformats.org/drawingml/2006/main">
               <a:ext uri="{FF2B5EF4-FFF2-40B4-BE49-F238E27FC236}">
-                <a16:creationId xmlns:a16="http://schemas.microsoft.com/office/drawing/2014/main" id="{04D14CE9-66ED-4C53-AFAF-AD64EA390FC1}"/>
+                <a16:creationId xmlns:a16="http://schemas.microsoft.com/office/drawing/2014/main" id="{292E377D-756E-4920-BB5A-14678F0CBE04}"/>
               </a:ext>
             </a:extLst>
           </p:cNvPr>
@@ -30168,7 +30169,7 @@
           <p:cNvPr id="5" name="body">
             <a:extLst xmlns:a="http://schemas.openxmlformats.org/drawingml/2006/main">
               <a:ext uri="{FF2B5EF4-FFF2-40B4-BE49-F238E27FC236}">
-                <a16:creationId xmlns:a16="http://schemas.microsoft.com/office/drawing/2014/main" id="{F1B5CE0C-37E2-4249-8C0F-0F1334B165D0}"/>
+                <a16:creationId xmlns:a16="http://schemas.microsoft.com/office/drawing/2014/main" id="{AEAECF5F-76E8-4F46-9D8E-67054B6AD1B3}"/>
               </a:ext>
             </a:extLst>
           </p:cNvPr>
@@ -30225,7 +30226,7 @@
           <p:cNvPr id="6" name="body">
             <a:extLst xmlns:a="http://schemas.openxmlformats.org/drawingml/2006/main">
               <a:ext uri="{FF2B5EF4-FFF2-40B4-BE49-F238E27FC236}">
-                <a16:creationId xmlns:a16="http://schemas.microsoft.com/office/drawing/2014/main" id="{B83063B6-D983-4D56-9282-06F3F7DCB4D1}"/>
+                <a16:creationId xmlns:a16="http://schemas.microsoft.com/office/drawing/2014/main" id="{03530DE5-C2AE-4556-9F54-7DF397FAABAD}"/>
               </a:ext>
             </a:extLst>
           </p:cNvPr>
@@ -30282,7 +30283,7 @@
           <p:cNvPr id="7" name="body">
             <a:extLst xmlns:a="http://schemas.openxmlformats.org/drawingml/2006/main">
               <a:ext uri="{FF2B5EF4-FFF2-40B4-BE49-F238E27FC236}">
-                <a16:creationId xmlns:a16="http://schemas.microsoft.com/office/drawing/2014/main" id="{0AB6388D-76EC-438C-A850-5F3B612C98E3}"/>
+                <a16:creationId xmlns:a16="http://schemas.microsoft.com/office/drawing/2014/main" id="{263512C9-5CBE-4D2D-B7A2-081AD7452135}"/>
               </a:ext>
             </a:extLst>
           </p:cNvPr>
@@ -30339,7 +30340,7 @@
           <p:cNvPr id="8" name="body">
             <a:extLst xmlns:a="http://schemas.openxmlformats.org/drawingml/2006/main">
               <a:ext uri="{FF2B5EF4-FFF2-40B4-BE49-F238E27FC236}">
-                <a16:creationId xmlns:a16="http://schemas.microsoft.com/office/drawing/2014/main" id="{36EFD4FC-FAD7-4743-9C5C-6E8065A25CA7}"/>
+                <a16:creationId xmlns:a16="http://schemas.microsoft.com/office/drawing/2014/main" id="{6E866F1A-CB31-4976-AAA9-CDCA6F27EABB}"/>
               </a:ext>
             </a:extLst>
           </p:cNvPr>
@@ -30396,7 +30397,7 @@
           <p:cNvPr id="9" name="footnote">
             <a:extLst xmlns:a="http://schemas.openxmlformats.org/drawingml/2006/main">
               <a:ext uri="{FF2B5EF4-FFF2-40B4-BE49-F238E27FC236}">
-                <a16:creationId xmlns:a16="http://schemas.microsoft.com/office/drawing/2014/main" id="{55C4434F-66A5-4066-BEA5-C41D35685167}"/>
+                <a16:creationId xmlns:a16="http://schemas.microsoft.com/office/drawing/2014/main" id="{614D3B0D-4A9A-40E8-8DE6-27A6B22C48A8}"/>
               </a:ext>
             </a:extLst>
           </p:cNvPr>
@@ -30453,7 +30454,7 @@
           <p:cNvPr id="10" name="page">
             <a:extLst xmlns:a="http://schemas.openxmlformats.org/drawingml/2006/main">
               <a:ext uri="{FF2B5EF4-FFF2-40B4-BE49-F238E27FC236}">
-                <a16:creationId xmlns:a16="http://schemas.microsoft.com/office/drawing/2014/main" id="{3B3AFFA3-706E-4252-8772-EF230C0819BA}"/>
+                <a16:creationId xmlns:a16="http://schemas.microsoft.com/office/drawing/2014/main" id="{0341BC65-08EE-4831-BDD2-AB6A0B73C531}"/>
               </a:ext>
             </a:extLst>
           </p:cNvPr>
@@ -30508,7 +30509,7 @@
     </p:spTree>
     <p:extLst>
       <p:ext uri="{BB962C8B-B14F-4D97-AF65-F5344CB8AC3E}">
-        <p14:creationId xmlns:p14="http://schemas.microsoft.com/office/powerpoint/2010/main" val="43887909"/>
+        <p14:creationId xmlns:p14="http://schemas.microsoft.com/office/powerpoint/2010/main" val="1417202816"/>
       </p:ext>
     </p:extLst>
   </p:cSld>

</xml_diff>